<commit_message>
docs: deck v4 (24pt body, full v38-line coverage, bug details removed) + matching script
</commit_message>
<xml_diff>
--- a/meeting_figs/DFEI_progress_20260902_EN.pptx
+++ b/meeting_figs/DFEI_progress_20260902_EN.pptx
@@ -16,6 +16,7 @@
     <p:sldId id="264" r:id="rId15"/>
     <p:sldId id="265" r:id="rId16"/>
     <p:sldId id="266" r:id="rId17"/>
+    <p:sldId id="267" r:id="rId18"/>
   </p:sldIdLst>
   <p:sldSz cx="12191695" cy="6858000" type="screen4x3"/>
   <p:notesSz cx="6858000" cy="9144000"/>
@@ -3141,7 +3142,7 @@
         <p:spPr>
           <a:xfrm>
             <a:off x="731520" y="1828800"/>
-            <a:ext cx="10698480" cy="1645920"/>
+            <a:ext cx="10698480" cy="1828800"/>
           </a:xfrm>
           <a:prstGeom prst="rect">
             <a:avLst/>
@@ -3155,7 +3156,7 @@
           <a:lstStyle/>
           <a:p>
             <a:r>
-              <a:rPr sz="4400" b="1">
+              <a:rPr sz="4800" b="1">
                 <a:solidFill>
                   <a:srgbClr val="1F4E79"/>
                 </a:solidFill>
@@ -3174,7 +3175,7 @@
         </p:nvSpPr>
         <p:spPr>
           <a:xfrm>
-            <a:off x="731520" y="3657600"/>
+            <a:off x="731520" y="3840480"/>
             <a:ext cx="10698480" cy="1097280"/>
           </a:xfrm>
           <a:prstGeom prst="rect">
@@ -3189,7 +3190,7 @@
           <a:lstStyle/>
           <a:p>
             <a:r>
-              <a:rPr sz="2000">
+              <a:rPr sz="2200">
                 <a:solidFill>
                   <a:srgbClr val="333333"/>
                 </a:solidFill>
@@ -3208,7 +3209,7 @@
         </p:nvSpPr>
         <p:spPr>
           <a:xfrm>
-            <a:off x="731520" y="5029200"/>
+            <a:off x="731520" y="5120640"/>
             <a:ext cx="10698480" cy="822960"/>
           </a:xfrm>
           <a:prstGeom prst="rect">
@@ -3223,7 +3224,7 @@
           <a:lstStyle/>
           <a:p>
             <a:r>
-              <a:rPr sz="1500">
+              <a:rPr sz="1600">
                 <a:solidFill>
                   <a:srgbClr val="666666"/>
                 </a:solidFill>
@@ -3309,13 +3310,13 @@
           <a:lstStyle/>
           <a:p>
             <a:r>
-              <a:rPr sz="3400" b="1">
+              <a:rPr sz="3800" b="1">
                 <a:solidFill>
                   <a:srgbClr val="1F4E79"/>
                 </a:solidFill>
                 <a:latin typeface="Calibri"/>
               </a:rPr>
-              <a:t>Part 4 — Ongoing Attempts</a:t>
+              <a:t>Part 3 — Controlled Failures and Their Lessons</a:t>
             </a:r>
           </a:p>
         </p:txBody>
@@ -3328,7 +3329,7 @@
         </p:nvSpPr>
         <p:spPr>
           <a:xfrm>
-            <a:off x="548640" y="1143000"/>
+            <a:off x="548640" y="1188720"/>
             <a:ext cx="11064240" cy="38100"/>
           </a:xfrm>
           <a:prstGeom prst="rect">
@@ -3372,7 +3373,7 @@
         <p:spPr>
           <a:xfrm>
             <a:off x="731520" y="1280160"/>
-            <a:ext cx="10789920" cy="5120640"/>
+            <a:ext cx="10789920" cy="4937760"/>
           </a:xfrm>
           <a:prstGeom prst="rect">
             <a:avLst/>
@@ -3387,81 +3388,97 @@
           <a:p>
             <a:pPr>
               <a:spcAft>
-                <a:spcPts val="800"/>
+                <a:spcPts val="1000"/>
               </a:spcAft>
             </a:pPr>
             <a:r>
-              <a:rPr sz="1800">
+              <a:rPr sz="2200">
                 <a:solidFill>
                   <a:srgbClr val="333333"/>
                 </a:solidFill>
                 <a:latin typeface="Calibri"/>
               </a:rPr>
-              <a:t>•  Wider latent space (v53): tracks nodes 32-dim, tt edges 24-dim (16-dim sits at the physical-DOF lower bound)</a:t>
+              <a:t>•  PV subgraph training (v39-42): training on per-PV subgraphs while inference runs on the full graph</a:t>
             </a:r>
           </a:p>
           <a:p>
             <a:pPr>
               <a:spcAft>
-                <a:spcPts val="800"/>
+                <a:spcPts val="1000"/>
               </a:spcAft>
             </a:pPr>
             <a:r>
-              <a:rPr sz="1600">
+              <a:rPr sz="2000">
                 <a:solidFill>
                   <a:srgbClr val="333333"/>
                 </a:solidFill>
                 <a:latin typeface="Calibri"/>
               </a:rPr>
-              <a:t>    –  from-scratch training interrupted at ep74/150 — not converged; resume planned</a:t>
+              <a:t>    –  full-graph ability degraded: class1 76.8% → 56.4%; line closed</a:t>
             </a:r>
           </a:p>
           <a:p>
             <a:pPr>
               <a:spcAft>
-                <a:spcPts val="800"/>
+                <a:spcPts val="1000"/>
               </a:spcAft>
             </a:pPr>
             <a:r>
-              <a:rPr sz="1800">
+              <a:rPr sz="2200">
                 <a:solidFill>
                   <a:srgbClr val="333333"/>
                 </a:solidFill>
                 <a:latin typeface="Calibri"/>
               </a:rPr>
-              <a:t>•  Public-data verification (v45/v49): published dataset has no PID, class2/3 counts differ 4-14×; resume best val 33.4 @ep73</a:t>
+              <a:t>•  Combined mass + struct + mom (v48): aux losses (0.877) exceed the main task (0.559)</a:t>
             </a:r>
           </a:p>
           <a:p>
             <a:pPr>
               <a:spcAft>
-                <a:spcPts val="800"/>
+                <a:spcPts val="1000"/>
               </a:spcAft>
             </a:pPr>
             <a:r>
-              <a:rPr sz="1800">
+              <a:rPr sz="2000">
                 <a:solidFill>
                   <a:srgbClr val="333333"/>
                 </a:solidFill>
                 <a:latin typeface="Calibri"/>
               </a:rPr>
-              <a:t>•  Learned deterministic annealing: inference-side PV clustering with a learned affinity (no subgraph training) — core module CPU-verified</a:t>
+              <a:t>    –  reconstruction dropped 5pp although LCAG did not — backbone pulled toward auxiliary tasks</a:t>
             </a:r>
           </a:p>
           <a:p>
             <a:pPr>
               <a:spcAft>
-                <a:spcPts val="800"/>
+                <a:spcPts val="1000"/>
               </a:spcAft>
             </a:pPr>
             <a:r>
-              <a:rPr sz="1800">
+              <a:rPr sz="2000">
                 <a:solidFill>
                   <a:srgbClr val="333333"/>
                 </a:solidFill>
                 <a:latin typeface="Calibri"/>
               </a:rPr>
-              <a:t>•  Chain scoring for trigger assistance: criteria AUC 0.90 / 0.78 (realistic); scorer training ready, needs GPU</a:t>
+              <a:t>    –  resolution: lower aux weights — mom 0.2, struct 0.3</a:t>
+            </a:r>
+          </a:p>
+          <a:p>
+            <a:pPr>
+              <a:spcAft>
+                <a:spcPts val="1000"/>
+              </a:spcAft>
+            </a:pPr>
+            <a:r>
+              <a:rPr sz="2200">
+                <a:solidFill>
+                  <a:srgbClr val="333333"/>
+                </a:solidFill>
+                <a:latin typeface="Calibri"/>
+              </a:rPr>
+              <a:t>•  Lessons: train/infer graph mismatch is fatal; gradient balance between heads must be explicit</a:t>
             </a:r>
           </a:p>
         </p:txBody>
@@ -3541,13 +3558,13 @@
           <a:lstStyle/>
           <a:p>
             <a:r>
-              <a:rPr sz="3400" b="1">
+              <a:rPr sz="3800" b="1">
                 <a:solidFill>
                   <a:srgbClr val="1F4E79"/>
                 </a:solidFill>
                 <a:latin typeface="Calibri"/>
               </a:rPr>
-              <a:t>Next Steps and Open Questions</a:t>
+              <a:t>Part 4 — Ongoing Attempts</a:t>
             </a:r>
           </a:p>
         </p:txBody>
@@ -3560,7 +3577,7 @@
         </p:nvSpPr>
         <p:spPr>
           <a:xfrm>
-            <a:off x="548640" y="1143000"/>
+            <a:off x="548640" y="1188720"/>
             <a:ext cx="11064240" cy="38100"/>
           </a:xfrm>
           <a:prstGeom prst="rect">
@@ -3604,7 +3621,7 @@
         <p:spPr>
           <a:xfrm>
             <a:off x="731520" y="1280160"/>
-            <a:ext cx="10789920" cy="4937760"/>
+            <a:ext cx="10789920" cy="5120640"/>
           </a:xfrm>
           <a:prstGeom prst="rect">
             <a:avLst/>
@@ -3619,91 +3636,323 @@
           <a:p>
             <a:pPr>
               <a:spcAft>
-                <a:spcPts val="800"/>
+                <a:spcPts val="1000"/>
               </a:spcAft>
             </a:pPr>
             <a:r>
-              <a:rPr sz="1800">
+              <a:rPr sz="2200">
                 <a:solidFill>
                   <a:srgbClr val="333333"/>
                 </a:solidFill>
                 <a:latin typeface="Calibri"/>
               </a:rPr>
-              <a:t>•  Resume the wider-latent training to 150 ep; layer struct + mom at reduced weights</a:t>
+              <a:t>•  Wider latent space (v53): tracks nodes 32-dim, tt edges 24-dim — 16-dim sits at the physical-DOF lower bound</a:t>
             </a:r>
           </a:p>
           <a:p>
             <a:pPr>
               <a:spcAft>
-                <a:spcPts val="800"/>
+                <a:spcPts val="1000"/>
               </a:spcAft>
             </a:pPr>
             <a:r>
-              <a:rPr sz="1800">
+              <a:rPr sz="2000">
                 <a:solidFill>
                   <a:srgbClr val="333333"/>
                 </a:solidFill>
                 <a:latin typeface="Calibri"/>
               </a:rPr>
-              <a:t>•  Run queued evaluations; train the chain scorer; plug GNN affinity into learned DA</a:t>
+              <a:t>    –  from-scratch training interrupted at ep74/150, not converged; resume planned</a:t>
             </a:r>
           </a:p>
           <a:p>
             <a:pPr>
               <a:spcAft>
-                <a:spcPts val="800"/>
+                <a:spcPts val="1000"/>
               </a:spcAft>
             </a:pPr>
             <a:r>
-              <a:rPr sz="1800">
+              <a:rPr sz="2200">
                 <a:solidFill>
                   <a:srgbClr val="333333"/>
                 </a:solidFill>
                 <a:latin typeface="Calibri"/>
               </a:rPr>
-              <a:t>•  Open questions:</a:t>
+              <a:t>•  Public-data verification (v45/v49): no PID, class2/3 counts differ 4-14×; resume best val 33.4 @ep73</a:t>
             </a:r>
           </a:p>
           <a:p>
             <a:pPr>
               <a:spcAft>
-                <a:spcPts val="800"/>
+                <a:spcPts val="1000"/>
               </a:spcAft>
             </a:pPr>
             <a:r>
-              <a:rPr sz="1600">
+              <a:rPr sz="2200">
                 <a:solidFill>
                   <a:srgbClr val="333333"/>
                 </a:solidFill>
                 <a:latin typeface="Calibri"/>
               </a:rPr>
-              <a:t>    –  trigger assistance vs full-event reconstruction — which metric would the collaboration trust?</a:t>
+              <a:t>•  Learned deterministic annealing: inference-side PV clustering with learned affinity (no subgraph training); core module CPU-verified</a:t>
             </a:r>
           </a:p>
           <a:p>
             <a:pPr>
               <a:spcAft>
-                <a:spcPts val="800"/>
+                <a:spcPts val="1000"/>
               </a:spcAft>
             </a:pPr>
             <a:r>
-              <a:rPr sz="1600">
+              <a:rPr sz="2200">
                 <a:solidFill>
                   <a:srgbClr val="333333"/>
                 </a:solidFill>
                 <a:latin typeface="Calibri"/>
               </a:rPr>
-              <a:t>    –  is same-source (class2) clustering the real problem DFEI should solve?</a:t>
-            </a:r>
-          </a:p>
+              <a:t>•  Chain scoring for trigger assistance: criteria AUC 0.90 / 0.78 (realistic); training ready, needs GPU</a:t>
+            </a:r>
+          </a:p>
+        </p:txBody>
+      </p:sp>
+    </p:spTree>
+  </p:cSld>
+  <p:clrMapOvr>
+    <a:masterClrMapping/>
+  </p:clrMapOvr>
+</p:sld>
+</file>
+
+<file path=ppt/slides/slide12.xml><?xml version="1.0" encoding="utf-8"?>
+<p:sld xmlns:a="http://schemas.openxmlformats.org/drawingml/2006/main" xmlns:p="http://schemas.openxmlformats.org/presentationml/2006/main" xmlns:r="http://schemas.openxmlformats.org/officeDocument/2006/relationships">
+  <p:cSld>
+    <p:spTree>
+      <p:nvGrpSpPr>
+        <p:cNvPr id="1" name=""/>
+        <p:cNvGrpSpPr/>
+        <p:nvPr/>
+      </p:nvGrpSpPr>
+      <p:grpSpPr/>
+      <p:sp>
+        <p:nvSpPr>
+          <p:cNvPr id="2" name="TextBox 1"/>
+          <p:cNvSpPr txBox="1"/>
+          <p:nvPr/>
+        </p:nvSpPr>
+        <p:spPr>
+          <a:xfrm>
+            <a:off x="502920" y="6510528"/>
+            <a:ext cx="11155680" cy="274320"/>
+          </a:xfrm>
+          <a:prstGeom prst="rect">
+            <a:avLst/>
+          </a:prstGeom>
+          <a:noFill/>
+        </p:spPr>
+        <p:txBody>
+          <a:bodyPr wrap="none">
+            <a:spAutoFit/>
+          </a:bodyPr>
+          <a:lstStyle/>
+          <a:p>
+            <a:r>
+              <a:rPr sz="1000">
+                <a:solidFill>
+                  <a:srgbClr val="666666"/>
+                </a:solidFill>
+                <a:latin typeface="Calibri"/>
+              </a:rPr>
+              <a:t>Qingxiang Guo · UCAS · DFEI group meeting      12</a:t>
+            </a:r>
+          </a:p>
+        </p:txBody>
+      </p:sp>
+      <p:sp>
+        <p:nvSpPr>
+          <p:cNvPr id="3" name="TextBox 2"/>
+          <p:cNvSpPr txBox="1"/>
+          <p:nvPr/>
+        </p:nvSpPr>
+        <p:spPr>
+          <a:xfrm>
+            <a:off x="502920" y="164592"/>
+            <a:ext cx="11155680" cy="914400"/>
+          </a:xfrm>
+          <a:prstGeom prst="rect">
+            <a:avLst/>
+          </a:prstGeom>
+          <a:noFill/>
+        </p:spPr>
+        <p:txBody>
+          <a:bodyPr wrap="square">
+            <a:spAutoFit/>
+          </a:bodyPr>
+          <a:lstStyle/>
+          <a:p>
+            <a:r>
+              <a:rPr sz="3800" b="1">
+                <a:solidFill>
+                  <a:srgbClr val="1F4E79"/>
+                </a:solidFill>
+                <a:latin typeface="Calibri"/>
+              </a:rPr>
+              <a:t>Next Steps and Open Questions</a:t>
+            </a:r>
+          </a:p>
+        </p:txBody>
+      </p:sp>
+      <p:sp>
+        <p:nvSpPr>
+          <p:cNvPr id="4" name="Rectangle 3"/>
+          <p:cNvSpPr/>
+          <p:nvPr/>
+        </p:nvSpPr>
+        <p:spPr>
+          <a:xfrm>
+            <a:off x="548640" y="1188720"/>
+            <a:ext cx="11064240" cy="38100"/>
+          </a:xfrm>
+          <a:prstGeom prst="rect">
+            <a:avLst/>
+          </a:prstGeom>
+          <a:solidFill>
+            <a:srgbClr val="1F4E79"/>
+          </a:solidFill>
+          <a:ln>
+            <a:noFill/>
+          </a:ln>
+        </p:spPr>
+        <p:style>
+          <a:lnRef idx="1">
+            <a:schemeClr val="accent1"/>
+          </a:lnRef>
+          <a:fillRef idx="3">
+            <a:schemeClr val="accent1"/>
+          </a:fillRef>
+          <a:effectRef idx="2">
+            <a:schemeClr val="accent1"/>
+          </a:effectRef>
+          <a:fontRef idx="minor">
+            <a:schemeClr val="lt1"/>
+          </a:fontRef>
+        </p:style>
+        <p:txBody>
+          <a:bodyPr rtlCol="0" anchor="ctr"/>
+          <a:lstStyle/>
+          <a:p>
+            <a:pPr algn="ctr"/>
+          </a:p>
+        </p:txBody>
+      </p:sp>
+      <p:sp>
+        <p:nvSpPr>
+          <p:cNvPr id="5" name="TextBox 4"/>
+          <p:cNvSpPr txBox="1"/>
+          <p:nvPr/>
+        </p:nvSpPr>
+        <p:spPr>
+          <a:xfrm>
+            <a:off x="731520" y="1280160"/>
+            <a:ext cx="10789920" cy="4937760"/>
+          </a:xfrm>
+          <a:prstGeom prst="rect">
+            <a:avLst/>
+          </a:prstGeom>
+          <a:noFill/>
+        </p:spPr>
+        <p:txBody>
+          <a:bodyPr wrap="square">
+            <a:spAutoFit/>
+          </a:bodyPr>
+          <a:lstStyle/>
           <a:p>
             <a:pPr>
               <a:spcAft>
-                <a:spcPts val="800"/>
+                <a:spcPts val="1000"/>
               </a:spcAft>
             </a:pPr>
             <a:r>
-              <a:rPr sz="1600">
+              <a:rPr sz="2200">
+                <a:solidFill>
+                  <a:srgbClr val="333333"/>
+                </a:solidFill>
+                <a:latin typeface="Calibri"/>
+              </a:rPr>
+              <a:t>•  Resume the wider-latent training to 150 ep; layer struct + mom at reduced weights</a:t>
+            </a:r>
+          </a:p>
+          <a:p>
+            <a:pPr>
+              <a:spcAft>
+                <a:spcPts val="1000"/>
+              </a:spcAft>
+            </a:pPr>
+            <a:r>
+              <a:rPr sz="2200">
+                <a:solidFill>
+                  <a:srgbClr val="333333"/>
+                </a:solidFill>
+                <a:latin typeface="Calibri"/>
+              </a:rPr>
+              <a:t>•  Run queued evaluations; train the chain scorer; plug GNN affinity into learned DA</a:t>
+            </a:r>
+          </a:p>
+          <a:p>
+            <a:pPr>
+              <a:spcAft>
+                <a:spcPts val="1000"/>
+              </a:spcAft>
+            </a:pPr>
+            <a:r>
+              <a:rPr sz="2200">
+                <a:solidFill>
+                  <a:srgbClr val="333333"/>
+                </a:solidFill>
+                <a:latin typeface="Calibri"/>
+              </a:rPr>
+              <a:t>•  Open questions:</a:t>
+            </a:r>
+          </a:p>
+          <a:p>
+            <a:pPr>
+              <a:spcAft>
+                <a:spcPts val="1000"/>
+              </a:spcAft>
+            </a:pPr>
+            <a:r>
+              <a:rPr sz="2000">
+                <a:solidFill>
+                  <a:srgbClr val="333333"/>
+                </a:solidFill>
+                <a:latin typeface="Calibri"/>
+              </a:rPr>
+              <a:t>    –  trigger assistance vs full-event reconstruction — which metric would the collaboration trust?</a:t>
+            </a:r>
+          </a:p>
+          <a:p>
+            <a:pPr>
+              <a:spcAft>
+                <a:spcPts val="1000"/>
+              </a:spcAft>
+            </a:pPr>
+            <a:r>
+              <a:rPr sz="2000">
+                <a:solidFill>
+                  <a:srgbClr val="333333"/>
+                </a:solidFill>
+                <a:latin typeface="Calibri"/>
+              </a:rPr>
+              <a:t>    –  is same-source (class2) clustering the real problem DFEI should solve?</a:t>
+            </a:r>
+          </a:p>
+          <a:p>
+            <a:pPr>
+              <a:spcAft>
+                <a:spcPts val="1000"/>
+              </a:spcAft>
+            </a:pPr>
+            <a:r>
+              <a:rPr sz="2000">
                 <a:solidFill>
                   <a:srgbClr val="333333"/>
                 </a:solidFill>
@@ -3789,7 +4038,7 @@
           <a:lstStyle/>
           <a:p>
             <a:r>
-              <a:rPr sz="3400" b="1">
+              <a:rPr sz="3800" b="1">
                 <a:solidFill>
                   <a:srgbClr val="1F4E79"/>
                 </a:solidFill>
@@ -3800,13 +4049,13 @@
           </a:p>
           <a:p>
             <a:r>
-              <a:rPr sz="1600">
+              <a:rPr sz="1700">
                 <a:solidFill>
                   <a:srgbClr val="666666"/>
                 </a:solidFill>
                 <a:latin typeface="Calibri"/>
               </a:rPr>
-              <a:t>CERN official MC: /eos/lhcb/user/y/yukaiz/DFEI_IFT_20260702 · threshold 0.9 · 20 test files</a:t>
+              <a:t>CERN MC: /eos/lhcb/user/y/yukaiz/DFEI_IFT_20260702 · threshold 0.9 · 20 test files</a:t>
             </a:r>
           </a:p>
         </p:txBody>
@@ -3819,7 +4068,7 @@
         </p:nvSpPr>
         <p:spPr>
           <a:xfrm>
-            <a:off x="548640" y="1143000"/>
+            <a:off x="548640" y="1188720"/>
             <a:ext cx="11064240" cy="38100"/>
           </a:xfrm>
           <a:prstGeom prst="rect">
@@ -3862,8 +4111,8 @@
         </p:nvSpPr>
         <p:spPr>
           <a:xfrm>
-            <a:off x="731520" y="1280160"/>
-            <a:ext cx="10789920" cy="2011680"/>
+            <a:off x="731520" y="1371600"/>
+            <a:ext cx="10789920" cy="1828800"/>
           </a:xfrm>
           <a:prstGeom prst="rect">
             <a:avLst/>
@@ -3878,43 +4127,43 @@
           <a:p>
             <a:pPr>
               <a:spcAft>
-                <a:spcPts val="800"/>
+                <a:spcPts val="1000"/>
               </a:spcAft>
             </a:pPr>
             <a:r>
-              <a:rPr sz="1800">
+              <a:rPr sz="2200">
                 <a:solidFill>
                   <a:srgbClr val="333333"/>
                 </a:solidFill>
                 <a:latin typeface="Calibri"/>
               </a:rPr>
-              <a:t>•  All optimization work in this report is carried out on the CERN official Monte Carlo production (DFEI_IFT_20260702)</a:t>
+              <a:t>•  All work uses the CERN official Monte Carlo production (DFEI_IFT_20260702)</a:t>
             </a:r>
           </a:p>
           <a:p>
             <a:pPr>
               <a:spcAft>
-                <a:spcPts val="800"/>
+                <a:spcPts val="1000"/>
               </a:spcAft>
             </a:pPr>
             <a:r>
-              <a:rPr sz="1800">
+              <a:rPr sz="2200">
                 <a:solidFill>
                   <a:srgbClr val="333333"/>
                 </a:solidFill>
                 <a:latin typeface="Calibri"/>
               </a:rPr>
-              <a:t>•  Since fixing a silent class-weight bug, the optimization line has raised</a:t>
+              <a:t>•  Since fixing a silent class-weight bug, the line has raised</a:t>
             </a:r>
           </a:p>
           <a:p>
             <a:pPr>
               <a:spcAft>
-                <a:spcPts val="800"/>
+                <a:spcPts val="1000"/>
               </a:spcAft>
             </a:pPr>
             <a:r>
-              <a:rPr sz="1600">
+              <a:rPr sz="2000">
                 <a:solidFill>
                   <a:srgbClr val="333333"/>
                 </a:solidFill>
@@ -3926,11 +4175,11 @@
           <a:p>
             <a:pPr>
               <a:spcAft>
-                <a:spcPts val="800"/>
+                <a:spcPts val="1000"/>
               </a:spcAft>
             </a:pPr>
             <a:r>
-              <a:rPr sz="1600">
+              <a:rPr sz="2000">
                 <a:solidFill>
                   <a:srgbClr val="333333"/>
                 </a:solidFill>
@@ -3957,7 +4206,7 @@
         </p:blipFill>
         <p:spPr>
           <a:xfrm>
-            <a:off x="1097280" y="3200400"/>
+            <a:off x="1097280" y="3108960"/>
             <a:ext cx="9966960" cy="6047160"/>
           </a:xfrm>
           <a:prstGeom prst="rect">
@@ -4040,7 +4289,7 @@
           <a:lstStyle/>
           <a:p>
             <a:r>
-              <a:rPr sz="3400" b="1">
+              <a:rPr sz="3800" b="1">
                 <a:solidFill>
                   <a:srgbClr val="1F4E79"/>
                 </a:solidFill>
@@ -4051,7 +4300,7 @@
           </a:p>
           <a:p>
             <a:r>
-              <a:rPr sz="1600">
+              <a:rPr sz="1700">
                 <a:solidFill>
                   <a:srgbClr val="666666"/>
                 </a:solidFill>
@@ -4070,7 +4319,7 @@
         </p:nvSpPr>
         <p:spPr>
           <a:xfrm>
-            <a:off x="548640" y="1143000"/>
+            <a:off x="548640" y="1188720"/>
             <a:ext cx="11064240" cy="38100"/>
           </a:xfrm>
           <a:prstGeom prst="rect">
@@ -4129,59 +4378,75 @@
           <a:p>
             <a:pPr>
               <a:spcAft>
-                <a:spcPts val="800"/>
+                <a:spcPts val="1000"/>
               </a:spcAft>
             </a:pPr>
             <a:r>
-              <a:rPr sz="2000">
+              <a:rPr sz="2400">
                 <a:solidFill>
                   <a:srgbClr val="333333"/>
                 </a:solidFill>
                 <a:latin typeface="Calibri"/>
               </a:rPr>
-              <a:t>•  Part 1 — Making the supervision signal actually effective</a:t>
+              <a:t>•  Part 1 — Supervision and training–inference alignment</a:t>
             </a:r>
           </a:p>
           <a:p>
             <a:pPr>
               <a:spcAft>
-                <a:spcPts val="800"/>
+                <a:spcPts val="1000"/>
               </a:spcAft>
             </a:pPr>
             <a:r>
-              <a:rPr sz="2000">
+              <a:rPr sz="2200">
                 <a:solidFill>
                   <a:srgbClr val="333333"/>
                 </a:solidFill>
                 <a:latin typeface="Calibri"/>
               </a:rPr>
-              <a:t>•  Part 2 — Supervising the representations with physical / structural quantities</a:t>
+              <a:t>    –  differentiable pruning with annealing · class-2 weighting · in-chain LCA consistency</a:t>
             </a:r>
           </a:p>
           <a:p>
             <a:pPr>
               <a:spcAft>
-                <a:spcPts val="800"/>
+                <a:spcPts val="1000"/>
               </a:spcAft>
             </a:pPr>
             <a:r>
-              <a:rPr sz="2000">
+              <a:rPr sz="2400">
                 <a:solidFill>
                   <a:srgbClr val="333333"/>
                 </a:solidFill>
                 <a:latin typeface="Calibri"/>
               </a:rPr>
-              <a:t>•  Part 3 — Controlled failures and their lessons</a:t>
+              <a:t>•  Part 2 — Supervising representations with physics (source / mass / struct / mom heads)</a:t>
             </a:r>
           </a:p>
           <a:p>
             <a:pPr>
               <a:spcAft>
-                <a:spcPts val="800"/>
+                <a:spcPts val="1000"/>
               </a:spcAft>
             </a:pPr>
             <a:r>
-              <a:rPr sz="2000">
+              <a:rPr sz="2400">
+                <a:solidFill>
+                  <a:srgbClr val="333333"/>
+                </a:solidFill>
+                <a:latin typeface="Calibri"/>
+              </a:rPr>
+              <a:t>•  Part 3 — Controlled failures and their lessons</a:t>
+            </a:r>
+          </a:p>
+          <a:p>
+            <a:pPr>
+              <a:spcAft>
+                <a:spcPts val="1000"/>
+              </a:spcAft>
+            </a:pPr>
+            <a:r>
+              <a:rPr sz="2400">
                 <a:solidFill>
                   <a:srgbClr val="333333"/>
                 </a:solidFill>
@@ -4267,24 +4532,24 @@
           <a:lstStyle/>
           <a:p>
             <a:r>
-              <a:rPr sz="3400" b="1">
+              <a:rPr sz="3800" b="1">
                 <a:solidFill>
                   <a:srgbClr val="1F4E79"/>
                 </a:solidFill>
                 <a:latin typeface="Calibri"/>
               </a:rPr>
-              <a:t>Part 1 — Making the Supervision Signal Effective</a:t>
-            </a:r>
-          </a:p>
-          <a:p>
-            <a:r>
-              <a:rPr sz="1600">
+              <a:t>Part 1 — Differentiable Pruning with Annealing</a:t>
+            </a:r>
+          </a:p>
+          <a:p>
+            <a:r>
+              <a:rPr sz="1700">
                 <a:solidFill>
                   <a:srgbClr val="666666"/>
                 </a:solidFill>
                 <a:latin typeface="Calibri"/>
               </a:rPr>
-              <a:t>Fix the silent failure, align training with inference</a:t>
+              <a:t>Align training with the pruned graphs seen at inference</a:t>
             </a:r>
           </a:p>
         </p:txBody>
@@ -4297,7 +4562,7 @@
         </p:nvSpPr>
         <p:spPr>
           <a:xfrm>
-            <a:off x="548640" y="1143000"/>
+            <a:off x="548640" y="1188720"/>
             <a:ext cx="11064240" cy="38100"/>
           </a:xfrm>
           <a:prstGeom prst="rect">
@@ -4356,129 +4621,113 @@
           <a:p>
             <a:pPr>
               <a:spcAft>
-                <a:spcPts val="800"/>
+                <a:spcPts val="1000"/>
               </a:spcAft>
             </a:pPr>
             <a:r>
-              <a:rPr sz="1800">
+              <a:rPr sz="2200">
                 <a:solidFill>
                   <a:srgbClr val="333333"/>
                 </a:solidFill>
                 <a:latin typeface="Calibri"/>
               </a:rPr>
-              <a:t>•  Class-weight bug: config key LCA__weights (double underscore) never reached the loss → class1 ≈ 0%</a:t>
+              <a:t>•  Problem: training optimizes the full graph; inference prunes nodes/edges with hard thresholds first</a:t>
             </a:r>
           </a:p>
           <a:p>
             <a:pPr>
               <a:spcAft>
-                <a:spcPts val="800"/>
+                <a:spcPts val="1000"/>
               </a:spcAft>
             </a:pPr>
             <a:r>
-              <a:rPr sz="1600">
+              <a:rPr sz="2200">
                 <a:solidFill>
                   <a:srgbClr val="333333"/>
                 </a:solidFill>
                 <a:latin typeface="Calibri"/>
               </a:rPr>
-              <a:t>    –  fix → v31 baseline: PerfectReco 23.9%</a:t>
+              <a:t>•  Solution: a soft mask on the weights, w_eff = w · σ((w − cut)/τ)</a:t>
             </a:r>
           </a:p>
           <a:p>
             <a:pPr>
               <a:spcAft>
-                <a:spcPts val="800"/>
+                <a:spcPts val="1000"/>
               </a:spcAft>
             </a:pPr>
             <a:r>
-              <a:rPr sz="1800">
+              <a:rPr sz="2200">
                 <a:solidFill>
                   <a:srgbClr val="333333"/>
                 </a:solidFill>
                 <a:latin typeface="Calibri"/>
               </a:rPr>
-              <a:t>•  Differentiable pruning: soft mask w·σ((w−cut)/τ), τ annealed 1.0→0.1, cut aligned to inference (0.5→0.85)</a:t>
+              <a:t>•  Temperature τ annealed 1.0 → 0.1 over training:</a:t>
             </a:r>
           </a:p>
           <a:p>
             <a:pPr>
               <a:spcAft>
-                <a:spcPts val="800"/>
+                <a:spcPts val="1000"/>
               </a:spcAft>
             </a:pPr>
             <a:r>
-              <a:rPr sz="1600">
+              <a:rPr sz="2000">
                 <a:solidFill>
                   <a:srgbClr val="333333"/>
                 </a:solidFill>
                 <a:latin typeface="Calibri"/>
               </a:rPr>
-              <a:t>    –  trains the model on the same pruned graphs that inference sees</a:t>
+              <a:t>    –  large τ → smooth mask and stable gradients</a:t>
             </a:r>
           </a:p>
           <a:p>
             <a:pPr>
               <a:spcAft>
-                <a:spcPts val="800"/>
+                <a:spcPts val="1000"/>
               </a:spcAft>
             </a:pPr>
             <a:r>
-              <a:rPr sz="1800">
+              <a:rPr sz="2000">
                 <a:solidFill>
                   <a:srgbClr val="333333"/>
                 </a:solidFill>
                 <a:latin typeface="Calibri"/>
               </a:rPr>
-              <a:t>•  Class-2 (same-mother) weighting, settled at 2.0</a:t>
+              <a:t>    –  small τ → approximates the hard threshold at the end</a:t>
             </a:r>
           </a:p>
           <a:p>
             <a:pPr>
               <a:spcAft>
-                <a:spcPts val="800"/>
+                <a:spcPts val="1000"/>
               </a:spcAft>
             </a:pPr>
             <a:r>
-              <a:rPr sz="1800">
+              <a:rPr sz="2200">
                 <a:solidFill>
                   <a:srgbClr val="333333"/>
                 </a:solidFill>
                 <a:latin typeface="Calibri"/>
               </a:rPr>
-              <a:t>•  In-chain LCA consistency: hinge + direct cross-entropy on truth-chain edges only</a:t>
+              <a:t>•  Pruning cut aligned to inference and tightened over versions:</a:t>
             </a:r>
           </a:p>
           <a:p>
             <a:pPr>
               <a:spcAft>
-                <a:spcPts val="800"/>
+                <a:spcPts val="1000"/>
               </a:spcAft>
             </a:pPr>
             <a:r>
-              <a:rPr sz="1600">
+              <a:rPr sz="2000">
                 <a:solidFill>
                   <a:srgbClr val="333333"/>
                 </a:solidFill>
                 <a:latin typeface="Calibri"/>
               </a:rPr>
-              <a:t>    –  structural edges are ~0.1% of all edges — without direct CE, class0 dilutes them</a:t>
-            </a:r>
-          </a:p>
-          <a:p>
-            <a:pPr>
-              <a:spcAft>
-                <a:spcPts val="800"/>
-              </a:spcAft>
-            </a:pPr>
-            <a:r>
-              <a:rPr sz="1800">
-                <a:solidFill>
-                  <a:srgbClr val="333333"/>
-                </a:solidFill>
-                <a:latin typeface="Calibri"/>
-              </a:rPr>
-              <a:t>•  Net: PerfectReco 23.9% → 29.3% (v31 → v38)</a:t>
+              <a:t>    –  0.5 (v36) → 0.7 (v37) → 0.85 (v38), converging to the 0.9 inference threshold</a:t>
             </a:r>
           </a:p>
         </p:txBody>
@@ -4558,24 +4807,24 @@
           <a:lstStyle/>
           <a:p>
             <a:r>
-              <a:rPr sz="3400" b="1">
+              <a:rPr sz="3800" b="1">
                 <a:solidFill>
                   <a:srgbClr val="1F4E79"/>
                 </a:solidFill>
                 <a:latin typeface="Calibri"/>
               </a:rPr>
-              <a:t>Part 2 — Supervising Representations with Physics</a:t>
-            </a:r>
-          </a:p>
-          <a:p>
-            <a:r>
-              <a:rPr sz="1600">
+              <a:t>Part 1 — LCA Supervision Adjustment</a:t>
+            </a:r>
+          </a:p>
+          <a:p>
+            <a:r>
+              <a:rPr sz="1700">
                 <a:solidFill>
                   <a:srgbClr val="666666"/>
                 </a:solidFill>
                 <a:latin typeface="Calibri"/>
               </a:rPr>
-              <a:t>A common idea behind several heads</a:t>
+              <a:t>Class-2 weighting and in-chain consistency, refined by experiments</a:t>
             </a:r>
           </a:p>
         </p:txBody>
@@ -4588,7 +4837,7 @@
         </p:nvSpPr>
         <p:spPr>
           <a:xfrm>
-            <a:off x="548640" y="1143000"/>
+            <a:off x="548640" y="1188720"/>
             <a:ext cx="11064240" cy="38100"/>
           </a:xfrm>
           <a:prstGeom prst="rect">
@@ -4632,7 +4881,7 @@
         <p:spPr>
           <a:xfrm>
             <a:off x="731520" y="1280160"/>
-            <a:ext cx="10789920" cy="4937760"/>
+            <a:ext cx="10789920" cy="5120640"/>
           </a:xfrm>
           <a:prstGeom prst="rect">
             <a:avLst/>
@@ -4647,113 +4896,97 @@
           <a:p>
             <a:pPr>
               <a:spcAft>
-                <a:spcPts val="800"/>
+                <a:spcPts val="1000"/>
               </a:spcAft>
             </a:pPr>
             <a:r>
-              <a:rPr sz="1800">
+              <a:rPr sz="2200">
                 <a:solidFill>
                   <a:srgbClr val="333333"/>
                 </a:solidFill>
                 <a:latin typeface="Calibri"/>
               </a:rPr>
-              <a:t>•  Idea: physical / structural quantities are data-intrinsic; supervise the representation with them, keep the model end-to-end</a:t>
+              <a:t>•  Class-2 (same-mother) edges are the structural bottleneck:</a:t>
             </a:r>
           </a:p>
           <a:p>
             <a:pPr>
               <a:spcAft>
-                <a:spcPts val="800"/>
+                <a:spcPts val="1000"/>
               </a:spcAft>
             </a:pPr>
             <a:r>
-              <a:rPr sz="1800">
+              <a:rPr sz="2000">
                 <a:solidFill>
                   <a:srgbClr val="333333"/>
                 </a:solidFill>
                 <a:latin typeface="Calibri"/>
               </a:rPr>
-              <a:t>•  Several heads share this theme:</a:t>
+              <a:t>    –  weight 3.0 (v37) over-weighted → class1 dropped; settled at 2.0 (v38)</a:t>
             </a:r>
           </a:p>
           <a:p>
             <a:pPr>
               <a:spcAft>
-                <a:spcPts val="800"/>
+                <a:spcPts val="1000"/>
               </a:spcAft>
             </a:pPr>
             <a:r>
-              <a:rPr sz="1600">
+              <a:rPr sz="2200">
                 <a:solidFill>
                   <a:srgbClr val="333333"/>
                 </a:solidFill>
                 <a:latin typeface="Calibri"/>
               </a:rPr>
-              <a:t>    –  source head (Rumor-Centrality root) — added early, same idea</a:t>
+              <a:t>•  In-chain LCA consistency, supervised only on truth-chain edges:</a:t>
             </a:r>
           </a:p>
           <a:p>
             <a:pPr>
               <a:spcAft>
-                <a:spcPts val="800"/>
+                <a:spcPts val="1000"/>
               </a:spcAft>
             </a:pPr>
             <a:r>
-              <a:rPr sz="1600">
+              <a:rPr sz="2000">
                 <a:solidFill>
                   <a:srgbClr val="333333"/>
                 </a:solidFill>
                 <a:latin typeface="Calibri"/>
               </a:rPr>
-              <a:t>    –  mass head — edge-level log10(m_ππ)</a:t>
+              <a:t>    –  v37: hinge loss — keep chain edges confident (margin 0.3)</a:t>
             </a:r>
           </a:p>
           <a:p>
             <a:pPr>
               <a:spcAft>
-                <a:spcPts val="800"/>
+                <a:spcPts val="1000"/>
               </a:spcAft>
             </a:pPr>
             <a:r>
-              <a:rPr sz="1600">
+              <a:rPr sz="2000">
                 <a:solidFill>
                   <a:srgbClr val="333333"/>
                 </a:solidFill>
                 <a:latin typeface="Calibri"/>
               </a:rPr>
-              <a:t>    –  structure head — node depth + RC value</a:t>
+              <a:t>    –  v38: + cross-entropy on chain-edge classes — structural edges are ~0.1% of all edges; direct CE prevents class0 dilution</a:t>
             </a:r>
           </a:p>
           <a:p>
             <a:pPr>
               <a:spcAft>
-                <a:spcPts val="800"/>
+                <a:spcPts val="1000"/>
               </a:spcAft>
             </a:pPr>
             <a:r>
-              <a:rPr sz="1600">
+              <a:rPr sz="2200">
                 <a:solidFill>
                   <a:srgbClr val="333333"/>
                 </a:solidFill>
                 <a:latin typeface="Calibri"/>
               </a:rPr>
-              <a:t>    –  momentum head — node normalized momentum</a:t>
-            </a:r>
-          </a:p>
-          <a:p>
-            <a:pPr>
-              <a:spcAft>
-                <a:spcPts val="800"/>
-              </a:spcAft>
-            </a:pPr>
-            <a:r>
-              <a:rPr sz="1800">
-                <a:solidFill>
-                  <a:srgbClr val="333333"/>
-                </a:solidFill>
-                <a:latin typeface="Calibri"/>
-              </a:rPr>
-              <a:t>•  Verification: linear probes (PhyIP-style) on the frozen backbone</a:t>
+              <a:t>•  Net effect of Part 1 (v31 → v38): PerfectReco 23.9% → 29.3%</a:t>
             </a:r>
           </a:p>
         </p:txBody>
@@ -4833,24 +5066,24 @@
           <a:lstStyle/>
           <a:p>
             <a:r>
-              <a:rPr sz="3400" b="1">
+              <a:rPr sz="3800" b="1">
                 <a:solidFill>
                   <a:srgbClr val="1F4E79"/>
                 </a:solidFill>
                 <a:latin typeface="Calibri"/>
               </a:rPr>
-              <a:t>The Mass Head: Main Result</a:t>
-            </a:r>
-          </a:p>
-          <a:p>
-            <a:r>
-              <a:rPr sz="1600">
+              <a:t>Part 2 — Supervising Representations with Physics</a:t>
+            </a:r>
+          </a:p>
+          <a:p>
+            <a:r>
+              <a:rPr sz="1700">
                 <a:solidFill>
                   <a:srgbClr val="666666"/>
                 </a:solidFill>
                 <a:latin typeface="Calibri"/>
               </a:rPr>
-              <a:t>Edge-level regression of log10(m_ππ)</a:t>
+              <a:t>One common idea behind several heads</a:t>
             </a:r>
           </a:p>
         </p:txBody>
@@ -4863,7 +5096,7 @@
         </p:nvSpPr>
         <p:spPr>
           <a:xfrm>
-            <a:off x="548640" y="1143000"/>
+            <a:off x="548640" y="1188720"/>
             <a:ext cx="11064240" cy="38100"/>
           </a:xfrm>
           <a:prstGeom prst="rect">
@@ -4906,8 +5139,8 @@
         </p:nvSpPr>
         <p:spPr>
           <a:xfrm>
-            <a:off x="731520" y="1188720"/>
-            <a:ext cx="6035040" cy="5120640"/>
+            <a:off x="731520" y="1280160"/>
+            <a:ext cx="10789920" cy="4937760"/>
           </a:xfrm>
           <a:prstGeom prst="rect">
             <a:avLst/>
@@ -4922,125 +5155,117 @@
           <a:p>
             <a:pPr>
               <a:spcAft>
-                <a:spcPts val="800"/>
+                <a:spcPts val="1000"/>
               </a:spcAft>
             </a:pPr>
             <a:r>
-              <a:rPr sz="1800">
+              <a:rPr sz="2200">
                 <a:solidFill>
                   <a:srgbClr val="333333"/>
                 </a:solidFill>
                 <a:latin typeface="Calibri"/>
               </a:rPr>
-              <a:t>•  Same-mother track pairs sit near resonance masses → the edge representation must encode sister relations</a:t>
+              <a:t>•  Idea: physical / structural quantities are data-intrinsic; supervise the representation with them, keeping the model end-to-end</a:t>
             </a:r>
           </a:p>
           <a:p>
             <a:pPr>
               <a:spcAft>
-                <a:spcPts val="800"/>
+                <a:spcPts val="1000"/>
               </a:spcAft>
             </a:pPr>
             <a:r>
-              <a:rPr sz="1800">
+              <a:rPr sz="2200">
                 <a:solidFill>
                   <a:srgbClr val="333333"/>
                 </a:solidFill>
                 <a:latin typeface="Calibri"/>
               </a:rPr>
-              <a:t>•  Setup: SmoothL1 on log10(m_MeV), sentinel edges masked, weight 1.0</a:t>
+              <a:t>•  Heads sharing this theme:</a:t>
             </a:r>
           </a:p>
           <a:p>
             <a:pPr>
               <a:spcAft>
-                <a:spcPts val="800"/>
+                <a:spcPts val="1000"/>
               </a:spcAft>
             </a:pPr>
             <a:r>
-              <a:rPr sz="1800">
+              <a:rPr sz="2000">
                 <a:solidFill>
                   <a:srgbClr val="333333"/>
                 </a:solidFill>
                 <a:latin typeface="Calibri"/>
               </a:rPr>
-              <a:t>•  v38 → masshead2 (20 test files):</a:t>
+              <a:t>    –  source head (v36) — Rumor-Centrality root; early instance of the same idea</a:t>
             </a:r>
           </a:p>
           <a:p>
             <a:pPr>
               <a:spcAft>
-                <a:spcPts val="800"/>
+                <a:spcPts val="1000"/>
               </a:spcAft>
             </a:pPr>
             <a:r>
-              <a:rPr sz="1600">
+              <a:rPr sz="2000">
                 <a:solidFill>
                   <a:srgbClr val="333333"/>
                 </a:solidFill>
                 <a:latin typeface="Calibri"/>
               </a:rPr>
-              <a:t>    –  PerfectReco 29.3% → 32.7%  (+3.4pp)</a:t>
+              <a:t>    –  mass head — edge-level log10(m_ππ)</a:t>
             </a:r>
           </a:p>
           <a:p>
             <a:pPr>
               <a:spcAft>
-                <a:spcPts val="800"/>
+                <a:spcPts val="1000"/>
               </a:spcAft>
             </a:pPr>
             <a:r>
-              <a:rPr sz="1600">
+              <a:rPr sz="2000">
                 <a:solidFill>
                   <a:srgbClr val="333333"/>
                 </a:solidFill>
                 <a:latin typeface="Calibri"/>
               </a:rPr>
-              <a:t>    –  AllParticles 52.1% → 55.9%  (+3.8pp)</a:t>
+              <a:t>    –  structure head — node depth + RC value</a:t>
             </a:r>
           </a:p>
           <a:p>
             <a:pPr>
               <a:spcAft>
-                <a:spcPts val="800"/>
+                <a:spcPts val="1000"/>
               </a:spcAft>
             </a:pPr>
             <a:r>
-              <a:rPr sz="1600">
+              <a:rPr sz="2000">
                 <a:solidFill>
                   <a:srgbClr val="333333"/>
                 </a:solidFill>
                 <a:latin typeface="Calibri"/>
               </a:rPr>
-              <a:t>    –  LCAG class2 44.7% → 51.1%  (+6.4pp)</a:t>
-            </a:r>
-          </a:p>
-        </p:txBody>
-      </p:sp>
-      <p:pic>
-        <p:nvPicPr>
-          <p:cNvPr id="6" name="Picture 5" descr="NN_edges_2_roc.png"/>
-          <p:cNvPicPr>
-            <a:picLocks noChangeAspect="1"/>
-          </p:cNvPicPr>
-          <p:nvPr/>
-        </p:nvPicPr>
-        <p:blipFill>
-          <a:blip r:embed="rId2"/>
-          <a:stretch>
-            <a:fillRect/>
-          </a:stretch>
-        </p:blipFill>
-        <p:spPr>
-          <a:xfrm>
-            <a:off x="6949440" y="1554480"/>
-            <a:ext cx="4754880" cy="3187931"/>
-          </a:xfrm>
-          <a:prstGeom prst="rect">
-            <a:avLst/>
-          </a:prstGeom>
-        </p:spPr>
-      </p:pic>
+              <a:t>    –  momentum head — node normalized momentum</a:t>
+            </a:r>
+          </a:p>
+          <a:p>
+            <a:pPr>
+              <a:spcAft>
+                <a:spcPts val="1000"/>
+              </a:spcAft>
+            </a:pPr>
+            <a:r>
+              <a:rPr sz="2200">
+                <a:solidFill>
+                  <a:srgbClr val="333333"/>
+                </a:solidFill>
+                <a:latin typeface="Calibri"/>
+              </a:rPr>
+              <a:t>•  Verification: linear probes on the frozen backbone (Ridge regression)</a:t>
+            </a:r>
+          </a:p>
+        </p:txBody>
+      </p:sp>
     </p:spTree>
   </p:cSld>
   <p:clrMapOvr>
@@ -5116,24 +5341,24 @@
           <a:lstStyle/>
           <a:p>
             <a:r>
-              <a:rPr sz="3400" b="1">
+              <a:rPr sz="3800" b="1">
                 <a:solidFill>
                   <a:srgbClr val="1F4E79"/>
                 </a:solidFill>
                 <a:latin typeface="Calibri"/>
               </a:rPr>
-              <a:t>Structure and Momentum Heads</a:t>
-            </a:r>
-          </a:p>
-          <a:p>
-            <a:r>
-              <a:rPr sz="1600">
+              <a:t>The Mass Head: Main Result</a:t>
+            </a:r>
+          </a:p>
+          <a:p>
+            <a:r>
+              <a:rPr sz="1700">
                 <a:solidFill>
                   <a:srgbClr val="666666"/>
                 </a:solidFill>
                 <a:latin typeface="Calibri"/>
               </a:rPr>
-              <a:t>Node-level supervision of tree position and momentum</a:t>
+              <a:t>Edge-level regression of log10(m_ππ)</a:t>
             </a:r>
           </a:p>
         </p:txBody>
@@ -5146,7 +5371,7 @@
         </p:nvSpPr>
         <p:spPr>
           <a:xfrm>
-            <a:off x="548640" y="1143000"/>
+            <a:off x="548640" y="1188720"/>
             <a:ext cx="11064240" cy="38100"/>
           </a:xfrm>
           <a:prstGeom prst="rect">
@@ -5181,6 +5406,289 @@
           </a:p>
         </p:txBody>
       </p:sp>
+      <p:sp>
+        <p:nvSpPr>
+          <p:cNvPr id="5" name="TextBox 4"/>
+          <p:cNvSpPr txBox="1"/>
+          <p:nvPr/>
+        </p:nvSpPr>
+        <p:spPr>
+          <a:xfrm>
+            <a:off x="731520" y="1188720"/>
+            <a:ext cx="6035040" cy="5120640"/>
+          </a:xfrm>
+          <a:prstGeom prst="rect">
+            <a:avLst/>
+          </a:prstGeom>
+          <a:noFill/>
+        </p:spPr>
+        <p:txBody>
+          <a:bodyPr wrap="square">
+            <a:spAutoFit/>
+          </a:bodyPr>
+          <a:lstStyle/>
+          <a:p>
+            <a:pPr>
+              <a:spcAft>
+                <a:spcPts val="1000"/>
+              </a:spcAft>
+            </a:pPr>
+            <a:r>
+              <a:rPr sz="2200">
+                <a:solidFill>
+                  <a:srgbClr val="333333"/>
+                </a:solidFill>
+                <a:latin typeface="Calibri"/>
+              </a:rPr>
+              <a:t>•  Same-mother track pairs sit near resonance masses → the edge representation must encode sister relations</a:t>
+            </a:r>
+          </a:p>
+          <a:p>
+            <a:pPr>
+              <a:spcAft>
+                <a:spcPts val="1000"/>
+              </a:spcAft>
+            </a:pPr>
+            <a:r>
+              <a:rPr sz="2200">
+                <a:solidFill>
+                  <a:srgbClr val="333333"/>
+                </a:solidFill>
+                <a:latin typeface="Calibri"/>
+              </a:rPr>
+              <a:t>•  Setup: SmoothL1 on log10(m_MeV), sentinel edges masked, weight 1.0</a:t>
+            </a:r>
+          </a:p>
+          <a:p>
+            <a:pPr>
+              <a:spcAft>
+                <a:spcPts val="1000"/>
+              </a:spcAft>
+            </a:pPr>
+            <a:r>
+              <a:rPr sz="2200">
+                <a:solidFill>
+                  <a:srgbClr val="333333"/>
+                </a:solidFill>
+                <a:latin typeface="Calibri"/>
+              </a:rPr>
+              <a:t>•  v38 → masshead2 (20 test files):</a:t>
+            </a:r>
+          </a:p>
+          <a:p>
+            <a:pPr>
+              <a:spcAft>
+                <a:spcPts val="1000"/>
+              </a:spcAft>
+            </a:pPr>
+            <a:r>
+              <a:rPr sz="2000">
+                <a:solidFill>
+                  <a:srgbClr val="333333"/>
+                </a:solidFill>
+                <a:latin typeface="Calibri"/>
+              </a:rPr>
+              <a:t>    –  PerfectReco 29.3% → 32.7%  (+3.4pp)</a:t>
+            </a:r>
+          </a:p>
+          <a:p>
+            <a:pPr>
+              <a:spcAft>
+                <a:spcPts val="1000"/>
+              </a:spcAft>
+            </a:pPr>
+            <a:r>
+              <a:rPr sz="2000">
+                <a:solidFill>
+                  <a:srgbClr val="333333"/>
+                </a:solidFill>
+                <a:latin typeface="Calibri"/>
+              </a:rPr>
+              <a:t>    –  AllParticles 52.1% → 55.9%  (+3.8pp)</a:t>
+            </a:r>
+          </a:p>
+          <a:p>
+            <a:pPr>
+              <a:spcAft>
+                <a:spcPts val="1000"/>
+              </a:spcAft>
+            </a:pPr>
+            <a:r>
+              <a:rPr sz="2000">
+                <a:solidFill>
+                  <a:srgbClr val="333333"/>
+                </a:solidFill>
+                <a:latin typeface="Calibri"/>
+              </a:rPr>
+              <a:t>    –  LCAG class2 44.7% → 51.1%  (+6.4pp)</a:t>
+            </a:r>
+          </a:p>
+        </p:txBody>
+      </p:sp>
+      <p:pic>
+        <p:nvPicPr>
+          <p:cNvPr id="6" name="Picture 5" descr="NN_edges_2_roc.png"/>
+          <p:cNvPicPr>
+            <a:picLocks noChangeAspect="1"/>
+          </p:cNvPicPr>
+          <p:nvPr/>
+        </p:nvPicPr>
+        <p:blipFill>
+          <a:blip r:embed="rId2"/>
+          <a:stretch>
+            <a:fillRect/>
+          </a:stretch>
+        </p:blipFill>
+        <p:spPr>
+          <a:xfrm>
+            <a:off x="6949440" y="1554480"/>
+            <a:ext cx="4754880" cy="3187931"/>
+          </a:xfrm>
+          <a:prstGeom prst="rect">
+            <a:avLst/>
+          </a:prstGeom>
+        </p:spPr>
+      </p:pic>
+    </p:spTree>
+  </p:cSld>
+  <p:clrMapOvr>
+    <a:masterClrMapping/>
+  </p:clrMapOvr>
+</p:sld>
+</file>
+
+<file path=ppt/slides/slide8.xml><?xml version="1.0" encoding="utf-8"?>
+<p:sld xmlns:a="http://schemas.openxmlformats.org/drawingml/2006/main" xmlns:p="http://schemas.openxmlformats.org/presentationml/2006/main" xmlns:r="http://schemas.openxmlformats.org/officeDocument/2006/relationships">
+  <p:cSld>
+    <p:spTree>
+      <p:nvGrpSpPr>
+        <p:cNvPr id="1" name=""/>
+        <p:cNvGrpSpPr/>
+        <p:nvPr/>
+      </p:nvGrpSpPr>
+      <p:grpSpPr/>
+      <p:sp>
+        <p:nvSpPr>
+          <p:cNvPr id="2" name="TextBox 1"/>
+          <p:cNvSpPr txBox="1"/>
+          <p:nvPr/>
+        </p:nvSpPr>
+        <p:spPr>
+          <a:xfrm>
+            <a:off x="502920" y="6510528"/>
+            <a:ext cx="11155680" cy="274320"/>
+          </a:xfrm>
+          <a:prstGeom prst="rect">
+            <a:avLst/>
+          </a:prstGeom>
+          <a:noFill/>
+        </p:spPr>
+        <p:txBody>
+          <a:bodyPr wrap="none">
+            <a:spAutoFit/>
+          </a:bodyPr>
+          <a:lstStyle/>
+          <a:p>
+            <a:r>
+              <a:rPr sz="1000">
+                <a:solidFill>
+                  <a:srgbClr val="666666"/>
+                </a:solidFill>
+                <a:latin typeface="Calibri"/>
+              </a:rPr>
+              <a:t>Qingxiang Guo · UCAS · DFEI group meeting      8</a:t>
+            </a:r>
+          </a:p>
+        </p:txBody>
+      </p:sp>
+      <p:sp>
+        <p:nvSpPr>
+          <p:cNvPr id="3" name="TextBox 2"/>
+          <p:cNvSpPr txBox="1"/>
+          <p:nvPr/>
+        </p:nvSpPr>
+        <p:spPr>
+          <a:xfrm>
+            <a:off x="502920" y="164592"/>
+            <a:ext cx="11155680" cy="914400"/>
+          </a:xfrm>
+          <a:prstGeom prst="rect">
+            <a:avLst/>
+          </a:prstGeom>
+          <a:noFill/>
+        </p:spPr>
+        <p:txBody>
+          <a:bodyPr wrap="square">
+            <a:spAutoFit/>
+          </a:bodyPr>
+          <a:lstStyle/>
+          <a:p>
+            <a:r>
+              <a:rPr sz="3800" b="1">
+                <a:solidFill>
+                  <a:srgbClr val="1F4E79"/>
+                </a:solidFill>
+                <a:latin typeface="Calibri"/>
+              </a:rPr>
+              <a:t>Structure and Momentum Heads</a:t>
+            </a:r>
+          </a:p>
+          <a:p>
+            <a:r>
+              <a:rPr sz="1700">
+                <a:solidFill>
+                  <a:srgbClr val="666666"/>
+                </a:solidFill>
+                <a:latin typeface="Calibri"/>
+              </a:rPr>
+              <a:t>Node-level supervision of tree position and momentum</a:t>
+            </a:r>
+          </a:p>
+        </p:txBody>
+      </p:sp>
+      <p:sp>
+        <p:nvSpPr>
+          <p:cNvPr id="4" name="Rectangle 3"/>
+          <p:cNvSpPr/>
+          <p:nvPr/>
+        </p:nvSpPr>
+        <p:spPr>
+          <a:xfrm>
+            <a:off x="548640" y="1188720"/>
+            <a:ext cx="11064240" cy="38100"/>
+          </a:xfrm>
+          <a:prstGeom prst="rect">
+            <a:avLst/>
+          </a:prstGeom>
+          <a:solidFill>
+            <a:srgbClr val="1F4E79"/>
+          </a:solidFill>
+          <a:ln>
+            <a:noFill/>
+          </a:ln>
+        </p:spPr>
+        <p:style>
+          <a:lnRef idx="1">
+            <a:schemeClr val="accent1"/>
+          </a:lnRef>
+          <a:fillRef idx="3">
+            <a:schemeClr val="accent1"/>
+          </a:fillRef>
+          <a:effectRef idx="2">
+            <a:schemeClr val="accent1"/>
+          </a:effectRef>
+          <a:fontRef idx="minor">
+            <a:schemeClr val="lt1"/>
+          </a:fontRef>
+        </p:style>
+        <p:txBody>
+          <a:bodyPr rtlCol="0" anchor="ctr"/>
+          <a:lstStyle/>
+          <a:p>
+            <a:pPr algn="ctr"/>
+          </a:p>
+        </p:txBody>
+      </p:sp>
       <p:graphicFrame>
         <p:nvGraphicFramePr>
           <p:cNvPr id="5" name="Table 4"/>
@@ -5191,7 +5699,7 @@
         </p:nvGraphicFramePr>
         <p:xfrm>
           <a:off x="731520" y="1371600"/>
-          <a:ext cx="10789920" cy="2377440"/>
+          <a:ext cx="10789920" cy="2560320"/>
         </p:xfrm>
         <a:graphic>
           <a:graphicData uri="http://schemas.openxmlformats.org/drawingml/2006/table">
@@ -5205,7 +5713,7 @@
                 <a:gridCol w="2697480"/>
                 <a:gridCol w="2697480"/>
               </a:tblGrid>
-              <a:tr h="594360">
+              <a:tr h="640080">
                 <a:tc>
                   <a:txBody>
                     <a:bodyPr/>
@@ -5213,7 +5721,7 @@
                     <a:p>
                       <a:pPr algn="ctr"/>
                       <a:r>
-                        <a:rPr sz="1600">
+                        <a:rPr sz="1800">
                           <a:solidFill>
                             <a:srgbClr val="FFFFFF"/>
                           </a:solidFill>
@@ -5236,7 +5744,7 @@
                     <a:p>
                       <a:pPr algn="ctr"/>
                       <a:r>
-                        <a:rPr sz="1600">
+                        <a:rPr sz="1800">
                           <a:solidFill>
                             <a:srgbClr val="FFFFFF"/>
                           </a:solidFill>
@@ -5259,7 +5767,7 @@
                     <a:p>
                       <a:pPr algn="ctr"/>
                       <a:r>
-                        <a:rPr sz="1600">
+                        <a:rPr sz="1800">
                           <a:solidFill>
                             <a:srgbClr val="FFFFFF"/>
                           </a:solidFill>
@@ -5282,7 +5790,7 @@
                     <a:p>
                       <a:pPr algn="ctr"/>
                       <a:r>
-                        <a:rPr sz="1600">
+                        <a:rPr sz="1800">
                           <a:solidFill>
                             <a:srgbClr val="FFFFFF"/>
                           </a:solidFill>
@@ -5299,7 +5807,7 @@
                   </a:tcPr>
                 </a:tc>
               </a:tr>
-              <a:tr h="594360">
+              <a:tr h="640080">
                 <a:tc>
                   <a:txBody>
                     <a:bodyPr/>
@@ -5307,13 +5815,13 @@
                     <a:p>
                       <a:pPr algn="l"/>
                       <a:r>
-                        <a:rPr sz="1600">
+                        <a:rPr sz="1800">
                           <a:solidFill>
                             <a:srgbClr val="333333"/>
                           </a:solidFill>
                           <a:latin typeface="Calibri"/>
                         </a:rPr>
-                        <a:t>baseline (mass only)</a:t>
+                        <a:t>baseline</a:t>
                       </a:r>
                     </a:p>
                   </a:txBody>
@@ -5326,13 +5834,13 @@
                     <a:p>
                       <a:pPr algn="l"/>
                       <a:r>
-                        <a:rPr sz="1600">
+                        <a:rPr sz="1800">
                           <a:solidFill>
                             <a:srgbClr val="333333"/>
                           </a:solidFill>
                           <a:latin typeface="Calibri"/>
                         </a:rPr>
-                        <a:t>—</a:t>
+                        <a:t>mass only</a:t>
                       </a:r>
                     </a:p>
                   </a:txBody>
@@ -5345,7 +5853,7 @@
                     <a:p>
                       <a:pPr algn="l"/>
                       <a:r>
-                        <a:rPr sz="1600">
+                        <a:rPr sz="1800">
                           <a:solidFill>
                             <a:srgbClr val="333333"/>
                           </a:solidFill>
@@ -5368,7 +5876,7 @@
                   <a:tcPr marL="54864" marR="54864" marT="18288" marB="18288"/>
                 </a:tc>
               </a:tr>
-              <a:tr h="594360">
+              <a:tr h="640080">
                 <a:tc>
                   <a:txBody>
                     <a:bodyPr/>
@@ -5376,7 +5884,7 @@
                     <a:p>
                       <a:pPr algn="l"/>
                       <a:r>
-                        <a:rPr sz="1600">
+                        <a:rPr sz="1800">
                           <a:solidFill>
                             <a:srgbClr val="333333"/>
                           </a:solidFill>
@@ -5399,13 +5907,13 @@
                     <a:p>
                       <a:pPr algn="l"/>
                       <a:r>
-                        <a:rPr sz="1600">
+                        <a:rPr sz="1800">
                           <a:solidFill>
                             <a:srgbClr val="333333"/>
                           </a:solidFill>
                           <a:latin typeface="Calibri"/>
                         </a:rPr>
-                        <a:t>depth + RC value</a:t>
+                        <a:t>depth + RC</a:t>
                       </a:r>
                     </a:p>
                   </a:txBody>
@@ -5422,7 +5930,7 @@
                     <a:p>
                       <a:pPr algn="l"/>
                       <a:r>
-                        <a:rPr sz="1600">
+                        <a:rPr sz="1800">
                           <a:solidFill>
                             <a:srgbClr val="333333"/>
                           </a:solidFill>
@@ -5445,13 +5953,13 @@
                     <a:p>
                       <a:pPr algn="l"/>
                       <a:r>
-                        <a:rPr sz="1600">
+                        <a:rPr sz="1800">
                           <a:solidFill>
                             <a:srgbClr val="333333"/>
                           </a:solidFill>
                           <a:latin typeface="Calibri"/>
                         </a:rPr>
-                        <a:t>best single head; class3 60.8→63.2</a:t>
+                        <a:t>best single head</a:t>
                       </a:r>
                     </a:p>
                   </a:txBody>
@@ -5462,7 +5970,7 @@
                   </a:tcPr>
                 </a:tc>
               </a:tr>
-              <a:tr h="594360">
+              <a:tr h="640080">
                 <a:tc>
                   <a:txBody>
                     <a:bodyPr/>
@@ -5470,7 +5978,7 @@
                     <a:p>
                       <a:pPr algn="l"/>
                       <a:r>
-                        <a:rPr sz="1600">
+                        <a:rPr sz="1800">
                           <a:solidFill>
                             <a:srgbClr val="333333"/>
                           </a:solidFill>
@@ -5489,7 +5997,7 @@
                     <a:p>
                       <a:pPr algn="l"/>
                       <a:r>
-                        <a:rPr sz="1600">
+                        <a:rPr sz="1800">
                           <a:solidFill>
                             <a:srgbClr val="333333"/>
                           </a:solidFill>
@@ -5508,7 +6016,7 @@
                     <a:p>
                       <a:pPr algn="l"/>
                       <a:r>
-                        <a:rPr sz="1600">
+                        <a:rPr sz="1800">
                           <a:solidFill>
                             <a:srgbClr val="333333"/>
                           </a:solidFill>
@@ -5527,13 +6035,13 @@
                     <a:p>
                       <a:pPr algn="l"/>
                       <a:r>
-                        <a:rPr sz="1600">
+                        <a:rPr sz="1800">
                           <a:solidFill>
                             <a:srgbClr val="333333"/>
                           </a:solidFill>
                           <a:latin typeface="Calibri"/>
                         </a:rPr>
-                        <a:t>fixes node R²≈0 for momentum</a:t>
+                        <a:t>fixes node R²≈0</a:t>
                       </a:r>
                     </a:p>
                   </a:txBody>
@@ -5552,7 +6060,7 @@
         </p:nvSpPr>
         <p:spPr>
           <a:xfrm>
-            <a:off x="731520" y="3931920"/>
+            <a:off x="731520" y="4114800"/>
             <a:ext cx="10789920" cy="2377440"/>
           </a:xfrm>
           <a:prstGeom prst="rect">
@@ -5568,43 +6076,43 @@
           <a:p>
             <a:pPr>
               <a:spcAft>
-                <a:spcPts val="800"/>
+                <a:spcPts val="1000"/>
               </a:spcAft>
             </a:pPr>
             <a:r>
-              <a:rPr sz="1800">
+              <a:rPr sz="2200">
                 <a:solidFill>
                   <a:srgbClr val="333333"/>
                 </a:solidFill>
                 <a:latin typeface="Calibri"/>
               </a:rPr>
-              <a:t>•  Struct head: depth = BFS distance to chain centroid; RC = Rumor-Centrality value — node position in the tree</a:t>
+              <a:t>•  Struct: depth (BFS to chain centroid) + RC value — node position in the tree; class3 60.8→63.2</a:t>
             </a:r>
           </a:p>
           <a:p>
             <a:pPr>
               <a:spcAft>
-                <a:spcPts val="800"/>
+                <a:spcPts val="1000"/>
               </a:spcAft>
             </a:pPr>
             <a:r>
-              <a:rPr sz="1800">
+              <a:rPr sz="2200">
                 <a:solidFill>
                   <a:srgbClr val="333333"/>
                 </a:solidFill>
                 <a:latin typeface="Calibri"/>
               </a:rPr>
-              <a:t>•  Mom head motivated by a probe: node representations were linearly unreadable for momentum (R² ≈ 0)</a:t>
+              <a:t>•  Mom: motivated by a probe — node representations were linearly unreadable for momentum (R² ≈ 0)</a:t>
             </a:r>
           </a:p>
           <a:p>
             <a:pPr>
               <a:spcAft>
-                <a:spcPts val="800"/>
+                <a:spcPts val="1000"/>
               </a:spcAft>
             </a:pPr>
             <a:r>
-              <a:rPr sz="1800">
+              <a:rPr sz="2200">
                 <a:solidFill>
                   <a:srgbClr val="333333"/>
                 </a:solidFill>
@@ -5623,7 +6131,7 @@
 </p:sld>
 </file>
 
-<file path=ppt/slides/slide8.xml><?xml version="1.0" encoding="utf-8"?>
+<file path=ppt/slides/slide9.xml><?xml version="1.0" encoding="utf-8"?>
 <p:sld xmlns:a="http://schemas.openxmlformats.org/drawingml/2006/main" xmlns:p="http://schemas.openxmlformats.org/presentationml/2006/main" xmlns:r="http://schemas.openxmlformats.org/officeDocument/2006/relationships">
   <p:cSld>
     <p:spTree>
@@ -5662,7 +6170,7 @@
                 </a:solidFill>
                 <a:latin typeface="Calibri"/>
               </a:rPr>
-              <a:t>Qingxiang Guo · UCAS · DFEI group meeting      8</a:t>
+              <a:t>Qingxiang Guo · UCAS · DFEI group meeting      9</a:t>
             </a:r>
           </a:p>
         </p:txBody>
@@ -5690,7 +6198,7 @@
           <a:lstStyle/>
           <a:p>
             <a:r>
-              <a:rPr sz="3400" b="1">
+              <a:rPr sz="3800" b="1">
                 <a:solidFill>
                   <a:srgbClr val="1F4E79"/>
                 </a:solidFill>
@@ -5701,7 +6209,7 @@
           </a:p>
           <a:p>
             <a:r>
-              <a:rPr sz="1600">
+              <a:rPr sz="1700">
                 <a:solidFill>
                   <a:srgbClr val="666666"/>
                 </a:solidFill>
@@ -5720,7 +6228,7 @@
         </p:nvSpPr>
         <p:spPr>
           <a:xfrm>
-            <a:off x="548640" y="1143000"/>
+            <a:off x="548640" y="1188720"/>
             <a:ext cx="11064240" cy="38100"/>
           </a:xfrm>
           <a:prstGeom prst="rect">
@@ -5786,7 +6294,7 @@
                     <a:p>
                       <a:pPr algn="ctr"/>
                       <a:r>
-                        <a:rPr sz="1800">
+                        <a:rPr sz="2000">
                           <a:solidFill>
                             <a:srgbClr val="FFFFFF"/>
                           </a:solidFill>
@@ -5809,7 +6317,7 @@
                     <a:p>
                       <a:pPr algn="ctr"/>
                       <a:r>
-                        <a:rPr sz="1800">
+                        <a:rPr sz="2000">
                           <a:solidFill>
                             <a:srgbClr val="FFFFFF"/>
                           </a:solidFill>
@@ -5832,7 +6340,7 @@
                     <a:p>
                       <a:pPr algn="ctr"/>
                       <a:r>
-                        <a:rPr sz="1800">
+                        <a:rPr sz="2000">
                           <a:solidFill>
                             <a:srgbClr val="FFFFFF"/>
                           </a:solidFill>
@@ -5857,7 +6365,7 @@
                     <a:p>
                       <a:pPr algn="l"/>
                       <a:r>
-                        <a:rPr sz="1800">
+                        <a:rPr sz="2000">
                           <a:solidFill>
                             <a:srgbClr val="333333"/>
                           </a:solidFill>
@@ -5876,7 +6384,7 @@
                     <a:p>
                       <a:pPr algn="l"/>
                       <a:r>
-                        <a:rPr sz="1800">
+                        <a:rPr sz="2000">
                           <a:solidFill>
                             <a:srgbClr val="333333"/>
                           </a:solidFill>
@@ -5895,7 +6403,7 @@
                     <a:p>
                       <a:pPr algn="l"/>
                       <a:r>
-                        <a:rPr sz="1800">
+                        <a:rPr sz="2000">
                           <a:solidFill>
                             <a:srgbClr val="333333"/>
                           </a:solidFill>
@@ -5916,7 +6424,7 @@
                     <a:p>
                       <a:pPr algn="l"/>
                       <a:r>
-                        <a:rPr sz="1800">
+                        <a:rPr sz="2000">
                           <a:solidFill>
                             <a:srgbClr val="333333"/>
                           </a:solidFill>
@@ -5939,7 +6447,7 @@
                     <a:p>
                       <a:pPr algn="l"/>
                       <a:r>
-                        <a:rPr sz="1800">
+                        <a:rPr sz="2000">
                           <a:solidFill>
                             <a:srgbClr val="333333"/>
                           </a:solidFill>
@@ -5962,7 +6470,7 @@
                     <a:p>
                       <a:pPr algn="l"/>
                       <a:r>
-                        <a:rPr sz="1800">
+                        <a:rPr sz="2000">
                           <a:solidFill>
                             <a:srgbClr val="333333"/>
                           </a:solidFill>
@@ -6007,11 +6515,11 @@
           <a:p>
             <a:pPr>
               <a:spcAft>
-                <a:spcPts val="800"/>
+                <a:spcPts val="1000"/>
               </a:spcAft>
             </a:pPr>
             <a:r>
-              <a:rPr sz="1800">
+              <a:rPr sz="2200">
                 <a:solidFill>
                   <a:srgbClr val="333333"/>
                 </a:solidFill>
@@ -6023,265 +6531,17 @@
           <a:p>
             <a:pPr>
               <a:spcAft>
-                <a:spcPts val="800"/>
+                <a:spcPts val="1000"/>
               </a:spcAft>
             </a:pPr>
             <a:r>
-              <a:rPr sz="1800">
+              <a:rPr sz="2200">
                 <a:solidFill>
                   <a:srgbClr val="333333"/>
                 </a:solidFill>
                 <a:latin typeface="Calibri"/>
               </a:rPr>
               <a:t>•  Nodes remain unreadable for momentum → addressed by the momentum head (to be re-probed)</a:t>
-            </a:r>
-          </a:p>
-        </p:txBody>
-      </p:sp>
-    </p:spTree>
-  </p:cSld>
-  <p:clrMapOvr>
-    <a:masterClrMapping/>
-  </p:clrMapOvr>
-</p:sld>
-</file>
-
-<file path=ppt/slides/slide9.xml><?xml version="1.0" encoding="utf-8"?>
-<p:sld xmlns:a="http://schemas.openxmlformats.org/drawingml/2006/main" xmlns:p="http://schemas.openxmlformats.org/presentationml/2006/main" xmlns:r="http://schemas.openxmlformats.org/officeDocument/2006/relationships">
-  <p:cSld>
-    <p:spTree>
-      <p:nvGrpSpPr>
-        <p:cNvPr id="1" name=""/>
-        <p:cNvGrpSpPr/>
-        <p:nvPr/>
-      </p:nvGrpSpPr>
-      <p:grpSpPr/>
-      <p:sp>
-        <p:nvSpPr>
-          <p:cNvPr id="2" name="TextBox 1"/>
-          <p:cNvSpPr txBox="1"/>
-          <p:nvPr/>
-        </p:nvSpPr>
-        <p:spPr>
-          <a:xfrm>
-            <a:off x="502920" y="6510528"/>
-            <a:ext cx="11155680" cy="274320"/>
-          </a:xfrm>
-          <a:prstGeom prst="rect">
-            <a:avLst/>
-          </a:prstGeom>
-          <a:noFill/>
-        </p:spPr>
-        <p:txBody>
-          <a:bodyPr wrap="none">
-            <a:spAutoFit/>
-          </a:bodyPr>
-          <a:lstStyle/>
-          <a:p>
-            <a:r>
-              <a:rPr sz="1000">
-                <a:solidFill>
-                  <a:srgbClr val="666666"/>
-                </a:solidFill>
-                <a:latin typeface="Calibri"/>
-              </a:rPr>
-              <a:t>Qingxiang Guo · UCAS · DFEI group meeting      9</a:t>
-            </a:r>
-          </a:p>
-        </p:txBody>
-      </p:sp>
-      <p:sp>
-        <p:nvSpPr>
-          <p:cNvPr id="3" name="TextBox 2"/>
-          <p:cNvSpPr txBox="1"/>
-          <p:nvPr/>
-        </p:nvSpPr>
-        <p:spPr>
-          <a:xfrm>
-            <a:off x="502920" y="164592"/>
-            <a:ext cx="11155680" cy="914400"/>
-          </a:xfrm>
-          <a:prstGeom prst="rect">
-            <a:avLst/>
-          </a:prstGeom>
-          <a:noFill/>
-        </p:spPr>
-        <p:txBody>
-          <a:bodyPr wrap="square">
-            <a:spAutoFit/>
-          </a:bodyPr>
-          <a:lstStyle/>
-          <a:p>
-            <a:r>
-              <a:rPr sz="3400" b="1">
-                <a:solidFill>
-                  <a:srgbClr val="1F4E79"/>
-                </a:solidFill>
-                <a:latin typeface="Calibri"/>
-              </a:rPr>
-              <a:t>Part 3 — Controlled Failures and Their Lessons</a:t>
-            </a:r>
-          </a:p>
-        </p:txBody>
-      </p:sp>
-      <p:sp>
-        <p:nvSpPr>
-          <p:cNvPr id="4" name="Rectangle 3"/>
-          <p:cNvSpPr/>
-          <p:nvPr/>
-        </p:nvSpPr>
-        <p:spPr>
-          <a:xfrm>
-            <a:off x="548640" y="1143000"/>
-            <a:ext cx="11064240" cy="38100"/>
-          </a:xfrm>
-          <a:prstGeom prst="rect">
-            <a:avLst/>
-          </a:prstGeom>
-          <a:solidFill>
-            <a:srgbClr val="1F4E79"/>
-          </a:solidFill>
-          <a:ln>
-            <a:noFill/>
-          </a:ln>
-        </p:spPr>
-        <p:style>
-          <a:lnRef idx="1">
-            <a:schemeClr val="accent1"/>
-          </a:lnRef>
-          <a:fillRef idx="3">
-            <a:schemeClr val="accent1"/>
-          </a:fillRef>
-          <a:effectRef idx="2">
-            <a:schemeClr val="accent1"/>
-          </a:effectRef>
-          <a:fontRef idx="minor">
-            <a:schemeClr val="lt1"/>
-          </a:fontRef>
-        </p:style>
-        <p:txBody>
-          <a:bodyPr rtlCol="0" anchor="ctr"/>
-          <a:lstStyle/>
-          <a:p>
-            <a:pPr algn="ctr"/>
-          </a:p>
-        </p:txBody>
-      </p:sp>
-      <p:sp>
-        <p:nvSpPr>
-          <p:cNvPr id="5" name="TextBox 4"/>
-          <p:cNvSpPr txBox="1"/>
-          <p:nvPr/>
-        </p:nvSpPr>
-        <p:spPr>
-          <a:xfrm>
-            <a:off x="731520" y="1280160"/>
-            <a:ext cx="10789920" cy="4937760"/>
-          </a:xfrm>
-          <a:prstGeom prst="rect">
-            <a:avLst/>
-          </a:prstGeom>
-          <a:noFill/>
-        </p:spPr>
-        <p:txBody>
-          <a:bodyPr wrap="square">
-            <a:spAutoFit/>
-          </a:bodyPr>
-          <a:lstStyle/>
-          <a:p>
-            <a:pPr>
-              <a:spcAft>
-                <a:spcPts val="800"/>
-              </a:spcAft>
-            </a:pPr>
-            <a:r>
-              <a:rPr sz="1800">
-                <a:solidFill>
-                  <a:srgbClr val="333333"/>
-                </a:solidFill>
-                <a:latin typeface="Calibri"/>
-              </a:rPr>
-              <a:t>•  PV subgraph training (v39-42): train per-PV subgraphs → backbone sees only subgraphs, inference runs on the full graph</a:t>
-            </a:r>
-          </a:p>
-          <a:p>
-            <a:pPr>
-              <a:spcAft>
-                <a:spcPts val="800"/>
-              </a:spcAft>
-            </a:pPr>
-            <a:r>
-              <a:rPr sz="1600">
-                <a:solidFill>
-                  <a:srgbClr val="333333"/>
-                </a:solidFill>
-                <a:latin typeface="Calibri"/>
-              </a:rPr>
-              <a:t>    –  full-graph ability degraded: class1 76.8% → 56.4%; line closed</a:t>
-            </a:r>
-          </a:p>
-          <a:p>
-            <a:pPr>
-              <a:spcAft>
-                <a:spcPts val="800"/>
-              </a:spcAft>
-            </a:pPr>
-            <a:r>
-              <a:rPr sz="1800">
-                <a:solidFill>
-                  <a:srgbClr val="333333"/>
-                </a:solidFill>
-                <a:latin typeface="Calibri"/>
-              </a:rPr>
-              <a:t>•  Combined mass + struct + mom (v48): auxiliary losses (0.877) exceed the main task (0.559) → reconstruction dropped 5pp</a:t>
-            </a:r>
-          </a:p>
-          <a:p>
-            <a:pPr>
-              <a:spcAft>
-                <a:spcPts val="800"/>
-              </a:spcAft>
-            </a:pPr>
-            <a:r>
-              <a:rPr sz="1600">
-                <a:solidFill>
-                  <a:srgbClr val="333333"/>
-                </a:solidFill>
-                <a:latin typeface="Calibri"/>
-              </a:rPr>
-              <a:t>    –  LCAG did not drop; the shared backbone was pulled toward the auxiliary tasks</a:t>
-            </a:r>
-          </a:p>
-          <a:p>
-            <a:pPr>
-              <a:spcAft>
-                <a:spcPts val="800"/>
-              </a:spcAft>
-            </a:pPr>
-            <a:r>
-              <a:rPr sz="1600">
-                <a:solidFill>
-                  <a:srgbClr val="333333"/>
-                </a:solidFill>
-                <a:latin typeface="Calibri"/>
-              </a:rPr>
-              <a:t>    –  resolution: lower aux weights — mom 0.2, struct 0.3</a:t>
-            </a:r>
-          </a:p>
-          <a:p>
-            <a:pPr>
-              <a:spcAft>
-                <a:spcPts val="800"/>
-              </a:spcAft>
-            </a:pPr>
-            <a:r>
-              <a:rPr sz="1800">
-                <a:solidFill>
-                  <a:srgbClr val="333333"/>
-                </a:solidFill>
-                <a:latin typeface="Calibri"/>
-              </a:rPr>
-              <a:t>•  Lessons: train/infer graph mismatch is fatal; gradient balance between heads must be explicit</a:t>
             </a:r>
           </a:p>
         </p:txBody>

</xml_diff>

<commit_message>
docs: add pruning sigmoid + w_eff flow figures to deck S4
</commit_message>
<xml_diff>
--- a/meeting_figs/DFEI_progress_20260902_EN.pptx
+++ b/meeting_figs/DFEI_progress_20260902_EN.pptx
@@ -4605,8 +4605,8 @@
         </p:nvSpPr>
         <p:spPr>
           <a:xfrm>
-            <a:off x="731520" y="1280160"/>
-            <a:ext cx="10789920" cy="5120640"/>
+            <a:off x="731520" y="1234440"/>
+            <a:ext cx="10789920" cy="2377440"/>
           </a:xfrm>
           <a:prstGeom prst="rect">
             <a:avLst/>
@@ -4631,7 +4631,7 @@
                 </a:solidFill>
                 <a:latin typeface="Calibri"/>
               </a:rPr>
-              <a:t>•  Problem: training optimizes the full graph; inference prunes nodes/edges with hard thresholds first</a:t>
+              <a:t>•  Problem: training sees the full graph; inference prunes with hard thresholds first</a:t>
             </a:r>
           </a:p>
           <a:p>
@@ -4647,7 +4647,7 @@
                 </a:solidFill>
                 <a:latin typeface="Calibri"/>
               </a:rPr>
-              <a:t>•  Solution: a soft mask on the weights, w_eff = w · σ((w − cut)/τ)</a:t>
+              <a:t>•  Fix: soft mask w_eff = w · σ((w − cut)/τ), temperature τ annealed 1.0 → 0.1</a:t>
             </a:r>
           </a:p>
           <a:p>
@@ -4657,13 +4657,13 @@
               </a:spcAft>
             </a:pPr>
             <a:r>
-              <a:rPr sz="2200">
+              <a:rPr sz="2000">
                 <a:solidFill>
                   <a:srgbClr val="333333"/>
                 </a:solidFill>
                 <a:latin typeface="Calibri"/>
               </a:rPr>
-              <a:t>•  Temperature τ annealed 1.0 → 0.1 over training:</a:t>
+              <a:t>    –  large τ → smooth mask, stable gradients; small τ → approximates the hard threshold</a:t>
             </a:r>
           </a:p>
           <a:p>
@@ -4673,65 +4673,65 @@
               </a:spcAft>
             </a:pPr>
             <a:r>
-              <a:rPr sz="2000">
+              <a:rPr sz="2200">
                 <a:solidFill>
                   <a:srgbClr val="333333"/>
                 </a:solidFill>
                 <a:latin typeface="Calibri"/>
               </a:rPr>
-              <a:t>    –  large τ → smooth mask and stable gradients</a:t>
-            </a:r>
-          </a:p>
-          <a:p>
-            <a:pPr>
-              <a:spcAft>
-                <a:spcPts val="1000"/>
-              </a:spcAft>
-            </a:pPr>
-            <a:r>
-              <a:rPr sz="2000">
-                <a:solidFill>
-                  <a:srgbClr val="333333"/>
-                </a:solidFill>
-                <a:latin typeface="Calibri"/>
-              </a:rPr>
-              <a:t>    –  small τ → approximates the hard threshold at the end</a:t>
-            </a:r>
-          </a:p>
-          <a:p>
-            <a:pPr>
-              <a:spcAft>
-                <a:spcPts val="1000"/>
-              </a:spcAft>
-            </a:pPr>
-            <a:r>
-              <a:rPr sz="2200">
-                <a:solidFill>
-                  <a:srgbClr val="333333"/>
-                </a:solidFill>
-                <a:latin typeface="Calibri"/>
-              </a:rPr>
-              <a:t>•  Pruning cut aligned to inference and tightened over versions:</a:t>
-            </a:r>
-          </a:p>
-          <a:p>
-            <a:pPr>
-              <a:spcAft>
-                <a:spcPts val="1000"/>
-              </a:spcAft>
-            </a:pPr>
-            <a:r>
-              <a:rPr sz="2000">
-                <a:solidFill>
-                  <a:srgbClr val="333333"/>
-                </a:solidFill>
-                <a:latin typeface="Calibri"/>
-              </a:rPr>
-              <a:t>    –  0.5 (v36) → 0.7 (v37) → 0.85 (v38), converging to the 0.9 inference threshold</a:t>
-            </a:r>
-          </a:p>
-        </p:txBody>
-      </p:sp>
+              <a:t>•  Cut aligned to inference and tightened over versions: 0.5 (v36) → 0.7 (v37) → 0.85 (v38) → 0.9 (inference)</a:t>
+            </a:r>
+          </a:p>
+        </p:txBody>
+      </p:sp>
+      <p:pic>
+        <p:nvPicPr>
+          <p:cNvPr id="6" name="Picture 5" descr="pruning_sigmoid_tau.png"/>
+          <p:cNvPicPr>
+            <a:picLocks noChangeAspect="1"/>
+          </p:cNvPicPr>
+          <p:nvPr/>
+        </p:nvPicPr>
+        <p:blipFill>
+          <a:blip r:embed="rId2"/>
+          <a:stretch>
+            <a:fillRect/>
+          </a:stretch>
+        </p:blipFill>
+        <p:spPr>
+          <a:xfrm>
+            <a:off x="640080" y="3611880"/>
+            <a:ext cx="5760720" cy="2199932"/>
+          </a:xfrm>
+          <a:prstGeom prst="rect">
+            <a:avLst/>
+          </a:prstGeom>
+        </p:spPr>
+      </p:pic>
+      <p:pic>
+        <p:nvPicPr>
+          <p:cNvPr id="7" name="Picture 6" descr="pruning_flow.png"/>
+          <p:cNvPicPr>
+            <a:picLocks noChangeAspect="1"/>
+          </p:cNvPicPr>
+          <p:nvPr/>
+        </p:nvPicPr>
+        <p:blipFill>
+          <a:blip r:embed="rId3"/>
+          <a:stretch>
+            <a:fillRect/>
+          </a:stretch>
+        </p:blipFill>
+        <p:spPr>
+          <a:xfrm>
+            <a:off x="6492240" y="3794760"/>
+            <a:ext cx="5394960" cy="2141384"/>
+          </a:xfrm>
+          <a:prstGeom prst="rect">
+            <a:avLst/>
+          </a:prstGeom>
+        </p:spPr>
+      </p:pic>
     </p:spTree>
   </p:cSld>
   <p:clrMapOvr>

</xml_diff>

<commit_message>
docs: native flow chart in S4 (rgb fix)
</commit_message>
<xml_diff>
--- a/meeting_figs/DFEI_progress_20260902_EN.pptx
+++ b/meeting_figs/DFEI_progress_20260902_EN.pptx
@@ -4708,30 +4708,743 @@
           </a:prstGeom>
         </p:spPr>
       </p:pic>
-      <p:pic>
-        <p:nvPicPr>
-          <p:cNvPr id="7" name="Picture 6" descr="pruning_flow.png"/>
-          <p:cNvPicPr>
-            <a:picLocks noChangeAspect="1"/>
-          </p:cNvPicPr>
+      <p:sp>
+        <p:nvSpPr>
+          <p:cNvPr id="7" name="Rounded Rectangle 6"/>
+          <p:cNvSpPr/>
           <p:nvPr/>
-        </p:nvPicPr>
-        <p:blipFill>
-          <a:blip r:embed="rId3"/>
-          <a:stretch>
-            <a:fillRect/>
-          </a:stretch>
-        </p:blipFill>
-        <p:spPr>
-          <a:xfrm>
-            <a:off x="6492240" y="3794760"/>
-            <a:ext cx="5394960" cy="2141384"/>
+        </p:nvSpPr>
+        <p:spPr>
+          <a:xfrm>
+            <a:off x="6583680" y="3657600"/>
+            <a:ext cx="1371600" cy="777240"/>
+          </a:xfrm>
+          <a:prstGeom prst="roundRect">
+            <a:avLst/>
+          </a:prstGeom>
+          <a:solidFill>
+            <a:srgbClr val="EAF2F8"/>
+          </a:solidFill>
+          <a:ln w="20320">
+            <a:solidFill>
+              <a:srgbClr val="1F4E79"/>
+            </a:solidFill>
+          </a:ln>
+        </p:spPr>
+        <p:style>
+          <a:lnRef idx="1">
+            <a:schemeClr val="accent1"/>
+          </a:lnRef>
+          <a:fillRef idx="3">
+            <a:schemeClr val="accent1"/>
+          </a:fillRef>
+          <a:effectRef idx="2">
+            <a:schemeClr val="accent1"/>
+          </a:effectRef>
+          <a:fontRef idx="minor">
+            <a:schemeClr val="lt1"/>
+          </a:fontRef>
+        </p:style>
+        <p:txBody>
+          <a:bodyPr rtlCol="0" anchor="ctr" wrap="square" lIns="27432" rIns="27432" tIns="9144" bIns="9144"/>
+          <a:lstStyle/>
+          <a:p>
+            <a:pPr algn="ctr"/>
+            <a:r>
+              <a:rPr sz="900" b="0">
+                <a:solidFill>
+                  <a:srgbClr val="333333"/>
+                </a:solidFill>
+                <a:latin typeface="Calibri"/>
+              </a:rPr>
+              <a:t>GNN block</a:t>
+            </a:r>
+          </a:p>
+          <a:p>
+            <a:pPr algn="ctr"/>
+            <a:r>
+              <a:rPr sz="900" b="0">
+                <a:solidFill>
+                  <a:srgbClr val="333333"/>
+                </a:solidFill>
+                <a:latin typeface="Calibri"/>
+              </a:rPr>
+              <a:t>(node/edge</a:t>
+            </a:r>
+          </a:p>
+          <a:p>
+            <a:pPr algn="ctr"/>
+            <a:r>
+              <a:rPr sz="900" b="0">
+                <a:solidFill>
+                  <a:srgbClr val="333333"/>
+                </a:solidFill>
+                <a:latin typeface="Calibri"/>
+              </a:rPr>
+              <a:t>reprs)</a:t>
+            </a:r>
+          </a:p>
+        </p:txBody>
+      </p:sp>
+      <p:sp>
+        <p:nvSpPr>
+          <p:cNvPr id="8" name="Right Arrow 7"/>
+          <p:cNvSpPr/>
+          <p:nvPr/>
+        </p:nvSpPr>
+        <p:spPr>
+          <a:xfrm>
+            <a:off x="8010144" y="3858768"/>
+            <a:ext cx="292608" cy="365760"/>
+          </a:xfrm>
+          <a:prstGeom prst="rightArrow">
+            <a:avLst/>
+          </a:prstGeom>
+          <a:solidFill>
+            <a:srgbClr val="1F4E79"/>
+          </a:solidFill>
+          <a:ln>
+            <a:noFill/>
+          </a:ln>
+        </p:spPr>
+        <p:style>
+          <a:lnRef idx="1">
+            <a:schemeClr val="accent1"/>
+          </a:lnRef>
+          <a:fillRef idx="3">
+            <a:schemeClr val="accent1"/>
+          </a:fillRef>
+          <a:effectRef idx="2">
+            <a:schemeClr val="accent1"/>
+          </a:effectRef>
+          <a:fontRef idx="minor">
+            <a:schemeClr val="lt1"/>
+          </a:fontRef>
+        </p:style>
+        <p:txBody>
+          <a:bodyPr rtlCol="0" anchor="ctr"/>
+          <a:lstStyle/>
+          <a:p>
+            <a:pPr algn="ctr"/>
+          </a:p>
+        </p:txBody>
+      </p:sp>
+      <p:sp>
+        <p:nvSpPr>
+          <p:cNvPr id="9" name="Rounded Rectangle 8"/>
+          <p:cNvSpPr/>
+          <p:nvPr/>
+        </p:nvSpPr>
+        <p:spPr>
+          <a:xfrm>
+            <a:off x="8339327" y="3657600"/>
+            <a:ext cx="1371600" cy="777240"/>
+          </a:xfrm>
+          <a:prstGeom prst="roundRect">
+            <a:avLst/>
+          </a:prstGeom>
+          <a:solidFill>
+            <a:srgbClr val="EAF2F8"/>
+          </a:solidFill>
+          <a:ln w="20320">
+            <a:solidFill>
+              <a:srgbClr val="1F4E79"/>
+            </a:solidFill>
+          </a:ln>
+        </p:spPr>
+        <p:style>
+          <a:lnRef idx="1">
+            <a:schemeClr val="accent1"/>
+          </a:lnRef>
+          <a:fillRef idx="3">
+            <a:schemeClr val="accent1"/>
+          </a:fillRef>
+          <a:effectRef idx="2">
+            <a:schemeClr val="accent1"/>
+          </a:effectRef>
+          <a:fontRef idx="minor">
+            <a:schemeClr val="lt1"/>
+          </a:fontRef>
+        </p:style>
+        <p:txBody>
+          <a:bodyPr rtlCol="0" anchor="ctr" wrap="square" lIns="27432" rIns="27432" tIns="9144" bIns="9144"/>
+          <a:lstStyle/>
+          <a:p>
+            <a:pPr algn="ctr"/>
+            <a:r>
+              <a:rPr sz="900" b="0">
+                <a:solidFill>
+                  <a:srgbClr val="333333"/>
+                </a:solidFill>
+                <a:latin typeface="Calibri"/>
+              </a:rPr>
+              <a:t>Weight MLP</a:t>
+            </a:r>
+          </a:p>
+          <a:p>
+            <a:pPr algn="ctr"/>
+            <a:r>
+              <a:rPr sz="900" b="0">
+                <a:solidFill>
+                  <a:srgbClr val="333333"/>
+                </a:solidFill>
+                <a:latin typeface="Calibri"/>
+              </a:rPr>
+              <a:t>(sigmoid head)</a:t>
+            </a:r>
+          </a:p>
+        </p:txBody>
+      </p:sp>
+      <p:sp>
+        <p:nvSpPr>
+          <p:cNvPr id="10" name="Right Arrow 9"/>
+          <p:cNvSpPr/>
+          <p:nvPr/>
+        </p:nvSpPr>
+        <p:spPr>
+          <a:xfrm>
+            <a:off x="9765792" y="3858768"/>
+            <a:ext cx="292608" cy="365760"/>
+          </a:xfrm>
+          <a:prstGeom prst="rightArrow">
+            <a:avLst/>
+          </a:prstGeom>
+          <a:solidFill>
+            <a:srgbClr val="1F4E79"/>
+          </a:solidFill>
+          <a:ln>
+            <a:noFill/>
+          </a:ln>
+        </p:spPr>
+        <p:style>
+          <a:lnRef idx="1">
+            <a:schemeClr val="accent1"/>
+          </a:lnRef>
+          <a:fillRef idx="3">
+            <a:schemeClr val="accent1"/>
+          </a:fillRef>
+          <a:effectRef idx="2">
+            <a:schemeClr val="accent1"/>
+          </a:effectRef>
+          <a:fontRef idx="minor">
+            <a:schemeClr val="lt1"/>
+          </a:fontRef>
+        </p:style>
+        <p:txBody>
+          <a:bodyPr rtlCol="0" anchor="ctr"/>
+          <a:lstStyle/>
+          <a:p>
+            <a:pPr algn="ctr"/>
+          </a:p>
+        </p:txBody>
+      </p:sp>
+      <p:sp>
+        <p:nvSpPr>
+          <p:cNvPr id="11" name="Rounded Rectangle 10"/>
+          <p:cNvSpPr/>
+          <p:nvPr/>
+        </p:nvSpPr>
+        <p:spPr>
+          <a:xfrm>
+            <a:off x="10104120" y="3657600"/>
+            <a:ext cx="914400" cy="777240"/>
+          </a:xfrm>
+          <a:prstGeom prst="roundRect">
+            <a:avLst/>
+          </a:prstGeom>
+          <a:solidFill>
+            <a:srgbClr val="EAF2F8"/>
+          </a:solidFill>
+          <a:ln w="20320">
+            <a:solidFill>
+              <a:srgbClr val="1F4E79"/>
+            </a:solidFill>
+          </a:ln>
+        </p:spPr>
+        <p:style>
+          <a:lnRef idx="1">
+            <a:schemeClr val="accent1"/>
+          </a:lnRef>
+          <a:fillRef idx="3">
+            <a:schemeClr val="accent1"/>
+          </a:fillRef>
+          <a:effectRef idx="2">
+            <a:schemeClr val="accent1"/>
+          </a:effectRef>
+          <a:fontRef idx="minor">
+            <a:schemeClr val="lt1"/>
+          </a:fontRef>
+        </p:style>
+        <p:txBody>
+          <a:bodyPr rtlCol="0" anchor="ctr" wrap="square" lIns="27432" rIns="27432" tIns="9144" bIns="9144"/>
+          <a:lstStyle/>
+          <a:p>
+            <a:pPr algn="ctr"/>
+            <a:r>
+              <a:rPr sz="1000" b="1">
+                <a:solidFill>
+                  <a:srgbClr val="333333"/>
+                </a:solidFill>
+                <a:latin typeface="Calibri"/>
+              </a:rPr>
+              <a:t>w ∈ [0,1]</a:t>
+            </a:r>
+          </a:p>
+        </p:txBody>
+      </p:sp>
+      <p:sp>
+        <p:nvSpPr>
+          <p:cNvPr id="12" name="Down Arrow 11"/>
+          <p:cNvSpPr/>
+          <p:nvPr/>
+        </p:nvSpPr>
+        <p:spPr>
+          <a:xfrm>
+            <a:off x="10442448" y="4462272"/>
+            <a:ext cx="274320" cy="384048"/>
+          </a:xfrm>
+          <a:prstGeom prst="downArrow">
+            <a:avLst/>
+          </a:prstGeom>
+          <a:solidFill>
+            <a:srgbClr val="1F4E79"/>
+          </a:solidFill>
+          <a:ln>
+            <a:noFill/>
+          </a:ln>
+        </p:spPr>
+        <p:style>
+          <a:lnRef idx="1">
+            <a:schemeClr val="accent1"/>
+          </a:lnRef>
+          <a:fillRef idx="3">
+            <a:schemeClr val="accent1"/>
+          </a:fillRef>
+          <a:effectRef idx="2">
+            <a:schemeClr val="accent1"/>
+          </a:effectRef>
+          <a:fontRef idx="minor">
+            <a:schemeClr val="lt1"/>
+          </a:fontRef>
+        </p:style>
+        <p:txBody>
+          <a:bodyPr rtlCol="0" anchor="ctr"/>
+          <a:lstStyle/>
+          <a:p>
+            <a:pPr algn="ctr"/>
+          </a:p>
+        </p:txBody>
+      </p:sp>
+      <p:sp>
+        <p:nvSpPr>
+          <p:cNvPr id="13" name="Rounded Rectangle 12"/>
+          <p:cNvSpPr/>
+          <p:nvPr/>
+        </p:nvSpPr>
+        <p:spPr>
+          <a:xfrm>
+            <a:off x="9098280" y="4864608"/>
+            <a:ext cx="2834640" cy="960120"/>
+          </a:xfrm>
+          <a:prstGeom prst="roundRect">
+            <a:avLst/>
+          </a:prstGeom>
+          <a:solidFill>
+            <a:srgbClr val="FDEBD0"/>
+          </a:solidFill>
+          <a:ln w="20320">
+            <a:solidFill>
+              <a:srgbClr val="C0392B"/>
+            </a:solidFill>
+          </a:ln>
+        </p:spPr>
+        <p:style>
+          <a:lnRef idx="1">
+            <a:schemeClr val="accent1"/>
+          </a:lnRef>
+          <a:fillRef idx="3">
+            <a:schemeClr val="accent1"/>
+          </a:fillRef>
+          <a:effectRef idx="2">
+            <a:schemeClr val="accent1"/>
+          </a:effectRef>
+          <a:fontRef idx="minor">
+            <a:schemeClr val="lt1"/>
+          </a:fontRef>
+        </p:style>
+        <p:txBody>
+          <a:bodyPr rtlCol="0" anchor="ctr" wrap="square" lIns="27432" rIns="27432" tIns="9144" bIns="9144"/>
+          <a:lstStyle/>
+          <a:p>
+            <a:pPr algn="ctr"/>
+            <a:r>
+              <a:rPr sz="1000" b="1">
+                <a:solidFill>
+                  <a:srgbClr val="333333"/>
+                </a:solidFill>
+                <a:latin typeface="Calibri"/>
+              </a:rPr>
+              <a:t>Soft mask</a:t>
+            </a:r>
+          </a:p>
+          <a:p>
+            <a:pPr algn="ctr"/>
+            <a:r>
+              <a:rPr sz="1000" b="1">
+                <a:solidFill>
+                  <a:srgbClr val="333333"/>
+                </a:solidFill>
+                <a:latin typeface="Calibri"/>
+              </a:rPr>
+              <a:t>w_eff = w·σ((w−cut)/τ)</a:t>
+            </a:r>
+          </a:p>
+          <a:p>
+            <a:pPr algn="ctr"/>
+            <a:r>
+              <a:rPr sz="1000" b="1">
+                <a:solidFill>
+                  <a:srgbClr val="333333"/>
+                </a:solidFill>
+                <a:latin typeface="Calibri"/>
+              </a:rPr>
+              <a:t>τ: 1.0 → 0.1 (annealed)</a:t>
+            </a:r>
+          </a:p>
+        </p:txBody>
+      </p:sp>
+      <p:sp>
+        <p:nvSpPr>
+          <p:cNvPr id="14" name="TextBox 13"/>
+          <p:cNvSpPr txBox="1"/>
+          <p:nvPr/>
+        </p:nvSpPr>
+        <p:spPr>
+          <a:xfrm>
+            <a:off x="6583680" y="4956048"/>
+            <a:ext cx="2468880" cy="731520"/>
           </a:xfrm>
           <a:prstGeom prst="rect">
             <a:avLst/>
           </a:prstGeom>
-        </p:spPr>
-      </p:pic>
+          <a:noFill/>
+        </p:spPr>
+        <p:txBody>
+          <a:bodyPr wrap="square">
+            <a:spAutoFit/>
+          </a:bodyPr>
+          <a:lstStyle/>
+          <a:p>
+            <a:pPr algn="ctr"/>
+            <a:r>
+              <a:rPr sz="900" i="0">
+                <a:solidFill>
+                  <a:srgbClr val="C0392B"/>
+                </a:solidFill>
+                <a:latin typeface="Calibri"/>
+              </a:rPr>
+              <a:t>τ annealed during
+training (1.0 → 0.1)</a:t>
+            </a:r>
+          </a:p>
+        </p:txBody>
+      </p:sp>
+      <p:sp>
+        <p:nvSpPr>
+          <p:cNvPr id="15" name="Right Arrow 14"/>
+          <p:cNvSpPr/>
+          <p:nvPr/>
+        </p:nvSpPr>
+        <p:spPr>
+          <a:xfrm>
+            <a:off x="9052560" y="5230368"/>
+            <a:ext cx="457200" cy="228600"/>
+          </a:xfrm>
+          <a:prstGeom prst="rightArrow">
+            <a:avLst/>
+          </a:prstGeom>
+          <a:solidFill>
+            <a:srgbClr val="C0392B"/>
+          </a:solidFill>
+          <a:ln>
+            <a:noFill/>
+          </a:ln>
+        </p:spPr>
+        <p:style>
+          <a:lnRef idx="1">
+            <a:schemeClr val="accent1"/>
+          </a:lnRef>
+          <a:fillRef idx="3">
+            <a:schemeClr val="accent1"/>
+          </a:fillRef>
+          <a:effectRef idx="2">
+            <a:schemeClr val="accent1"/>
+          </a:effectRef>
+          <a:fontRef idx="minor">
+            <a:schemeClr val="lt1"/>
+          </a:fontRef>
+        </p:style>
+        <p:txBody>
+          <a:bodyPr rtlCol="0" anchor="ctr"/>
+          <a:lstStyle/>
+          <a:p>
+            <a:pPr algn="ctr"/>
+          </a:p>
+        </p:txBody>
+      </p:sp>
+      <p:sp>
+        <p:nvSpPr>
+          <p:cNvPr id="16" name="Left Arrow 15"/>
+          <p:cNvSpPr/>
+          <p:nvPr/>
+        </p:nvSpPr>
+        <p:spPr>
+          <a:xfrm>
+            <a:off x="8595360" y="5394960"/>
+            <a:ext cx="502920" cy="228600"/>
+          </a:xfrm>
+          <a:prstGeom prst="leftArrow">
+            <a:avLst/>
+          </a:prstGeom>
+          <a:solidFill>
+            <a:srgbClr val="2CA02C"/>
+          </a:solidFill>
+          <a:ln>
+            <a:noFill/>
+          </a:ln>
+        </p:spPr>
+        <p:style>
+          <a:lnRef idx="1">
+            <a:schemeClr val="accent1"/>
+          </a:lnRef>
+          <a:fillRef idx="3">
+            <a:schemeClr val="accent1"/>
+          </a:fillRef>
+          <a:effectRef idx="2">
+            <a:schemeClr val="accent1"/>
+          </a:effectRef>
+          <a:fontRef idx="minor">
+            <a:schemeClr val="lt1"/>
+          </a:fontRef>
+        </p:style>
+        <p:txBody>
+          <a:bodyPr rtlCol="0" anchor="ctr"/>
+          <a:lstStyle/>
+          <a:p>
+            <a:pPr algn="ctr"/>
+          </a:p>
+        </p:txBody>
+      </p:sp>
+      <p:sp>
+        <p:nvSpPr>
+          <p:cNvPr id="17" name="Rounded Rectangle 16"/>
+          <p:cNvSpPr/>
+          <p:nvPr/>
+        </p:nvSpPr>
+        <p:spPr>
+          <a:xfrm>
+            <a:off x="6309360" y="5486400"/>
+            <a:ext cx="2194560" cy="731520"/>
+          </a:xfrm>
+          <a:prstGeom prst="roundRect">
+            <a:avLst/>
+          </a:prstGeom>
+          <a:solidFill>
+            <a:srgbClr val="EAF2F8"/>
+          </a:solidFill>
+          <a:ln w="20320">
+            <a:solidFill>
+              <a:srgbClr val="2CA02C"/>
+            </a:solidFill>
+          </a:ln>
+        </p:spPr>
+        <p:style>
+          <a:lnRef idx="1">
+            <a:schemeClr val="accent1"/>
+          </a:lnRef>
+          <a:fillRef idx="3">
+            <a:schemeClr val="accent1"/>
+          </a:fillRef>
+          <a:effectRef idx="2">
+            <a:schemeClr val="accent1"/>
+          </a:effectRef>
+          <a:fontRef idx="minor">
+            <a:schemeClr val="lt1"/>
+          </a:fontRef>
+        </p:style>
+        <p:txBody>
+          <a:bodyPr rtlCol="0" anchor="ctr" wrap="square" lIns="27432" rIns="27432" tIns="9144" bIns="9144"/>
+          <a:lstStyle/>
+          <a:p>
+            <a:pPr algn="ctr"/>
+            <a:r>
+              <a:rPr sz="900" b="0">
+                <a:solidFill>
+                  <a:srgbClr val="333333"/>
+                </a:solidFill>
+                <a:latin typeface="Calibri"/>
+              </a:rPr>
+              <a:t>weighted message passing</a:t>
+            </a:r>
+          </a:p>
+          <a:p>
+            <a:pPr algn="ctr"/>
+            <a:r>
+              <a:rPr sz="900" b="0">
+                <a:solidFill>
+                  <a:srgbClr val="333333"/>
+                </a:solidFill>
+                <a:latin typeface="Calibri"/>
+              </a:rPr>
+              <a:t>(back into the GN blocks)</a:t>
+            </a:r>
+          </a:p>
+        </p:txBody>
+      </p:sp>
+      <p:sp>
+        <p:nvSpPr>
+          <p:cNvPr id="18" name="Down Arrow 17"/>
+          <p:cNvSpPr/>
+          <p:nvPr/>
+        </p:nvSpPr>
+        <p:spPr>
+          <a:xfrm>
+            <a:off x="10607040" y="5852160"/>
+            <a:ext cx="274320" cy="365760"/>
+          </a:xfrm>
+          <a:prstGeom prst="downArrow">
+            <a:avLst/>
+          </a:prstGeom>
+          <a:solidFill>
+            <a:srgbClr val="1F4E79"/>
+          </a:solidFill>
+          <a:ln>
+            <a:noFill/>
+          </a:ln>
+        </p:spPr>
+        <p:style>
+          <a:lnRef idx="1">
+            <a:schemeClr val="accent1"/>
+          </a:lnRef>
+          <a:fillRef idx="3">
+            <a:schemeClr val="accent1"/>
+          </a:fillRef>
+          <a:effectRef idx="2">
+            <a:schemeClr val="accent1"/>
+          </a:effectRef>
+          <a:fontRef idx="minor">
+            <a:schemeClr val="lt1"/>
+          </a:fontRef>
+        </p:style>
+        <p:txBody>
+          <a:bodyPr rtlCol="0" anchor="ctr"/>
+          <a:lstStyle/>
+          <a:p>
+            <a:pPr algn="ctr"/>
+          </a:p>
+        </p:txBody>
+      </p:sp>
+      <p:sp>
+        <p:nvSpPr>
+          <p:cNvPr id="19" name="Rounded Rectangle 18"/>
+          <p:cNvSpPr/>
+          <p:nvPr/>
+        </p:nvSpPr>
+        <p:spPr>
+          <a:xfrm>
+            <a:off x="9418320" y="6172200"/>
+            <a:ext cx="2468880" cy="365760"/>
+          </a:xfrm>
+          <a:prstGeom prst="roundRect">
+            <a:avLst/>
+          </a:prstGeom>
+          <a:solidFill>
+            <a:srgbClr val="EAF2F8"/>
+          </a:solidFill>
+          <a:ln w="20320">
+            <a:solidFill>
+              <a:srgbClr val="1F4E79"/>
+            </a:solidFill>
+          </a:ln>
+        </p:spPr>
+        <p:style>
+          <a:lnRef idx="1">
+            <a:schemeClr val="accent1"/>
+          </a:lnRef>
+          <a:fillRef idx="3">
+            <a:schemeClr val="accent1"/>
+          </a:fillRef>
+          <a:effectRef idx="2">
+            <a:schemeClr val="accent1"/>
+          </a:effectRef>
+          <a:fontRef idx="minor">
+            <a:schemeClr val="lt1"/>
+          </a:fontRef>
+        </p:style>
+        <p:txBody>
+          <a:bodyPr rtlCol="0" anchor="ctr" wrap="square" lIns="27432" rIns="27432" tIns="9144" bIns="9144"/>
+          <a:lstStyle/>
+          <a:p>
+            <a:pPr algn="ctr"/>
+            <a:r>
+              <a:rPr sz="800" b="0">
+                <a:solidFill>
+                  <a:srgbClr val="333333"/>
+                </a:solidFill>
+                <a:latin typeface="Calibri"/>
+              </a:rPr>
+              <a:t>pruning loss vs truth (BCE)</a:t>
+            </a:r>
+          </a:p>
+          <a:p>
+            <a:pPr algn="ctr"/>
+            <a:r>
+              <a:rPr sz="800" b="0">
+                <a:solidFill>
+                  <a:srgbClr val="333333"/>
+                </a:solidFill>
+                <a:latin typeface="Calibri"/>
+              </a:rPr>
+              <a:t>(mask makes it differentiable)</a:t>
+            </a:r>
+          </a:p>
+        </p:txBody>
+      </p:sp>
+      <p:sp>
+        <p:nvSpPr>
+          <p:cNvPr id="20" name="TextBox 19"/>
+          <p:cNvSpPr txBox="1"/>
+          <p:nvPr/>
+        </p:nvSpPr>
+        <p:spPr>
+          <a:xfrm>
+            <a:off x="6583680" y="6309360"/>
+            <a:ext cx="2377440" cy="320040"/>
+          </a:xfrm>
+          <a:prstGeom prst="rect">
+            <a:avLst/>
+          </a:prstGeom>
+          <a:noFill/>
+        </p:spPr>
+        <p:txBody>
+          <a:bodyPr wrap="square">
+            <a:spAutoFit/>
+          </a:bodyPr>
+          <a:lstStyle/>
+          <a:p>
+            <a:pPr algn="ctr"/>
+            <a:r>
+              <a:rPr sz="900" i="1">
+                <a:solidFill>
+                  <a:srgbClr val="666666"/>
+                </a:solidFill>
+                <a:latin typeface="Calibri"/>
+              </a:rPr>
+              <a:t>inference (no mask): keep if w ≥ 0.9</a:t>
+            </a:r>
+          </a:p>
+        </p:txBody>
+      </p:sp>
     </p:spTree>
   </p:cSld>
   <p:clrMapOvr>

</xml_diff>

<commit_message>
docs: clarify cut (fixed per run) vs inference threshold 0.9 in S4 figures
</commit_message>
<xml_diff>
--- a/meeting_figs/DFEI_progress_20260902_EN.pptx
+++ b/meeting_figs/DFEI_progress_20260902_EN.pptx
@@ -4701,7 +4701,7 @@
         <p:spPr>
           <a:xfrm>
             <a:off x="640080" y="3611880"/>
-            <a:ext cx="5760720" cy="2199932"/>
+            <a:ext cx="5760720" cy="2206685"/>
           </a:xfrm>
           <a:prstGeom prst="rect">
             <a:avLst/>
@@ -5078,7 +5078,7 @@
           <a:p>
             <a:pPr algn="ctr"/>
             <a:r>
-              <a:rPr sz="1000" b="1">
+              <a:rPr sz="900" b="1">
                 <a:solidFill>
                   <a:srgbClr val="333333"/>
                 </a:solidFill>
@@ -5090,7 +5090,7 @@
           <a:p>
             <a:pPr algn="ctr"/>
             <a:r>
-              <a:rPr sz="1000" b="1">
+              <a:rPr sz="900" b="1">
                 <a:solidFill>
                   <a:srgbClr val="333333"/>
                 </a:solidFill>
@@ -5102,13 +5102,25 @@
           <a:p>
             <a:pPr algn="ctr"/>
             <a:r>
-              <a:rPr sz="1000" b="1">
+              <a:rPr sz="900" b="1">
                 <a:solidFill>
                   <a:srgbClr val="333333"/>
                 </a:solidFill>
                 <a:latin typeface="Calibri"/>
               </a:rPr>
-              <a:t>τ: 1.0 → 0.1 (annealed)</a:t>
+              <a:t>cut fixed per run (0.85)</a:t>
+            </a:r>
+          </a:p>
+          <a:p>
+            <a:pPr algn="ctr"/>
+            <a:r>
+              <a:rPr sz="900" b="1">
+                <a:solidFill>
+                  <a:srgbClr val="333333"/>
+                </a:solidFill>
+                <a:latin typeface="Calibri"/>
+              </a:rPr>
+              <a:t>τ annealed: 1.0 → 0.1</a:t>
             </a:r>
           </a:p>
         </p:txBody>
@@ -5137,14 +5149,15 @@
           <a:p>
             <a:pPr algn="ctr"/>
             <a:r>
-              <a:rPr sz="900" i="0">
+              <a:rPr sz="800" i="0">
                 <a:solidFill>
                   <a:srgbClr val="C0392B"/>
                 </a:solidFill>
                 <a:latin typeface="Calibri"/>
               </a:rPr>
-              <a:t>τ annealed during
-training (1.0 → 0.1)</a:t>
+              <a:t>within a run:
+cut fixed, τ anneals
+→ same cut, sharper enforcement</a:t>
             </a:r>
           </a:p>
         </p:txBody>

</xml_diff>

<commit_message>
docs: add in-chain LCA figures (dilution, hinge, CE, where) to deck S5
</commit_message>
<xml_diff>
--- a/meeting_figs/DFEI_progress_20260902_EN.pptx
+++ b/meeting_figs/DFEI_progress_20260902_EN.pptx
@@ -5606,8 +5606,8 @@
         </p:nvSpPr>
         <p:spPr>
           <a:xfrm>
-            <a:off x="731520" y="1280160"/>
-            <a:ext cx="10789920" cy="5120640"/>
+            <a:off x="731520" y="1234440"/>
+            <a:ext cx="10789920" cy="2286000"/>
           </a:xfrm>
           <a:prstGeom prst="rect">
             <a:avLst/>
@@ -5632,7 +5632,7 @@
                 </a:solidFill>
                 <a:latin typeface="Calibri"/>
               </a:rPr>
-              <a:t>•  Class-2 (same-mother) edges are the structural bottleneck:</a:t>
+              <a:t>•  Class-2 (same-mother) edges are the structural bottleneck: weight 3.0 (v37) over-weighted → 2.0 (v38)</a:t>
             </a:r>
           </a:p>
           <a:p>
@@ -5642,13 +5642,13 @@
               </a:spcAft>
             </a:pPr>
             <a:r>
-              <a:rPr sz="2000">
+              <a:rPr sz="2200">
                 <a:solidFill>
                   <a:srgbClr val="333333"/>
                 </a:solidFill>
                 <a:latin typeface="Calibri"/>
               </a:rPr>
-              <a:t>    –  weight 3.0 (v37) over-weighted → class1 dropped; settled at 2.0 (v38)</a:t>
+              <a:t>•  In-chain consistency, on truth-chain edges only:</a:t>
             </a:r>
           </a:p>
           <a:p>
@@ -5658,13 +5658,13 @@
               </a:spcAft>
             </a:pPr>
             <a:r>
-              <a:rPr sz="2200">
+              <a:rPr sz="2000">
                 <a:solidFill>
                   <a:srgbClr val="333333"/>
                 </a:solidFill>
                 <a:latin typeface="Calibri"/>
               </a:rPr>
-              <a:t>•  In-chain LCA consistency, supervised only on truth-chain edges:</a:t>
+              <a:t>    –  hinge (v37): keep chain edges confident (margin 0.3)</a:t>
             </a:r>
           </a:p>
           <a:p>
@@ -5680,7 +5680,7 @@
                 </a:solidFill>
                 <a:latin typeface="Calibri"/>
               </a:rPr>
-              <a:t>    –  v37: hinge loss — keep chain edges confident (margin 0.3)</a:t>
+              <a:t>    –  chain-CE (v38): direct cross-entropy on chain-edge classes — structural edges are ~0.1% of all edges</a:t>
             </a:r>
           </a:p>
           <a:p>
@@ -5690,33 +5690,41 @@
               </a:spcAft>
             </a:pPr>
             <a:r>
-              <a:rPr sz="2000">
+              <a:rPr sz="2200">
                 <a:solidFill>
                   <a:srgbClr val="333333"/>
                 </a:solidFill>
                 <a:latin typeface="Calibri"/>
               </a:rPr>
-              <a:t>    –  v38: + cross-entropy on chain-edge classes — structural edges are ~0.1% of all edges; direct CE prevents class0 dilution</a:t>
-            </a:r>
-          </a:p>
-          <a:p>
-            <a:pPr>
-              <a:spcAft>
-                <a:spcPts val="1000"/>
-              </a:spcAft>
-            </a:pPr>
-            <a:r>
-              <a:rPr sz="2200">
-                <a:solidFill>
-                  <a:srgbClr val="333333"/>
-                </a:solidFill>
-                <a:latin typeface="Calibri"/>
-              </a:rPr>
               <a:t>•  Net effect of Part 1 (v31 → v38): PerfectReco 23.9% → 29.3%</a:t>
             </a:r>
           </a:p>
         </p:txBody>
       </p:sp>
+      <p:pic>
+        <p:nvPicPr>
+          <p:cNvPr id="6" name="Picture 5" descr="chain_lca_curves.png"/>
+          <p:cNvPicPr>
+            <a:picLocks noChangeAspect="1"/>
+          </p:cNvPicPr>
+          <p:nvPr/>
+        </p:nvPicPr>
+        <p:blipFill>
+          <a:blip r:embed="rId2"/>
+          <a:stretch>
+            <a:fillRect/>
+          </a:stretch>
+        </p:blipFill>
+        <p:spPr>
+          <a:xfrm>
+            <a:off x="731520" y="3611880"/>
+            <a:ext cx="10881360" cy="2597411"/>
+          </a:xfrm>
+          <a:prstGeom prst="rect">
+            <a:avLst/>
+          </a:prstGeom>
+        </p:spPr>
+      </p:pic>
     </p:spTree>
   </p:cSld>
   <p:clrMapOvr>

</xml_diff>

<commit_message>
docs: add class-imbalance + before/after chain figures as new S6
</commit_message>
<xml_diff>
--- a/meeting_figs/DFEI_progress_20260902_EN.pptx
+++ b/meeting_figs/DFEI_progress_20260902_EN.pptx
@@ -17,6 +17,7 @@
     <p:sldId id="265" r:id="rId16"/>
     <p:sldId id="266" r:id="rId17"/>
     <p:sldId id="267" r:id="rId18"/>
+    <p:sldId id="268" r:id="rId19"/>
   </p:sldIdLst>
   <p:sldSz cx="12191695" cy="6858000" type="screen4x3"/>
   <p:notesSz cx="6858000" cy="9144000"/>
@@ -3316,7 +3317,18 @@
                 </a:solidFill>
                 <a:latin typeface="Calibri"/>
               </a:rPr>
-              <a:t>Part 3 — Controlled Failures and Their Lessons</a:t>
+              <a:t>Verification: Linear Probes on the Frozen Backbone</a:t>
+            </a:r>
+          </a:p>
+          <a:p>
+            <a:r>
+              <a:rPr sz="1700">
+                <a:solidFill>
+                  <a:srgbClr val="666666"/>
+                </a:solidFill>
+                <a:latin typeface="Calibri"/>
+              </a:rPr>
+              <a:t>Ridge regression; R² of the physical quantity</a:t>
             </a:r>
           </a:p>
         </p:txBody>
@@ -3364,16 +3376,244 @@
           </a:p>
         </p:txBody>
       </p:sp>
-      <p:sp>
-        <p:nvSpPr>
-          <p:cNvPr id="5" name="TextBox 4"/>
+      <p:graphicFrame>
+        <p:nvGraphicFramePr>
+          <p:cNvPr id="5" name="Table 4"/>
+          <p:cNvGraphicFramePr>
+            <a:graphicFrameLocks noGrp="1"/>
+          </p:cNvGraphicFramePr>
+          <p:nvPr/>
+        </p:nvGraphicFramePr>
+        <p:xfrm>
+          <a:off x="731520" y="1371600"/>
+          <a:ext cx="7772400" cy="1645920"/>
+        </p:xfrm>
+        <a:graphic>
+          <a:graphicData uri="http://schemas.openxmlformats.org/drawingml/2006/table">
+            <a:tbl>
+              <a:tblPr firstRow="1" bandRow="1">
+                <a:tableStyleId>{5C22544A-7EE6-4342-B048-85BDC9FD1C3A}</a:tableStyleId>
+              </a:tblPr>
+              <a:tblGrid>
+                <a:gridCol w="2590800"/>
+                <a:gridCol w="2590800"/>
+                <a:gridCol w="2590800"/>
+              </a:tblGrid>
+              <a:tr h="548640">
+                <a:tc>
+                  <a:txBody>
+                    <a:bodyPr/>
+                    <a:lstStyle/>
+                    <a:p>
+                      <a:pPr algn="ctr"/>
+                      <a:r>
+                        <a:rPr sz="2000">
+                          <a:solidFill>
+                            <a:srgbClr val="FFFFFF"/>
+                          </a:solidFill>
+                          <a:latin typeface="Calibri"/>
+                        </a:rPr>
+                        <a:t>Probe</a:t>
+                      </a:r>
+                    </a:p>
+                  </a:txBody>
+                  <a:tcPr marL="54864" marR="54864" marT="18288" marB="18288">
+                    <a:solidFill>
+                      <a:srgbClr val="1F4E79"/>
+                    </a:solidFill>
+                  </a:tcPr>
+                </a:tc>
+                <a:tc>
+                  <a:txBody>
+                    <a:bodyPr/>
+                    <a:lstStyle/>
+                    <a:p>
+                      <a:pPr algn="ctr"/>
+                      <a:r>
+                        <a:rPr sz="2000">
+                          <a:solidFill>
+                            <a:srgbClr val="FFFFFF"/>
+                          </a:solidFill>
+                          <a:latin typeface="Calibri"/>
+                        </a:rPr>
+                        <a:t>v38</a:t>
+                      </a:r>
+                    </a:p>
+                  </a:txBody>
+                  <a:tcPr marL="54864" marR="54864" marT="18288" marB="18288">
+                    <a:solidFill>
+                      <a:srgbClr val="1F4E79"/>
+                    </a:solidFill>
+                  </a:tcPr>
+                </a:tc>
+                <a:tc>
+                  <a:txBody>
+                    <a:bodyPr/>
+                    <a:lstStyle/>
+                    <a:p>
+                      <a:pPr algn="ctr"/>
+                      <a:r>
+                        <a:rPr sz="2000">
+                          <a:solidFill>
+                            <a:srgbClr val="FFFFFF"/>
+                          </a:solidFill>
+                          <a:latin typeface="Calibri"/>
+                        </a:rPr>
+                        <a:t>masshead2</a:t>
+                      </a:r>
+                    </a:p>
+                  </a:txBody>
+                  <a:tcPr marL="54864" marR="54864" marT="18288" marB="18288">
+                    <a:solidFill>
+                      <a:srgbClr val="1F4E79"/>
+                    </a:solidFill>
+                  </a:tcPr>
+                </a:tc>
+              </a:tr>
+              <a:tr h="548640">
+                <a:tc>
+                  <a:txBody>
+                    <a:bodyPr/>
+                    <a:lstStyle/>
+                    <a:p>
+                      <a:pPr algn="l"/>
+                      <a:r>
+                        <a:rPr sz="2000">
+                          <a:solidFill>
+                            <a:srgbClr val="333333"/>
+                          </a:solidFill>
+                          <a:latin typeface="Calibri"/>
+                        </a:rPr>
+                        <a:t>edge repr → log10(m_ππ)</a:t>
+                      </a:r>
+                    </a:p>
+                  </a:txBody>
+                  <a:tcPr marL="54864" marR="54864" marT="18288" marB="18288"/>
+                </a:tc>
+                <a:tc>
+                  <a:txBody>
+                    <a:bodyPr/>
+                    <a:lstStyle/>
+                    <a:p>
+                      <a:pPr algn="l"/>
+                      <a:r>
+                        <a:rPr sz="2000">
+                          <a:solidFill>
+                            <a:srgbClr val="333333"/>
+                          </a:solidFill>
+                          <a:latin typeface="Calibri"/>
+                        </a:rPr>
+                        <a:t>R² = 0.003</a:t>
+                      </a:r>
+                    </a:p>
+                  </a:txBody>
+                  <a:tcPr marL="54864" marR="54864" marT="18288" marB="18288"/>
+                </a:tc>
+                <a:tc>
+                  <a:txBody>
+                    <a:bodyPr/>
+                    <a:lstStyle/>
+                    <a:p>
+                      <a:pPr algn="l"/>
+                      <a:r>
+                        <a:rPr sz="2000">
+                          <a:solidFill>
+                            <a:srgbClr val="333333"/>
+                          </a:solidFill>
+                          <a:latin typeface="Calibri"/>
+                        </a:rPr>
+                        <a:t>R² = 0.930</a:t>
+                      </a:r>
+                    </a:p>
+                  </a:txBody>
+                  <a:tcPr marL="54864" marR="54864" marT="18288" marB="18288"/>
+                </a:tc>
+              </a:tr>
+              <a:tr h="548640">
+                <a:tc>
+                  <a:txBody>
+                    <a:bodyPr/>
+                    <a:lstStyle/>
+                    <a:p>
+                      <a:pPr algn="l"/>
+                      <a:r>
+                        <a:rPr sz="2000">
+                          <a:solidFill>
+                            <a:srgbClr val="333333"/>
+                          </a:solidFill>
+                          <a:latin typeface="Calibri"/>
+                        </a:rPr>
+                        <a:t>node repr → p (px/py/pz)</a:t>
+                      </a:r>
+                    </a:p>
+                  </a:txBody>
+                  <a:tcPr marL="54864" marR="54864" marT="18288" marB="18288">
+                    <a:solidFill>
+                      <a:srgbClr val="EAF2F8"/>
+                    </a:solidFill>
+                  </a:tcPr>
+                </a:tc>
+                <a:tc>
+                  <a:txBody>
+                    <a:bodyPr/>
+                    <a:lstStyle/>
+                    <a:p>
+                      <a:pPr algn="l"/>
+                      <a:r>
+                        <a:rPr sz="2000">
+                          <a:solidFill>
+                            <a:srgbClr val="333333"/>
+                          </a:solidFill>
+                          <a:latin typeface="Calibri"/>
+                        </a:rPr>
+                        <a:t>R² ≈ 0</a:t>
+                      </a:r>
+                    </a:p>
+                  </a:txBody>
+                  <a:tcPr marL="54864" marR="54864" marT="18288" marB="18288">
+                    <a:solidFill>
+                      <a:srgbClr val="EAF2F8"/>
+                    </a:solidFill>
+                  </a:tcPr>
+                </a:tc>
+                <a:tc>
+                  <a:txBody>
+                    <a:bodyPr/>
+                    <a:lstStyle/>
+                    <a:p>
+                      <a:pPr algn="l"/>
+                      <a:r>
+                        <a:rPr sz="2000">
+                          <a:solidFill>
+                            <a:srgbClr val="333333"/>
+                          </a:solidFill>
+                          <a:latin typeface="Calibri"/>
+                        </a:rPr>
+                        <a:t>R² ≈ 0</a:t>
+                      </a:r>
+                    </a:p>
+                  </a:txBody>
+                  <a:tcPr marL="54864" marR="54864" marT="18288" marB="18288">
+                    <a:solidFill>
+                      <a:srgbClr val="EAF2F8"/>
+                    </a:solidFill>
+                  </a:tcPr>
+                </a:tc>
+              </a:tr>
+            </a:tbl>
+          </a:graphicData>
+        </a:graphic>
+      </p:graphicFrame>
+      <p:sp>
+        <p:nvSpPr>
+          <p:cNvPr id="6" name="TextBox 5"/>
           <p:cNvSpPr txBox="1"/>
           <p:nvPr/>
         </p:nvSpPr>
         <p:spPr>
           <a:xfrm>
-            <a:off x="731520" y="1280160"/>
-            <a:ext cx="10789920" cy="4937760"/>
+            <a:off x="731520" y="3383280"/>
+            <a:ext cx="10789920" cy="2560320"/>
           </a:xfrm>
           <a:prstGeom prst="rect">
             <a:avLst/>
@@ -3398,7 +3638,7 @@
                 </a:solidFill>
                 <a:latin typeface="Calibri"/>
               </a:rPr>
-              <a:t>•  PV subgraph training (v39-42): training on per-PV subgraphs while inference runs on the full graph</a:t>
+              <a:t>•  Mass supervision moves mass information into the edge representation — confirmed end-to-end</a:t>
             </a:r>
           </a:p>
           <a:p>
@@ -3408,77 +3648,13 @@
               </a:spcAft>
             </a:pPr>
             <a:r>
-              <a:rPr sz="2000">
+              <a:rPr sz="2200">
                 <a:solidFill>
                   <a:srgbClr val="333333"/>
                 </a:solidFill>
                 <a:latin typeface="Calibri"/>
               </a:rPr>
-              <a:t>    –  full-graph ability degraded: class1 76.8% → 56.4%; line closed</a:t>
-            </a:r>
-          </a:p>
-          <a:p>
-            <a:pPr>
-              <a:spcAft>
-                <a:spcPts val="1000"/>
-              </a:spcAft>
-            </a:pPr>
-            <a:r>
-              <a:rPr sz="2200">
-                <a:solidFill>
-                  <a:srgbClr val="333333"/>
-                </a:solidFill>
-                <a:latin typeface="Calibri"/>
-              </a:rPr>
-              <a:t>•  Combined mass + struct + mom (v48): aux losses (0.877) exceed the main task (0.559)</a:t>
-            </a:r>
-          </a:p>
-          <a:p>
-            <a:pPr>
-              <a:spcAft>
-                <a:spcPts val="1000"/>
-              </a:spcAft>
-            </a:pPr>
-            <a:r>
-              <a:rPr sz="2000">
-                <a:solidFill>
-                  <a:srgbClr val="333333"/>
-                </a:solidFill>
-                <a:latin typeface="Calibri"/>
-              </a:rPr>
-              <a:t>    –  reconstruction dropped 5pp although LCAG did not — backbone pulled toward auxiliary tasks</a:t>
-            </a:r>
-          </a:p>
-          <a:p>
-            <a:pPr>
-              <a:spcAft>
-                <a:spcPts val="1000"/>
-              </a:spcAft>
-            </a:pPr>
-            <a:r>
-              <a:rPr sz="2000">
-                <a:solidFill>
-                  <a:srgbClr val="333333"/>
-                </a:solidFill>
-                <a:latin typeface="Calibri"/>
-              </a:rPr>
-              <a:t>    –  resolution: lower aux weights — mom 0.2, struct 0.3</a:t>
-            </a:r>
-          </a:p>
-          <a:p>
-            <a:pPr>
-              <a:spcAft>
-                <a:spcPts val="1000"/>
-              </a:spcAft>
-            </a:pPr>
-            <a:r>
-              <a:rPr sz="2200">
-                <a:solidFill>
-                  <a:srgbClr val="333333"/>
-                </a:solidFill>
-                <a:latin typeface="Calibri"/>
-              </a:rPr>
-              <a:t>•  Lessons: train/infer graph mismatch is fatal; gradient balance between heads must be explicit</a:t>
+              <a:t>•  Nodes remain unreadable for momentum → addressed by the momentum head (to be re-probed)</a:t>
             </a:r>
           </a:p>
         </p:txBody>
@@ -3564,7 +3740,7 @@
                 </a:solidFill>
                 <a:latin typeface="Calibri"/>
               </a:rPr>
-              <a:t>Part 4 — Ongoing Attempts</a:t>
+              <a:t>Part 3 — Controlled Failures and Their Lessons</a:t>
             </a:r>
           </a:p>
         </p:txBody>
@@ -3621,7 +3797,7 @@
         <p:spPr>
           <a:xfrm>
             <a:off x="731520" y="1280160"/>
-            <a:ext cx="10789920" cy="5120640"/>
+            <a:ext cx="10789920" cy="4937760"/>
           </a:xfrm>
           <a:prstGeom prst="rect">
             <a:avLst/>
@@ -3646,7 +3822,7 @@
                 </a:solidFill>
                 <a:latin typeface="Calibri"/>
               </a:rPr>
-              <a:t>•  Wider latent space (v53): tracks nodes 32-dim, tt edges 24-dim — 16-dim sits at the physical-DOF lower bound</a:t>
+              <a:t>•  PV subgraph training (v39-42): training on per-PV subgraphs while inference runs on the full graph</a:t>
             </a:r>
           </a:p>
           <a:p>
@@ -3662,7 +3838,7 @@
                 </a:solidFill>
                 <a:latin typeface="Calibri"/>
               </a:rPr>
-              <a:t>    –  from-scratch training interrupted at ep74/150, not converged; resume planned</a:t>
+              <a:t>    –  full-graph ability degraded: class1 76.8% → 56.4%; line closed</a:t>
             </a:r>
           </a:p>
           <a:p>
@@ -3678,7 +3854,7 @@
                 </a:solidFill>
                 <a:latin typeface="Calibri"/>
               </a:rPr>
-              <a:t>•  Public-data verification (v45/v49): no PID, class2/3 counts differ 4-14×; resume best val 33.4 @ep73</a:t>
+              <a:t>•  Combined mass + struct + mom (v48): aux losses (0.877) exceed the main task (0.559)</a:t>
             </a:r>
           </a:p>
           <a:p>
@@ -3688,13 +3864,13 @@
               </a:spcAft>
             </a:pPr>
             <a:r>
-              <a:rPr sz="2200">
+              <a:rPr sz="2000">
                 <a:solidFill>
                   <a:srgbClr val="333333"/>
                 </a:solidFill>
                 <a:latin typeface="Calibri"/>
               </a:rPr>
-              <a:t>•  Learned deterministic annealing: inference-side PV clustering with learned affinity (no subgraph training); core module CPU-verified</a:t>
+              <a:t>    –  reconstruction dropped 5pp although LCAG did not — backbone pulled toward auxiliary tasks</a:t>
             </a:r>
           </a:p>
           <a:p>
@@ -3704,13 +3880,29 @@
               </a:spcAft>
             </a:pPr>
             <a:r>
+              <a:rPr sz="2000">
+                <a:solidFill>
+                  <a:srgbClr val="333333"/>
+                </a:solidFill>
+                <a:latin typeface="Calibri"/>
+              </a:rPr>
+              <a:t>    –  resolution: lower aux weights — mom 0.2, struct 0.3</a:t>
+            </a:r>
+          </a:p>
+          <a:p>
+            <a:pPr>
+              <a:spcAft>
+                <a:spcPts val="1000"/>
+              </a:spcAft>
+            </a:pPr>
+            <a:r>
               <a:rPr sz="2200">
                 <a:solidFill>
                   <a:srgbClr val="333333"/>
                 </a:solidFill>
                 <a:latin typeface="Calibri"/>
               </a:rPr>
-              <a:t>•  Chain scoring for trigger assistance: criteria AUC 0.90 / 0.78 (realistic); training ready, needs GPU</a:t>
+              <a:t>•  Lessons: train/infer graph mismatch is fatal; gradient balance between heads must be explicit</a:t>
             </a:r>
           </a:p>
         </p:txBody>
@@ -3763,6 +3955,238 @@
                 <a:latin typeface="Calibri"/>
               </a:rPr>
               <a:t>Qingxiang Guo · UCAS · DFEI group meeting      12</a:t>
+            </a:r>
+          </a:p>
+        </p:txBody>
+      </p:sp>
+      <p:sp>
+        <p:nvSpPr>
+          <p:cNvPr id="3" name="TextBox 2"/>
+          <p:cNvSpPr txBox="1"/>
+          <p:nvPr/>
+        </p:nvSpPr>
+        <p:spPr>
+          <a:xfrm>
+            <a:off x="502920" y="164592"/>
+            <a:ext cx="11155680" cy="914400"/>
+          </a:xfrm>
+          <a:prstGeom prst="rect">
+            <a:avLst/>
+          </a:prstGeom>
+          <a:noFill/>
+        </p:spPr>
+        <p:txBody>
+          <a:bodyPr wrap="square">
+            <a:spAutoFit/>
+          </a:bodyPr>
+          <a:lstStyle/>
+          <a:p>
+            <a:r>
+              <a:rPr sz="3800" b="1">
+                <a:solidFill>
+                  <a:srgbClr val="1F4E79"/>
+                </a:solidFill>
+                <a:latin typeface="Calibri"/>
+              </a:rPr>
+              <a:t>Part 4 — Ongoing Attempts</a:t>
+            </a:r>
+          </a:p>
+        </p:txBody>
+      </p:sp>
+      <p:sp>
+        <p:nvSpPr>
+          <p:cNvPr id="4" name="Rectangle 3"/>
+          <p:cNvSpPr/>
+          <p:nvPr/>
+        </p:nvSpPr>
+        <p:spPr>
+          <a:xfrm>
+            <a:off x="548640" y="1188720"/>
+            <a:ext cx="11064240" cy="38100"/>
+          </a:xfrm>
+          <a:prstGeom prst="rect">
+            <a:avLst/>
+          </a:prstGeom>
+          <a:solidFill>
+            <a:srgbClr val="1F4E79"/>
+          </a:solidFill>
+          <a:ln>
+            <a:noFill/>
+          </a:ln>
+        </p:spPr>
+        <p:style>
+          <a:lnRef idx="1">
+            <a:schemeClr val="accent1"/>
+          </a:lnRef>
+          <a:fillRef idx="3">
+            <a:schemeClr val="accent1"/>
+          </a:fillRef>
+          <a:effectRef idx="2">
+            <a:schemeClr val="accent1"/>
+          </a:effectRef>
+          <a:fontRef idx="minor">
+            <a:schemeClr val="lt1"/>
+          </a:fontRef>
+        </p:style>
+        <p:txBody>
+          <a:bodyPr rtlCol="0" anchor="ctr"/>
+          <a:lstStyle/>
+          <a:p>
+            <a:pPr algn="ctr"/>
+          </a:p>
+        </p:txBody>
+      </p:sp>
+      <p:sp>
+        <p:nvSpPr>
+          <p:cNvPr id="5" name="TextBox 4"/>
+          <p:cNvSpPr txBox="1"/>
+          <p:nvPr/>
+        </p:nvSpPr>
+        <p:spPr>
+          <a:xfrm>
+            <a:off x="731520" y="1280160"/>
+            <a:ext cx="10789920" cy="5120640"/>
+          </a:xfrm>
+          <a:prstGeom prst="rect">
+            <a:avLst/>
+          </a:prstGeom>
+          <a:noFill/>
+        </p:spPr>
+        <p:txBody>
+          <a:bodyPr wrap="square">
+            <a:spAutoFit/>
+          </a:bodyPr>
+          <a:lstStyle/>
+          <a:p>
+            <a:pPr>
+              <a:spcAft>
+                <a:spcPts val="1000"/>
+              </a:spcAft>
+            </a:pPr>
+            <a:r>
+              <a:rPr sz="2200">
+                <a:solidFill>
+                  <a:srgbClr val="333333"/>
+                </a:solidFill>
+                <a:latin typeface="Calibri"/>
+              </a:rPr>
+              <a:t>•  Wider latent space (v53): tracks nodes 32-dim, tt edges 24-dim — 16-dim sits at the physical-DOF lower bound</a:t>
+            </a:r>
+          </a:p>
+          <a:p>
+            <a:pPr>
+              <a:spcAft>
+                <a:spcPts val="1000"/>
+              </a:spcAft>
+            </a:pPr>
+            <a:r>
+              <a:rPr sz="2000">
+                <a:solidFill>
+                  <a:srgbClr val="333333"/>
+                </a:solidFill>
+                <a:latin typeface="Calibri"/>
+              </a:rPr>
+              <a:t>    –  from-scratch training interrupted at ep74/150, not converged; resume planned</a:t>
+            </a:r>
+          </a:p>
+          <a:p>
+            <a:pPr>
+              <a:spcAft>
+                <a:spcPts val="1000"/>
+              </a:spcAft>
+            </a:pPr>
+            <a:r>
+              <a:rPr sz="2200">
+                <a:solidFill>
+                  <a:srgbClr val="333333"/>
+                </a:solidFill>
+                <a:latin typeface="Calibri"/>
+              </a:rPr>
+              <a:t>•  Public-data verification (v45/v49): no PID, class2/3 counts differ 4-14×; resume best val 33.4 @ep73</a:t>
+            </a:r>
+          </a:p>
+          <a:p>
+            <a:pPr>
+              <a:spcAft>
+                <a:spcPts val="1000"/>
+              </a:spcAft>
+            </a:pPr>
+            <a:r>
+              <a:rPr sz="2200">
+                <a:solidFill>
+                  <a:srgbClr val="333333"/>
+                </a:solidFill>
+                <a:latin typeface="Calibri"/>
+              </a:rPr>
+              <a:t>•  Learned deterministic annealing: inference-side PV clustering with learned affinity (no subgraph training); core module CPU-verified</a:t>
+            </a:r>
+          </a:p>
+          <a:p>
+            <a:pPr>
+              <a:spcAft>
+                <a:spcPts val="1000"/>
+              </a:spcAft>
+            </a:pPr>
+            <a:r>
+              <a:rPr sz="2200">
+                <a:solidFill>
+                  <a:srgbClr val="333333"/>
+                </a:solidFill>
+                <a:latin typeface="Calibri"/>
+              </a:rPr>
+              <a:t>•  Chain scoring for trigger assistance: criteria AUC 0.90 / 0.78 (realistic); training ready, needs GPU</a:t>
+            </a:r>
+          </a:p>
+        </p:txBody>
+      </p:sp>
+    </p:spTree>
+  </p:cSld>
+  <p:clrMapOvr>
+    <a:masterClrMapping/>
+  </p:clrMapOvr>
+</p:sld>
+</file>
+
+<file path=ppt/slides/slide13.xml><?xml version="1.0" encoding="utf-8"?>
+<p:sld xmlns:a="http://schemas.openxmlformats.org/drawingml/2006/main" xmlns:p="http://schemas.openxmlformats.org/presentationml/2006/main" xmlns:r="http://schemas.openxmlformats.org/officeDocument/2006/relationships">
+  <p:cSld>
+    <p:spTree>
+      <p:nvGrpSpPr>
+        <p:cNvPr id="1" name=""/>
+        <p:cNvGrpSpPr/>
+        <p:nvPr/>
+      </p:nvGrpSpPr>
+      <p:grpSpPr/>
+      <p:sp>
+        <p:nvSpPr>
+          <p:cNvPr id="2" name="TextBox 1"/>
+          <p:cNvSpPr txBox="1"/>
+          <p:nvPr/>
+        </p:nvSpPr>
+        <p:spPr>
+          <a:xfrm>
+            <a:off x="502920" y="6510528"/>
+            <a:ext cx="11155680" cy="274320"/>
+          </a:xfrm>
+          <a:prstGeom prst="rect">
+            <a:avLst/>
+          </a:prstGeom>
+          <a:noFill/>
+        </p:spPr>
+        <p:txBody>
+          <a:bodyPr wrap="none">
+            <a:spAutoFit/>
+          </a:bodyPr>
+          <a:lstStyle/>
+          <a:p>
+            <a:r>
+              <a:rPr sz="1000">
+                <a:solidFill>
+                  <a:srgbClr val="666666"/>
+                </a:solidFill>
+                <a:latin typeface="Calibri"/>
+              </a:rPr>
+              <a:t>Qingxiang Guo · UCAS · DFEI group meeting      13</a:t>
             </a:r>
           </a:p>
         </p:txBody>
@@ -5806,7 +6230,7 @@
                 </a:solidFill>
                 <a:latin typeface="Calibri"/>
               </a:rPr>
-              <a:t>Part 2 — Supervising Representations with Physics</a:t>
+              <a:t>Why Chains Die: Rare Classes + Misclassification</a:t>
             </a:r>
           </a:p>
           <a:p>
@@ -5817,7 +6241,7 @@
                 </a:solidFill>
                 <a:latin typeface="Calibri"/>
               </a:rPr>
-              <a:t>One common idea behind several heads</a:t>
+              <a:t>Chain-CE fixes the training signal for the rare structural classes</a:t>
             </a:r>
           </a:p>
         </p:txBody>
@@ -5873,8 +6297,8 @@
         </p:nvSpPr>
         <p:spPr>
           <a:xfrm>
-            <a:off x="731520" y="1280160"/>
-            <a:ext cx="10789920" cy="4937760"/>
+            <a:off x="731520" y="1234440"/>
+            <a:ext cx="10789920" cy="2103120"/>
           </a:xfrm>
           <a:prstGeom prst="rect">
             <a:avLst/>
@@ -5899,7 +6323,7 @@
                 </a:solidFill>
                 <a:latin typeface="Calibri"/>
               </a:rPr>
-              <a:t>•  Idea: physical / structural quantities are data-intrinsic; supervise the representation with them, keeping the model end-to-end</a:t>
+              <a:t>•  Structural edges are ~0.1% of all edges — the GNN is weakest exactly there (esp. class 2)</a:t>
             </a:r>
           </a:p>
           <a:p>
@@ -5915,7 +6339,7 @@
                 </a:solidFill>
                 <a:latin typeface="Calibri"/>
               </a:rPr>
-              <a:t>•  Heads sharing this theme:</a:t>
+              <a:t>•  One misclassified structural edge → pruned → the whole chain dies</a:t>
             </a:r>
           </a:p>
           <a:p>
@@ -5925,77 +6349,96 @@
               </a:spcAft>
             </a:pPr>
             <a:r>
-              <a:rPr sz="2000">
+              <a:rPr sz="2200">
                 <a:solidFill>
                   <a:srgbClr val="333333"/>
                 </a:solidFill>
                 <a:latin typeface="Calibri"/>
               </a:rPr>
-              <a:t>    –  source head (v36) — Rumor-Centrality root; early instance of the same idea</a:t>
-            </a:r>
-          </a:p>
-          <a:p>
-            <a:pPr>
-              <a:spcAft>
-                <a:spcPts val="1000"/>
-              </a:spcAft>
-            </a:pPr>
-            <a:r>
-              <a:rPr sz="2000">
-                <a:solidFill>
-                  <a:srgbClr val="333333"/>
-                </a:solidFill>
-                <a:latin typeface="Calibri"/>
-              </a:rPr>
-              <a:t>    –  mass head — edge-level log10(m_ππ)</a:t>
-            </a:r>
-          </a:p>
-          <a:p>
-            <a:pPr>
-              <a:spcAft>
-                <a:spcPts val="1000"/>
-              </a:spcAft>
-            </a:pPr>
-            <a:r>
-              <a:rPr sz="2000">
-                <a:solidFill>
-                  <a:srgbClr val="333333"/>
-                </a:solidFill>
-                <a:latin typeface="Calibri"/>
-              </a:rPr>
-              <a:t>    –  structure head — node depth + RC value</a:t>
-            </a:r>
-          </a:p>
-          <a:p>
-            <a:pPr>
-              <a:spcAft>
-                <a:spcPts val="1000"/>
-              </a:spcAft>
-            </a:pPr>
-            <a:r>
-              <a:rPr sz="2000">
-                <a:solidFill>
-                  <a:srgbClr val="333333"/>
-                </a:solidFill>
-                <a:latin typeface="Calibri"/>
-              </a:rPr>
-              <a:t>    –  momentum head — node normalized momentum</a:t>
-            </a:r>
-          </a:p>
-          <a:p>
-            <a:pPr>
-              <a:spcAft>
-                <a:spcPts val="1000"/>
-              </a:spcAft>
-            </a:pPr>
-            <a:r>
-              <a:rPr sz="2200">
-                <a:solidFill>
-                  <a:srgbClr val="333333"/>
-                </a:solidFill>
-                <a:latin typeface="Calibri"/>
-              </a:rPr>
-              <a:t>•  Verification: linear probes on the frozen backbone (Ridge regression)</a:t>
+              <a:t>•  Chain-CE (v38) supervises truth-chain edge classes directly → chains survive</a:t>
+            </a:r>
+          </a:p>
+        </p:txBody>
+      </p:sp>
+      <p:pic>
+        <p:nvPicPr>
+          <p:cNvPr id="6" name="Picture 5" descr="chain_lca_imbalance.png"/>
+          <p:cNvPicPr>
+            <a:picLocks noChangeAspect="1"/>
+          </p:cNvPicPr>
+          <p:nvPr/>
+        </p:nvPicPr>
+        <p:blipFill>
+          <a:blip r:embed="rId2"/>
+          <a:stretch>
+            <a:fillRect/>
+          </a:stretch>
+        </p:blipFill>
+        <p:spPr>
+          <a:xfrm>
+            <a:off x="640080" y="3383280"/>
+            <a:ext cx="5760720" cy="1568007"/>
+          </a:xfrm>
+          <a:prstGeom prst="rect">
+            <a:avLst/>
+          </a:prstGeom>
+        </p:spPr>
+      </p:pic>
+      <p:pic>
+        <p:nvPicPr>
+          <p:cNvPr id="7" name="Picture 6" descr="chain_lca_before_after.png"/>
+          <p:cNvPicPr>
+            <a:picLocks noChangeAspect="1"/>
+          </p:cNvPicPr>
+          <p:nvPr/>
+        </p:nvPicPr>
+        <p:blipFill>
+          <a:blip r:embed="rId3"/>
+          <a:stretch>
+            <a:fillRect/>
+          </a:stretch>
+        </p:blipFill>
+        <p:spPr>
+          <a:xfrm>
+            <a:off x="6492240" y="3383280"/>
+            <a:ext cx="5394960" cy="1871839"/>
+          </a:xfrm>
+          <a:prstGeom prst="rect">
+            <a:avLst/>
+          </a:prstGeom>
+        </p:spPr>
+      </p:pic>
+      <p:sp>
+        <p:nvSpPr>
+          <p:cNvPr id="8" name="TextBox 7"/>
+          <p:cNvSpPr txBox="1"/>
+          <p:nvPr/>
+        </p:nvSpPr>
+        <p:spPr>
+          <a:xfrm>
+            <a:off x="731520" y="6126480"/>
+            <a:ext cx="10789920" cy="365760"/>
+          </a:xfrm>
+          <a:prstGeom prst="rect">
+            <a:avLst/>
+          </a:prstGeom>
+          <a:noFill/>
+        </p:spPr>
+        <p:txBody>
+          <a:bodyPr wrap="square">
+            <a:spAutoFit/>
+          </a:bodyPr>
+          <a:lstStyle/>
+          <a:p>
+            <a:pPr algn="ctr"/>
+            <a:r>
+              <a:rPr sz="1200" i="1">
+                <a:solidFill>
+                  <a:srgbClr val="666666"/>
+                </a:solidFill>
+                <a:latin typeface="Calibri"/>
+              </a:rPr>
+              <a:t>class 2 (sister) is the structural bottleneck — rare AND hardest to classify; the chain losses target exactly this</a:t>
             </a:r>
           </a:p>
         </p:txBody>
@@ -6047,7 +6490,7 @@
                 </a:solidFill>
                 <a:latin typeface="Calibri"/>
               </a:rPr>
-              <a:t>Qingxiang Guo · UCAS · DFEI group meeting      7</a:t>
+              <a:t>Qingxiang Guo · UCAS · DFEI group meeting      6</a:t>
             </a:r>
           </a:p>
         </p:txBody>
@@ -6081,7 +6524,7 @@
                 </a:solidFill>
                 <a:latin typeface="Calibri"/>
               </a:rPr>
-              <a:t>The Mass Head: Main Result</a:t>
+              <a:t>Part 2 — Supervising Representations with Physics</a:t>
             </a:r>
           </a:p>
           <a:p>
@@ -6092,7 +6535,7 @@
                 </a:solidFill>
                 <a:latin typeface="Calibri"/>
               </a:rPr>
-              <a:t>Edge-level regression of log10(m_ππ)</a:t>
+              <a:t>One common idea behind several heads</a:t>
             </a:r>
           </a:p>
         </p:txBody>
@@ -6148,6 +6591,281 @@
         </p:nvSpPr>
         <p:spPr>
           <a:xfrm>
+            <a:off x="731520" y="1280160"/>
+            <a:ext cx="10789920" cy="4937760"/>
+          </a:xfrm>
+          <a:prstGeom prst="rect">
+            <a:avLst/>
+          </a:prstGeom>
+          <a:noFill/>
+        </p:spPr>
+        <p:txBody>
+          <a:bodyPr wrap="square">
+            <a:spAutoFit/>
+          </a:bodyPr>
+          <a:lstStyle/>
+          <a:p>
+            <a:pPr>
+              <a:spcAft>
+                <a:spcPts val="1000"/>
+              </a:spcAft>
+            </a:pPr>
+            <a:r>
+              <a:rPr sz="2200">
+                <a:solidFill>
+                  <a:srgbClr val="333333"/>
+                </a:solidFill>
+                <a:latin typeface="Calibri"/>
+              </a:rPr>
+              <a:t>•  Idea: physical / structural quantities are data-intrinsic; supervise the representation with them, keeping the model end-to-end</a:t>
+            </a:r>
+          </a:p>
+          <a:p>
+            <a:pPr>
+              <a:spcAft>
+                <a:spcPts val="1000"/>
+              </a:spcAft>
+            </a:pPr>
+            <a:r>
+              <a:rPr sz="2200">
+                <a:solidFill>
+                  <a:srgbClr val="333333"/>
+                </a:solidFill>
+                <a:latin typeface="Calibri"/>
+              </a:rPr>
+              <a:t>•  Heads sharing this theme:</a:t>
+            </a:r>
+          </a:p>
+          <a:p>
+            <a:pPr>
+              <a:spcAft>
+                <a:spcPts val="1000"/>
+              </a:spcAft>
+            </a:pPr>
+            <a:r>
+              <a:rPr sz="2000">
+                <a:solidFill>
+                  <a:srgbClr val="333333"/>
+                </a:solidFill>
+                <a:latin typeface="Calibri"/>
+              </a:rPr>
+              <a:t>    –  source head (v36) — Rumor-Centrality root; early instance of the same idea</a:t>
+            </a:r>
+          </a:p>
+          <a:p>
+            <a:pPr>
+              <a:spcAft>
+                <a:spcPts val="1000"/>
+              </a:spcAft>
+            </a:pPr>
+            <a:r>
+              <a:rPr sz="2000">
+                <a:solidFill>
+                  <a:srgbClr val="333333"/>
+                </a:solidFill>
+                <a:latin typeface="Calibri"/>
+              </a:rPr>
+              <a:t>    –  mass head — edge-level log10(m_ππ)</a:t>
+            </a:r>
+          </a:p>
+          <a:p>
+            <a:pPr>
+              <a:spcAft>
+                <a:spcPts val="1000"/>
+              </a:spcAft>
+            </a:pPr>
+            <a:r>
+              <a:rPr sz="2000">
+                <a:solidFill>
+                  <a:srgbClr val="333333"/>
+                </a:solidFill>
+                <a:latin typeface="Calibri"/>
+              </a:rPr>
+              <a:t>    –  structure head — node depth + RC value</a:t>
+            </a:r>
+          </a:p>
+          <a:p>
+            <a:pPr>
+              <a:spcAft>
+                <a:spcPts val="1000"/>
+              </a:spcAft>
+            </a:pPr>
+            <a:r>
+              <a:rPr sz="2000">
+                <a:solidFill>
+                  <a:srgbClr val="333333"/>
+                </a:solidFill>
+                <a:latin typeface="Calibri"/>
+              </a:rPr>
+              <a:t>    –  momentum head — node normalized momentum</a:t>
+            </a:r>
+          </a:p>
+          <a:p>
+            <a:pPr>
+              <a:spcAft>
+                <a:spcPts val="1000"/>
+              </a:spcAft>
+            </a:pPr>
+            <a:r>
+              <a:rPr sz="2200">
+                <a:solidFill>
+                  <a:srgbClr val="333333"/>
+                </a:solidFill>
+                <a:latin typeface="Calibri"/>
+              </a:rPr>
+              <a:t>•  Verification: linear probes on the frozen backbone (Ridge regression)</a:t>
+            </a:r>
+          </a:p>
+        </p:txBody>
+      </p:sp>
+    </p:spTree>
+  </p:cSld>
+  <p:clrMapOvr>
+    <a:masterClrMapping/>
+  </p:clrMapOvr>
+</p:sld>
+</file>
+
+<file path=ppt/slides/slide8.xml><?xml version="1.0" encoding="utf-8"?>
+<p:sld xmlns:a="http://schemas.openxmlformats.org/drawingml/2006/main" xmlns:p="http://schemas.openxmlformats.org/presentationml/2006/main" xmlns:r="http://schemas.openxmlformats.org/officeDocument/2006/relationships">
+  <p:cSld>
+    <p:spTree>
+      <p:nvGrpSpPr>
+        <p:cNvPr id="1" name=""/>
+        <p:cNvGrpSpPr/>
+        <p:nvPr/>
+      </p:nvGrpSpPr>
+      <p:grpSpPr/>
+      <p:sp>
+        <p:nvSpPr>
+          <p:cNvPr id="2" name="TextBox 1"/>
+          <p:cNvSpPr txBox="1"/>
+          <p:nvPr/>
+        </p:nvSpPr>
+        <p:spPr>
+          <a:xfrm>
+            <a:off x="502920" y="6510528"/>
+            <a:ext cx="11155680" cy="274320"/>
+          </a:xfrm>
+          <a:prstGeom prst="rect">
+            <a:avLst/>
+          </a:prstGeom>
+          <a:noFill/>
+        </p:spPr>
+        <p:txBody>
+          <a:bodyPr wrap="none">
+            <a:spAutoFit/>
+          </a:bodyPr>
+          <a:lstStyle/>
+          <a:p>
+            <a:r>
+              <a:rPr sz="1000">
+                <a:solidFill>
+                  <a:srgbClr val="666666"/>
+                </a:solidFill>
+                <a:latin typeface="Calibri"/>
+              </a:rPr>
+              <a:t>Qingxiang Guo · UCAS · DFEI group meeting      8</a:t>
+            </a:r>
+          </a:p>
+        </p:txBody>
+      </p:sp>
+      <p:sp>
+        <p:nvSpPr>
+          <p:cNvPr id="3" name="TextBox 2"/>
+          <p:cNvSpPr txBox="1"/>
+          <p:nvPr/>
+        </p:nvSpPr>
+        <p:spPr>
+          <a:xfrm>
+            <a:off x="502920" y="164592"/>
+            <a:ext cx="11155680" cy="914400"/>
+          </a:xfrm>
+          <a:prstGeom prst="rect">
+            <a:avLst/>
+          </a:prstGeom>
+          <a:noFill/>
+        </p:spPr>
+        <p:txBody>
+          <a:bodyPr wrap="square">
+            <a:spAutoFit/>
+          </a:bodyPr>
+          <a:lstStyle/>
+          <a:p>
+            <a:r>
+              <a:rPr sz="3800" b="1">
+                <a:solidFill>
+                  <a:srgbClr val="1F4E79"/>
+                </a:solidFill>
+                <a:latin typeface="Calibri"/>
+              </a:rPr>
+              <a:t>The Mass Head: Main Result</a:t>
+            </a:r>
+          </a:p>
+          <a:p>
+            <a:r>
+              <a:rPr sz="1700">
+                <a:solidFill>
+                  <a:srgbClr val="666666"/>
+                </a:solidFill>
+                <a:latin typeface="Calibri"/>
+              </a:rPr>
+              <a:t>Edge-level regression of log10(m_ππ)</a:t>
+            </a:r>
+          </a:p>
+        </p:txBody>
+      </p:sp>
+      <p:sp>
+        <p:nvSpPr>
+          <p:cNvPr id="4" name="Rectangle 3"/>
+          <p:cNvSpPr/>
+          <p:nvPr/>
+        </p:nvSpPr>
+        <p:spPr>
+          <a:xfrm>
+            <a:off x="548640" y="1188720"/>
+            <a:ext cx="11064240" cy="38100"/>
+          </a:xfrm>
+          <a:prstGeom prst="rect">
+            <a:avLst/>
+          </a:prstGeom>
+          <a:solidFill>
+            <a:srgbClr val="1F4E79"/>
+          </a:solidFill>
+          <a:ln>
+            <a:noFill/>
+          </a:ln>
+        </p:spPr>
+        <p:style>
+          <a:lnRef idx="1">
+            <a:schemeClr val="accent1"/>
+          </a:lnRef>
+          <a:fillRef idx="3">
+            <a:schemeClr val="accent1"/>
+          </a:fillRef>
+          <a:effectRef idx="2">
+            <a:schemeClr val="accent1"/>
+          </a:effectRef>
+          <a:fontRef idx="minor">
+            <a:schemeClr val="lt1"/>
+          </a:fontRef>
+        </p:style>
+        <p:txBody>
+          <a:bodyPr rtlCol="0" anchor="ctr"/>
+          <a:lstStyle/>
+          <a:p>
+            <a:pPr algn="ctr"/>
+          </a:p>
+        </p:txBody>
+      </p:sp>
+      <p:sp>
+        <p:nvSpPr>
+          <p:cNvPr id="5" name="TextBox 4"/>
+          <p:cNvSpPr txBox="1"/>
+          <p:nvPr/>
+        </p:nvSpPr>
+        <p:spPr>
+          <a:xfrm>
             <a:off x="731520" y="1188720"/>
             <a:ext cx="6035040" cy="5120640"/>
           </a:xfrm>
@@ -6291,7 +7009,7 @@
 </p:sld>
 </file>
 
-<file path=ppt/slides/slide8.xml><?xml version="1.0" encoding="utf-8"?>
+<file path=ppt/slides/slide9.xml><?xml version="1.0" encoding="utf-8"?>
 <p:sld xmlns:a="http://schemas.openxmlformats.org/drawingml/2006/main" xmlns:p="http://schemas.openxmlformats.org/presentationml/2006/main" xmlns:r="http://schemas.openxmlformats.org/officeDocument/2006/relationships">
   <p:cSld>
     <p:spTree>
@@ -6865,429 +7583,6 @@
 </p:sld>
 </file>
 
-<file path=ppt/slides/slide9.xml><?xml version="1.0" encoding="utf-8"?>
-<p:sld xmlns:a="http://schemas.openxmlformats.org/drawingml/2006/main" xmlns:p="http://schemas.openxmlformats.org/presentationml/2006/main" xmlns:r="http://schemas.openxmlformats.org/officeDocument/2006/relationships">
-  <p:cSld>
-    <p:spTree>
-      <p:nvGrpSpPr>
-        <p:cNvPr id="1" name=""/>
-        <p:cNvGrpSpPr/>
-        <p:nvPr/>
-      </p:nvGrpSpPr>
-      <p:grpSpPr/>
-      <p:sp>
-        <p:nvSpPr>
-          <p:cNvPr id="2" name="TextBox 1"/>
-          <p:cNvSpPr txBox="1"/>
-          <p:nvPr/>
-        </p:nvSpPr>
-        <p:spPr>
-          <a:xfrm>
-            <a:off x="502920" y="6510528"/>
-            <a:ext cx="11155680" cy="274320"/>
-          </a:xfrm>
-          <a:prstGeom prst="rect">
-            <a:avLst/>
-          </a:prstGeom>
-          <a:noFill/>
-        </p:spPr>
-        <p:txBody>
-          <a:bodyPr wrap="none">
-            <a:spAutoFit/>
-          </a:bodyPr>
-          <a:lstStyle/>
-          <a:p>
-            <a:r>
-              <a:rPr sz="1000">
-                <a:solidFill>
-                  <a:srgbClr val="666666"/>
-                </a:solidFill>
-                <a:latin typeface="Calibri"/>
-              </a:rPr>
-              <a:t>Qingxiang Guo · UCAS · DFEI group meeting      9</a:t>
-            </a:r>
-          </a:p>
-        </p:txBody>
-      </p:sp>
-      <p:sp>
-        <p:nvSpPr>
-          <p:cNvPr id="3" name="TextBox 2"/>
-          <p:cNvSpPr txBox="1"/>
-          <p:nvPr/>
-        </p:nvSpPr>
-        <p:spPr>
-          <a:xfrm>
-            <a:off x="502920" y="164592"/>
-            <a:ext cx="11155680" cy="914400"/>
-          </a:xfrm>
-          <a:prstGeom prst="rect">
-            <a:avLst/>
-          </a:prstGeom>
-          <a:noFill/>
-        </p:spPr>
-        <p:txBody>
-          <a:bodyPr wrap="square">
-            <a:spAutoFit/>
-          </a:bodyPr>
-          <a:lstStyle/>
-          <a:p>
-            <a:r>
-              <a:rPr sz="3800" b="1">
-                <a:solidFill>
-                  <a:srgbClr val="1F4E79"/>
-                </a:solidFill>
-                <a:latin typeface="Calibri"/>
-              </a:rPr>
-              <a:t>Verification: Linear Probes on the Frozen Backbone</a:t>
-            </a:r>
-          </a:p>
-          <a:p>
-            <a:r>
-              <a:rPr sz="1700">
-                <a:solidFill>
-                  <a:srgbClr val="666666"/>
-                </a:solidFill>
-                <a:latin typeface="Calibri"/>
-              </a:rPr>
-              <a:t>Ridge regression; R² of the physical quantity</a:t>
-            </a:r>
-          </a:p>
-        </p:txBody>
-      </p:sp>
-      <p:sp>
-        <p:nvSpPr>
-          <p:cNvPr id="4" name="Rectangle 3"/>
-          <p:cNvSpPr/>
-          <p:nvPr/>
-        </p:nvSpPr>
-        <p:spPr>
-          <a:xfrm>
-            <a:off x="548640" y="1188720"/>
-            <a:ext cx="11064240" cy="38100"/>
-          </a:xfrm>
-          <a:prstGeom prst="rect">
-            <a:avLst/>
-          </a:prstGeom>
-          <a:solidFill>
-            <a:srgbClr val="1F4E79"/>
-          </a:solidFill>
-          <a:ln>
-            <a:noFill/>
-          </a:ln>
-        </p:spPr>
-        <p:style>
-          <a:lnRef idx="1">
-            <a:schemeClr val="accent1"/>
-          </a:lnRef>
-          <a:fillRef idx="3">
-            <a:schemeClr val="accent1"/>
-          </a:fillRef>
-          <a:effectRef idx="2">
-            <a:schemeClr val="accent1"/>
-          </a:effectRef>
-          <a:fontRef idx="minor">
-            <a:schemeClr val="lt1"/>
-          </a:fontRef>
-        </p:style>
-        <p:txBody>
-          <a:bodyPr rtlCol="0" anchor="ctr"/>
-          <a:lstStyle/>
-          <a:p>
-            <a:pPr algn="ctr"/>
-          </a:p>
-        </p:txBody>
-      </p:sp>
-      <p:graphicFrame>
-        <p:nvGraphicFramePr>
-          <p:cNvPr id="5" name="Table 4"/>
-          <p:cNvGraphicFramePr>
-            <a:graphicFrameLocks noGrp="1"/>
-          </p:cNvGraphicFramePr>
-          <p:nvPr/>
-        </p:nvGraphicFramePr>
-        <p:xfrm>
-          <a:off x="731520" y="1371600"/>
-          <a:ext cx="7772400" cy="1645920"/>
-        </p:xfrm>
-        <a:graphic>
-          <a:graphicData uri="http://schemas.openxmlformats.org/drawingml/2006/table">
-            <a:tbl>
-              <a:tblPr firstRow="1" bandRow="1">
-                <a:tableStyleId>{5C22544A-7EE6-4342-B048-85BDC9FD1C3A}</a:tableStyleId>
-              </a:tblPr>
-              <a:tblGrid>
-                <a:gridCol w="2590800"/>
-                <a:gridCol w="2590800"/>
-                <a:gridCol w="2590800"/>
-              </a:tblGrid>
-              <a:tr h="548640">
-                <a:tc>
-                  <a:txBody>
-                    <a:bodyPr/>
-                    <a:lstStyle/>
-                    <a:p>
-                      <a:pPr algn="ctr"/>
-                      <a:r>
-                        <a:rPr sz="2000">
-                          <a:solidFill>
-                            <a:srgbClr val="FFFFFF"/>
-                          </a:solidFill>
-                          <a:latin typeface="Calibri"/>
-                        </a:rPr>
-                        <a:t>Probe</a:t>
-                      </a:r>
-                    </a:p>
-                  </a:txBody>
-                  <a:tcPr marL="54864" marR="54864" marT="18288" marB="18288">
-                    <a:solidFill>
-                      <a:srgbClr val="1F4E79"/>
-                    </a:solidFill>
-                  </a:tcPr>
-                </a:tc>
-                <a:tc>
-                  <a:txBody>
-                    <a:bodyPr/>
-                    <a:lstStyle/>
-                    <a:p>
-                      <a:pPr algn="ctr"/>
-                      <a:r>
-                        <a:rPr sz="2000">
-                          <a:solidFill>
-                            <a:srgbClr val="FFFFFF"/>
-                          </a:solidFill>
-                          <a:latin typeface="Calibri"/>
-                        </a:rPr>
-                        <a:t>v38</a:t>
-                      </a:r>
-                    </a:p>
-                  </a:txBody>
-                  <a:tcPr marL="54864" marR="54864" marT="18288" marB="18288">
-                    <a:solidFill>
-                      <a:srgbClr val="1F4E79"/>
-                    </a:solidFill>
-                  </a:tcPr>
-                </a:tc>
-                <a:tc>
-                  <a:txBody>
-                    <a:bodyPr/>
-                    <a:lstStyle/>
-                    <a:p>
-                      <a:pPr algn="ctr"/>
-                      <a:r>
-                        <a:rPr sz="2000">
-                          <a:solidFill>
-                            <a:srgbClr val="FFFFFF"/>
-                          </a:solidFill>
-                          <a:latin typeface="Calibri"/>
-                        </a:rPr>
-                        <a:t>masshead2</a:t>
-                      </a:r>
-                    </a:p>
-                  </a:txBody>
-                  <a:tcPr marL="54864" marR="54864" marT="18288" marB="18288">
-                    <a:solidFill>
-                      <a:srgbClr val="1F4E79"/>
-                    </a:solidFill>
-                  </a:tcPr>
-                </a:tc>
-              </a:tr>
-              <a:tr h="548640">
-                <a:tc>
-                  <a:txBody>
-                    <a:bodyPr/>
-                    <a:lstStyle/>
-                    <a:p>
-                      <a:pPr algn="l"/>
-                      <a:r>
-                        <a:rPr sz="2000">
-                          <a:solidFill>
-                            <a:srgbClr val="333333"/>
-                          </a:solidFill>
-                          <a:latin typeface="Calibri"/>
-                        </a:rPr>
-                        <a:t>edge repr → log10(m_ππ)</a:t>
-                      </a:r>
-                    </a:p>
-                  </a:txBody>
-                  <a:tcPr marL="54864" marR="54864" marT="18288" marB="18288"/>
-                </a:tc>
-                <a:tc>
-                  <a:txBody>
-                    <a:bodyPr/>
-                    <a:lstStyle/>
-                    <a:p>
-                      <a:pPr algn="l"/>
-                      <a:r>
-                        <a:rPr sz="2000">
-                          <a:solidFill>
-                            <a:srgbClr val="333333"/>
-                          </a:solidFill>
-                          <a:latin typeface="Calibri"/>
-                        </a:rPr>
-                        <a:t>R² = 0.003</a:t>
-                      </a:r>
-                    </a:p>
-                  </a:txBody>
-                  <a:tcPr marL="54864" marR="54864" marT="18288" marB="18288"/>
-                </a:tc>
-                <a:tc>
-                  <a:txBody>
-                    <a:bodyPr/>
-                    <a:lstStyle/>
-                    <a:p>
-                      <a:pPr algn="l"/>
-                      <a:r>
-                        <a:rPr sz="2000">
-                          <a:solidFill>
-                            <a:srgbClr val="333333"/>
-                          </a:solidFill>
-                          <a:latin typeface="Calibri"/>
-                        </a:rPr>
-                        <a:t>R² = 0.930</a:t>
-                      </a:r>
-                    </a:p>
-                  </a:txBody>
-                  <a:tcPr marL="54864" marR="54864" marT="18288" marB="18288"/>
-                </a:tc>
-              </a:tr>
-              <a:tr h="548640">
-                <a:tc>
-                  <a:txBody>
-                    <a:bodyPr/>
-                    <a:lstStyle/>
-                    <a:p>
-                      <a:pPr algn="l"/>
-                      <a:r>
-                        <a:rPr sz="2000">
-                          <a:solidFill>
-                            <a:srgbClr val="333333"/>
-                          </a:solidFill>
-                          <a:latin typeface="Calibri"/>
-                        </a:rPr>
-                        <a:t>node repr → p (px/py/pz)</a:t>
-                      </a:r>
-                    </a:p>
-                  </a:txBody>
-                  <a:tcPr marL="54864" marR="54864" marT="18288" marB="18288">
-                    <a:solidFill>
-                      <a:srgbClr val="EAF2F8"/>
-                    </a:solidFill>
-                  </a:tcPr>
-                </a:tc>
-                <a:tc>
-                  <a:txBody>
-                    <a:bodyPr/>
-                    <a:lstStyle/>
-                    <a:p>
-                      <a:pPr algn="l"/>
-                      <a:r>
-                        <a:rPr sz="2000">
-                          <a:solidFill>
-                            <a:srgbClr val="333333"/>
-                          </a:solidFill>
-                          <a:latin typeface="Calibri"/>
-                        </a:rPr>
-                        <a:t>R² ≈ 0</a:t>
-                      </a:r>
-                    </a:p>
-                  </a:txBody>
-                  <a:tcPr marL="54864" marR="54864" marT="18288" marB="18288">
-                    <a:solidFill>
-                      <a:srgbClr val="EAF2F8"/>
-                    </a:solidFill>
-                  </a:tcPr>
-                </a:tc>
-                <a:tc>
-                  <a:txBody>
-                    <a:bodyPr/>
-                    <a:lstStyle/>
-                    <a:p>
-                      <a:pPr algn="l"/>
-                      <a:r>
-                        <a:rPr sz="2000">
-                          <a:solidFill>
-                            <a:srgbClr val="333333"/>
-                          </a:solidFill>
-                          <a:latin typeface="Calibri"/>
-                        </a:rPr>
-                        <a:t>R² ≈ 0</a:t>
-                      </a:r>
-                    </a:p>
-                  </a:txBody>
-                  <a:tcPr marL="54864" marR="54864" marT="18288" marB="18288">
-                    <a:solidFill>
-                      <a:srgbClr val="EAF2F8"/>
-                    </a:solidFill>
-                  </a:tcPr>
-                </a:tc>
-              </a:tr>
-            </a:tbl>
-          </a:graphicData>
-        </a:graphic>
-      </p:graphicFrame>
-      <p:sp>
-        <p:nvSpPr>
-          <p:cNvPr id="6" name="TextBox 5"/>
-          <p:cNvSpPr txBox="1"/>
-          <p:nvPr/>
-        </p:nvSpPr>
-        <p:spPr>
-          <a:xfrm>
-            <a:off x="731520" y="3383280"/>
-            <a:ext cx="10789920" cy="2560320"/>
-          </a:xfrm>
-          <a:prstGeom prst="rect">
-            <a:avLst/>
-          </a:prstGeom>
-          <a:noFill/>
-        </p:spPr>
-        <p:txBody>
-          <a:bodyPr wrap="square">
-            <a:spAutoFit/>
-          </a:bodyPr>
-          <a:lstStyle/>
-          <a:p>
-            <a:pPr>
-              <a:spcAft>
-                <a:spcPts val="1000"/>
-              </a:spcAft>
-            </a:pPr>
-            <a:r>
-              <a:rPr sz="2200">
-                <a:solidFill>
-                  <a:srgbClr val="333333"/>
-                </a:solidFill>
-                <a:latin typeface="Calibri"/>
-              </a:rPr>
-              <a:t>•  Mass supervision moves mass information into the edge representation — confirmed end-to-end</a:t>
-            </a:r>
-          </a:p>
-          <a:p>
-            <a:pPr>
-              <a:spcAft>
-                <a:spcPts val="1000"/>
-              </a:spcAft>
-            </a:pPr>
-            <a:r>
-              <a:rPr sz="2200">
-                <a:solidFill>
-                  <a:srgbClr val="333333"/>
-                </a:solidFill>
-                <a:latin typeface="Calibri"/>
-              </a:rPr>
-              <a:t>•  Nodes remain unreadable for momentum → addressed by the momentum head (to be re-probed)</a:t>
-            </a:r>
-          </a:p>
-        </p:txBody>
-      </p:sp>
-    </p:spTree>
-  </p:cSld>
-  <p:clrMapOvr>
-    <a:masterClrMapping/>
-  </p:clrMapOvr>
-</p:sld>
-</file>
-
 <file path=ppt/theme/theme1.xml><?xml version="1.0" encoding="utf-8"?>
 <a:theme xmlns:a="http://schemas.openxmlformats.org/drawingml/2006/main" name="Office Theme">
   <a:themeElements>

</xml_diff>

<commit_message>
docs: fix slide numbering (13 pages)
</commit_message>
<xml_diff>
--- a/meeting_figs/DFEI_progress_20260902_EN.pptx
+++ b/meeting_figs/DFEI_progress_20260902_EN.pptx
@@ -6490,7 +6490,7 @@
                 </a:solidFill>
                 <a:latin typeface="Calibri"/>
               </a:rPr>
-              <a:t>Qingxiang Guo · UCAS · DFEI group meeting      6</a:t>
+              <a:t>Qingxiang Guo · UCAS · DFEI group meeting      7</a:t>
             </a:r>
           </a:p>
         </p:txBody>
@@ -7048,7 +7048,7 @@
                 </a:solidFill>
                 <a:latin typeface="Calibri"/>
               </a:rPr>
-              <a:t>Qingxiang Guo · UCAS · DFEI group meeting      8</a:t>
+              <a:t>Qingxiang Guo · UCAS · DFEI group meeting      9</a:t>
             </a:r>
           </a:p>
         </p:txBody>

</xml_diff>

<commit_message>
docs: split LCA slide into 3 pages (dilution problem / hinge / chain-CE)
- New S5: the class-0 dilution problem (new single-panel figure)
- New S6: hinge (v37) — mechanism schematic showing where confidence
  comes from (LCAG softmax, max pk) and where the loss lives (truth-chain
  edges only) + loss curve
- New S7: chain-CE (v38) — CE = -log(p_true) curve + where chain-CE is
  applied vs the global CE
- Renumbered deck 1-16; trimmed a now-redundant bullet on the imbalance slide
</commit_message>
<xml_diff>
--- a/meeting_figs/DFEI_progress_20260902_EN.pptx
+++ b/meeting_figs/DFEI_progress_20260902_EN.pptx
@@ -19,6 +19,8 @@
     <p:sldId id="267" r:id="rId18"/>
     <p:sldId id="268" r:id="rId19"/>
     <p:sldId id="269" r:id="rId20"/>
+    <p:sldId id="270" r:id="rId21"/>
+    <p:sldId id="271" r:id="rId22"/>
   </p:sldIdLst>
   <p:sldSz cx="12191695" cy="6858000" type="screen4x3"/>
   <p:notesSz cx="6858000" cy="9144000"/>
@@ -3285,6 +3287,564 @@
                 <a:latin typeface="Calibri"/>
               </a:rPr>
               <a:t>Qingxiang Guo · UCAS · DFEI group meeting      10</a:t>
+            </a:r>
+          </a:p>
+        </p:txBody>
+      </p:sp>
+      <p:sp>
+        <p:nvSpPr>
+          <p:cNvPr id="3" name="TextBox 2"/>
+          <p:cNvSpPr txBox="1"/>
+          <p:nvPr/>
+        </p:nvSpPr>
+        <p:spPr>
+          <a:xfrm>
+            <a:off x="502920" y="164592"/>
+            <a:ext cx="11155680" cy="914400"/>
+          </a:xfrm>
+          <a:prstGeom prst="rect">
+            <a:avLst/>
+          </a:prstGeom>
+          <a:noFill/>
+        </p:spPr>
+        <p:txBody>
+          <a:bodyPr wrap="square">
+            <a:spAutoFit/>
+          </a:bodyPr>
+          <a:lstStyle/>
+          <a:p>
+            <a:r>
+              <a:rPr sz="3800" b="1">
+                <a:solidFill>
+                  <a:srgbClr val="1F4E79"/>
+                </a:solidFill>
+                <a:latin typeface="Calibri"/>
+              </a:rPr>
+              <a:t>Part 2 — Supervising Representations with Physics</a:t>
+            </a:r>
+          </a:p>
+          <a:p>
+            <a:r>
+              <a:rPr sz="1700">
+                <a:solidFill>
+                  <a:srgbClr val="666666"/>
+                </a:solidFill>
+                <a:latin typeface="Calibri"/>
+              </a:rPr>
+              <a:t>One common idea behind several heads</a:t>
+            </a:r>
+          </a:p>
+        </p:txBody>
+      </p:sp>
+      <p:sp>
+        <p:nvSpPr>
+          <p:cNvPr id="4" name="Rectangle 3"/>
+          <p:cNvSpPr/>
+          <p:nvPr/>
+        </p:nvSpPr>
+        <p:spPr>
+          <a:xfrm>
+            <a:off x="548640" y="1188720"/>
+            <a:ext cx="11064240" cy="38100"/>
+          </a:xfrm>
+          <a:prstGeom prst="rect">
+            <a:avLst/>
+          </a:prstGeom>
+          <a:solidFill>
+            <a:srgbClr val="1F4E79"/>
+          </a:solidFill>
+          <a:ln>
+            <a:noFill/>
+          </a:ln>
+        </p:spPr>
+        <p:style>
+          <a:lnRef idx="1">
+            <a:schemeClr val="accent1"/>
+          </a:lnRef>
+          <a:fillRef idx="3">
+            <a:schemeClr val="accent1"/>
+          </a:fillRef>
+          <a:effectRef idx="2">
+            <a:schemeClr val="accent1"/>
+          </a:effectRef>
+          <a:fontRef idx="minor">
+            <a:schemeClr val="lt1"/>
+          </a:fontRef>
+        </p:style>
+        <p:txBody>
+          <a:bodyPr rtlCol="0" anchor="ctr"/>
+          <a:lstStyle/>
+          <a:p>
+            <a:pPr algn="ctr"/>
+          </a:p>
+        </p:txBody>
+      </p:sp>
+      <p:sp>
+        <p:nvSpPr>
+          <p:cNvPr id="5" name="TextBox 4"/>
+          <p:cNvSpPr txBox="1"/>
+          <p:nvPr/>
+        </p:nvSpPr>
+        <p:spPr>
+          <a:xfrm>
+            <a:off x="731520" y="1280160"/>
+            <a:ext cx="10789920" cy="4937760"/>
+          </a:xfrm>
+          <a:prstGeom prst="rect">
+            <a:avLst/>
+          </a:prstGeom>
+          <a:noFill/>
+        </p:spPr>
+        <p:txBody>
+          <a:bodyPr wrap="square">
+            <a:spAutoFit/>
+          </a:bodyPr>
+          <a:lstStyle/>
+          <a:p>
+            <a:pPr>
+              <a:spcAft>
+                <a:spcPts val="1000"/>
+              </a:spcAft>
+            </a:pPr>
+            <a:r>
+              <a:rPr sz="2200">
+                <a:solidFill>
+                  <a:srgbClr val="333333"/>
+                </a:solidFill>
+                <a:latin typeface="Calibri"/>
+              </a:rPr>
+              <a:t>•  Idea: physical / structural quantities are data-intrinsic; supervise the representation with them, keeping the model end-to-end</a:t>
+            </a:r>
+          </a:p>
+          <a:p>
+            <a:pPr>
+              <a:spcAft>
+                <a:spcPts val="1000"/>
+              </a:spcAft>
+            </a:pPr>
+            <a:r>
+              <a:rPr sz="2200">
+                <a:solidFill>
+                  <a:srgbClr val="333333"/>
+                </a:solidFill>
+                <a:latin typeface="Calibri"/>
+              </a:rPr>
+              <a:t>•  Heads sharing this theme:</a:t>
+            </a:r>
+          </a:p>
+          <a:p>
+            <a:pPr>
+              <a:spcAft>
+                <a:spcPts val="1000"/>
+              </a:spcAft>
+            </a:pPr>
+            <a:r>
+              <a:rPr sz="2000">
+                <a:solidFill>
+                  <a:srgbClr val="333333"/>
+                </a:solidFill>
+                <a:latin typeface="Calibri"/>
+              </a:rPr>
+              <a:t>    –  source head (v36) — Rumor-Centrality root; early instance of the same idea</a:t>
+            </a:r>
+          </a:p>
+          <a:p>
+            <a:pPr>
+              <a:spcAft>
+                <a:spcPts val="1000"/>
+              </a:spcAft>
+            </a:pPr>
+            <a:r>
+              <a:rPr sz="2000">
+                <a:solidFill>
+                  <a:srgbClr val="333333"/>
+                </a:solidFill>
+                <a:latin typeface="Calibri"/>
+              </a:rPr>
+              <a:t>    –  mass head — edge-level log10(m_ππ)</a:t>
+            </a:r>
+          </a:p>
+          <a:p>
+            <a:pPr>
+              <a:spcAft>
+                <a:spcPts val="1000"/>
+              </a:spcAft>
+            </a:pPr>
+            <a:r>
+              <a:rPr sz="2000">
+                <a:solidFill>
+                  <a:srgbClr val="333333"/>
+                </a:solidFill>
+                <a:latin typeface="Calibri"/>
+              </a:rPr>
+              <a:t>    –  structure head — node depth + RC value</a:t>
+            </a:r>
+          </a:p>
+          <a:p>
+            <a:pPr>
+              <a:spcAft>
+                <a:spcPts val="1000"/>
+              </a:spcAft>
+            </a:pPr>
+            <a:r>
+              <a:rPr sz="2000">
+                <a:solidFill>
+                  <a:srgbClr val="333333"/>
+                </a:solidFill>
+                <a:latin typeface="Calibri"/>
+              </a:rPr>
+              <a:t>    –  momentum head — node normalized momentum</a:t>
+            </a:r>
+          </a:p>
+          <a:p>
+            <a:pPr>
+              <a:spcAft>
+                <a:spcPts val="1000"/>
+              </a:spcAft>
+            </a:pPr>
+            <a:r>
+              <a:rPr sz="2200">
+                <a:solidFill>
+                  <a:srgbClr val="333333"/>
+                </a:solidFill>
+                <a:latin typeface="Calibri"/>
+              </a:rPr>
+              <a:t>•  Verification: linear probes on the frozen backbone (Ridge regression)</a:t>
+            </a:r>
+          </a:p>
+        </p:txBody>
+      </p:sp>
+    </p:spTree>
+  </p:cSld>
+  <p:clrMapOvr>
+    <a:masterClrMapping/>
+  </p:clrMapOvr>
+</p:sld>
+</file>
+
+<file path=ppt/slides/slide11.xml><?xml version="1.0" encoding="utf-8"?>
+<p:sld xmlns:a="http://schemas.openxmlformats.org/drawingml/2006/main" xmlns:p="http://schemas.openxmlformats.org/presentationml/2006/main" xmlns:r="http://schemas.openxmlformats.org/officeDocument/2006/relationships">
+  <p:cSld>
+    <p:spTree>
+      <p:nvGrpSpPr>
+        <p:cNvPr id="1" name=""/>
+        <p:cNvGrpSpPr/>
+        <p:nvPr/>
+      </p:nvGrpSpPr>
+      <p:grpSpPr/>
+      <p:sp>
+        <p:nvSpPr>
+          <p:cNvPr id="2" name="TextBox 1"/>
+          <p:cNvSpPr txBox="1"/>
+          <p:nvPr/>
+        </p:nvSpPr>
+        <p:spPr>
+          <a:xfrm>
+            <a:off x="502920" y="6510528"/>
+            <a:ext cx="11155680" cy="274320"/>
+          </a:xfrm>
+          <a:prstGeom prst="rect">
+            <a:avLst/>
+          </a:prstGeom>
+          <a:noFill/>
+        </p:spPr>
+        <p:txBody>
+          <a:bodyPr wrap="none">
+            <a:spAutoFit/>
+          </a:bodyPr>
+          <a:lstStyle/>
+          <a:p>
+            <a:r>
+              <a:rPr sz="1000">
+                <a:solidFill>
+                  <a:srgbClr val="666666"/>
+                </a:solidFill>
+                <a:latin typeface="Calibri"/>
+              </a:rPr>
+              <a:t>Qingxiang Guo · UCAS · DFEI group meeting      11</a:t>
+            </a:r>
+          </a:p>
+        </p:txBody>
+      </p:sp>
+      <p:sp>
+        <p:nvSpPr>
+          <p:cNvPr id="3" name="TextBox 2"/>
+          <p:cNvSpPr txBox="1"/>
+          <p:nvPr/>
+        </p:nvSpPr>
+        <p:spPr>
+          <a:xfrm>
+            <a:off x="502920" y="164592"/>
+            <a:ext cx="11155680" cy="914400"/>
+          </a:xfrm>
+          <a:prstGeom prst="rect">
+            <a:avLst/>
+          </a:prstGeom>
+          <a:noFill/>
+        </p:spPr>
+        <p:txBody>
+          <a:bodyPr wrap="square">
+            <a:spAutoFit/>
+          </a:bodyPr>
+          <a:lstStyle/>
+          <a:p>
+            <a:r>
+              <a:rPr sz="3800" b="1">
+                <a:solidFill>
+                  <a:srgbClr val="1F4E79"/>
+                </a:solidFill>
+                <a:latin typeface="Calibri"/>
+              </a:rPr>
+              <a:t>The Mass Head: Main Result</a:t>
+            </a:r>
+          </a:p>
+          <a:p>
+            <a:r>
+              <a:rPr sz="1700">
+                <a:solidFill>
+                  <a:srgbClr val="666666"/>
+                </a:solidFill>
+                <a:latin typeface="Calibri"/>
+              </a:rPr>
+              <a:t>Edge-level regression of log10(m_ππ)</a:t>
+            </a:r>
+          </a:p>
+        </p:txBody>
+      </p:sp>
+      <p:sp>
+        <p:nvSpPr>
+          <p:cNvPr id="4" name="Rectangle 3"/>
+          <p:cNvSpPr/>
+          <p:nvPr/>
+        </p:nvSpPr>
+        <p:spPr>
+          <a:xfrm>
+            <a:off x="548640" y="1188720"/>
+            <a:ext cx="11064240" cy="38100"/>
+          </a:xfrm>
+          <a:prstGeom prst="rect">
+            <a:avLst/>
+          </a:prstGeom>
+          <a:solidFill>
+            <a:srgbClr val="1F4E79"/>
+          </a:solidFill>
+          <a:ln>
+            <a:noFill/>
+          </a:ln>
+        </p:spPr>
+        <p:style>
+          <a:lnRef idx="1">
+            <a:schemeClr val="accent1"/>
+          </a:lnRef>
+          <a:fillRef idx="3">
+            <a:schemeClr val="accent1"/>
+          </a:fillRef>
+          <a:effectRef idx="2">
+            <a:schemeClr val="accent1"/>
+          </a:effectRef>
+          <a:fontRef idx="minor">
+            <a:schemeClr val="lt1"/>
+          </a:fontRef>
+        </p:style>
+        <p:txBody>
+          <a:bodyPr rtlCol="0" anchor="ctr"/>
+          <a:lstStyle/>
+          <a:p>
+            <a:pPr algn="ctr"/>
+          </a:p>
+        </p:txBody>
+      </p:sp>
+      <p:sp>
+        <p:nvSpPr>
+          <p:cNvPr id="5" name="TextBox 4"/>
+          <p:cNvSpPr txBox="1"/>
+          <p:nvPr/>
+        </p:nvSpPr>
+        <p:spPr>
+          <a:xfrm>
+            <a:off x="731520" y="1188720"/>
+            <a:ext cx="6035040" cy="5120640"/>
+          </a:xfrm>
+          <a:prstGeom prst="rect">
+            <a:avLst/>
+          </a:prstGeom>
+          <a:noFill/>
+        </p:spPr>
+        <p:txBody>
+          <a:bodyPr wrap="square">
+            <a:spAutoFit/>
+          </a:bodyPr>
+          <a:lstStyle/>
+          <a:p>
+            <a:pPr>
+              <a:spcAft>
+                <a:spcPts val="1000"/>
+              </a:spcAft>
+            </a:pPr>
+            <a:r>
+              <a:rPr sz="2200">
+                <a:solidFill>
+                  <a:srgbClr val="333333"/>
+                </a:solidFill>
+                <a:latin typeface="Calibri"/>
+              </a:rPr>
+              <a:t>•  Same-mother track pairs sit near resonance masses → the edge representation must encode sister relations</a:t>
+            </a:r>
+          </a:p>
+          <a:p>
+            <a:pPr>
+              <a:spcAft>
+                <a:spcPts val="1000"/>
+              </a:spcAft>
+            </a:pPr>
+            <a:r>
+              <a:rPr sz="2200">
+                <a:solidFill>
+                  <a:srgbClr val="333333"/>
+                </a:solidFill>
+                <a:latin typeface="Calibri"/>
+              </a:rPr>
+              <a:t>•  Setup: SmoothL1 on log10(m_MeV), sentinel edges masked, weight 1.0</a:t>
+            </a:r>
+          </a:p>
+          <a:p>
+            <a:pPr>
+              <a:spcAft>
+                <a:spcPts val="1000"/>
+              </a:spcAft>
+            </a:pPr>
+            <a:r>
+              <a:rPr sz="2200">
+                <a:solidFill>
+                  <a:srgbClr val="333333"/>
+                </a:solidFill>
+                <a:latin typeface="Calibri"/>
+              </a:rPr>
+              <a:t>•  v38 → masshead2 (20 test files):</a:t>
+            </a:r>
+          </a:p>
+          <a:p>
+            <a:pPr>
+              <a:spcAft>
+                <a:spcPts val="1000"/>
+              </a:spcAft>
+            </a:pPr>
+            <a:r>
+              <a:rPr sz="2000">
+                <a:solidFill>
+                  <a:srgbClr val="333333"/>
+                </a:solidFill>
+                <a:latin typeface="Calibri"/>
+              </a:rPr>
+              <a:t>    –  PerfectReco 29.3% → 32.7%  (+3.4pp)</a:t>
+            </a:r>
+          </a:p>
+          <a:p>
+            <a:pPr>
+              <a:spcAft>
+                <a:spcPts val="1000"/>
+              </a:spcAft>
+            </a:pPr>
+            <a:r>
+              <a:rPr sz="2000">
+                <a:solidFill>
+                  <a:srgbClr val="333333"/>
+                </a:solidFill>
+                <a:latin typeface="Calibri"/>
+              </a:rPr>
+              <a:t>    –  AllParticles 52.1% → 55.9%  (+3.8pp)</a:t>
+            </a:r>
+          </a:p>
+          <a:p>
+            <a:pPr>
+              <a:spcAft>
+                <a:spcPts val="1000"/>
+              </a:spcAft>
+            </a:pPr>
+            <a:r>
+              <a:rPr sz="2000">
+                <a:solidFill>
+                  <a:srgbClr val="333333"/>
+                </a:solidFill>
+                <a:latin typeface="Calibri"/>
+              </a:rPr>
+              <a:t>    –  LCAG class2 44.7% → 51.1%  (+6.4pp)</a:t>
+            </a:r>
+          </a:p>
+        </p:txBody>
+      </p:sp>
+      <p:pic>
+        <p:nvPicPr>
+          <p:cNvPr id="6" name="Picture 5" descr="NN_edges_2_roc.png"/>
+          <p:cNvPicPr>
+            <a:picLocks noChangeAspect="1"/>
+          </p:cNvPicPr>
+          <p:nvPr/>
+        </p:nvPicPr>
+        <p:blipFill>
+          <a:blip r:embed="rId2"/>
+          <a:stretch>
+            <a:fillRect/>
+          </a:stretch>
+        </p:blipFill>
+        <p:spPr>
+          <a:xfrm>
+            <a:off x="6949440" y="1554480"/>
+            <a:ext cx="4754880" cy="3187931"/>
+          </a:xfrm>
+          <a:prstGeom prst="rect">
+            <a:avLst/>
+          </a:prstGeom>
+        </p:spPr>
+      </p:pic>
+    </p:spTree>
+  </p:cSld>
+  <p:clrMapOvr>
+    <a:masterClrMapping/>
+  </p:clrMapOvr>
+</p:sld>
+</file>
+
+<file path=ppt/slides/slide12.xml><?xml version="1.0" encoding="utf-8"?>
+<p:sld xmlns:a="http://schemas.openxmlformats.org/drawingml/2006/main" xmlns:p="http://schemas.openxmlformats.org/presentationml/2006/main" xmlns:r="http://schemas.openxmlformats.org/officeDocument/2006/relationships">
+  <p:cSld>
+    <p:spTree>
+      <p:nvGrpSpPr>
+        <p:cNvPr id="1" name=""/>
+        <p:cNvGrpSpPr/>
+        <p:nvPr/>
+      </p:nvGrpSpPr>
+      <p:grpSpPr/>
+      <p:sp>
+        <p:nvSpPr>
+          <p:cNvPr id="2" name="TextBox 1"/>
+          <p:cNvSpPr txBox="1"/>
+          <p:nvPr/>
+        </p:nvSpPr>
+        <p:spPr>
+          <a:xfrm>
+            <a:off x="502920" y="6510528"/>
+            <a:ext cx="11155680" cy="274320"/>
+          </a:xfrm>
+          <a:prstGeom prst="rect">
+            <a:avLst/>
+          </a:prstGeom>
+          <a:noFill/>
+        </p:spPr>
+        <p:txBody>
+          <a:bodyPr wrap="none">
+            <a:spAutoFit/>
+          </a:bodyPr>
+          <a:lstStyle/>
+          <a:p>
+            <a:r>
+              <a:rPr sz="1000">
+                <a:solidFill>
+                  <a:srgbClr val="666666"/>
+                </a:solidFill>
+                <a:latin typeface="Calibri"/>
+              </a:rPr>
+              <a:t>Qingxiang Guo · UCAS · DFEI group meeting      12</a:t>
             </a:r>
           </a:p>
         </p:txBody>
@@ -3819,7 +4379,7 @@
 </p:sld>
 </file>
 
-<file path=ppt/slides/slide11.xml><?xml version="1.0" encoding="utf-8"?>
+<file path=ppt/slides/slide13.xml><?xml version="1.0" encoding="utf-8"?>
 <p:sld xmlns:a="http://schemas.openxmlformats.org/drawingml/2006/main" xmlns:p="http://schemas.openxmlformats.org/presentationml/2006/main" xmlns:r="http://schemas.openxmlformats.org/officeDocument/2006/relationships">
   <p:cSld>
     <p:spTree>
@@ -3858,7 +4418,7 @@
                 </a:solidFill>
                 <a:latin typeface="Calibri"/>
               </a:rPr>
-              <a:t>Qingxiang Guo · UCAS · DFEI group meeting      11</a:t>
+              <a:t>Qingxiang Guo · UCAS · DFEI group meeting      13</a:t>
             </a:r>
           </a:p>
         </p:txBody>
@@ -4242,7 +4802,7 @@
 </p:sld>
 </file>
 
-<file path=ppt/slides/slide12.xml><?xml version="1.0" encoding="utf-8"?>
+<file path=ppt/slides/slide14.xml><?xml version="1.0" encoding="utf-8"?>
 <p:sld xmlns:a="http://schemas.openxmlformats.org/drawingml/2006/main" xmlns:p="http://schemas.openxmlformats.org/presentationml/2006/main" xmlns:r="http://schemas.openxmlformats.org/officeDocument/2006/relationships">
   <p:cSld>
     <p:spTree>
@@ -4281,7 +4841,7 @@
                 </a:solidFill>
                 <a:latin typeface="Calibri"/>
               </a:rPr>
-              <a:t>Qingxiang Guo · UCAS · DFEI group meeting      12</a:t>
+              <a:t>Qingxiang Guo · UCAS · DFEI group meeting      14</a:t>
             </a:r>
           </a:p>
         </p:txBody>
@@ -4490,7 +5050,7 @@
 </p:sld>
 </file>
 
-<file path=ppt/slides/slide13.xml><?xml version="1.0" encoding="utf-8"?>
+<file path=ppt/slides/slide15.xml><?xml version="1.0" encoding="utf-8"?>
 <p:sld xmlns:a="http://schemas.openxmlformats.org/drawingml/2006/main" xmlns:p="http://schemas.openxmlformats.org/presentationml/2006/main" xmlns:r="http://schemas.openxmlformats.org/officeDocument/2006/relationships">
   <p:cSld>
     <p:spTree>
@@ -4529,7 +5089,7 @@
                 </a:solidFill>
                 <a:latin typeface="Calibri"/>
               </a:rPr>
-              <a:t>Qingxiang Guo · UCAS · DFEI group meeting      13</a:t>
+              <a:t>Qingxiang Guo · UCAS · DFEI group meeting      15</a:t>
             </a:r>
           </a:p>
         </p:txBody>
@@ -4722,7 +5282,7 @@
 </p:sld>
 </file>
 
-<file path=ppt/slides/slide14.xml><?xml version="1.0" encoding="utf-8"?>
+<file path=ppt/slides/slide16.xml><?xml version="1.0" encoding="utf-8"?>
 <p:sld xmlns:a="http://schemas.openxmlformats.org/drawingml/2006/main" xmlns:p="http://schemas.openxmlformats.org/presentationml/2006/main" xmlns:r="http://schemas.openxmlformats.org/officeDocument/2006/relationships">
   <p:cSld>
     <p:spTree>
@@ -4761,7 +5321,7 @@
                 </a:solidFill>
                 <a:latin typeface="Calibri"/>
               </a:rPr>
-              <a:t>Qingxiang Guo · UCAS · DFEI group meeting      14</a:t>
+              <a:t>Qingxiang Guo · UCAS · DFEI group meeting      16</a:t>
             </a:r>
           </a:p>
         </p:txBody>
@@ -6538,7 +7098,7 @@
                 </a:solidFill>
                 <a:latin typeface="Calibri"/>
               </a:rPr>
-              <a:t>Part 1 — LCA Supervision Adjustment</a:t>
+              <a:t>Part 1 — The Problem: Class-0 Dilution</a:t>
             </a:r>
           </a:p>
           <a:p>
@@ -6549,7 +7109,7 @@
                 </a:solidFill>
                 <a:latin typeface="Calibri"/>
               </a:rPr>
-              <a:t>Class-2 weighting and in-chain consistency, refined by experiments</a:t>
+              <a:t>Why the standard classifier fails on chain structure</a:t>
             </a:r>
           </a:p>
         </p:txBody>
@@ -6606,7 +7166,7 @@
         <p:spPr>
           <a:xfrm>
             <a:off x="731520" y="1234440"/>
-            <a:ext cx="10789920" cy="2286000"/>
+            <a:ext cx="10789920" cy="2194560"/>
           </a:xfrm>
           <a:prstGeom prst="rect">
             <a:avLst/>
@@ -6631,7 +7191,7 @@
                 </a:solidFill>
                 <a:latin typeface="Calibri"/>
               </a:rPr>
-              <a:t>•  Class-2 (same-mother) edges are the structural bottleneck: weight 3.0 (v37) over-weighted → 2.0 (v38)</a:t>
+              <a:t>•  class 0 (background) is 99.9% of edges; structural classes 1/2/3 together are ~0.1%</a:t>
             </a:r>
           </a:p>
           <a:p>
@@ -6647,7 +7207,7 @@
                 </a:solidFill>
                 <a:latin typeface="Calibri"/>
               </a:rPr>
-              <a:t>•  In-chain consistency, on truth-chain edges only:</a:t>
+              <a:t>•  The main LCAG loss is a global cross-entropy over every edge → its gradient is ~99.9% "predict background"</a:t>
             </a:r>
           </a:p>
           <a:p>
@@ -6657,13 +7217,13 @@
               </a:spcAft>
             </a:pPr>
             <a:r>
-              <a:rPr sz="2000">
+              <a:rPr sz="2200">
                 <a:solidFill>
                   <a:srgbClr val="333333"/>
                 </a:solidFill>
                 <a:latin typeface="Calibri"/>
               </a:rPr>
-              <a:t>    –  hinge (v37): keep chain edges confident (margin 0.3)</a:t>
+              <a:t>•  Consequence: rare structural edges are undertrained → misclassified → chains break</a:t>
             </a:r>
           </a:p>
           <a:p>
@@ -6673,36 +7233,20 @@
               </a:spcAft>
             </a:pPr>
             <a:r>
-              <a:rPr sz="2000">
+              <a:rPr sz="2200">
                 <a:solidFill>
                   <a:srgbClr val="333333"/>
                 </a:solidFill>
                 <a:latin typeface="Calibri"/>
               </a:rPr>
-              <a:t>    –  chain-CE (v38): direct cross-entropy on chain-edge classes — structural edges are ~0.1% of all edges</a:t>
-            </a:r>
-          </a:p>
-          <a:p>
-            <a:pPr>
-              <a:spcAft>
-                <a:spcPts val="1000"/>
-              </a:spcAft>
-            </a:pPr>
-            <a:r>
-              <a:rPr sz="2200">
-                <a:solidFill>
-                  <a:srgbClr val="333333"/>
-                </a:solidFill>
-                <a:latin typeface="Calibri"/>
-              </a:rPr>
-              <a:t>•  Net effect of Part 1 (v31 → v38): PerfectReco 23.9% → 29.3%</a:t>
+              <a:t>•  Fixes in Part 1: class-2 weighting (3.0 → 2.0), then hinge (v37), then chain-CE (v38)</a:t>
             </a:r>
           </a:p>
         </p:txBody>
       </p:sp>
       <p:pic>
         <p:nvPicPr>
-          <p:cNvPr id="6" name="Picture 5" descr="chain_lca_curves.png"/>
+          <p:cNvPr id="6" name="Picture 5" descr="chain_lca_dilution.png"/>
           <p:cNvPicPr>
             <a:picLocks noChangeAspect="1"/>
           </p:cNvPicPr>
@@ -6716,14 +7260,49 @@
         </p:blipFill>
         <p:spPr>
           <a:xfrm>
-            <a:off x="731520" y="3611880"/>
-            <a:ext cx="10881360" cy="2597411"/>
+            <a:off x="1554480" y="3474720"/>
+            <a:ext cx="9052560" cy="3944567"/>
           </a:xfrm>
           <a:prstGeom prst="rect">
             <a:avLst/>
           </a:prstGeom>
         </p:spPr>
       </p:pic>
+      <p:sp>
+        <p:nvSpPr>
+          <p:cNvPr id="7" name="TextBox 6"/>
+          <p:cNvSpPr txBox="1"/>
+          <p:nvPr/>
+        </p:nvSpPr>
+        <p:spPr>
+          <a:xfrm>
+            <a:off x="731520" y="6263640"/>
+            <a:ext cx="10789920" cy="365760"/>
+          </a:xfrm>
+          <a:prstGeom prst="rect">
+            <a:avLst/>
+          </a:prstGeom>
+          <a:noFill/>
+        </p:spPr>
+        <p:txBody>
+          <a:bodyPr wrap="square">
+            <a:spAutoFit/>
+          </a:bodyPr>
+          <a:lstStyle/>
+          <a:p>
+            <a:pPr algn="ctr"/>
+            <a:r>
+              <a:rPr sz="1200" i="1">
+                <a:solidFill>
+                  <a:srgbClr val="666666"/>
+                </a:solidFill>
+                <a:latin typeface="Calibri"/>
+              </a:rPr>
+              <a:t>Implication: with ~1000 background edges per structural edge, the global CE alone cannot teach the model classes 1/2/3</a:t>
+            </a:r>
+          </a:p>
+        </p:txBody>
+      </p:sp>
     </p:spTree>
   </p:cSld>
   <p:clrMapOvr>
@@ -6805,7 +7384,7 @@
                 </a:solidFill>
                 <a:latin typeface="Calibri"/>
               </a:rPr>
-              <a:t>Why Chains Die (1/2): The Class Imbalance</a:t>
+              <a:t>Fix 1 (v37): Hinge — Stay Confident</a:t>
             </a:r>
           </a:p>
           <a:p>
@@ -6816,7 +7395,7 @@
                 </a:solidFill>
                 <a:latin typeface="Calibri"/>
               </a:rPr>
-              <a:t>Structural edges are ~0.1% and the hardest to classify</a:t>
+              <a:t>An extra loss that keeps chain edges confidently classified</a:t>
             </a:r>
           </a:p>
         </p:txBody>
@@ -6873,7 +7452,7 @@
         <p:spPr>
           <a:xfrm>
             <a:off x="731520" y="1234440"/>
-            <a:ext cx="10789920" cy="2103120"/>
+            <a:ext cx="10789920" cy="2194560"/>
           </a:xfrm>
           <a:prstGeom prst="rect">
             <a:avLst/>
@@ -6898,7 +7477,7 @@
                 </a:solidFill>
                 <a:latin typeface="Calibri"/>
               </a:rPr>
-              <a:t>•  class 0 (background) is 99.9% of edges; each structural class is ~0.04%</a:t>
+              <a:t>•  Confidence: per edge the LCAG head gives a 4-class softmax (p0…p3); confidence = max(pk)</a:t>
             </a:r>
           </a:p>
           <a:p>
@@ -6914,7 +7493,7 @@
                 </a:solidFill>
                 <a:latin typeface="Calibri"/>
               </a:rPr>
-              <a:t>•  The GNN is weakest exactly on the rarest classes — especially class 2 (sister)</a:t>
+              <a:t>•  Loss = max(0, margin − confidence), margin 0.3 — added as an extra term to the total loss</a:t>
             </a:r>
           </a:p>
           <a:p>
@@ -6930,14 +7509,46 @@
                 </a:solidFill>
                 <a:latin typeface="Calibri"/>
               </a:rPr>
-              <a:t>•  In the global CE, the gradient is ~99.9% "predict background" → rare classes are undertrained</a:t>
+              <a:t>•  Applied ONLY on truth-chain edges — the true chains are known from MC truth during training</a:t>
+            </a:r>
+          </a:p>
+          <a:p>
+            <a:pPr>
+              <a:spcAft>
+                <a:spcPts val="1000"/>
+              </a:spcAft>
+            </a:pPr>
+            <a:r>
+              <a:rPr sz="2200">
+                <a:solidFill>
+                  <a:srgbClr val="333333"/>
+                </a:solidFill>
+                <a:latin typeface="Calibri"/>
+              </a:rPr>
+              <a:t>•  Role: chain edges give the global CE almost no gradient → the hinge makes sure they are at least confident</a:t>
+            </a:r>
+          </a:p>
+          <a:p>
+            <a:pPr>
+              <a:spcAft>
+                <a:spcPts val="1000"/>
+              </a:spcAft>
+            </a:pPr>
+            <a:r>
+              <a:rPr sz="2200">
+                <a:solidFill>
+                  <a:srgbClr val="333333"/>
+                </a:solidFill>
+                <a:latin typeface="Calibri"/>
+              </a:rPr>
+              <a:t>•  Limitation: it demands confidence, not the right class — CE (next slide) adds the "which class"</a:t>
             </a:r>
           </a:p>
         </p:txBody>
       </p:sp>
       <p:pic>
         <p:nvPicPr>
-          <p:cNvPr id="6" name="Picture 5" descr="chain_lca_imbalance.png"/>
+          <p:cNvPr id="6" name="Picture 5" descr="chain_lca_hinge.png"/>
           <p:cNvPicPr>
             <a:picLocks noChangeAspect="1"/>
           </p:cNvPicPr>
@@ -6951,8 +7562,8 @@
         </p:blipFill>
         <p:spPr>
           <a:xfrm>
-            <a:off x="1097280" y="3429000"/>
-            <a:ext cx="9966960" cy="2712900"/>
+            <a:off x="822960" y="3429000"/>
+            <a:ext cx="10515600" cy="3861374"/>
           </a:xfrm>
           <a:prstGeom prst="rect">
             <a:avLst/>
@@ -6967,7 +7578,7 @@
         </p:nvSpPr>
         <p:spPr>
           <a:xfrm>
-            <a:off x="731520" y="6217920"/>
+            <a:off x="731520" y="6309360"/>
             <a:ext cx="10789920" cy="365760"/>
           </a:xfrm>
           <a:prstGeom prst="rect">
@@ -6989,7 +7600,7 @@
                 </a:solidFill>
                 <a:latin typeface="Calibri"/>
               </a:rPr>
-              <a:t>Implication: without extra supervision, the classifier barely learns classes 1/2/3 — the chain losses exist to fix this</a:t>
+              <a:t>Implication: confidence here is max(pk) from the LCAG head — not the pruning weight w; the loss lives on truth-chain edges only</a:t>
             </a:r>
           </a:p>
         </p:txBody>
@@ -7075,7 +7686,7 @@
                 </a:solidFill>
                 <a:latin typeface="Calibri"/>
               </a:rPr>
-              <a:t>Why Chains Die (2/2): One Misclassified Edge</a:t>
+              <a:t>Fix 2 (v38): Chain Cross-Entropy</a:t>
             </a:r>
           </a:p>
           <a:p>
@@ -7086,7 +7697,7 @@
                 </a:solidFill>
                 <a:latin typeface="Calibri"/>
               </a:rPr>
-              <a:t>Chain-CE keeps every structural edge correct</a:t>
+              <a:t>Be the RIGHT class — on chain edges only</a:t>
             </a:r>
           </a:p>
         </p:txBody>
@@ -7143,7 +7754,7 @@
         <p:spPr>
           <a:xfrm>
             <a:off x="731520" y="1234440"/>
-            <a:ext cx="10789920" cy="2103120"/>
+            <a:ext cx="10789920" cy="2194560"/>
           </a:xfrm>
           <a:prstGeom prst="rect">
             <a:avLst/>
@@ -7168,7 +7779,7 @@
                 </a:solidFill>
                 <a:latin typeface="Calibri"/>
               </a:rPr>
-              <a:t>•  At inference, an edge the classifier calls class 0 is pruned</a:t>
+              <a:t>•  CE = −log(p_true): p_true is the probability the model assigns to the edge’s TRUE class</a:t>
             </a:r>
           </a:p>
           <a:p>
@@ -7184,7 +7795,7 @@
                 </a:solidFill>
                 <a:latin typeface="Calibri"/>
               </a:rPr>
-              <a:t>•  If ANY structural edge of a chain is misclassified, the whole chain dies</a:t>
+              <a:t>•  Confident and right (p_true → 1) → CE ≈ 0; unsure or wrong → CE large</a:t>
             </a:r>
           </a:p>
           <a:p>
@@ -7200,14 +7811,46 @@
                 </a:solidFill>
                 <a:latin typeface="Calibri"/>
               </a:rPr>
-              <a:t>•  Chain-CE (v38) supervises truth-chain edge classes directly → chains survive</a:t>
+              <a:t>•  Chain-CE (v38): added ON TOP of the hinge, on truth-chain edges (classes 1/2/3) → direct, undiluted gradient</a:t>
+            </a:r>
+          </a:p>
+          <a:p>
+            <a:pPr>
+              <a:spcAft>
+                <a:spcPts val="1000"/>
+              </a:spcAft>
+            </a:pPr>
+            <a:r>
+              <a:rPr sz="2200">
+                <a:solidFill>
+                  <a:srgbClr val="333333"/>
+                </a:solidFill>
+                <a:latin typeface="Calibri"/>
+              </a:rPr>
+              <a:t>•  v37 → v38 (weight 2.0 + chain-CE + cut 0.85): PerfectReco 27.3% → 29.3%</a:t>
+            </a:r>
+          </a:p>
+          <a:p>
+            <a:pPr>
+              <a:spcAft>
+                <a:spcPts val="1000"/>
+              </a:spcAft>
+            </a:pPr>
+            <a:r>
+              <a:rPr sz="2200">
+                <a:solidFill>
+                  <a:srgbClr val="333333"/>
+                </a:solidFill>
+                <a:latin typeface="Calibri"/>
+              </a:rPr>
+              <a:t>•  Net effect of Part 1 (v31 → v38): 23.9% → 29.3%</a:t>
             </a:r>
           </a:p>
         </p:txBody>
       </p:sp>
       <p:pic>
         <p:nvPicPr>
-          <p:cNvPr id="6" name="Picture 5" descr="chain_lca_before_after.png"/>
+          <p:cNvPr id="6" name="Picture 5" descr="chain_lca_ce.png"/>
           <p:cNvPicPr>
             <a:picLocks noChangeAspect="1"/>
           </p:cNvPicPr>
@@ -7221,8 +7864,8 @@
         </p:blipFill>
         <p:spPr>
           <a:xfrm>
-            <a:off x="1097280" y="3429000"/>
-            <a:ext cx="9966960" cy="3458144"/>
+            <a:off x="822960" y="3429000"/>
+            <a:ext cx="10515600" cy="3896991"/>
           </a:xfrm>
           <a:prstGeom prst="rect">
             <a:avLst/>
@@ -7237,7 +7880,7 @@
         </p:nvSpPr>
         <p:spPr>
           <a:xfrm>
-            <a:off x="731520" y="6217920"/>
+            <a:off x="731520" y="6309360"/>
             <a:ext cx="10789920" cy="365760"/>
           </a:xfrm>
           <a:prstGeom prst="rect">
@@ -7259,7 +7902,7 @@
                 </a:solidFill>
                 <a:latin typeface="Calibri"/>
               </a:rPr>
-              <a:t>Implication: chain survival depends on every structural edge being classified correctly — that is what the hinge + chain-CE provide</a:t>
+              <a:t>Implication: same loss function as the global CE — the fix is WHERE it is applied, not which loss</a:t>
             </a:r>
           </a:p>
         </p:txBody>
@@ -7345,7 +7988,7 @@
                 </a:solidFill>
                 <a:latin typeface="Calibri"/>
               </a:rPr>
-              <a:t>Part 2 — Supervising Representations with Physics</a:t>
+              <a:t>Why Chains Die (1/2): The Class Imbalance</a:t>
             </a:r>
           </a:p>
           <a:p>
@@ -7356,7 +7999,7 @@
                 </a:solidFill>
                 <a:latin typeface="Calibri"/>
               </a:rPr>
-              <a:t>One common idea behind several heads</a:t>
+              <a:t>Structural edges are ~0.1% and the hardest to classify</a:t>
             </a:r>
           </a:p>
         </p:txBody>
@@ -7412,8 +8055,8 @@
         </p:nvSpPr>
         <p:spPr>
           <a:xfrm>
-            <a:off x="731520" y="1280160"/>
-            <a:ext cx="10789920" cy="4937760"/>
+            <a:off x="731520" y="1234440"/>
+            <a:ext cx="10789920" cy="2103120"/>
           </a:xfrm>
           <a:prstGeom prst="rect">
             <a:avLst/>
@@ -7438,7 +8081,7 @@
                 </a:solidFill>
                 <a:latin typeface="Calibri"/>
               </a:rPr>
-              <a:t>•  Idea: physical / structural quantities are data-intrinsic; supervise the representation with them, keeping the model end-to-end</a:t>
+              <a:t>•  class 0 (background) is 99.9% of edges; each structural class is ~0.04%</a:t>
             </a:r>
           </a:p>
           <a:p>
@@ -7454,7 +8097,7 @@
                 </a:solidFill>
                 <a:latin typeface="Calibri"/>
               </a:rPr>
-              <a:t>•  Heads sharing this theme:</a:t>
+              <a:t>•  The GNN is weakest exactly on the rarest classes — especially class 2 (sister)</a:t>
             </a:r>
           </a:p>
           <a:p>
@@ -7464,77 +8107,72 @@
               </a:spcAft>
             </a:pPr>
             <a:r>
-              <a:rPr sz="2000">
+              <a:rPr sz="2200">
                 <a:solidFill>
                   <a:srgbClr val="333333"/>
                 </a:solidFill>
                 <a:latin typeface="Calibri"/>
               </a:rPr>
-              <a:t>    –  source head (v36) — Rumor-Centrality root; early instance of the same idea</a:t>
-            </a:r>
-          </a:p>
-          <a:p>
-            <a:pPr>
-              <a:spcAft>
-                <a:spcPts val="1000"/>
-              </a:spcAft>
-            </a:pPr>
-            <a:r>
-              <a:rPr sz="2000">
-                <a:solidFill>
-                  <a:srgbClr val="333333"/>
-                </a:solidFill>
-                <a:latin typeface="Calibri"/>
-              </a:rPr>
-              <a:t>    –  mass head — edge-level log10(m_ππ)</a:t>
-            </a:r>
-          </a:p>
-          <a:p>
-            <a:pPr>
-              <a:spcAft>
-                <a:spcPts val="1000"/>
-              </a:spcAft>
-            </a:pPr>
-            <a:r>
-              <a:rPr sz="2000">
-                <a:solidFill>
-                  <a:srgbClr val="333333"/>
-                </a:solidFill>
-                <a:latin typeface="Calibri"/>
-              </a:rPr>
-              <a:t>    –  structure head — node depth + RC value</a:t>
-            </a:r>
-          </a:p>
-          <a:p>
-            <a:pPr>
-              <a:spcAft>
-                <a:spcPts val="1000"/>
-              </a:spcAft>
-            </a:pPr>
-            <a:r>
-              <a:rPr sz="2000">
-                <a:solidFill>
-                  <a:srgbClr val="333333"/>
-                </a:solidFill>
-                <a:latin typeface="Calibri"/>
-              </a:rPr>
-              <a:t>    –  momentum head — node normalized momentum</a:t>
-            </a:r>
-          </a:p>
-          <a:p>
-            <a:pPr>
-              <a:spcAft>
-                <a:spcPts val="1000"/>
-              </a:spcAft>
-            </a:pPr>
-            <a:r>
-              <a:rPr sz="2200">
-                <a:solidFill>
-                  <a:srgbClr val="333333"/>
-                </a:solidFill>
-                <a:latin typeface="Calibri"/>
-              </a:rPr>
-              <a:t>•  Verification: linear probes on the frozen backbone (Ridge regression)</a:t>
+              <a:t>•  Right panel: measured per-class accuracy — worst exactly on the rare structural classes</a:t>
+            </a:r>
+          </a:p>
+        </p:txBody>
+      </p:sp>
+      <p:pic>
+        <p:nvPicPr>
+          <p:cNvPr id="6" name="Picture 5" descr="chain_lca_imbalance.png"/>
+          <p:cNvPicPr>
+            <a:picLocks noChangeAspect="1"/>
+          </p:cNvPicPr>
+          <p:nvPr/>
+        </p:nvPicPr>
+        <p:blipFill>
+          <a:blip r:embed="rId2"/>
+          <a:stretch>
+            <a:fillRect/>
+          </a:stretch>
+        </p:blipFill>
+        <p:spPr>
+          <a:xfrm>
+            <a:off x="1097280" y="3429000"/>
+            <a:ext cx="9966960" cy="2712900"/>
+          </a:xfrm>
+          <a:prstGeom prst="rect">
+            <a:avLst/>
+          </a:prstGeom>
+        </p:spPr>
+      </p:pic>
+      <p:sp>
+        <p:nvSpPr>
+          <p:cNvPr id="7" name="TextBox 6"/>
+          <p:cNvSpPr txBox="1"/>
+          <p:nvPr/>
+        </p:nvSpPr>
+        <p:spPr>
+          <a:xfrm>
+            <a:off x="731520" y="6217920"/>
+            <a:ext cx="10789920" cy="365760"/>
+          </a:xfrm>
+          <a:prstGeom prst="rect">
+            <a:avLst/>
+          </a:prstGeom>
+          <a:noFill/>
+        </p:spPr>
+        <p:txBody>
+          <a:bodyPr wrap="square">
+            <a:spAutoFit/>
+          </a:bodyPr>
+          <a:lstStyle/>
+          <a:p>
+            <a:pPr algn="ctr"/>
+            <a:r>
+              <a:rPr sz="1200" i="1">
+                <a:solidFill>
+                  <a:srgbClr val="666666"/>
+                </a:solidFill>
+                <a:latin typeface="Calibri"/>
+              </a:rPr>
+              <a:t>Implication: without extra supervision, the classifier barely learns classes 1/2/3 — the chain losses exist to fix this</a:t>
             </a:r>
           </a:p>
         </p:txBody>
@@ -7620,7 +8258,7 @@
                 </a:solidFill>
                 <a:latin typeface="Calibri"/>
               </a:rPr>
-              <a:t>The Mass Head: Main Result</a:t>
+              <a:t>Why Chains Die (2/2): One Misclassified Edge</a:t>
             </a:r>
           </a:p>
           <a:p>
@@ -7631,7 +8269,7 @@
                 </a:solidFill>
                 <a:latin typeface="Calibri"/>
               </a:rPr>
-              <a:t>Edge-level regression of log10(m_ππ)</a:t>
+              <a:t>Chain-CE keeps every structural edge correct</a:t>
             </a:r>
           </a:p>
         </p:txBody>
@@ -7687,8 +8325,8 @@
         </p:nvSpPr>
         <p:spPr>
           <a:xfrm>
-            <a:off x="731520" y="1188720"/>
-            <a:ext cx="6035040" cy="5120640"/>
+            <a:off x="731520" y="1234440"/>
+            <a:ext cx="10789920" cy="2103120"/>
           </a:xfrm>
           <a:prstGeom prst="rect">
             <a:avLst/>
@@ -7713,7 +8351,7 @@
                 </a:solidFill>
                 <a:latin typeface="Calibri"/>
               </a:rPr>
-              <a:t>•  Same-mother track pairs sit near resonance masses → the edge representation must encode sister relations</a:t>
+              <a:t>•  At inference, an edge the classifier calls class 0 is pruned</a:t>
             </a:r>
           </a:p>
           <a:p>
@@ -7729,7 +8367,7 @@
                 </a:solidFill>
                 <a:latin typeface="Calibri"/>
               </a:rPr>
-              <a:t>•  Setup: SmoothL1 on log10(m_MeV), sentinel edges masked, weight 1.0</a:t>
+              <a:t>•  If ANY structural edge of a chain is misclassified, the whole chain dies</a:t>
             </a:r>
           </a:p>
           <a:p>
@@ -7745,62 +8383,14 @@
                 </a:solidFill>
                 <a:latin typeface="Calibri"/>
               </a:rPr>
-              <a:t>•  v38 → masshead2 (20 test files):</a:t>
-            </a:r>
-          </a:p>
-          <a:p>
-            <a:pPr>
-              <a:spcAft>
-                <a:spcPts val="1000"/>
-              </a:spcAft>
-            </a:pPr>
-            <a:r>
-              <a:rPr sz="2000">
-                <a:solidFill>
-                  <a:srgbClr val="333333"/>
-                </a:solidFill>
-                <a:latin typeface="Calibri"/>
-              </a:rPr>
-              <a:t>    –  PerfectReco 29.3% → 32.7%  (+3.4pp)</a:t>
-            </a:r>
-          </a:p>
-          <a:p>
-            <a:pPr>
-              <a:spcAft>
-                <a:spcPts val="1000"/>
-              </a:spcAft>
-            </a:pPr>
-            <a:r>
-              <a:rPr sz="2000">
-                <a:solidFill>
-                  <a:srgbClr val="333333"/>
-                </a:solidFill>
-                <a:latin typeface="Calibri"/>
-              </a:rPr>
-              <a:t>    –  AllParticles 52.1% → 55.9%  (+3.8pp)</a:t>
-            </a:r>
-          </a:p>
-          <a:p>
-            <a:pPr>
-              <a:spcAft>
-                <a:spcPts val="1000"/>
-              </a:spcAft>
-            </a:pPr>
-            <a:r>
-              <a:rPr sz="2000">
-                <a:solidFill>
-                  <a:srgbClr val="333333"/>
-                </a:solidFill>
-                <a:latin typeface="Calibri"/>
-              </a:rPr>
-              <a:t>    –  LCAG class2 44.7% → 51.1%  (+6.4pp)</a:t>
+              <a:t>•  Chain-CE (v38) supervises truth-chain edge classes directly → chains survive</a:t>
             </a:r>
           </a:p>
         </p:txBody>
       </p:sp>
       <p:pic>
         <p:nvPicPr>
-          <p:cNvPr id="6" name="Picture 5" descr="NN_edges_2_roc.png"/>
+          <p:cNvPr id="6" name="Picture 5" descr="chain_lca_before_after.png"/>
           <p:cNvPicPr>
             <a:picLocks noChangeAspect="1"/>
           </p:cNvPicPr>
@@ -7814,14 +8404,49 @@
         </p:blipFill>
         <p:spPr>
           <a:xfrm>
-            <a:off x="6949440" y="1554480"/>
-            <a:ext cx="4754880" cy="3187931"/>
+            <a:off x="1097280" y="3429000"/>
+            <a:ext cx="9966960" cy="3458144"/>
           </a:xfrm>
           <a:prstGeom prst="rect">
             <a:avLst/>
           </a:prstGeom>
         </p:spPr>
       </p:pic>
+      <p:sp>
+        <p:nvSpPr>
+          <p:cNvPr id="7" name="TextBox 6"/>
+          <p:cNvSpPr txBox="1"/>
+          <p:nvPr/>
+        </p:nvSpPr>
+        <p:spPr>
+          <a:xfrm>
+            <a:off x="731520" y="6217920"/>
+            <a:ext cx="10789920" cy="365760"/>
+          </a:xfrm>
+          <a:prstGeom prst="rect">
+            <a:avLst/>
+          </a:prstGeom>
+          <a:noFill/>
+        </p:spPr>
+        <p:txBody>
+          <a:bodyPr wrap="square">
+            <a:spAutoFit/>
+          </a:bodyPr>
+          <a:lstStyle/>
+          <a:p>
+            <a:pPr algn="ctr"/>
+            <a:r>
+              <a:rPr sz="1200" i="1">
+                <a:solidFill>
+                  <a:srgbClr val="666666"/>
+                </a:solidFill>
+                <a:latin typeface="Calibri"/>
+              </a:rPr>
+              <a:t>Implication: chain survival depends on every structural edge being classified correctly — that is what the hinge + chain-CE provide</a:t>
+            </a:r>
+          </a:p>
+        </p:txBody>
+      </p:sp>
     </p:spTree>
   </p:cSld>
   <p:clrMapOvr>

</xml_diff>

<commit_message>
docs: reward theme for hinge/CE; text-left/plot-right layout with stacked plots
- S6/S7 reframed as "Reward 1: Confidence Bonus" (hinge) and "Reward 2:
  Correctness Bonus" (chain-CE); reward wording in figures and bullets
- All content slides now text-left / plot-right; two-plot slides stack
  top-right and bottom-right (hinge, CE, imbalance, before/after)
- Split every 2-panel figure into separate PNGs; removed the superseded
  combined figures
</commit_message>
<xml_diff>
--- a/meeting_figs/DFEI_progress_20260902_EN.pptx
+++ b/meeting_figs/DFEI_progress_20260902_EN.pptx
@@ -5670,8 +5670,8 @@
         </p:nvSpPr>
         <p:spPr>
           <a:xfrm>
-            <a:off x="731520" y="1371600"/>
-            <a:ext cx="10789920" cy="1828800"/>
+            <a:off x="640080" y="1463040"/>
+            <a:ext cx="5486400" cy="4206240"/>
           </a:xfrm>
           <a:prstGeom prst="rect">
             <a:avLst/>
@@ -5765,8 +5765,8 @@
         </p:blipFill>
         <p:spPr>
           <a:xfrm>
-            <a:off x="1097280" y="3108960"/>
-            <a:ext cx="9966960" cy="6047160"/>
+            <a:off x="6400800" y="2103120"/>
+            <a:ext cx="5394960" cy="3273233"/>
           </a:xfrm>
           <a:prstGeom prst="rect">
             <a:avLst/>
@@ -7165,8 +7165,8 @@
         </p:nvSpPr>
         <p:spPr>
           <a:xfrm>
-            <a:off x="731520" y="1234440"/>
-            <a:ext cx="10789920" cy="2194560"/>
+            <a:off x="640080" y="1371600"/>
+            <a:ext cx="5486400" cy="4754880"/>
           </a:xfrm>
           <a:prstGeom prst="rect">
             <a:avLst/>
@@ -7260,8 +7260,8 @@
         </p:blipFill>
         <p:spPr>
           <a:xfrm>
-            <a:off x="1554480" y="3474720"/>
-            <a:ext cx="9052560" cy="3944567"/>
+            <a:off x="6400800" y="2377440"/>
+            <a:ext cx="5394960" cy="2350803"/>
           </a:xfrm>
           <a:prstGeom prst="rect">
             <a:avLst/>
@@ -7384,7 +7384,7 @@
                 </a:solidFill>
                 <a:latin typeface="Calibri"/>
               </a:rPr>
-              <a:t>Fix 1 (v37): Hinge — Stay Confident</a:t>
+              <a:t>Reward 1 (v37): Hinge — Confidence Bonus</a:t>
             </a:r>
           </a:p>
           <a:p>
@@ -7395,7 +7395,7 @@
                 </a:solidFill>
                 <a:latin typeface="Calibri"/>
               </a:rPr>
-              <a:t>An extra loss that keeps chain edges confidently classified</a:t>
+              <a:t>A training-only reward that pays out when chain edges are confidently classified</a:t>
             </a:r>
           </a:p>
         </p:txBody>
@@ -7451,8 +7451,8 @@
         </p:nvSpPr>
         <p:spPr>
           <a:xfrm>
-            <a:off x="731520" y="1234440"/>
-            <a:ext cx="10789920" cy="2194560"/>
+            <a:off x="640080" y="1371600"/>
+            <a:ext cx="5486400" cy="4846320"/>
           </a:xfrm>
           <a:prstGeom prst="rect">
             <a:avLst/>
@@ -7477,7 +7477,7 @@
                 </a:solidFill>
                 <a:latin typeface="Calibri"/>
               </a:rPr>
-              <a:t>•  Confidence: per edge the LCAG head gives a 4-class softmax (p0…p3); confidence = max(pk)</a:t>
+              <a:t>•  It is a loss term that behaves like a reward: be confident on a chain edge → pay nothing</a:t>
             </a:r>
           </a:p>
           <a:p>
@@ -7493,7 +7493,7 @@
                 </a:solidFill>
                 <a:latin typeface="Calibri"/>
               </a:rPr>
-              <a:t>•  Loss = max(0, margin − confidence), margin 0.3 — added as an extra term to the total loss</a:t>
+              <a:t>•  Confidence comes from the LCAG head: per-edge 4-class softmax (p0…p3), confidence = max(pk)</a:t>
             </a:r>
           </a:p>
           <a:p>
@@ -7509,7 +7509,7 @@
                 </a:solidFill>
                 <a:latin typeface="Calibri"/>
               </a:rPr>
-              <a:t>•  Applied ONLY on truth-chain edges — the true chains are known from MC truth during training</a:t>
+              <a:t>•  Penalty = max(0, margin − confidence), margin 0.3 → zero once confidence ≥ 0.3</a:t>
             </a:r>
           </a:p>
           <a:p>
@@ -7525,7 +7525,7 @@
                 </a:solidFill>
                 <a:latin typeface="Calibri"/>
               </a:rPr>
-              <a:t>•  Role: chain edges give the global CE almost no gradient → the hinge makes sure they are at least confident</a:t>
+              <a:t>•  Paid ONLY on truth-chain edges — the true chains are known from MC truth during training</a:t>
             </a:r>
           </a:p>
           <a:p>
@@ -7541,14 +7541,14 @@
                 </a:solidFill>
                 <a:latin typeface="Calibri"/>
               </a:rPr>
-              <a:t>•  Limitation: it demands confidence, not the right class — CE (next slide) adds the "which class"</a:t>
+              <a:t>•  Role: chain edges give the global CE almost no gradient → hinge keeps them confident; CE (next) fixes "which class"</a:t>
             </a:r>
           </a:p>
         </p:txBody>
       </p:sp>
       <p:pic>
         <p:nvPicPr>
-          <p:cNvPr id="6" name="Picture 5" descr="chain_lca_hinge.png"/>
+          <p:cNvPr id="6" name="Picture 5" descr="chain_lca_hinge_mechanism.png"/>
           <p:cNvPicPr>
             <a:picLocks noChangeAspect="1"/>
           </p:cNvPicPr>
@@ -7562,17 +7562,41 @@
         </p:blipFill>
         <p:spPr>
           <a:xfrm>
-            <a:off x="822960" y="3429000"/>
-            <a:ext cx="10515600" cy="3861374"/>
+            <a:off x="6400800" y="1371600"/>
+            <a:ext cx="5394960" cy="2253674"/>
           </a:xfrm>
           <a:prstGeom prst="rect">
             <a:avLst/>
           </a:prstGeom>
         </p:spPr>
       </p:pic>
-      <p:sp>
-        <p:nvSpPr>
-          <p:cNvPr id="7" name="TextBox 6"/>
+      <p:pic>
+        <p:nvPicPr>
+          <p:cNvPr id="7" name="Picture 6" descr="chain_lca_hinge_curve.png"/>
+          <p:cNvPicPr>
+            <a:picLocks noChangeAspect="1"/>
+          </p:cNvPicPr>
+          <p:nvPr/>
+        </p:nvPicPr>
+        <p:blipFill>
+          <a:blip r:embed="rId3"/>
+          <a:stretch>
+            <a:fillRect/>
+          </a:stretch>
+        </p:blipFill>
+        <p:spPr>
+          <a:xfrm>
+            <a:off x="6400800" y="3794760"/>
+            <a:ext cx="5394960" cy="2255054"/>
+          </a:xfrm>
+          <a:prstGeom prst="rect">
+            <a:avLst/>
+          </a:prstGeom>
+        </p:spPr>
+      </p:pic>
+      <p:sp>
+        <p:nvSpPr>
+          <p:cNvPr id="8" name="TextBox 7"/>
           <p:cNvSpPr txBox="1"/>
           <p:nvPr/>
         </p:nvSpPr>
@@ -7600,7 +7624,7 @@
                 </a:solidFill>
                 <a:latin typeface="Calibri"/>
               </a:rPr>
-              <a:t>Implication: confidence here is max(pk) from the LCAG head — not the pruning weight w; the loss lives on truth-chain edges only</a:t>
+              <a:t>Implication: hinge is a training-only confidence bonus on chain edges — confidence = max(pk), not the pruning weight w</a:t>
             </a:r>
           </a:p>
         </p:txBody>
@@ -7686,7 +7710,7 @@
                 </a:solidFill>
                 <a:latin typeface="Calibri"/>
               </a:rPr>
-              <a:t>Fix 2 (v38): Chain Cross-Entropy</a:t>
+              <a:t>Reward 2 (v38): Chain-CE — Correctness Bonus</a:t>
             </a:r>
           </a:p>
           <a:p>
@@ -7697,7 +7721,7 @@
                 </a:solidFill>
                 <a:latin typeface="Calibri"/>
               </a:rPr>
-              <a:t>Be the RIGHT class — on chain edges only</a:t>
+              <a:t>A training-only reward for being the RIGHT class, on chain edges</a:t>
             </a:r>
           </a:p>
         </p:txBody>
@@ -7753,8 +7777,8 @@
         </p:nvSpPr>
         <p:spPr>
           <a:xfrm>
-            <a:off x="731520" y="1234440"/>
-            <a:ext cx="10789920" cy="2194560"/>
+            <a:off x="640080" y="1371600"/>
+            <a:ext cx="5486400" cy="4846320"/>
           </a:xfrm>
           <a:prstGeom prst="rect">
             <a:avLst/>
@@ -7795,7 +7819,7 @@
                 </a:solidFill>
                 <a:latin typeface="Calibri"/>
               </a:rPr>
-              <a:t>•  Confident and right (p_true → 1) → CE ≈ 0; unsure or wrong → CE large</a:t>
+              <a:t>•  Right and confident (p_true → 1) → penalty ≈ 0; unsure or wrong → penalty large</a:t>
             </a:r>
           </a:p>
           <a:p>
@@ -7811,7 +7835,7 @@
                 </a:solidFill>
                 <a:latin typeface="Calibri"/>
               </a:rPr>
-              <a:t>•  Chain-CE (v38): added ON TOP of the hinge, on truth-chain edges (classes 1/2/3) → direct, undiluted gradient</a:t>
+              <a:t>•  Chain-CE (v38): added ON TOP of the hinge, paid on truth-chain edges (classes 1/2/3) → direct, undiluted gradient</a:t>
             </a:r>
           </a:p>
           <a:p>
@@ -7850,7 +7874,7 @@
       </p:sp>
       <p:pic>
         <p:nvPicPr>
-          <p:cNvPr id="6" name="Picture 5" descr="chain_lca_ce.png"/>
+          <p:cNvPr id="6" name="Picture 5" descr="chain_lca_ce_curve.png"/>
           <p:cNvPicPr>
             <a:picLocks noChangeAspect="1"/>
           </p:cNvPicPr>
@@ -7864,17 +7888,41 @@
         </p:blipFill>
         <p:spPr>
           <a:xfrm>
-            <a:off x="822960" y="3429000"/>
-            <a:ext cx="10515600" cy="3896991"/>
+            <a:off x="6400800" y="1371600"/>
+            <a:ext cx="5394960" cy="2255054"/>
           </a:xfrm>
           <a:prstGeom prst="rect">
             <a:avLst/>
           </a:prstGeom>
         </p:spPr>
       </p:pic>
-      <p:sp>
-        <p:nvSpPr>
-          <p:cNvPr id="7" name="TextBox 6"/>
+      <p:pic>
+        <p:nvPicPr>
+          <p:cNvPr id="7" name="Picture 6" descr="chain_lca_ce_where.png"/>
+          <p:cNvPicPr>
+            <a:picLocks noChangeAspect="1"/>
+          </p:cNvPicPr>
+          <p:nvPr/>
+        </p:nvPicPr>
+        <p:blipFill>
+          <a:blip r:embed="rId3"/>
+          <a:stretch>
+            <a:fillRect/>
+          </a:stretch>
+        </p:blipFill>
+        <p:spPr>
+          <a:xfrm>
+            <a:off x="6400800" y="3794760"/>
+            <a:ext cx="5394960" cy="2253674"/>
+          </a:xfrm>
+          <a:prstGeom prst="rect">
+            <a:avLst/>
+          </a:prstGeom>
+        </p:spPr>
+      </p:pic>
+      <p:sp>
+        <p:nvSpPr>
+          <p:cNvPr id="8" name="TextBox 7"/>
           <p:cNvSpPr txBox="1"/>
           <p:nvPr/>
         </p:nvSpPr>
@@ -7902,7 +7950,7 @@
                 </a:solidFill>
                 <a:latin typeface="Calibri"/>
               </a:rPr>
-              <a:t>Implication: same loss function as the global CE — the fix is WHERE it is applied, not which loss</a:t>
+              <a:t>Implication: same function as the global CE — the reward is WHERE it is paid (chain edges only)</a:t>
             </a:r>
           </a:p>
         </p:txBody>
@@ -8055,8 +8103,8 @@
         </p:nvSpPr>
         <p:spPr>
           <a:xfrm>
-            <a:off x="731520" y="1234440"/>
-            <a:ext cx="10789920" cy="2103120"/>
+            <a:off x="640080" y="1554480"/>
+            <a:ext cx="5486400" cy="4206240"/>
           </a:xfrm>
           <a:prstGeom prst="rect">
             <a:avLst/>
@@ -8113,14 +8161,14 @@
                 </a:solidFill>
                 <a:latin typeface="Calibri"/>
               </a:rPr>
-              <a:t>•  Right panel: measured per-class accuracy — worst exactly on the rare structural classes</a:t>
+              <a:t>•  Per-class accuracy: worst exactly on the rare structural classes</a:t>
             </a:r>
           </a:p>
         </p:txBody>
       </p:sp>
       <p:pic>
         <p:nvPicPr>
-          <p:cNvPr id="6" name="Picture 5" descr="chain_lca_imbalance.png"/>
+          <p:cNvPr id="6" name="Picture 5" descr="chain_lca_imbalance_dist.png"/>
           <p:cNvPicPr>
             <a:picLocks noChangeAspect="1"/>
           </p:cNvPicPr>
@@ -8134,23 +8182,47 @@
         </p:blipFill>
         <p:spPr>
           <a:xfrm>
-            <a:off x="1097280" y="3429000"/>
-            <a:ext cx="9966960" cy="2712900"/>
+            <a:off x="6400800" y="1371600"/>
+            <a:ext cx="5394960" cy="2060254"/>
           </a:xfrm>
           <a:prstGeom prst="rect">
             <a:avLst/>
           </a:prstGeom>
         </p:spPr>
       </p:pic>
-      <p:sp>
-        <p:nvSpPr>
-          <p:cNvPr id="7" name="TextBox 6"/>
+      <p:pic>
+        <p:nvPicPr>
+          <p:cNvPr id="7" name="Picture 6" descr="chain_lca_imbalance_acc.png"/>
+          <p:cNvPicPr>
+            <a:picLocks noChangeAspect="1"/>
+          </p:cNvPicPr>
+          <p:nvPr/>
+        </p:nvPicPr>
+        <p:blipFill>
+          <a:blip r:embed="rId3"/>
+          <a:stretch>
+            <a:fillRect/>
+          </a:stretch>
+        </p:blipFill>
+        <p:spPr>
+          <a:xfrm>
+            <a:off x="6400800" y="3840480"/>
+            <a:ext cx="5394960" cy="2061516"/>
+          </a:xfrm>
+          <a:prstGeom prst="rect">
+            <a:avLst/>
+          </a:prstGeom>
+        </p:spPr>
+      </p:pic>
+      <p:sp>
+        <p:nvSpPr>
+          <p:cNvPr id="8" name="TextBox 7"/>
           <p:cNvSpPr txBox="1"/>
           <p:nvPr/>
         </p:nvSpPr>
         <p:spPr>
           <a:xfrm>
-            <a:off x="731520" y="6217920"/>
+            <a:off x="731520" y="6263640"/>
             <a:ext cx="10789920" cy="365760"/>
           </a:xfrm>
           <a:prstGeom prst="rect">
@@ -8325,8 +8397,8 @@
         </p:nvSpPr>
         <p:spPr>
           <a:xfrm>
-            <a:off x="731520" y="1234440"/>
-            <a:ext cx="10789920" cy="2103120"/>
+            <a:off x="640080" y="1554480"/>
+            <a:ext cx="5486400" cy="4206240"/>
           </a:xfrm>
           <a:prstGeom prst="rect">
             <a:avLst/>
@@ -8390,7 +8462,7 @@
       </p:sp>
       <p:pic>
         <p:nvPicPr>
-          <p:cNvPr id="6" name="Picture 5" descr="chain_lca_before_after.png"/>
+          <p:cNvPr id="6" name="Picture 5" descr="chain_lca_before.png"/>
           <p:cNvPicPr>
             <a:picLocks noChangeAspect="1"/>
           </p:cNvPicPr>
@@ -8404,23 +8476,47 @@
         </p:blipFill>
         <p:spPr>
           <a:xfrm>
-            <a:off x="1097280" y="3429000"/>
-            <a:ext cx="9966960" cy="3458144"/>
+            <a:off x="6400800" y="1371600"/>
+            <a:ext cx="5394960" cy="2253674"/>
           </a:xfrm>
           <a:prstGeom prst="rect">
             <a:avLst/>
           </a:prstGeom>
         </p:spPr>
       </p:pic>
-      <p:sp>
-        <p:nvSpPr>
-          <p:cNvPr id="7" name="TextBox 6"/>
+      <p:pic>
+        <p:nvPicPr>
+          <p:cNvPr id="7" name="Picture 6" descr="chain_lca_after.png"/>
+          <p:cNvPicPr>
+            <a:picLocks noChangeAspect="1"/>
+          </p:cNvPicPr>
+          <p:nvPr/>
+        </p:nvPicPr>
+        <p:blipFill>
+          <a:blip r:embed="rId3"/>
+          <a:stretch>
+            <a:fillRect/>
+          </a:stretch>
+        </p:blipFill>
+        <p:spPr>
+          <a:xfrm>
+            <a:off x="6400800" y="3794760"/>
+            <a:ext cx="5394960" cy="2253674"/>
+          </a:xfrm>
+          <a:prstGeom prst="rect">
+            <a:avLst/>
+          </a:prstGeom>
+        </p:spPr>
+      </p:pic>
+      <p:sp>
+        <p:nvSpPr>
+          <p:cNvPr id="8" name="TextBox 7"/>
           <p:cNvSpPr txBox="1"/>
           <p:nvPr/>
         </p:nvSpPr>
         <p:spPr>
           <a:xfrm>
-            <a:off x="731520" y="6217920"/>
+            <a:off x="731520" y="6263640"/>
             <a:ext cx="10789920" cy="365760"/>
           </a:xfrm>
           <a:prstGeom prst="rect">

</xml_diff>

<commit_message>
docs: split part 1 into pruning + rewarding; clarify later parts with plots
- Part 1 = Differentiable Pruning with Annealing; Part 2 = Rewarding the Chain
- "Why Chains Die" moved to the start of Part 2 (imbalance, one misclassified edge),
  then root cause (dilution), then hinge (v37), chain-CE (v38)
- New S10 "The Strategy Works": PerfectReco per version + per-class accuracy
  before/after the rewards (v31 -> v38)
- Later parts now figure-backed: head zoo (S11), mass ROC with caption (S12),
  struct/mom tree schematic (S13), probe R2 chart (S14), v48 gradient-balance
  chart (S15); Parts renumbered to 5, deck is 17 pages
</commit_message>
<xml_diff>
--- a/meeting_figs/DFEI_progress_20260902_EN.pptx
+++ b/meeting_figs/DFEI_progress_20260902_EN.pptx
@@ -21,6 +21,7 @@
     <p:sldId id="269" r:id="rId20"/>
     <p:sldId id="270" r:id="rId21"/>
     <p:sldId id="271" r:id="rId22"/>
+    <p:sldId id="272" r:id="rId23"/>
   </p:sldIdLst>
   <p:sldSz cx="12191695" cy="6858000" type="screen4x3"/>
   <p:notesSz cx="6858000" cy="9144000"/>
@@ -3320,7 +3321,7 @@
                 </a:solidFill>
                 <a:latin typeface="Calibri"/>
               </a:rPr>
-              <a:t>Part 2 — Supervising Representations with Physics</a:t>
+              <a:t>Part 2 — The Strategy Works</a:t>
             </a:r>
           </a:p>
           <a:p>
@@ -3331,7 +3332,7 @@
                 </a:solidFill>
                 <a:latin typeface="Calibri"/>
               </a:rPr>
-              <a:t>One common idea behind several heads</a:t>
+              <a:t>Rewards raise PerfectReco and per-class accuracy</a:t>
             </a:r>
           </a:p>
         </p:txBody>
@@ -3387,8 +3388,8 @@
         </p:nvSpPr>
         <p:spPr>
           <a:xfrm>
-            <a:off x="731520" y="1280160"/>
-            <a:ext cx="10789920" cy="4937760"/>
+            <a:off x="640080" y="1463040"/>
+            <a:ext cx="5486400" cy="4206240"/>
           </a:xfrm>
           <a:prstGeom prst="rect">
             <a:avLst/>
@@ -3413,7 +3414,7 @@
                 </a:solidFill>
                 <a:latin typeface="Calibri"/>
               </a:rPr>
-              <a:t>•  Idea: physical / structural quantities are data-intrinsic; supervise the representation with them, keeping the model end-to-end</a:t>
+              <a:t>•  Reward line builds on Part 1 (pruning, v36: 26.3%)</a:t>
             </a:r>
           </a:p>
           <a:p>
@@ -3423,13 +3424,13 @@
               </a:spcAft>
             </a:pPr>
             <a:r>
-              <a:rPr sz="2200">
+              <a:rPr sz="2000">
                 <a:solidFill>
                   <a:srgbClr val="333333"/>
                 </a:solidFill>
                 <a:latin typeface="Calibri"/>
               </a:rPr>
-              <a:t>•  Heads sharing this theme:</a:t>
+              <a:t>    –  hinge (v37): 26.3% → 27.3%</a:t>
             </a:r>
           </a:p>
           <a:p>
@@ -3445,7 +3446,7 @@
                 </a:solidFill>
                 <a:latin typeface="Calibri"/>
               </a:rPr>
-              <a:t>    –  source head (v36) — Rumor-Centrality root; early instance of the same idea</a:t>
+              <a:t>    –  chain-CE (v38): 27.3% → 29.3%</a:t>
             </a:r>
           </a:p>
           <a:p>
@@ -3455,13 +3456,13 @@
               </a:spcAft>
             </a:pPr>
             <a:r>
-              <a:rPr sz="2000">
+              <a:rPr sz="2200">
                 <a:solidFill>
                   <a:srgbClr val="333333"/>
                 </a:solidFill>
                 <a:latin typeface="Calibri"/>
               </a:rPr>
-              <a:t>    –  mass head — edge-level log10(m_ππ)</a:t>
+              <a:t>•  Per-class accuracy (v31 → v38): class1 67.8 → 76.8; class2 41.3 → 47.9</a:t>
             </a:r>
           </a:p>
           <a:p>
@@ -3471,45 +3472,72 @@
               </a:spcAft>
             </a:pPr>
             <a:r>
-              <a:rPr sz="2000">
+              <a:rPr sz="2200">
                 <a:solidFill>
                   <a:srgbClr val="333333"/>
                 </a:solidFill>
                 <a:latin typeface="Calibri"/>
               </a:rPr>
-              <a:t>    –  structure head — node depth + RC value</a:t>
-            </a:r>
-          </a:p>
-          <a:p>
-            <a:pPr>
-              <a:spcAft>
-                <a:spcPts val="1000"/>
-              </a:spcAft>
-            </a:pPr>
-            <a:r>
-              <a:rPr sz="2000">
-                <a:solidFill>
-                  <a:srgbClr val="333333"/>
-                </a:solidFill>
-                <a:latin typeface="Calibri"/>
-              </a:rPr>
-              <a:t>    –  momentum head — node normalized momentum</a:t>
-            </a:r>
-          </a:p>
-          <a:p>
-            <a:pPr>
-              <a:spcAft>
-                <a:spcPts val="1000"/>
-              </a:spcAft>
-            </a:pPr>
-            <a:r>
-              <a:rPr sz="2200">
-                <a:solidFill>
-                  <a:srgbClr val="333333"/>
-                </a:solidFill>
-                <a:latin typeface="Calibri"/>
-              </a:rPr>
-              <a:t>•  Verification: linear probes on the frozen backbone (Ridge regression)</a:t>
+              <a:t>•  Same evaluation: CERN MC, thr 0.9, 20 test files</a:t>
+            </a:r>
+          </a:p>
+        </p:txBody>
+      </p:sp>
+      <p:pic>
+        <p:nvPicPr>
+          <p:cNvPr id="6" name="Picture 5" descr="reward_results.png"/>
+          <p:cNvPicPr>
+            <a:picLocks noChangeAspect="1"/>
+          </p:cNvPicPr>
+          <p:nvPr/>
+        </p:nvPicPr>
+        <p:blipFill>
+          <a:blip r:embed="rId2"/>
+          <a:stretch>
+            <a:fillRect/>
+          </a:stretch>
+        </p:blipFill>
+        <p:spPr>
+          <a:xfrm>
+            <a:off x="6400800" y="2194560"/>
+            <a:ext cx="5394960" cy="1808967"/>
+          </a:xfrm>
+          <a:prstGeom prst="rect">
+            <a:avLst/>
+          </a:prstGeom>
+        </p:spPr>
+      </p:pic>
+      <p:sp>
+        <p:nvSpPr>
+          <p:cNvPr id="7" name="TextBox 6"/>
+          <p:cNvSpPr txBox="1"/>
+          <p:nvPr/>
+        </p:nvSpPr>
+        <p:spPr>
+          <a:xfrm>
+            <a:off x="731520" y="6263640"/>
+            <a:ext cx="10789920" cy="365760"/>
+          </a:xfrm>
+          <a:prstGeom prst="rect">
+            <a:avLst/>
+          </a:prstGeom>
+          <a:noFill/>
+        </p:spPr>
+        <p:txBody>
+          <a:bodyPr wrap="square">
+            <a:spAutoFit/>
+          </a:bodyPr>
+          <a:lstStyle/>
+          <a:p>
+            <a:pPr algn="ctr"/>
+            <a:r>
+              <a:rPr sz="1200" i="1">
+                <a:solidFill>
+                  <a:srgbClr val="666666"/>
+                </a:solidFill>
+                <a:latin typeface="Calibri"/>
+              </a:rPr>
+              <a:t>Implication: the rewards directly improve the structural classes the global CE ignores — chains survive more often</a:t>
             </a:r>
           </a:p>
         </p:txBody>
@@ -3595,7 +3623,7 @@
                 </a:solidFill>
                 <a:latin typeface="Calibri"/>
               </a:rPr>
-              <a:t>The Mass Head: Main Result</a:t>
+              <a:t>Part 3 — Supervising Representations with Physics</a:t>
             </a:r>
           </a:p>
           <a:p>
@@ -3606,7 +3634,7 @@
                 </a:solidFill>
                 <a:latin typeface="Calibri"/>
               </a:rPr>
-              <a:t>Edge-level regression of log10(m_ππ)</a:t>
+              <a:t>One common idea behind several heads</a:t>
             </a:r>
           </a:p>
         </p:txBody>
@@ -3662,8 +3690,8 @@
         </p:nvSpPr>
         <p:spPr>
           <a:xfrm>
-            <a:off x="731520" y="1188720"/>
-            <a:ext cx="6035040" cy="5120640"/>
+            <a:off x="640080" y="1371600"/>
+            <a:ext cx="5486400" cy="4937760"/>
           </a:xfrm>
           <a:prstGeom prst="rect">
             <a:avLst/>
@@ -3688,7 +3716,7 @@
                 </a:solidFill>
                 <a:latin typeface="Calibri"/>
               </a:rPr>
-              <a:t>•  Same-mother track pairs sit near resonance masses → the edge representation must encode sister relations</a:t>
+              <a:t>•  Idea: physical / structural quantities are data-intrinsic; supervise the representation with them, keeping the model end-to-end</a:t>
             </a:r>
           </a:p>
           <a:p>
@@ -3704,7 +3732,7 @@
                 </a:solidFill>
                 <a:latin typeface="Calibri"/>
               </a:rPr>
-              <a:t>•  Setup: SmoothL1 on log10(m_MeV), sentinel edges masked, weight 1.0</a:t>
+              <a:t>•  The head zoo: one shared backbone, many supervised targets</a:t>
             </a:r>
           </a:p>
           <a:p>
@@ -3714,13 +3742,13 @@
               </a:spcAft>
             </a:pPr>
             <a:r>
-              <a:rPr sz="2200">
+              <a:rPr sz="2000">
                 <a:solidFill>
                   <a:srgbClr val="333333"/>
                 </a:solidFill>
                 <a:latin typeface="Calibri"/>
               </a:rPr>
-              <a:t>•  v38 → masshead2 (20 test files):</a:t>
+              <a:t>    –  source head (v36) — Rumor-Centrality root; early instance of the same idea</a:t>
             </a:r>
           </a:p>
           <a:p>
@@ -3736,7 +3764,7 @@
                 </a:solidFill>
                 <a:latin typeface="Calibri"/>
               </a:rPr>
-              <a:t>    –  PerfectReco 29.3% → 32.7%  (+3.4pp)</a:t>
+              <a:t>    –  mass head — edge-level log10(m_ππ)</a:t>
             </a:r>
           </a:p>
           <a:p>
@@ -3752,7 +3780,7 @@
                 </a:solidFill>
                 <a:latin typeface="Calibri"/>
               </a:rPr>
-              <a:t>    –  AllParticles 52.1% → 55.9%  (+3.8pp)</a:t>
+              <a:t>    –  structure head — node depth + RC value</a:t>
             </a:r>
           </a:p>
           <a:p>
@@ -3768,14 +3796,30 @@
                 </a:solidFill>
                 <a:latin typeface="Calibri"/>
               </a:rPr>
-              <a:t>    –  LCAG class2 44.7% → 51.1%  (+6.4pp)</a:t>
+              <a:t>    –  momentum head — node normalized momentum</a:t>
+            </a:r>
+          </a:p>
+          <a:p>
+            <a:pPr>
+              <a:spcAft>
+                <a:spcPts val="1000"/>
+              </a:spcAft>
+            </a:pPr>
+            <a:r>
+              <a:rPr sz="2200">
+                <a:solidFill>
+                  <a:srgbClr val="333333"/>
+                </a:solidFill>
+                <a:latin typeface="Calibri"/>
+              </a:rPr>
+              <a:t>•  Verification: linear probes on the frozen backbone (Ridge regression)</a:t>
             </a:r>
           </a:p>
         </p:txBody>
       </p:sp>
       <p:pic>
         <p:nvPicPr>
-          <p:cNvPr id="6" name="Picture 5" descr="NN_edges_2_roc.png"/>
+          <p:cNvPr id="6" name="Picture 5" descr="head_zoo.png"/>
           <p:cNvPicPr>
             <a:picLocks noChangeAspect="1"/>
           </p:cNvPicPr>
@@ -3789,14 +3833,49 @@
         </p:blipFill>
         <p:spPr>
           <a:xfrm>
-            <a:off x="6949440" y="1554480"/>
-            <a:ext cx="4754880" cy="3187931"/>
+            <a:off x="6400800" y="2011680"/>
+            <a:ext cx="5394960" cy="2253674"/>
           </a:xfrm>
           <a:prstGeom prst="rect">
             <a:avLst/>
           </a:prstGeom>
         </p:spPr>
       </p:pic>
+      <p:sp>
+        <p:nvSpPr>
+          <p:cNvPr id="7" name="TextBox 6"/>
+          <p:cNvSpPr txBox="1"/>
+          <p:nvPr/>
+        </p:nvSpPr>
+        <p:spPr>
+          <a:xfrm>
+            <a:off x="731520" y="6263640"/>
+            <a:ext cx="10789920" cy="365760"/>
+          </a:xfrm>
+          <a:prstGeom prst="rect">
+            <a:avLst/>
+          </a:prstGeom>
+          <a:noFill/>
+        </p:spPr>
+        <p:txBody>
+          <a:bodyPr wrap="square">
+            <a:spAutoFit/>
+          </a:bodyPr>
+          <a:lstStyle/>
+          <a:p>
+            <a:pPr algn="ctr"/>
+            <a:r>
+              <a:rPr sz="1200" i="1">
+                <a:solidFill>
+                  <a:srgbClr val="666666"/>
+                </a:solidFill>
+                <a:latin typeface="Calibri"/>
+              </a:rPr>
+              <a:t>Implication: the backbone must represent the physics — the heads only tell it what to keep</a:t>
+            </a:r>
+          </a:p>
+        </p:txBody>
+      </p:sp>
     </p:spTree>
   </p:cSld>
   <p:clrMapOvr>
@@ -3878,7 +3957,7 @@
                 </a:solidFill>
                 <a:latin typeface="Calibri"/>
               </a:rPr>
-              <a:t>Structure and Momentum Heads</a:t>
+              <a:t>The Mass Head: Main Result</a:t>
             </a:r>
           </a:p>
           <a:p>
@@ -3889,7 +3968,7 @@
                 </a:solidFill>
                 <a:latin typeface="Calibri"/>
               </a:rPr>
-              <a:t>Node-level supervision of tree position and momentum</a:t>
+              <a:t>Edge-level regression of log10(m_ππ)</a:t>
             </a:r>
           </a:p>
         </p:txBody>
@@ -3937,6 +4016,359 @@
           </a:p>
         </p:txBody>
       </p:sp>
+      <p:sp>
+        <p:nvSpPr>
+          <p:cNvPr id="5" name="TextBox 4"/>
+          <p:cNvSpPr txBox="1"/>
+          <p:nvPr/>
+        </p:nvSpPr>
+        <p:spPr>
+          <a:xfrm>
+            <a:off x="640080" y="1371600"/>
+            <a:ext cx="5486400" cy="4846320"/>
+          </a:xfrm>
+          <a:prstGeom prst="rect">
+            <a:avLst/>
+          </a:prstGeom>
+          <a:noFill/>
+        </p:spPr>
+        <p:txBody>
+          <a:bodyPr wrap="square">
+            <a:spAutoFit/>
+          </a:bodyPr>
+          <a:lstStyle/>
+          <a:p>
+            <a:pPr>
+              <a:spcAft>
+                <a:spcPts val="1000"/>
+              </a:spcAft>
+            </a:pPr>
+            <a:r>
+              <a:rPr sz="2200">
+                <a:solidFill>
+                  <a:srgbClr val="333333"/>
+                </a:solidFill>
+                <a:latin typeface="Calibri"/>
+              </a:rPr>
+              <a:t>•  Same-mother track pairs sit near resonance masses → the edge representation must encode sister relations</a:t>
+            </a:r>
+          </a:p>
+          <a:p>
+            <a:pPr>
+              <a:spcAft>
+                <a:spcPts val="1000"/>
+              </a:spcAft>
+            </a:pPr>
+            <a:r>
+              <a:rPr sz="2200">
+                <a:solidFill>
+                  <a:srgbClr val="333333"/>
+                </a:solidFill>
+                <a:latin typeface="Calibri"/>
+              </a:rPr>
+              <a:t>•  Setup: SmoothL1 on log10(m_MeV), sentinel edges masked, weight 1.0</a:t>
+            </a:r>
+          </a:p>
+          <a:p>
+            <a:pPr>
+              <a:spcAft>
+                <a:spcPts val="1000"/>
+              </a:spcAft>
+            </a:pPr>
+            <a:r>
+              <a:rPr sz="2200">
+                <a:solidFill>
+                  <a:srgbClr val="333333"/>
+                </a:solidFill>
+                <a:latin typeface="Calibri"/>
+              </a:rPr>
+              <a:t>•  v38 → masshead2 (20 test files):</a:t>
+            </a:r>
+          </a:p>
+          <a:p>
+            <a:pPr>
+              <a:spcAft>
+                <a:spcPts val="1000"/>
+              </a:spcAft>
+            </a:pPr>
+            <a:r>
+              <a:rPr sz="2000">
+                <a:solidFill>
+                  <a:srgbClr val="333333"/>
+                </a:solidFill>
+                <a:latin typeface="Calibri"/>
+              </a:rPr>
+              <a:t>    –  PerfectReco 29.3% → 32.7%  (+3.4pp)</a:t>
+            </a:r>
+          </a:p>
+          <a:p>
+            <a:pPr>
+              <a:spcAft>
+                <a:spcPts val="1000"/>
+              </a:spcAft>
+            </a:pPr>
+            <a:r>
+              <a:rPr sz="2000">
+                <a:solidFill>
+                  <a:srgbClr val="333333"/>
+                </a:solidFill>
+                <a:latin typeface="Calibri"/>
+              </a:rPr>
+              <a:t>    –  AllParticles 52.1% → 55.9%  (+3.8pp)</a:t>
+            </a:r>
+          </a:p>
+          <a:p>
+            <a:pPr>
+              <a:spcAft>
+                <a:spcPts val="1000"/>
+              </a:spcAft>
+            </a:pPr>
+            <a:r>
+              <a:rPr sz="2000">
+                <a:solidFill>
+                  <a:srgbClr val="333333"/>
+                </a:solidFill>
+                <a:latin typeface="Calibri"/>
+              </a:rPr>
+              <a:t>    –  LCAG class2 44.7% → 51.1%  (+6.4pp)</a:t>
+            </a:r>
+          </a:p>
+        </p:txBody>
+      </p:sp>
+      <p:pic>
+        <p:nvPicPr>
+          <p:cNvPr id="6" name="Picture 5" descr="NN_edges_2_roc.png"/>
+          <p:cNvPicPr>
+            <a:picLocks noChangeAspect="1"/>
+          </p:cNvPicPr>
+          <p:nvPr/>
+        </p:nvPicPr>
+        <p:blipFill>
+          <a:blip r:embed="rId2"/>
+          <a:stretch>
+            <a:fillRect/>
+          </a:stretch>
+        </p:blipFill>
+        <p:spPr>
+          <a:xfrm>
+            <a:off x="6400800" y="1554480"/>
+            <a:ext cx="5394960" cy="3617075"/>
+          </a:xfrm>
+          <a:prstGeom prst="rect">
+            <a:avLst/>
+          </a:prstGeom>
+        </p:spPr>
+      </p:pic>
+      <p:sp>
+        <p:nvSpPr>
+          <p:cNvPr id="7" name="TextBox 6"/>
+          <p:cNvSpPr txBox="1"/>
+          <p:nvPr/>
+        </p:nvSpPr>
+        <p:spPr>
+          <a:xfrm>
+            <a:off x="6400800" y="5257800"/>
+            <a:ext cx="5394960" cy="822960"/>
+          </a:xfrm>
+          <a:prstGeom prst="rect">
+            <a:avLst/>
+          </a:prstGeom>
+          <a:noFill/>
+        </p:spPr>
+        <p:txBody>
+          <a:bodyPr wrap="square">
+            <a:spAutoFit/>
+          </a:bodyPr>
+          <a:lstStyle/>
+          <a:p>
+            <a:pPr algn="ctr"/>
+            <a:r>
+              <a:rPr sz="1200" i="0">
+                <a:solidFill>
+                  <a:srgbClr val="666666"/>
+                </a:solidFill>
+                <a:latin typeface="Calibri"/>
+              </a:rPr>
+              <a:t>ROC — LCAG class-2 (sister) edge detection, v47 masshead2, 20 test files. Mass supervision moves sister information into the edge representation.</a:t>
+            </a:r>
+          </a:p>
+        </p:txBody>
+      </p:sp>
+      <p:sp>
+        <p:nvSpPr>
+          <p:cNvPr id="8" name="TextBox 7"/>
+          <p:cNvSpPr txBox="1"/>
+          <p:nvPr/>
+        </p:nvSpPr>
+        <p:spPr>
+          <a:xfrm>
+            <a:off x="731520" y="6309360"/>
+            <a:ext cx="10789920" cy="365760"/>
+          </a:xfrm>
+          <a:prstGeom prst="rect">
+            <a:avLst/>
+          </a:prstGeom>
+          <a:noFill/>
+        </p:spPr>
+        <p:txBody>
+          <a:bodyPr wrap="square">
+            <a:spAutoFit/>
+          </a:bodyPr>
+          <a:lstStyle/>
+          <a:p>
+            <a:pPr algn="ctr"/>
+            <a:r>
+              <a:rPr sz="1200" i="1">
+                <a:solidFill>
+                  <a:srgbClr val="666666"/>
+                </a:solidFill>
+                <a:latin typeface="Calibri"/>
+              </a:rPr>
+              <a:t>Implication: supervising a physical target improved the hardest structural class — and the whole reconstruction</a:t>
+            </a:r>
+          </a:p>
+        </p:txBody>
+      </p:sp>
+    </p:spTree>
+  </p:cSld>
+  <p:clrMapOvr>
+    <a:masterClrMapping/>
+  </p:clrMapOvr>
+</p:sld>
+</file>
+
+<file path=ppt/slides/slide13.xml><?xml version="1.0" encoding="utf-8"?>
+<p:sld xmlns:a="http://schemas.openxmlformats.org/drawingml/2006/main" xmlns:p="http://schemas.openxmlformats.org/presentationml/2006/main" xmlns:r="http://schemas.openxmlformats.org/officeDocument/2006/relationships">
+  <p:cSld>
+    <p:spTree>
+      <p:nvGrpSpPr>
+        <p:cNvPr id="1" name=""/>
+        <p:cNvGrpSpPr/>
+        <p:nvPr/>
+      </p:nvGrpSpPr>
+      <p:grpSpPr/>
+      <p:sp>
+        <p:nvSpPr>
+          <p:cNvPr id="2" name="TextBox 1"/>
+          <p:cNvSpPr txBox="1"/>
+          <p:nvPr/>
+        </p:nvSpPr>
+        <p:spPr>
+          <a:xfrm>
+            <a:off x="502920" y="6510528"/>
+            <a:ext cx="11155680" cy="274320"/>
+          </a:xfrm>
+          <a:prstGeom prst="rect">
+            <a:avLst/>
+          </a:prstGeom>
+          <a:noFill/>
+        </p:spPr>
+        <p:txBody>
+          <a:bodyPr wrap="none">
+            <a:spAutoFit/>
+          </a:bodyPr>
+          <a:lstStyle/>
+          <a:p>
+            <a:r>
+              <a:rPr sz="1000">
+                <a:solidFill>
+                  <a:srgbClr val="666666"/>
+                </a:solidFill>
+                <a:latin typeface="Calibri"/>
+              </a:rPr>
+              <a:t>Qingxiang Guo · UCAS · DFEI group meeting      13</a:t>
+            </a:r>
+          </a:p>
+        </p:txBody>
+      </p:sp>
+      <p:sp>
+        <p:nvSpPr>
+          <p:cNvPr id="3" name="TextBox 2"/>
+          <p:cNvSpPr txBox="1"/>
+          <p:nvPr/>
+        </p:nvSpPr>
+        <p:spPr>
+          <a:xfrm>
+            <a:off x="502920" y="164592"/>
+            <a:ext cx="11155680" cy="914400"/>
+          </a:xfrm>
+          <a:prstGeom prst="rect">
+            <a:avLst/>
+          </a:prstGeom>
+          <a:noFill/>
+        </p:spPr>
+        <p:txBody>
+          <a:bodyPr wrap="square">
+            <a:spAutoFit/>
+          </a:bodyPr>
+          <a:lstStyle/>
+          <a:p>
+            <a:r>
+              <a:rPr sz="3800" b="1">
+                <a:solidFill>
+                  <a:srgbClr val="1F4E79"/>
+                </a:solidFill>
+                <a:latin typeface="Calibri"/>
+              </a:rPr>
+              <a:t>Structure and Momentum Heads</a:t>
+            </a:r>
+          </a:p>
+          <a:p>
+            <a:r>
+              <a:rPr sz="1700">
+                <a:solidFill>
+                  <a:srgbClr val="666666"/>
+                </a:solidFill>
+                <a:latin typeface="Calibri"/>
+              </a:rPr>
+              <a:t>Node-level supervision of tree position and momentum</a:t>
+            </a:r>
+          </a:p>
+        </p:txBody>
+      </p:sp>
+      <p:sp>
+        <p:nvSpPr>
+          <p:cNvPr id="4" name="Rectangle 3"/>
+          <p:cNvSpPr/>
+          <p:nvPr/>
+        </p:nvSpPr>
+        <p:spPr>
+          <a:xfrm>
+            <a:off x="548640" y="1188720"/>
+            <a:ext cx="11064240" cy="38100"/>
+          </a:xfrm>
+          <a:prstGeom prst="rect">
+            <a:avLst/>
+          </a:prstGeom>
+          <a:solidFill>
+            <a:srgbClr val="1F4E79"/>
+          </a:solidFill>
+          <a:ln>
+            <a:noFill/>
+          </a:ln>
+        </p:spPr>
+        <p:style>
+          <a:lnRef idx="1">
+            <a:schemeClr val="accent1"/>
+          </a:lnRef>
+          <a:fillRef idx="3">
+            <a:schemeClr val="accent1"/>
+          </a:fillRef>
+          <a:effectRef idx="2">
+            <a:schemeClr val="accent1"/>
+          </a:effectRef>
+          <a:fontRef idx="minor">
+            <a:schemeClr val="lt1"/>
+          </a:fontRef>
+        </p:style>
+        <p:txBody>
+          <a:bodyPr rtlCol="0" anchor="ctr"/>
+          <a:lstStyle/>
+          <a:p>
+            <a:pPr algn="ctr"/>
+          </a:p>
+        </p:txBody>
+      </p:sp>
       <p:graphicFrame>
         <p:nvGraphicFramePr>
           <p:cNvPr id="5" name="Table 4"/>
@@ -3946,8 +4378,8 @@
           <p:nvPr/>
         </p:nvGraphicFramePr>
         <p:xfrm>
-          <a:off x="731520" y="1371600"/>
-          <a:ext cx="10789920" cy="2560320"/>
+          <a:off x="640080" y="1371600"/>
+          <a:ext cx="5486400" cy="1737360"/>
         </p:xfrm>
         <a:graphic>
           <a:graphicData uri="http://schemas.openxmlformats.org/drawingml/2006/table">
@@ -3956,12 +4388,11 @@
                 <a:tableStyleId>{5C22544A-7EE6-4342-B048-85BDC9FD1C3A}</a:tableStyleId>
               </a:tblPr>
               <a:tblGrid>
-                <a:gridCol w="2697480"/>
-                <a:gridCol w="2697480"/>
-                <a:gridCol w="2697480"/>
-                <a:gridCol w="2697480"/>
+                <a:gridCol w="1828800"/>
+                <a:gridCol w="1828800"/>
+                <a:gridCol w="1828800"/>
               </a:tblGrid>
-              <a:tr h="640080">
+              <a:tr h="434340">
                 <a:tc>
                   <a:txBody>
                     <a:bodyPr/>
@@ -3969,7 +4400,7 @@
                     <a:p>
                       <a:pPr algn="ctr"/>
                       <a:r>
-                        <a:rPr sz="1800">
+                        <a:rPr sz="1500">
                           <a:solidFill>
                             <a:srgbClr val="FFFFFF"/>
                           </a:solidFill>
@@ -3992,7 +4423,7 @@
                     <a:p>
                       <a:pPr algn="ctr"/>
                       <a:r>
-                        <a:rPr sz="1800">
+                        <a:rPr sz="1500">
                           <a:solidFill>
                             <a:srgbClr val="FFFFFF"/>
                           </a:solidFill>
@@ -4015,36 +4446,13 @@
                     <a:p>
                       <a:pPr algn="ctr"/>
                       <a:r>
-                        <a:rPr sz="1800">
+                        <a:rPr sz="1500">
                           <a:solidFill>
                             <a:srgbClr val="FFFFFF"/>
                           </a:solidFill>
                           <a:latin typeface="Calibri"/>
                         </a:rPr>
-                        <a:t>Ablation (5-file eval)</a:t>
-                      </a:r>
-                    </a:p>
-                  </a:txBody>
-                  <a:tcPr marL="54864" marR="54864" marT="18288" marB="18288">
-                    <a:solidFill>
-                      <a:srgbClr val="1F4E79"/>
-                    </a:solidFill>
-                  </a:tcPr>
-                </a:tc>
-                <a:tc>
-                  <a:txBody>
-                    <a:bodyPr/>
-                    <a:lstStyle/>
-                    <a:p>
-                      <a:pPr algn="ctr"/>
-                      <a:r>
-                        <a:rPr sz="1800">
-                          <a:solidFill>
-                            <a:srgbClr val="FFFFFF"/>
-                          </a:solidFill>
-                          <a:latin typeface="Calibri"/>
-                        </a:rPr>
-                        <a:t>Notes</a:t>
+                        <a:t>All / Perfect (5-file eval)</a:t>
                       </a:r>
                     </a:p>
                   </a:txBody>
@@ -4055,7 +4463,7 @@
                   </a:tcPr>
                 </a:tc>
               </a:tr>
-              <a:tr h="640080">
+              <a:tr h="434340">
                 <a:tc>
                   <a:txBody>
                     <a:bodyPr/>
@@ -4063,7 +4471,7 @@
                     <a:p>
                       <a:pPr algn="l"/>
                       <a:r>
-                        <a:rPr sz="1800">
+                        <a:rPr sz="1500">
                           <a:solidFill>
                             <a:srgbClr val="333333"/>
                           </a:solidFill>
@@ -4082,7 +4490,7 @@
                     <a:p>
                       <a:pPr algn="l"/>
                       <a:r>
-                        <a:rPr sz="1800">
+                        <a:rPr sz="1500">
                           <a:solidFill>
                             <a:srgbClr val="333333"/>
                           </a:solidFill>
@@ -4101,30 +4509,20 @@
                     <a:p>
                       <a:pPr algn="l"/>
                       <a:r>
-                        <a:rPr sz="1800">
+                        <a:rPr sz="1500">
                           <a:solidFill>
                             <a:srgbClr val="333333"/>
                           </a:solidFill>
                           <a:latin typeface="Calibri"/>
                         </a:rPr>
-                        <a:t>All 51.4 / Perfect 29.7</a:t>
+                        <a:t>51.4 / 29.7</a:t>
                       </a:r>
                     </a:p>
                   </a:txBody>
                   <a:tcPr marL="54864" marR="54864" marT="18288" marB="18288"/>
                 </a:tc>
-                <a:tc>
-                  <a:txBody>
-                    <a:bodyPr/>
-                    <a:lstStyle/>
-                    <a:p>
-                      <a:pPr algn="l"/>
-                    </a:p>
-                  </a:txBody>
-                  <a:tcPr marL="54864" marR="54864" marT="18288" marB="18288"/>
-                </a:tc>
               </a:tr>
-              <a:tr h="640080">
+              <a:tr h="434340">
                 <a:tc>
                   <a:txBody>
                     <a:bodyPr/>
@@ -4132,7 +4530,7 @@
                     <a:p>
                       <a:pPr algn="l"/>
                       <a:r>
-                        <a:rPr sz="1800">
+                        <a:rPr sz="1500">
                           <a:solidFill>
                             <a:srgbClr val="333333"/>
                           </a:solidFill>
@@ -4155,7 +4553,7 @@
                     <a:p>
                       <a:pPr algn="l"/>
                       <a:r>
-                        <a:rPr sz="1800">
+                        <a:rPr sz="1500">
                           <a:solidFill>
                             <a:srgbClr val="333333"/>
                           </a:solidFill>
@@ -4178,36 +4576,13 @@
                     <a:p>
                       <a:pPr algn="l"/>
                       <a:r>
-                        <a:rPr sz="1800">
+                        <a:rPr sz="1500">
                           <a:solidFill>
                             <a:srgbClr val="333333"/>
                           </a:solidFill>
                           <a:latin typeface="Calibri"/>
                         </a:rPr>
-                        <a:t>All 54.5 (+3.1) / Perfect 30.5 (+0.8)</a:t>
-                      </a:r>
-                    </a:p>
-                  </a:txBody>
-                  <a:tcPr marL="54864" marR="54864" marT="18288" marB="18288">
-                    <a:solidFill>
-                      <a:srgbClr val="EAF2F8"/>
-                    </a:solidFill>
-                  </a:tcPr>
-                </a:tc>
-                <a:tc>
-                  <a:txBody>
-                    <a:bodyPr/>
-                    <a:lstStyle/>
-                    <a:p>
-                      <a:pPr algn="l"/>
-                      <a:r>
-                        <a:rPr sz="1800">
-                          <a:solidFill>
-                            <a:srgbClr val="333333"/>
-                          </a:solidFill>
-                          <a:latin typeface="Calibri"/>
-                        </a:rPr>
-                        <a:t>best single head</a:t>
+                        <a:t>54.5 / 30.5 (+0.8) — best</a:t>
                       </a:r>
                     </a:p>
                   </a:txBody>
@@ -4218,7 +4593,7 @@
                   </a:tcPr>
                 </a:tc>
               </a:tr>
-              <a:tr h="640080">
+              <a:tr h="434340">
                 <a:tc>
                   <a:txBody>
                     <a:bodyPr/>
@@ -4226,7 +4601,7 @@
                     <a:p>
                       <a:pPr algn="l"/>
                       <a:r>
-                        <a:rPr sz="1800">
+                        <a:rPr sz="1500">
                           <a:solidFill>
                             <a:srgbClr val="333333"/>
                           </a:solidFill>
@@ -4245,7 +4620,7 @@
                     <a:p>
                       <a:pPr algn="l"/>
                       <a:r>
-                        <a:rPr sz="1800">
+                        <a:rPr sz="1500">
                           <a:solidFill>
                             <a:srgbClr val="333333"/>
                           </a:solidFill>
@@ -4264,32 +4639,13 @@
                     <a:p>
                       <a:pPr algn="l"/>
                       <a:r>
-                        <a:rPr sz="1800">
+                        <a:rPr sz="1500">
                           <a:solidFill>
                             <a:srgbClr val="333333"/>
                           </a:solidFill>
                           <a:latin typeface="Calibri"/>
                         </a:rPr>
-                        <a:t>All 53.8 (+2.4) / Perfect 30.5 (+0.8)</a:t>
-                      </a:r>
-                    </a:p>
-                  </a:txBody>
-                  <a:tcPr marL="54864" marR="54864" marT="18288" marB="18288"/>
-                </a:tc>
-                <a:tc>
-                  <a:txBody>
-                    <a:bodyPr/>
-                    <a:lstStyle/>
-                    <a:p>
-                      <a:pPr algn="l"/>
-                      <a:r>
-                        <a:rPr sz="1800">
-                          <a:solidFill>
-                            <a:srgbClr val="333333"/>
-                          </a:solidFill>
-                          <a:latin typeface="Calibri"/>
-                        </a:rPr>
-                        <a:t>fixes node R²≈0</a:t>
+                        <a:t>53.8 / 30.5 (+0.8)</a:t>
                       </a:r>
                     </a:p>
                   </a:txBody>
@@ -4308,8 +4664,8 @@
         </p:nvSpPr>
         <p:spPr>
           <a:xfrm>
-            <a:off x="731520" y="4114800"/>
-            <a:ext cx="10789920" cy="2377440"/>
+            <a:off x="640080" y="3383280"/>
+            <a:ext cx="5486400" cy="2743200"/>
           </a:xfrm>
           <a:prstGeom prst="rect">
             <a:avLst/>
@@ -4334,7 +4690,7 @@
                 </a:solidFill>
                 <a:latin typeface="Calibri"/>
               </a:rPr>
-              <a:t>•  Struct: depth (BFS to chain centroid) + RC value — node position in the tree; class3 60.8→63.2</a:t>
+              <a:t>•  Struct: depth (BFS to chain centroid) + RC value — where the node sits in the tree (see right); class3 60.8→63.2</a:t>
             </a:r>
           </a:p>
           <a:p>
@@ -4371,68 +4727,40 @@
           </a:p>
         </p:txBody>
       </p:sp>
-    </p:spTree>
-  </p:cSld>
-  <p:clrMapOvr>
-    <a:masterClrMapping/>
-  </p:clrMapOvr>
-</p:sld>
-</file>
-
-<file path=ppt/slides/slide13.xml><?xml version="1.0" encoding="utf-8"?>
-<p:sld xmlns:a="http://schemas.openxmlformats.org/drawingml/2006/main" xmlns:p="http://schemas.openxmlformats.org/presentationml/2006/main" xmlns:r="http://schemas.openxmlformats.org/officeDocument/2006/relationships">
-  <p:cSld>
-    <p:spTree>
-      <p:nvGrpSpPr>
-        <p:cNvPr id="1" name=""/>
-        <p:cNvGrpSpPr/>
-        <p:nvPr/>
-      </p:nvGrpSpPr>
-      <p:grpSpPr/>
-      <p:sp>
-        <p:nvSpPr>
-          <p:cNvPr id="2" name="TextBox 1"/>
+      <p:pic>
+        <p:nvPicPr>
+          <p:cNvPr id="7" name="Picture 6" descr="struct_mom_tree.png"/>
+          <p:cNvPicPr>
+            <a:picLocks noChangeAspect="1"/>
+          </p:cNvPicPr>
+          <p:nvPr/>
+        </p:nvPicPr>
+        <p:blipFill>
+          <a:blip r:embed="rId2"/>
+          <a:stretch>
+            <a:fillRect/>
+          </a:stretch>
+        </p:blipFill>
+        <p:spPr>
+          <a:xfrm>
+            <a:off x="6400800" y="1828800"/>
+            <a:ext cx="5394960" cy="2253674"/>
+          </a:xfrm>
+          <a:prstGeom prst="rect">
+            <a:avLst/>
+          </a:prstGeom>
+        </p:spPr>
+      </p:pic>
+      <p:sp>
+        <p:nvSpPr>
+          <p:cNvPr id="8" name="TextBox 7"/>
           <p:cNvSpPr txBox="1"/>
           <p:nvPr/>
         </p:nvSpPr>
         <p:spPr>
           <a:xfrm>
-            <a:off x="502920" y="6510528"/>
-            <a:ext cx="11155680" cy="274320"/>
-          </a:xfrm>
-          <a:prstGeom prst="rect">
-            <a:avLst/>
-          </a:prstGeom>
-          <a:noFill/>
-        </p:spPr>
-        <p:txBody>
-          <a:bodyPr wrap="none">
-            <a:spAutoFit/>
-          </a:bodyPr>
-          <a:lstStyle/>
-          <a:p>
-            <a:r>
-              <a:rPr sz="1000">
-                <a:solidFill>
-                  <a:srgbClr val="666666"/>
-                </a:solidFill>
-                <a:latin typeface="Calibri"/>
-              </a:rPr>
-              <a:t>Qingxiang Guo · UCAS · DFEI group meeting      13</a:t>
-            </a:r>
-          </a:p>
-        </p:txBody>
-      </p:sp>
-      <p:sp>
-        <p:nvSpPr>
-          <p:cNvPr id="3" name="TextBox 2"/>
-          <p:cNvSpPr txBox="1"/>
-          <p:nvPr/>
-        </p:nvSpPr>
-        <p:spPr>
-          <a:xfrm>
-            <a:off x="502920" y="164592"/>
-            <a:ext cx="11155680" cy="914400"/>
+            <a:off x="731520" y="6263640"/>
+            <a:ext cx="10789920" cy="365760"/>
           </a:xfrm>
           <a:prstGeom prst="rect">
             <a:avLst/>
@@ -4445,351 +4773,15 @@
           </a:bodyPr>
           <a:lstStyle/>
           <a:p>
-            <a:r>
-              <a:rPr sz="3800" b="1">
-                <a:solidFill>
-                  <a:srgbClr val="1F4E79"/>
-                </a:solidFill>
-                <a:latin typeface="Calibri"/>
-              </a:rPr>
-              <a:t>Verification: Linear Probes on the Frozen Backbone</a:t>
-            </a:r>
-          </a:p>
-          <a:p>
-            <a:r>
-              <a:rPr sz="1700">
+            <a:pPr algn="ctr"/>
+            <a:r>
+              <a:rPr sz="1200" i="1">
                 <a:solidFill>
                   <a:srgbClr val="666666"/>
                 </a:solidFill>
                 <a:latin typeface="Calibri"/>
               </a:rPr>
-              <a:t>Ridge regression; R² of the physical quantity</a:t>
-            </a:r>
-          </a:p>
-        </p:txBody>
-      </p:sp>
-      <p:sp>
-        <p:nvSpPr>
-          <p:cNvPr id="4" name="Rectangle 3"/>
-          <p:cNvSpPr/>
-          <p:nvPr/>
-        </p:nvSpPr>
-        <p:spPr>
-          <a:xfrm>
-            <a:off x="548640" y="1188720"/>
-            <a:ext cx="11064240" cy="38100"/>
-          </a:xfrm>
-          <a:prstGeom prst="rect">
-            <a:avLst/>
-          </a:prstGeom>
-          <a:solidFill>
-            <a:srgbClr val="1F4E79"/>
-          </a:solidFill>
-          <a:ln>
-            <a:noFill/>
-          </a:ln>
-        </p:spPr>
-        <p:style>
-          <a:lnRef idx="1">
-            <a:schemeClr val="accent1"/>
-          </a:lnRef>
-          <a:fillRef idx="3">
-            <a:schemeClr val="accent1"/>
-          </a:fillRef>
-          <a:effectRef idx="2">
-            <a:schemeClr val="accent1"/>
-          </a:effectRef>
-          <a:fontRef idx="minor">
-            <a:schemeClr val="lt1"/>
-          </a:fontRef>
-        </p:style>
-        <p:txBody>
-          <a:bodyPr rtlCol="0" anchor="ctr"/>
-          <a:lstStyle/>
-          <a:p>
-            <a:pPr algn="ctr"/>
-          </a:p>
-        </p:txBody>
-      </p:sp>
-      <p:graphicFrame>
-        <p:nvGraphicFramePr>
-          <p:cNvPr id="5" name="Table 4"/>
-          <p:cNvGraphicFramePr>
-            <a:graphicFrameLocks noGrp="1"/>
-          </p:cNvGraphicFramePr>
-          <p:nvPr/>
-        </p:nvGraphicFramePr>
-        <p:xfrm>
-          <a:off x="731520" y="1371600"/>
-          <a:ext cx="7772400" cy="1645920"/>
-        </p:xfrm>
-        <a:graphic>
-          <a:graphicData uri="http://schemas.openxmlformats.org/drawingml/2006/table">
-            <a:tbl>
-              <a:tblPr firstRow="1" bandRow="1">
-                <a:tableStyleId>{5C22544A-7EE6-4342-B048-85BDC9FD1C3A}</a:tableStyleId>
-              </a:tblPr>
-              <a:tblGrid>
-                <a:gridCol w="2590800"/>
-                <a:gridCol w="2590800"/>
-                <a:gridCol w="2590800"/>
-              </a:tblGrid>
-              <a:tr h="548640">
-                <a:tc>
-                  <a:txBody>
-                    <a:bodyPr/>
-                    <a:lstStyle/>
-                    <a:p>
-                      <a:pPr algn="ctr"/>
-                      <a:r>
-                        <a:rPr sz="2000">
-                          <a:solidFill>
-                            <a:srgbClr val="FFFFFF"/>
-                          </a:solidFill>
-                          <a:latin typeface="Calibri"/>
-                        </a:rPr>
-                        <a:t>Probe</a:t>
-                      </a:r>
-                    </a:p>
-                  </a:txBody>
-                  <a:tcPr marL="54864" marR="54864" marT="18288" marB="18288">
-                    <a:solidFill>
-                      <a:srgbClr val="1F4E79"/>
-                    </a:solidFill>
-                  </a:tcPr>
-                </a:tc>
-                <a:tc>
-                  <a:txBody>
-                    <a:bodyPr/>
-                    <a:lstStyle/>
-                    <a:p>
-                      <a:pPr algn="ctr"/>
-                      <a:r>
-                        <a:rPr sz="2000">
-                          <a:solidFill>
-                            <a:srgbClr val="FFFFFF"/>
-                          </a:solidFill>
-                          <a:latin typeface="Calibri"/>
-                        </a:rPr>
-                        <a:t>v38</a:t>
-                      </a:r>
-                    </a:p>
-                  </a:txBody>
-                  <a:tcPr marL="54864" marR="54864" marT="18288" marB="18288">
-                    <a:solidFill>
-                      <a:srgbClr val="1F4E79"/>
-                    </a:solidFill>
-                  </a:tcPr>
-                </a:tc>
-                <a:tc>
-                  <a:txBody>
-                    <a:bodyPr/>
-                    <a:lstStyle/>
-                    <a:p>
-                      <a:pPr algn="ctr"/>
-                      <a:r>
-                        <a:rPr sz="2000">
-                          <a:solidFill>
-                            <a:srgbClr val="FFFFFF"/>
-                          </a:solidFill>
-                          <a:latin typeface="Calibri"/>
-                        </a:rPr>
-                        <a:t>masshead2</a:t>
-                      </a:r>
-                    </a:p>
-                  </a:txBody>
-                  <a:tcPr marL="54864" marR="54864" marT="18288" marB="18288">
-                    <a:solidFill>
-                      <a:srgbClr val="1F4E79"/>
-                    </a:solidFill>
-                  </a:tcPr>
-                </a:tc>
-              </a:tr>
-              <a:tr h="548640">
-                <a:tc>
-                  <a:txBody>
-                    <a:bodyPr/>
-                    <a:lstStyle/>
-                    <a:p>
-                      <a:pPr algn="l"/>
-                      <a:r>
-                        <a:rPr sz="2000">
-                          <a:solidFill>
-                            <a:srgbClr val="333333"/>
-                          </a:solidFill>
-                          <a:latin typeface="Calibri"/>
-                        </a:rPr>
-                        <a:t>edge repr → log10(m_ππ)</a:t>
-                      </a:r>
-                    </a:p>
-                  </a:txBody>
-                  <a:tcPr marL="54864" marR="54864" marT="18288" marB="18288"/>
-                </a:tc>
-                <a:tc>
-                  <a:txBody>
-                    <a:bodyPr/>
-                    <a:lstStyle/>
-                    <a:p>
-                      <a:pPr algn="l"/>
-                      <a:r>
-                        <a:rPr sz="2000">
-                          <a:solidFill>
-                            <a:srgbClr val="333333"/>
-                          </a:solidFill>
-                          <a:latin typeface="Calibri"/>
-                        </a:rPr>
-                        <a:t>R² = 0.003</a:t>
-                      </a:r>
-                    </a:p>
-                  </a:txBody>
-                  <a:tcPr marL="54864" marR="54864" marT="18288" marB="18288"/>
-                </a:tc>
-                <a:tc>
-                  <a:txBody>
-                    <a:bodyPr/>
-                    <a:lstStyle/>
-                    <a:p>
-                      <a:pPr algn="l"/>
-                      <a:r>
-                        <a:rPr sz="2000">
-                          <a:solidFill>
-                            <a:srgbClr val="333333"/>
-                          </a:solidFill>
-                          <a:latin typeface="Calibri"/>
-                        </a:rPr>
-                        <a:t>R² = 0.930</a:t>
-                      </a:r>
-                    </a:p>
-                  </a:txBody>
-                  <a:tcPr marL="54864" marR="54864" marT="18288" marB="18288"/>
-                </a:tc>
-              </a:tr>
-              <a:tr h="548640">
-                <a:tc>
-                  <a:txBody>
-                    <a:bodyPr/>
-                    <a:lstStyle/>
-                    <a:p>
-                      <a:pPr algn="l"/>
-                      <a:r>
-                        <a:rPr sz="2000">
-                          <a:solidFill>
-                            <a:srgbClr val="333333"/>
-                          </a:solidFill>
-                          <a:latin typeface="Calibri"/>
-                        </a:rPr>
-                        <a:t>node repr → p (px/py/pz)</a:t>
-                      </a:r>
-                    </a:p>
-                  </a:txBody>
-                  <a:tcPr marL="54864" marR="54864" marT="18288" marB="18288">
-                    <a:solidFill>
-                      <a:srgbClr val="EAF2F8"/>
-                    </a:solidFill>
-                  </a:tcPr>
-                </a:tc>
-                <a:tc>
-                  <a:txBody>
-                    <a:bodyPr/>
-                    <a:lstStyle/>
-                    <a:p>
-                      <a:pPr algn="l"/>
-                      <a:r>
-                        <a:rPr sz="2000">
-                          <a:solidFill>
-                            <a:srgbClr val="333333"/>
-                          </a:solidFill>
-                          <a:latin typeface="Calibri"/>
-                        </a:rPr>
-                        <a:t>R² ≈ 0</a:t>
-                      </a:r>
-                    </a:p>
-                  </a:txBody>
-                  <a:tcPr marL="54864" marR="54864" marT="18288" marB="18288">
-                    <a:solidFill>
-                      <a:srgbClr val="EAF2F8"/>
-                    </a:solidFill>
-                  </a:tcPr>
-                </a:tc>
-                <a:tc>
-                  <a:txBody>
-                    <a:bodyPr/>
-                    <a:lstStyle/>
-                    <a:p>
-                      <a:pPr algn="l"/>
-                      <a:r>
-                        <a:rPr sz="2000">
-                          <a:solidFill>
-                            <a:srgbClr val="333333"/>
-                          </a:solidFill>
-                          <a:latin typeface="Calibri"/>
-                        </a:rPr>
-                        <a:t>R² ≈ 0</a:t>
-                      </a:r>
-                    </a:p>
-                  </a:txBody>
-                  <a:tcPr marL="54864" marR="54864" marT="18288" marB="18288">
-                    <a:solidFill>
-                      <a:srgbClr val="EAF2F8"/>
-                    </a:solidFill>
-                  </a:tcPr>
-                </a:tc>
-              </a:tr>
-            </a:tbl>
-          </a:graphicData>
-        </a:graphic>
-      </p:graphicFrame>
-      <p:sp>
-        <p:nvSpPr>
-          <p:cNvPr id="6" name="TextBox 5"/>
-          <p:cNvSpPr txBox="1"/>
-          <p:nvPr/>
-        </p:nvSpPr>
-        <p:spPr>
-          <a:xfrm>
-            <a:off x="731520" y="3383280"/>
-            <a:ext cx="10789920" cy="2560320"/>
-          </a:xfrm>
-          <a:prstGeom prst="rect">
-            <a:avLst/>
-          </a:prstGeom>
-          <a:noFill/>
-        </p:spPr>
-        <p:txBody>
-          <a:bodyPr wrap="square">
-            <a:spAutoFit/>
-          </a:bodyPr>
-          <a:lstStyle/>
-          <a:p>
-            <a:pPr>
-              <a:spcAft>
-                <a:spcPts val="1000"/>
-              </a:spcAft>
-            </a:pPr>
-            <a:r>
-              <a:rPr sz="2200">
-                <a:solidFill>
-                  <a:srgbClr val="333333"/>
-                </a:solidFill>
-                <a:latin typeface="Calibri"/>
-              </a:rPr>
-              <a:t>•  Mass supervision moves mass information into the edge representation — confirmed end-to-end</a:t>
-            </a:r>
-          </a:p>
-          <a:p>
-            <a:pPr>
-              <a:spcAft>
-                <a:spcPts val="1000"/>
-              </a:spcAft>
-            </a:pPr>
-            <a:r>
-              <a:rPr sz="2200">
-                <a:solidFill>
-                  <a:srgbClr val="333333"/>
-                </a:solidFill>
-                <a:latin typeface="Calibri"/>
-              </a:rPr>
-              <a:t>•  Nodes remain unreadable for momentum → addressed by the momentum head (to be re-probed)</a:t>
+              <a:t>Implication: depth/RC label the node’s role in the tree — the struct head forces the node representation to encode it</a:t>
             </a:r>
           </a:p>
         </p:txBody>
@@ -4875,7 +4867,18 @@
                 </a:solidFill>
                 <a:latin typeface="Calibri"/>
               </a:rPr>
-              <a:t>Part 3 — Controlled Failures and Their Lessons</a:t>
+              <a:t>Verification: Linear Probes on the Frozen Backbone</a:t>
+            </a:r>
+          </a:p>
+          <a:p>
+            <a:r>
+              <a:rPr sz="1700">
+                <a:solidFill>
+                  <a:srgbClr val="666666"/>
+                </a:solidFill>
+                <a:latin typeface="Calibri"/>
+              </a:rPr>
+              <a:t>Ridge regression; R² of the physical quantity</a:t>
             </a:r>
           </a:p>
         </p:txBody>
@@ -4931,8 +4934,8 @@
         </p:nvSpPr>
         <p:spPr>
           <a:xfrm>
-            <a:off x="731520" y="1280160"/>
-            <a:ext cx="10789920" cy="4937760"/>
+            <a:off x="640080" y="1463040"/>
+            <a:ext cx="5486400" cy="4389120"/>
           </a:xfrm>
           <a:prstGeom prst="rect">
             <a:avLst/>
@@ -4957,7 +4960,7 @@
                 </a:solidFill>
                 <a:latin typeface="Calibri"/>
               </a:rPr>
-              <a:t>•  PV subgraph training (v39-42): training on per-PV subgraphs while inference runs on the full graph</a:t>
+              <a:t>•  Probe: fit a linear regressor on the frozen backbone — can the quantity be read off?</a:t>
             </a:r>
           </a:p>
           <a:p>
@@ -4967,13 +4970,13 @@
               </a:spcAft>
             </a:pPr>
             <a:r>
-              <a:rPr sz="2000">
+              <a:rPr sz="2200">
                 <a:solidFill>
                   <a:srgbClr val="333333"/>
                 </a:solidFill>
                 <a:latin typeface="Calibri"/>
               </a:rPr>
-              <a:t>    –  full-graph ability degraded: class1 76.8% → 56.4%; line closed</a:t>
+              <a:t>•  Edge repr → log10(m_ππ): R² 0.003 → 0.930 (masshead2)</a:t>
             </a:r>
           </a:p>
           <a:p>
@@ -4989,7 +4992,7 @@
                 </a:solidFill>
                 <a:latin typeface="Calibri"/>
               </a:rPr>
-              <a:t>•  Combined mass + struct + mom (v48): aux losses (0.877) exceed the main task (0.559)</a:t>
+              <a:t>•  Node repr → p (px/py/pz): R² ≈ 0 both before and after</a:t>
             </a:r>
           </a:p>
           <a:p>
@@ -4999,13 +5002,13 @@
               </a:spcAft>
             </a:pPr>
             <a:r>
-              <a:rPr sz="2000">
+              <a:rPr sz="2200">
                 <a:solidFill>
                   <a:srgbClr val="333333"/>
                 </a:solidFill>
                 <a:latin typeface="Calibri"/>
               </a:rPr>
-              <a:t>    –  reconstruction dropped 5pp although LCAG did not — backbone pulled toward auxiliary tasks</a:t>
+              <a:t>•  Mass supervision moves mass information into the edge representation — confirmed end-to-end</a:t>
             </a:r>
           </a:p>
           <a:p>
@@ -5015,29 +5018,72 @@
               </a:spcAft>
             </a:pPr>
             <a:r>
-              <a:rPr sz="2000">
+              <a:rPr sz="2200">
                 <a:solidFill>
                   <a:srgbClr val="333333"/>
                 </a:solidFill>
                 <a:latin typeface="Calibri"/>
               </a:rPr>
-              <a:t>    –  resolution: lower aux weights — mom 0.2, struct 0.3</a:t>
-            </a:r>
-          </a:p>
-          <a:p>
-            <a:pPr>
-              <a:spcAft>
-                <a:spcPts val="1000"/>
-              </a:spcAft>
-            </a:pPr>
-            <a:r>
-              <a:rPr sz="2200">
-                <a:solidFill>
-                  <a:srgbClr val="333333"/>
-                </a:solidFill>
-                <a:latin typeface="Calibri"/>
-              </a:rPr>
-              <a:t>•  Lessons: train/infer graph mismatch is fatal; gradient balance between heads must be explicit</a:t>
+              <a:t>•  Nodes remain unreadable for momentum → addressed by the momentum head (to be re-probed)</a:t>
+            </a:r>
+          </a:p>
+        </p:txBody>
+      </p:sp>
+      <p:pic>
+        <p:nvPicPr>
+          <p:cNvPr id="6" name="Picture 5" descr="probe_r2.png"/>
+          <p:cNvPicPr>
+            <a:picLocks noChangeAspect="1"/>
+          </p:cNvPicPr>
+          <p:nvPr/>
+        </p:nvPicPr>
+        <p:blipFill>
+          <a:blip r:embed="rId2"/>
+          <a:stretch>
+            <a:fillRect/>
+          </a:stretch>
+        </p:blipFill>
+        <p:spPr>
+          <a:xfrm>
+            <a:off x="6400800" y="2194560"/>
+            <a:ext cx="5394960" cy="2251752"/>
+          </a:xfrm>
+          <a:prstGeom prst="rect">
+            <a:avLst/>
+          </a:prstGeom>
+        </p:spPr>
+      </p:pic>
+      <p:sp>
+        <p:nvSpPr>
+          <p:cNvPr id="7" name="TextBox 6"/>
+          <p:cNvSpPr txBox="1"/>
+          <p:nvPr/>
+        </p:nvSpPr>
+        <p:spPr>
+          <a:xfrm>
+            <a:off x="731520" y="6263640"/>
+            <a:ext cx="10789920" cy="365760"/>
+          </a:xfrm>
+          <a:prstGeom prst="rect">
+            <a:avLst/>
+          </a:prstGeom>
+          <a:noFill/>
+        </p:spPr>
+        <p:txBody>
+          <a:bodyPr wrap="square">
+            <a:spAutoFit/>
+          </a:bodyPr>
+          <a:lstStyle/>
+          <a:p>
+            <a:pPr algn="ctr"/>
+            <a:r>
+              <a:rPr sz="1200" i="1">
+                <a:solidFill>
+                  <a:srgbClr val="666666"/>
+                </a:solidFill>
+                <a:latin typeface="Calibri"/>
+              </a:rPr>
+              <a:t>Implication: the probe is the check that supervision actually wrote the physics into the representation</a:t>
             </a:r>
           </a:p>
         </p:txBody>
@@ -5123,7 +5169,18 @@
                 </a:solidFill>
                 <a:latin typeface="Calibri"/>
               </a:rPr>
-              <a:t>Part 4 — Ongoing Attempts</a:t>
+              <a:t>Part 4 — Controlled Failures and Their Lessons</a:t>
+            </a:r>
+          </a:p>
+          <a:p>
+            <a:r>
+              <a:rPr sz="1700">
+                <a:solidFill>
+                  <a:srgbClr val="666666"/>
+                </a:solidFill>
+                <a:latin typeface="Calibri"/>
+              </a:rPr>
+              <a:t>Two failed lines, two lessons</a:t>
             </a:r>
           </a:p>
         </p:txBody>
@@ -5179,8 +5236,8 @@
         </p:nvSpPr>
         <p:spPr>
           <a:xfrm>
-            <a:off x="731520" y="1280160"/>
-            <a:ext cx="10789920" cy="5120640"/>
+            <a:off x="640080" y="1371600"/>
+            <a:ext cx="5486400" cy="4937760"/>
           </a:xfrm>
           <a:prstGeom prst="rect">
             <a:avLst/>
@@ -5205,7 +5262,7 @@
                 </a:solidFill>
                 <a:latin typeface="Calibri"/>
               </a:rPr>
-              <a:t>•  Wider latent space (v53): tracks nodes 32-dim, tt edges 24-dim — 16-dim sits at the physical-DOF lower bound</a:t>
+              <a:t>•  PV subgraph training (v39-42): training on per-PV subgraphs while inference runs on the full graph</a:t>
             </a:r>
           </a:p>
           <a:p>
@@ -5221,7 +5278,7 @@
                 </a:solidFill>
                 <a:latin typeface="Calibri"/>
               </a:rPr>
-              <a:t>    –  from-scratch training interrupted at ep74/150, not converged; resume planned</a:t>
+              <a:t>    –  full-graph ability degraded: class1 76.8% → 56.4%; line closed</a:t>
             </a:r>
           </a:p>
           <a:p>
@@ -5237,7 +5294,7 @@
                 </a:solidFill>
                 <a:latin typeface="Calibri"/>
               </a:rPr>
-              <a:t>•  Public-data verification (v45/v49): no PID, class2/3 counts differ 4-14×; resume best val 33.4 @ep73</a:t>
+              <a:t>•  Combined mass + struct + mom (v48): aux losses (0.877) exceed the main task (0.559)</a:t>
             </a:r>
           </a:p>
           <a:p>
@@ -5247,13 +5304,13 @@
               </a:spcAft>
             </a:pPr>
             <a:r>
-              <a:rPr sz="2200">
+              <a:rPr sz="2000">
                 <a:solidFill>
                   <a:srgbClr val="333333"/>
                 </a:solidFill>
                 <a:latin typeface="Calibri"/>
               </a:rPr>
-              <a:t>•  Learned deterministic annealing: inference-side PV clustering with learned affinity (no subgraph training); core module CPU-verified</a:t>
+              <a:t>    –  reconstruction dropped 5pp although LCAG did not — backbone pulled toward auxiliary tasks</a:t>
             </a:r>
           </a:p>
           <a:p>
@@ -5263,13 +5320,88 @@
               </a:spcAft>
             </a:pPr>
             <a:r>
+              <a:rPr sz="2000">
+                <a:solidFill>
+                  <a:srgbClr val="333333"/>
+                </a:solidFill>
+                <a:latin typeface="Calibri"/>
+              </a:rPr>
+              <a:t>    –  resolution: lower aux weights — mom 0.2, struct 0.3</a:t>
+            </a:r>
+          </a:p>
+          <a:p>
+            <a:pPr>
+              <a:spcAft>
+                <a:spcPts val="1000"/>
+              </a:spcAft>
+            </a:pPr>
+            <a:r>
               <a:rPr sz="2200">
                 <a:solidFill>
                   <a:srgbClr val="333333"/>
                 </a:solidFill>
                 <a:latin typeface="Calibri"/>
               </a:rPr>
-              <a:t>•  Chain scoring for trigger assistance: criteria AUC 0.90 / 0.78 (realistic); training ready, needs GPU</a:t>
+              <a:t>•  Lessons: train/infer graph mismatch is fatal; gradient balance must be explicit</a:t>
+            </a:r>
+          </a:p>
+        </p:txBody>
+      </p:sp>
+      <p:pic>
+        <p:nvPicPr>
+          <p:cNvPr id="6" name="Picture 5" descr="v48_failure.png"/>
+          <p:cNvPicPr>
+            <a:picLocks noChangeAspect="1"/>
+          </p:cNvPicPr>
+          <p:nvPr/>
+        </p:nvPicPr>
+        <p:blipFill>
+          <a:blip r:embed="rId2"/>
+          <a:stretch>
+            <a:fillRect/>
+          </a:stretch>
+        </p:blipFill>
+        <p:spPr>
+          <a:xfrm>
+            <a:off x="6400800" y="2011680"/>
+            <a:ext cx="5394960" cy="1807994"/>
+          </a:xfrm>
+          <a:prstGeom prst="rect">
+            <a:avLst/>
+          </a:prstGeom>
+        </p:spPr>
+      </p:pic>
+      <p:sp>
+        <p:nvSpPr>
+          <p:cNvPr id="7" name="TextBox 6"/>
+          <p:cNvSpPr txBox="1"/>
+          <p:nvPr/>
+        </p:nvSpPr>
+        <p:spPr>
+          <a:xfrm>
+            <a:off x="731520" y="6263640"/>
+            <a:ext cx="10789920" cy="365760"/>
+          </a:xfrm>
+          <a:prstGeom prst="rect">
+            <a:avLst/>
+          </a:prstGeom>
+          <a:noFill/>
+        </p:spPr>
+        <p:txBody>
+          <a:bodyPr wrap="square">
+            <a:spAutoFit/>
+          </a:bodyPr>
+          <a:lstStyle/>
+          <a:p>
+            <a:pPr algn="ctr"/>
+            <a:r>
+              <a:rPr sz="1200" i="1">
+                <a:solidFill>
+                  <a:srgbClr val="666666"/>
+                </a:solidFill>
+                <a:latin typeface="Calibri"/>
+              </a:rPr>
+              <a:t>Implication: the v48 failure shows why the head zoo needs explicit gradient balance — and why we ablate before stacking</a:t>
             </a:r>
           </a:p>
         </p:txBody>
@@ -5322,6 +5454,238 @@
                 <a:latin typeface="Calibri"/>
               </a:rPr>
               <a:t>Qingxiang Guo · UCAS · DFEI group meeting      16</a:t>
+            </a:r>
+          </a:p>
+        </p:txBody>
+      </p:sp>
+      <p:sp>
+        <p:nvSpPr>
+          <p:cNvPr id="3" name="TextBox 2"/>
+          <p:cNvSpPr txBox="1"/>
+          <p:nvPr/>
+        </p:nvSpPr>
+        <p:spPr>
+          <a:xfrm>
+            <a:off x="502920" y="164592"/>
+            <a:ext cx="11155680" cy="914400"/>
+          </a:xfrm>
+          <a:prstGeom prst="rect">
+            <a:avLst/>
+          </a:prstGeom>
+          <a:noFill/>
+        </p:spPr>
+        <p:txBody>
+          <a:bodyPr wrap="square">
+            <a:spAutoFit/>
+          </a:bodyPr>
+          <a:lstStyle/>
+          <a:p>
+            <a:r>
+              <a:rPr sz="3800" b="1">
+                <a:solidFill>
+                  <a:srgbClr val="1F4E79"/>
+                </a:solidFill>
+                <a:latin typeface="Calibri"/>
+              </a:rPr>
+              <a:t>Part 5 — Ongoing Attempts</a:t>
+            </a:r>
+          </a:p>
+        </p:txBody>
+      </p:sp>
+      <p:sp>
+        <p:nvSpPr>
+          <p:cNvPr id="4" name="Rectangle 3"/>
+          <p:cNvSpPr/>
+          <p:nvPr/>
+        </p:nvSpPr>
+        <p:spPr>
+          <a:xfrm>
+            <a:off x="548640" y="1188720"/>
+            <a:ext cx="11064240" cy="38100"/>
+          </a:xfrm>
+          <a:prstGeom prst="rect">
+            <a:avLst/>
+          </a:prstGeom>
+          <a:solidFill>
+            <a:srgbClr val="1F4E79"/>
+          </a:solidFill>
+          <a:ln>
+            <a:noFill/>
+          </a:ln>
+        </p:spPr>
+        <p:style>
+          <a:lnRef idx="1">
+            <a:schemeClr val="accent1"/>
+          </a:lnRef>
+          <a:fillRef idx="3">
+            <a:schemeClr val="accent1"/>
+          </a:fillRef>
+          <a:effectRef idx="2">
+            <a:schemeClr val="accent1"/>
+          </a:effectRef>
+          <a:fontRef idx="minor">
+            <a:schemeClr val="lt1"/>
+          </a:fontRef>
+        </p:style>
+        <p:txBody>
+          <a:bodyPr rtlCol="0" anchor="ctr"/>
+          <a:lstStyle/>
+          <a:p>
+            <a:pPr algn="ctr"/>
+          </a:p>
+        </p:txBody>
+      </p:sp>
+      <p:sp>
+        <p:nvSpPr>
+          <p:cNvPr id="5" name="TextBox 4"/>
+          <p:cNvSpPr txBox="1"/>
+          <p:nvPr/>
+        </p:nvSpPr>
+        <p:spPr>
+          <a:xfrm>
+            <a:off x="731520" y="1280160"/>
+            <a:ext cx="10789920" cy="5120640"/>
+          </a:xfrm>
+          <a:prstGeom prst="rect">
+            <a:avLst/>
+          </a:prstGeom>
+          <a:noFill/>
+        </p:spPr>
+        <p:txBody>
+          <a:bodyPr wrap="square">
+            <a:spAutoFit/>
+          </a:bodyPr>
+          <a:lstStyle/>
+          <a:p>
+            <a:pPr>
+              <a:spcAft>
+                <a:spcPts val="1000"/>
+              </a:spcAft>
+            </a:pPr>
+            <a:r>
+              <a:rPr sz="2200">
+                <a:solidFill>
+                  <a:srgbClr val="333333"/>
+                </a:solidFill>
+                <a:latin typeface="Calibri"/>
+              </a:rPr>
+              <a:t>•  Wider latent space (v53): tracks nodes 32-dim, tt edges 24-dim — 16-dim sits at the physical-DOF lower bound</a:t>
+            </a:r>
+          </a:p>
+          <a:p>
+            <a:pPr>
+              <a:spcAft>
+                <a:spcPts val="1000"/>
+              </a:spcAft>
+            </a:pPr>
+            <a:r>
+              <a:rPr sz="2000">
+                <a:solidFill>
+                  <a:srgbClr val="333333"/>
+                </a:solidFill>
+                <a:latin typeface="Calibri"/>
+              </a:rPr>
+              <a:t>    –  from-scratch training interrupted at ep74/150, not converged; resume planned</a:t>
+            </a:r>
+          </a:p>
+          <a:p>
+            <a:pPr>
+              <a:spcAft>
+                <a:spcPts val="1000"/>
+              </a:spcAft>
+            </a:pPr>
+            <a:r>
+              <a:rPr sz="2200">
+                <a:solidFill>
+                  <a:srgbClr val="333333"/>
+                </a:solidFill>
+                <a:latin typeface="Calibri"/>
+              </a:rPr>
+              <a:t>•  Public-data verification (v45/v49): no PID, class2/3 counts differ 4-14×; resume best val 33.4 @ep73</a:t>
+            </a:r>
+          </a:p>
+          <a:p>
+            <a:pPr>
+              <a:spcAft>
+                <a:spcPts val="1000"/>
+              </a:spcAft>
+            </a:pPr>
+            <a:r>
+              <a:rPr sz="2200">
+                <a:solidFill>
+                  <a:srgbClr val="333333"/>
+                </a:solidFill>
+                <a:latin typeface="Calibri"/>
+              </a:rPr>
+              <a:t>•  Learned deterministic annealing: inference-side PV clustering with learned affinity (no subgraph training); core module CPU-verified</a:t>
+            </a:r>
+          </a:p>
+          <a:p>
+            <a:pPr>
+              <a:spcAft>
+                <a:spcPts val="1000"/>
+              </a:spcAft>
+            </a:pPr>
+            <a:r>
+              <a:rPr sz="2200">
+                <a:solidFill>
+                  <a:srgbClr val="333333"/>
+                </a:solidFill>
+                <a:latin typeface="Calibri"/>
+              </a:rPr>
+              <a:t>•  Chain scoring for trigger assistance: criteria AUC 0.90 / 0.78 (realistic); training ready, needs GPU</a:t>
+            </a:r>
+          </a:p>
+        </p:txBody>
+      </p:sp>
+    </p:spTree>
+  </p:cSld>
+  <p:clrMapOvr>
+    <a:masterClrMapping/>
+  </p:clrMapOvr>
+</p:sld>
+</file>
+
+<file path=ppt/slides/slide17.xml><?xml version="1.0" encoding="utf-8"?>
+<p:sld xmlns:a="http://schemas.openxmlformats.org/drawingml/2006/main" xmlns:p="http://schemas.openxmlformats.org/presentationml/2006/main" xmlns:r="http://schemas.openxmlformats.org/officeDocument/2006/relationships">
+  <p:cSld>
+    <p:spTree>
+      <p:nvGrpSpPr>
+        <p:cNvPr id="1" name=""/>
+        <p:cNvGrpSpPr/>
+        <p:nvPr/>
+      </p:nvGrpSpPr>
+      <p:grpSpPr/>
+      <p:sp>
+        <p:nvSpPr>
+          <p:cNvPr id="2" name="TextBox 1"/>
+          <p:cNvSpPr txBox="1"/>
+          <p:nvPr/>
+        </p:nvSpPr>
+        <p:spPr>
+          <a:xfrm>
+            <a:off x="502920" y="6510528"/>
+            <a:ext cx="11155680" cy="274320"/>
+          </a:xfrm>
+          <a:prstGeom prst="rect">
+            <a:avLst/>
+          </a:prstGeom>
+          <a:noFill/>
+        </p:spPr>
+        <p:txBody>
+          <a:bodyPr wrap="none">
+            <a:spAutoFit/>
+          </a:bodyPr>
+          <a:lstStyle/>
+          <a:p>
+            <a:r>
+              <a:rPr sz="1000">
+                <a:solidFill>
+                  <a:srgbClr val="666666"/>
+                </a:solidFill>
+                <a:latin typeface="Calibri"/>
+              </a:rPr>
+              <a:t>Qingxiang Guo · UCAS · DFEI group meeting      17</a:t>
             </a:r>
           </a:p>
         </p:txBody>
@@ -5947,7 +6311,7 @@
                 </a:solidFill>
                 <a:latin typeface="Calibri"/>
               </a:rPr>
-              <a:t>•  Part 1 — Supervision and training–inference alignment</a:t>
+              <a:t>•  Part 1 — Differentiable Pruning with Annealing</a:t>
             </a:r>
           </a:p>
           <a:p>
@@ -5963,7 +6327,7 @@
                 </a:solidFill>
                 <a:latin typeface="Calibri"/>
               </a:rPr>
-              <a:t>    –  differentiable pruning with annealing · class-2 weighting · in-chain LCA consistency</a:t>
+              <a:t>    –  training–inference alignment: soft mask w_eff = w·σ((w−cut)/τ), τ annealed</a:t>
             </a:r>
           </a:p>
           <a:p>
@@ -5979,7 +6343,7 @@
                 </a:solidFill>
                 <a:latin typeface="Calibri"/>
               </a:rPr>
-              <a:t>•  Part 2 — Supervising representations with physics (source / mass / struct / mom heads)</a:t>
+              <a:t>•  Part 2 — Rewarding the Chain</a:t>
             </a:r>
           </a:p>
           <a:p>
@@ -5989,13 +6353,13 @@
               </a:spcAft>
             </a:pPr>
             <a:r>
-              <a:rPr sz="2400">
+              <a:rPr sz="2200">
                 <a:solidFill>
                   <a:srgbClr val="333333"/>
                 </a:solidFill>
                 <a:latin typeface="Calibri"/>
               </a:rPr>
-              <a:t>•  Part 3 — Controlled failures and their lessons</a:t>
+              <a:t>    –  why chains die · the rewards (hinge, chain-CE) · evidence it works</a:t>
             </a:r>
           </a:p>
           <a:p>
@@ -6011,7 +6375,39 @@
                 </a:solidFill>
                 <a:latin typeface="Calibri"/>
               </a:rPr>
-              <a:t>•  Part 4 — Ongoing attempts (wider latent space, and others)</a:t>
+              <a:t>•  Part 3 — Supervising Representations with Physics (source / mass / struct / mom)</a:t>
+            </a:r>
+          </a:p>
+          <a:p>
+            <a:pPr>
+              <a:spcAft>
+                <a:spcPts val="1000"/>
+              </a:spcAft>
+            </a:pPr>
+            <a:r>
+              <a:rPr sz="2400">
+                <a:solidFill>
+                  <a:srgbClr val="333333"/>
+                </a:solidFill>
+                <a:latin typeface="Calibri"/>
+              </a:rPr>
+              <a:t>•  Part 4 — Controlled Failures and Their Lessons</a:t>
+            </a:r>
+          </a:p>
+          <a:p>
+            <a:pPr>
+              <a:spcAft>
+                <a:spcPts val="1000"/>
+              </a:spcAft>
+            </a:pPr>
+            <a:r>
+              <a:rPr sz="2400">
+                <a:solidFill>
+                  <a:srgbClr val="333333"/>
+                </a:solidFill>
+                <a:latin typeface="Calibri"/>
+              </a:rPr>
+              <a:t>•  Part 5 — Ongoing Attempts</a:t>
             </a:r>
           </a:p>
         </p:txBody>
@@ -7098,7 +7494,7 @@
                 </a:solidFill>
                 <a:latin typeface="Calibri"/>
               </a:rPr>
-              <a:t>Part 1 — The Problem: Class-0 Dilution</a:t>
+              <a:t>Part 2 — Why Chains Die (1/2): The Class Imbalance</a:t>
             </a:r>
           </a:p>
           <a:p>
@@ -7109,7 +7505,7 @@
                 </a:solidFill>
                 <a:latin typeface="Calibri"/>
               </a:rPr>
-              <a:t>Why the standard classifier fails on chain structure</a:t>
+              <a:t>Structural edges are ~0.1% and the hardest to classify</a:t>
             </a:r>
           </a:p>
         </p:txBody>
@@ -7165,8 +7561,8 @@
         </p:nvSpPr>
         <p:spPr>
           <a:xfrm>
-            <a:off x="640080" y="1371600"/>
-            <a:ext cx="5486400" cy="4754880"/>
+            <a:off x="640080" y="1554480"/>
+            <a:ext cx="5486400" cy="4206240"/>
           </a:xfrm>
           <a:prstGeom prst="rect">
             <a:avLst/>
@@ -7191,7 +7587,7 @@
                 </a:solidFill>
                 <a:latin typeface="Calibri"/>
               </a:rPr>
-              <a:t>•  class 0 (background) is 99.9% of edges; structural classes 1/2/3 together are ~0.1%</a:t>
+              <a:t>•  class 0 (background) is 99.9% of edges; each structural class is ~0.04%</a:t>
             </a:r>
           </a:p>
           <a:p>
@@ -7207,7 +7603,7 @@
                 </a:solidFill>
                 <a:latin typeface="Calibri"/>
               </a:rPr>
-              <a:t>•  The main LCAG loss is a global cross-entropy over every edge → its gradient is ~99.9% "predict background"</a:t>
+              <a:t>•  The GNN is weakest exactly on the rarest classes — especially class 2 (sister)</a:t>
             </a:r>
           </a:p>
           <a:p>
@@ -7223,30 +7619,14 @@
                 </a:solidFill>
                 <a:latin typeface="Calibri"/>
               </a:rPr>
-              <a:t>•  Consequence: rare structural edges are undertrained → misclassified → chains break</a:t>
-            </a:r>
-          </a:p>
-          <a:p>
-            <a:pPr>
-              <a:spcAft>
-                <a:spcPts val="1000"/>
-              </a:spcAft>
-            </a:pPr>
-            <a:r>
-              <a:rPr sz="2200">
-                <a:solidFill>
-                  <a:srgbClr val="333333"/>
-                </a:solidFill>
-                <a:latin typeface="Calibri"/>
-              </a:rPr>
-              <a:t>•  Fixes in Part 1: class-2 weighting (3.0 → 2.0), then hinge (v37), then chain-CE (v38)</a:t>
+              <a:t>•  Per-class accuracy: worst exactly on the rare structural classes</a:t>
             </a:r>
           </a:p>
         </p:txBody>
       </p:sp>
       <p:pic>
         <p:nvPicPr>
-          <p:cNvPr id="6" name="Picture 5" descr="chain_lca_dilution.png"/>
+          <p:cNvPr id="6" name="Picture 5" descr="chain_lca_imbalance_dist.png"/>
           <p:cNvPicPr>
             <a:picLocks noChangeAspect="1"/>
           </p:cNvPicPr>
@@ -7260,17 +7640,41 @@
         </p:blipFill>
         <p:spPr>
           <a:xfrm>
-            <a:off x="6400800" y="2377440"/>
-            <a:ext cx="5394960" cy="2350803"/>
+            <a:off x="6400800" y="1371600"/>
+            <a:ext cx="5394960" cy="2060254"/>
           </a:xfrm>
           <a:prstGeom prst="rect">
             <a:avLst/>
           </a:prstGeom>
         </p:spPr>
       </p:pic>
-      <p:sp>
-        <p:nvSpPr>
-          <p:cNvPr id="7" name="TextBox 6"/>
+      <p:pic>
+        <p:nvPicPr>
+          <p:cNvPr id="7" name="Picture 6" descr="chain_lca_imbalance_acc.png"/>
+          <p:cNvPicPr>
+            <a:picLocks noChangeAspect="1"/>
+          </p:cNvPicPr>
+          <p:nvPr/>
+        </p:nvPicPr>
+        <p:blipFill>
+          <a:blip r:embed="rId3"/>
+          <a:stretch>
+            <a:fillRect/>
+          </a:stretch>
+        </p:blipFill>
+        <p:spPr>
+          <a:xfrm>
+            <a:off x="6400800" y="3840480"/>
+            <a:ext cx="5394960" cy="2061516"/>
+          </a:xfrm>
+          <a:prstGeom prst="rect">
+            <a:avLst/>
+          </a:prstGeom>
+        </p:spPr>
+      </p:pic>
+      <p:sp>
+        <p:nvSpPr>
+          <p:cNvPr id="8" name="TextBox 7"/>
           <p:cNvSpPr txBox="1"/>
           <p:nvPr/>
         </p:nvSpPr>
@@ -7298,7 +7702,7 @@
                 </a:solidFill>
                 <a:latin typeface="Calibri"/>
               </a:rPr>
-              <a:t>Implication: with ~1000 background edges per structural edge, the global CE alone cannot teach the model classes 1/2/3</a:t>
+              <a:t>Implication: without extra supervision, the classifier barely learns classes 1/2/3 — the rewards exist to fix this</a:t>
             </a:r>
           </a:p>
         </p:txBody>
@@ -7384,7 +7788,7 @@
                 </a:solidFill>
                 <a:latin typeface="Calibri"/>
               </a:rPr>
-              <a:t>Reward 1 (v37): Hinge — Confidence Bonus</a:t>
+              <a:t>Part 2 — Why Chains Die (2/2): One Misclassified Edge</a:t>
             </a:r>
           </a:p>
           <a:p>
@@ -7395,7 +7799,7 @@
                 </a:solidFill>
                 <a:latin typeface="Calibri"/>
               </a:rPr>
-              <a:t>A training-only reward that pays out when chain edges are confidently classified</a:t>
+              <a:t>Chain survival needs every structural edge correct</a:t>
             </a:r>
           </a:p>
         </p:txBody>
@@ -7451,8 +7855,8 @@
         </p:nvSpPr>
         <p:spPr>
           <a:xfrm>
-            <a:off x="640080" y="1371600"/>
-            <a:ext cx="5486400" cy="4846320"/>
+            <a:off x="640080" y="1554480"/>
+            <a:ext cx="5486400" cy="4206240"/>
           </a:xfrm>
           <a:prstGeom prst="rect">
             <a:avLst/>
@@ -7477,7 +7881,7 @@
                 </a:solidFill>
                 <a:latin typeface="Calibri"/>
               </a:rPr>
-              <a:t>•  It is a loss term that behaves like a reward: be confident on a chain edge → pay nothing</a:t>
+              <a:t>•  At inference, an edge the classifier calls class 0 is pruned</a:t>
             </a:r>
           </a:p>
           <a:p>
@@ -7493,7 +7897,7 @@
                 </a:solidFill>
                 <a:latin typeface="Calibri"/>
               </a:rPr>
-              <a:t>•  Confidence comes from the LCAG head: per-edge 4-class softmax (p0…p3), confidence = max(pk)</a:t>
+              <a:t>•  If ANY structural edge of a chain is misclassified, the whole chain dies</a:t>
             </a:r>
           </a:p>
           <a:p>
@@ -7509,46 +7913,14 @@
                 </a:solidFill>
                 <a:latin typeface="Calibri"/>
               </a:rPr>
-              <a:t>•  Penalty = max(0, margin − confidence), margin 0.3 → zero once confidence ≥ 0.3</a:t>
-            </a:r>
-          </a:p>
-          <a:p>
-            <a:pPr>
-              <a:spcAft>
-                <a:spcPts val="1000"/>
-              </a:spcAft>
-            </a:pPr>
-            <a:r>
-              <a:rPr sz="2200">
-                <a:solidFill>
-                  <a:srgbClr val="333333"/>
-                </a:solidFill>
-                <a:latin typeface="Calibri"/>
-              </a:rPr>
-              <a:t>•  Paid ONLY on truth-chain edges — the true chains are known from MC truth during training</a:t>
-            </a:r>
-          </a:p>
-          <a:p>
-            <a:pPr>
-              <a:spcAft>
-                <a:spcPts val="1000"/>
-              </a:spcAft>
-            </a:pPr>
-            <a:r>
-              <a:rPr sz="2200">
-                <a:solidFill>
-                  <a:srgbClr val="333333"/>
-                </a:solidFill>
-                <a:latin typeface="Calibri"/>
-              </a:rPr>
-              <a:t>•  Role: chain edges give the global CE almost no gradient → hinge keeps them confident; CE (next) fixes "which class"</a:t>
+              <a:t>•  The rewards (next slides) supervise truth-chain edge classes directly → chains survive</a:t>
             </a:r>
           </a:p>
         </p:txBody>
       </p:sp>
       <p:pic>
         <p:nvPicPr>
-          <p:cNvPr id="6" name="Picture 5" descr="chain_lca_hinge_mechanism.png"/>
+          <p:cNvPr id="6" name="Picture 5" descr="chain_lca_before.png"/>
           <p:cNvPicPr>
             <a:picLocks noChangeAspect="1"/>
           </p:cNvPicPr>
@@ -7572,7 +7944,7 @@
       </p:pic>
       <p:pic>
         <p:nvPicPr>
-          <p:cNvPr id="7" name="Picture 6" descr="chain_lca_hinge_curve.png"/>
+          <p:cNvPr id="7" name="Picture 6" descr="chain_lca_after.png"/>
           <p:cNvPicPr>
             <a:picLocks noChangeAspect="1"/>
           </p:cNvPicPr>
@@ -7587,7 +7959,7 @@
         <p:spPr>
           <a:xfrm>
             <a:off x="6400800" y="3794760"/>
-            <a:ext cx="5394960" cy="2255054"/>
+            <a:ext cx="5394960" cy="2253674"/>
           </a:xfrm>
           <a:prstGeom prst="rect">
             <a:avLst/>
@@ -7602,7 +7974,7 @@
         </p:nvSpPr>
         <p:spPr>
           <a:xfrm>
-            <a:off x="731520" y="6309360"/>
+            <a:off x="731520" y="6263640"/>
             <a:ext cx="10789920" cy="365760"/>
           </a:xfrm>
           <a:prstGeom prst="rect">
@@ -7624,7 +7996,7 @@
                 </a:solidFill>
                 <a:latin typeface="Calibri"/>
               </a:rPr>
-              <a:t>Implication: hinge is a training-only confidence bonus on chain edges — confidence = max(pk), not the pruning weight w</a:t>
+              <a:t>Implication: chain survival depends on every structural edge being classified correctly</a:t>
             </a:r>
           </a:p>
         </p:txBody>
@@ -7710,7 +8082,7 @@
                 </a:solidFill>
                 <a:latin typeface="Calibri"/>
               </a:rPr>
-              <a:t>Reward 2 (v38): Chain-CE — Correctness Bonus</a:t>
+              <a:t>Part 2 — The Root Cause: Class-0 Dilution</a:t>
             </a:r>
           </a:p>
           <a:p>
@@ -7721,7 +8093,7 @@
                 </a:solidFill>
                 <a:latin typeface="Calibri"/>
               </a:rPr>
-              <a:t>A training-only reward for being the RIGHT class, on chain edges</a:t>
+              <a:t>Why the standard classifier fails on chain structure</a:t>
             </a:r>
           </a:p>
         </p:txBody>
@@ -7778,7 +8150,7 @@
         <p:spPr>
           <a:xfrm>
             <a:off x="640080" y="1371600"/>
-            <a:ext cx="5486400" cy="4846320"/>
+            <a:ext cx="5486400" cy="4754880"/>
           </a:xfrm>
           <a:prstGeom prst="rect">
             <a:avLst/>
@@ -7803,7 +8175,7 @@
                 </a:solidFill>
                 <a:latin typeface="Calibri"/>
               </a:rPr>
-              <a:t>•  CE = −log(p_true): p_true is the probability the model assigns to the edge’s TRUE class</a:t>
+              <a:t>•  class 0 (background) is 99.9% of edges; structural classes 1/2/3 together are ~0.1%</a:t>
             </a:r>
           </a:p>
           <a:p>
@@ -7819,7 +8191,7 @@
                 </a:solidFill>
                 <a:latin typeface="Calibri"/>
               </a:rPr>
-              <a:t>•  Right and confident (p_true → 1) → penalty ≈ 0; unsure or wrong → penalty large</a:t>
+              <a:t>•  The main LCAG loss is a global cross-entropy over every edge → its gradient is ~99.9% "predict background"</a:t>
             </a:r>
           </a:p>
           <a:p>
@@ -7835,7 +8207,7 @@
                 </a:solidFill>
                 <a:latin typeface="Calibri"/>
               </a:rPr>
-              <a:t>•  Chain-CE (v38): added ON TOP of the hinge, paid on truth-chain edges (classes 1/2/3) → direct, undiluted gradient</a:t>
+              <a:t>•  Consequence: rare structural edges are undertrained → misclassified → chains break</a:t>
             </a:r>
           </a:p>
           <a:p>
@@ -7851,30 +8223,14 @@
                 </a:solidFill>
                 <a:latin typeface="Calibri"/>
               </a:rPr>
-              <a:t>•  v37 → v38 (weight 2.0 + chain-CE + cut 0.85): PerfectReco 27.3% → 29.3%</a:t>
-            </a:r>
-          </a:p>
-          <a:p>
-            <a:pPr>
-              <a:spcAft>
-                <a:spcPts val="1000"/>
-              </a:spcAft>
-            </a:pPr>
-            <a:r>
-              <a:rPr sz="2200">
-                <a:solidFill>
-                  <a:srgbClr val="333333"/>
-                </a:solidFill>
-                <a:latin typeface="Calibri"/>
-              </a:rPr>
-              <a:t>•  Net effect of Part 1 (v31 → v38): 23.9% → 29.3%</a:t>
+              <a:t>•  The fix: reward the chain — class-2 weighting (3.0 → 2.0), then hinge (v37), then chain-CE (v38)</a:t>
             </a:r>
           </a:p>
         </p:txBody>
       </p:sp>
       <p:pic>
         <p:nvPicPr>
-          <p:cNvPr id="6" name="Picture 5" descr="chain_lca_ce_curve.png"/>
+          <p:cNvPr id="6" name="Picture 5" descr="chain_lca_dilution.png"/>
           <p:cNvPicPr>
             <a:picLocks noChangeAspect="1"/>
           </p:cNvPicPr>
@@ -7888,47 +8244,23 @@
         </p:blipFill>
         <p:spPr>
           <a:xfrm>
-            <a:off x="6400800" y="1371600"/>
-            <a:ext cx="5394960" cy="2255054"/>
+            <a:off x="6400800" y="2377440"/>
+            <a:ext cx="5394960" cy="2350803"/>
           </a:xfrm>
           <a:prstGeom prst="rect">
             <a:avLst/>
           </a:prstGeom>
         </p:spPr>
       </p:pic>
-      <p:pic>
-        <p:nvPicPr>
-          <p:cNvPr id="7" name="Picture 6" descr="chain_lca_ce_where.png"/>
-          <p:cNvPicPr>
-            <a:picLocks noChangeAspect="1"/>
-          </p:cNvPicPr>
-          <p:nvPr/>
-        </p:nvPicPr>
-        <p:blipFill>
-          <a:blip r:embed="rId3"/>
-          <a:stretch>
-            <a:fillRect/>
-          </a:stretch>
-        </p:blipFill>
-        <p:spPr>
-          <a:xfrm>
-            <a:off x="6400800" y="3794760"/>
-            <a:ext cx="5394960" cy="2253674"/>
-          </a:xfrm>
-          <a:prstGeom prst="rect">
-            <a:avLst/>
-          </a:prstGeom>
-        </p:spPr>
-      </p:pic>
-      <p:sp>
-        <p:nvSpPr>
-          <p:cNvPr id="8" name="TextBox 7"/>
+      <p:sp>
+        <p:nvSpPr>
+          <p:cNvPr id="7" name="TextBox 6"/>
           <p:cNvSpPr txBox="1"/>
           <p:nvPr/>
         </p:nvSpPr>
         <p:spPr>
           <a:xfrm>
-            <a:off x="731520" y="6309360"/>
+            <a:off x="731520" y="6263640"/>
             <a:ext cx="10789920" cy="365760"/>
           </a:xfrm>
           <a:prstGeom prst="rect">
@@ -7950,7 +8282,7 @@
                 </a:solidFill>
                 <a:latin typeface="Calibri"/>
               </a:rPr>
-              <a:t>Implication: same function as the global CE — the reward is WHERE it is paid (chain edges only)</a:t>
+              <a:t>Implication: with ~1000 background edges per structural edge, the global CE alone cannot teach the model classes 1/2/3</a:t>
             </a:r>
           </a:p>
         </p:txBody>
@@ -8036,7 +8368,7 @@
                 </a:solidFill>
                 <a:latin typeface="Calibri"/>
               </a:rPr>
-              <a:t>Why Chains Die (1/2): The Class Imbalance</a:t>
+              <a:t>Reward 1 (v37): Hinge — Confidence Bonus</a:t>
             </a:r>
           </a:p>
           <a:p>
@@ -8047,7 +8379,7 @@
                 </a:solidFill>
                 <a:latin typeface="Calibri"/>
               </a:rPr>
-              <a:t>Structural edges are ~0.1% and the hardest to classify</a:t>
+              <a:t>A training-only reward that pays out when chain edges are confidently classified</a:t>
             </a:r>
           </a:p>
         </p:txBody>
@@ -8103,8 +8435,8 @@
         </p:nvSpPr>
         <p:spPr>
           <a:xfrm>
-            <a:off x="640080" y="1554480"/>
-            <a:ext cx="5486400" cy="4206240"/>
+            <a:off x="640080" y="1371600"/>
+            <a:ext cx="5486400" cy="4846320"/>
           </a:xfrm>
           <a:prstGeom prst="rect">
             <a:avLst/>
@@ -8129,7 +8461,7 @@
                 </a:solidFill>
                 <a:latin typeface="Calibri"/>
               </a:rPr>
-              <a:t>•  class 0 (background) is 99.9% of edges; each structural class is ~0.04%</a:t>
+              <a:t>•  It is a loss term that behaves like a reward: be confident on a chain edge → pay nothing</a:t>
             </a:r>
           </a:p>
           <a:p>
@@ -8145,7 +8477,7 @@
                 </a:solidFill>
                 <a:latin typeface="Calibri"/>
               </a:rPr>
-              <a:t>•  The GNN is weakest exactly on the rarest classes — especially class 2 (sister)</a:t>
+              <a:t>•  Confidence comes from the LCAG head: per-edge 4-class softmax (p0…p3), confidence = max(pk)</a:t>
             </a:r>
           </a:p>
           <a:p>
@@ -8161,14 +8493,46 @@
                 </a:solidFill>
                 <a:latin typeface="Calibri"/>
               </a:rPr>
-              <a:t>•  Per-class accuracy: worst exactly on the rare structural classes</a:t>
+              <a:t>•  Penalty = max(0, margin − confidence), margin 0.3 → zero once confidence ≥ 0.3</a:t>
+            </a:r>
+          </a:p>
+          <a:p>
+            <a:pPr>
+              <a:spcAft>
+                <a:spcPts val="1000"/>
+              </a:spcAft>
+            </a:pPr>
+            <a:r>
+              <a:rPr sz="2200">
+                <a:solidFill>
+                  <a:srgbClr val="333333"/>
+                </a:solidFill>
+                <a:latin typeface="Calibri"/>
+              </a:rPr>
+              <a:t>•  Paid ONLY on truth-chain edges — the true chains are known from MC truth during training</a:t>
+            </a:r>
+          </a:p>
+          <a:p>
+            <a:pPr>
+              <a:spcAft>
+                <a:spcPts val="1000"/>
+              </a:spcAft>
+            </a:pPr>
+            <a:r>
+              <a:rPr sz="2200">
+                <a:solidFill>
+                  <a:srgbClr val="333333"/>
+                </a:solidFill>
+                <a:latin typeface="Calibri"/>
+              </a:rPr>
+              <a:t>•  Role: chain edges give the global CE almost no gradient → hinge keeps them confident; CE (next) fixes "which class"</a:t>
             </a:r>
           </a:p>
         </p:txBody>
       </p:sp>
       <p:pic>
         <p:nvPicPr>
-          <p:cNvPr id="6" name="Picture 5" descr="chain_lca_imbalance_dist.png"/>
+          <p:cNvPr id="6" name="Picture 5" descr="chain_lca_hinge_mechanism.png"/>
           <p:cNvPicPr>
             <a:picLocks noChangeAspect="1"/>
           </p:cNvPicPr>
@@ -8183,7 +8547,7 @@
         <p:spPr>
           <a:xfrm>
             <a:off x="6400800" y="1371600"/>
-            <a:ext cx="5394960" cy="2060254"/>
+            <a:ext cx="5394960" cy="2253674"/>
           </a:xfrm>
           <a:prstGeom prst="rect">
             <a:avLst/>
@@ -8192,7 +8556,7 @@
       </p:pic>
       <p:pic>
         <p:nvPicPr>
-          <p:cNvPr id="7" name="Picture 6" descr="chain_lca_imbalance_acc.png"/>
+          <p:cNvPr id="7" name="Picture 6" descr="chain_lca_hinge_curve.png"/>
           <p:cNvPicPr>
             <a:picLocks noChangeAspect="1"/>
           </p:cNvPicPr>
@@ -8206,8 +8570,8 @@
         </p:blipFill>
         <p:spPr>
           <a:xfrm>
-            <a:off x="6400800" y="3840480"/>
-            <a:ext cx="5394960" cy="2061516"/>
+            <a:off x="6400800" y="3794760"/>
+            <a:ext cx="5394960" cy="2255054"/>
           </a:xfrm>
           <a:prstGeom prst="rect">
             <a:avLst/>
@@ -8222,7 +8586,7 @@
         </p:nvSpPr>
         <p:spPr>
           <a:xfrm>
-            <a:off x="731520" y="6263640"/>
+            <a:off x="731520" y="6309360"/>
             <a:ext cx="10789920" cy="365760"/>
           </a:xfrm>
           <a:prstGeom prst="rect">
@@ -8244,7 +8608,7 @@
                 </a:solidFill>
                 <a:latin typeface="Calibri"/>
               </a:rPr>
-              <a:t>Implication: without extra supervision, the classifier barely learns classes 1/2/3 — the chain losses exist to fix this</a:t>
+              <a:t>Implication: hinge is a training-only confidence bonus on chain edges — confidence = max(pk), not the pruning weight w</a:t>
             </a:r>
           </a:p>
         </p:txBody>
@@ -8330,7 +8694,7 @@
                 </a:solidFill>
                 <a:latin typeface="Calibri"/>
               </a:rPr>
-              <a:t>Why Chains Die (2/2): One Misclassified Edge</a:t>
+              <a:t>Reward 2 (v38): Chain-CE — Correctness Bonus</a:t>
             </a:r>
           </a:p>
           <a:p>
@@ -8341,7 +8705,7 @@
                 </a:solidFill>
                 <a:latin typeface="Calibri"/>
               </a:rPr>
-              <a:t>Chain-CE keeps every structural edge correct</a:t>
+              <a:t>A training-only reward for being the RIGHT class, on chain edges</a:t>
             </a:r>
           </a:p>
         </p:txBody>
@@ -8397,8 +8761,8 @@
         </p:nvSpPr>
         <p:spPr>
           <a:xfrm>
-            <a:off x="640080" y="1554480"/>
-            <a:ext cx="5486400" cy="4206240"/>
+            <a:off x="640080" y="1371600"/>
+            <a:ext cx="5486400" cy="4846320"/>
           </a:xfrm>
           <a:prstGeom prst="rect">
             <a:avLst/>
@@ -8423,7 +8787,7 @@
                 </a:solidFill>
                 <a:latin typeface="Calibri"/>
               </a:rPr>
-              <a:t>•  At inference, an edge the classifier calls class 0 is pruned</a:t>
+              <a:t>•  CE = −log(p_true): p_true is the probability the model assigns to the edge’s TRUE class</a:t>
             </a:r>
           </a:p>
           <a:p>
@@ -8439,7 +8803,7 @@
                 </a:solidFill>
                 <a:latin typeface="Calibri"/>
               </a:rPr>
-              <a:t>•  If ANY structural edge of a chain is misclassified, the whole chain dies</a:t>
+              <a:t>•  Right and confident (p_true → 1) → penalty ≈ 0; unsure or wrong → penalty large</a:t>
             </a:r>
           </a:p>
           <a:p>
@@ -8455,14 +8819,46 @@
                 </a:solidFill>
                 <a:latin typeface="Calibri"/>
               </a:rPr>
-              <a:t>•  Chain-CE (v38) supervises truth-chain edge classes directly → chains survive</a:t>
+              <a:t>•  Chain-CE (v38): added ON TOP of the hinge, paid on truth-chain edges (classes 1/2/3) → direct, undiluted gradient</a:t>
+            </a:r>
+          </a:p>
+          <a:p>
+            <a:pPr>
+              <a:spcAft>
+                <a:spcPts val="1000"/>
+              </a:spcAft>
+            </a:pPr>
+            <a:r>
+              <a:rPr sz="2200">
+                <a:solidFill>
+                  <a:srgbClr val="333333"/>
+                </a:solidFill>
+                <a:latin typeface="Calibri"/>
+              </a:rPr>
+              <a:t>•  v37 → v38 (weight 2.0 + chain-CE + cut 0.85): PerfectReco 27.3% → 29.3%</a:t>
+            </a:r>
+          </a:p>
+          <a:p>
+            <a:pPr>
+              <a:spcAft>
+                <a:spcPts val="1000"/>
+              </a:spcAft>
+            </a:pPr>
+            <a:r>
+              <a:rPr sz="2200">
+                <a:solidFill>
+                  <a:srgbClr val="333333"/>
+                </a:solidFill>
+                <a:latin typeface="Calibri"/>
+              </a:rPr>
+              <a:t>•  Net effect of Part 2 (v31 → v38): 23.9% → 29.3%</a:t>
             </a:r>
           </a:p>
         </p:txBody>
       </p:sp>
       <p:pic>
         <p:nvPicPr>
-          <p:cNvPr id="6" name="Picture 5" descr="chain_lca_before.png"/>
+          <p:cNvPr id="6" name="Picture 5" descr="chain_lca_ce_curve.png"/>
           <p:cNvPicPr>
             <a:picLocks noChangeAspect="1"/>
           </p:cNvPicPr>
@@ -8477,7 +8873,7 @@
         <p:spPr>
           <a:xfrm>
             <a:off x="6400800" y="1371600"/>
-            <a:ext cx="5394960" cy="2253674"/>
+            <a:ext cx="5394960" cy="2255054"/>
           </a:xfrm>
           <a:prstGeom prst="rect">
             <a:avLst/>
@@ -8486,7 +8882,7 @@
       </p:pic>
       <p:pic>
         <p:nvPicPr>
-          <p:cNvPr id="7" name="Picture 6" descr="chain_lca_after.png"/>
+          <p:cNvPr id="7" name="Picture 6" descr="chain_lca_ce_where.png"/>
           <p:cNvPicPr>
             <a:picLocks noChangeAspect="1"/>
           </p:cNvPicPr>
@@ -8516,7 +8912,7 @@
         </p:nvSpPr>
         <p:spPr>
           <a:xfrm>
-            <a:off x="731520" y="6263640"/>
+            <a:off x="731520" y="6309360"/>
             <a:ext cx="10789920" cy="365760"/>
           </a:xfrm>
           <a:prstGeom prst="rect">
@@ -8538,7 +8934,7 @@
                 </a:solidFill>
                 <a:latin typeface="Calibri"/>
               </a:rPr>
-              <a:t>Implication: chain survival depends on every structural edge being classified correctly — that is what the hinge + chain-CE provide</a:t>
+              <a:t>Implication: same function as the global CE — the reward is WHERE it is paid (chain edges only)</a:t>
             </a:r>
           </a:p>
         </p:txBody>

</xml_diff>

<commit_message>
docs: rebuild Part 3 — probes, native head zoo, depth & RC calculation
- S11: linear probes first — new probe_method figure shows HOW a probe is
  calculated (frozen backbone -> linear layer -> R2); evidence physics is
  lost (mass 0.003, mom ~0) then recovered (mass 0.93)
- S12: head zoo as native PowerPoint shapes (editable), new physics heads
  (source/mass/struct/mom) marked green vs original blue; dropped the PNG
- S13/S14: one page each for the struct-head targets — depth (BFS layers)
  and Rumor Centrality (subtree sizes, log R = -sum log tau, argmax root)
- Removed the unexplained ROC plot and its slide; parts renumbered (17 pages)
</commit_message>
<xml_diff>
--- a/meeting_figs/DFEI_progress_20260902_EN.pptx
+++ b/meeting_figs/DFEI_progress_20260902_EN.pptx
@@ -3623,7 +3623,7 @@
                 </a:solidFill>
                 <a:latin typeface="Calibri"/>
               </a:rPr>
-              <a:t>Part 3 — Supervising Representations with Physics</a:t>
+              <a:t>Part 3 — First, Check: Physics is Invisible</a:t>
             </a:r>
           </a:p>
           <a:p>
@@ -3634,7 +3634,7 @@
                 </a:solidFill>
                 <a:latin typeface="Calibri"/>
               </a:rPr>
-              <a:t>One common idea behind several heads</a:t>
+              <a:t>Linear probes show what the backbone does NOT encode</a:t>
             </a:r>
           </a:p>
         </p:txBody>
@@ -3691,7 +3691,7 @@
         <p:spPr>
           <a:xfrm>
             <a:off x="640080" y="1371600"/>
-            <a:ext cx="5486400" cy="4937760"/>
+            <a:ext cx="5486400" cy="4846320"/>
           </a:xfrm>
           <a:prstGeom prst="rect">
             <a:avLst/>
@@ -3716,7 +3716,7 @@
                 </a:solidFill>
                 <a:latin typeface="Calibri"/>
               </a:rPr>
-              <a:t>•  Idea: physical / structural quantities are data-intrinsic; supervise the representation with them, keeping the model end-to-end</a:t>
+              <a:t>•  Probe: freeze the backbone, fit one linear layer, try to read a physical quantity from the representation (top right)</a:t>
             </a:r>
           </a:p>
           <a:p>
@@ -3732,7 +3732,7 @@
                 </a:solidFill>
                 <a:latin typeface="Calibri"/>
               </a:rPr>
-              <a:t>•  The head zoo: one shared backbone, many supervised targets</a:t>
+              <a:t>•  If the quantity is not in the representation, the probe fails: R² ≈ 0</a:t>
             </a:r>
           </a:p>
           <a:p>
@@ -3742,13 +3742,13 @@
               </a:spcAft>
             </a:pPr>
             <a:r>
-              <a:rPr sz="2000">
-                <a:solidFill>
-                  <a:srgbClr val="333333"/>
-                </a:solidFill>
-                <a:latin typeface="Calibri"/>
-              </a:rPr>
-              <a:t>    –  source head (v36) — Rumor-Centrality root; early instance of the same idea</a:t>
+              <a:rPr sz="2200">
+                <a:solidFill>
+                  <a:srgbClr val="333333"/>
+                </a:solidFill>
+                <a:latin typeface="Calibri"/>
+              </a:rPr>
+              <a:t>•  Before any physics head: mass R² = 0.003, momentum R² ≈ 0 — physics is lost</a:t>
             </a:r>
           </a:p>
           <a:p>
@@ -3758,13 +3758,13 @@
               </a:spcAft>
             </a:pPr>
             <a:r>
-              <a:rPr sz="2000">
-                <a:solidFill>
-                  <a:srgbClr val="333333"/>
-                </a:solidFill>
-                <a:latin typeface="Calibri"/>
-              </a:rPr>
-              <a:t>    –  mass head — edge-level log10(m_ππ)</a:t>
+              <a:rPr sz="2200">
+                <a:solidFill>
+                  <a:srgbClr val="333333"/>
+                </a:solidFill>
+                <a:latin typeface="Calibri"/>
+              </a:rPr>
+              <a:t>•  So we added heads that supervise physics directly (head zoo, next)</a:t>
             </a:r>
           </a:p>
           <a:p>
@@ -3774,52 +3774,20 @@
               </a:spcAft>
             </a:pPr>
             <a:r>
-              <a:rPr sz="2000">
-                <a:solidFill>
-                  <a:srgbClr val="333333"/>
-                </a:solidFill>
-                <a:latin typeface="Calibri"/>
-              </a:rPr>
-              <a:t>    –  structure head — node depth + RC value</a:t>
-            </a:r>
-          </a:p>
-          <a:p>
-            <a:pPr>
-              <a:spcAft>
-                <a:spcPts val="1000"/>
-              </a:spcAft>
-            </a:pPr>
-            <a:r>
-              <a:rPr sz="2000">
-                <a:solidFill>
-                  <a:srgbClr val="333333"/>
-                </a:solidFill>
-                <a:latin typeface="Calibri"/>
-              </a:rPr>
-              <a:t>    –  momentum head — node normalized momentum</a:t>
-            </a:r>
-          </a:p>
-          <a:p>
-            <a:pPr>
-              <a:spcAft>
-                <a:spcPts val="1000"/>
-              </a:spcAft>
-            </a:pPr>
-            <a:r>
               <a:rPr sz="2200">
                 <a:solidFill>
                   <a:srgbClr val="333333"/>
                 </a:solidFill>
                 <a:latin typeface="Calibri"/>
               </a:rPr>
-              <a:t>•  Verification: linear probes on the frozen backbone (Ridge regression)</a:t>
+              <a:t>•  After mass supervision (masshead2): edge mass R² = 0.930; PerfectReco 29.3 → 32.7, class2 44.7 → 51.1</a:t>
             </a:r>
           </a:p>
         </p:txBody>
       </p:sp>
       <p:pic>
         <p:nvPicPr>
-          <p:cNvPr id="6" name="Picture 5" descr="head_zoo.png"/>
+          <p:cNvPr id="6" name="Picture 5" descr="probe_method.png"/>
           <p:cNvPicPr>
             <a:picLocks noChangeAspect="1"/>
           </p:cNvPicPr>
@@ -3833,7 +3801,7 @@
         </p:blipFill>
         <p:spPr>
           <a:xfrm>
-            <a:off x="6400800" y="2011680"/>
+            <a:off x="6400800" y="1371600"/>
             <a:ext cx="5394960" cy="2253674"/>
           </a:xfrm>
           <a:prstGeom prst="rect">
@@ -3841,15 +3809,39 @@
           </a:prstGeom>
         </p:spPr>
       </p:pic>
-      <p:sp>
-        <p:nvSpPr>
-          <p:cNvPr id="7" name="TextBox 6"/>
+      <p:pic>
+        <p:nvPicPr>
+          <p:cNvPr id="7" name="Picture 6" descr="probe_r2.png"/>
+          <p:cNvPicPr>
+            <a:picLocks noChangeAspect="1"/>
+          </p:cNvPicPr>
+          <p:nvPr/>
+        </p:nvPicPr>
+        <p:blipFill>
+          <a:blip r:embed="rId3"/>
+          <a:stretch>
+            <a:fillRect/>
+          </a:stretch>
+        </p:blipFill>
+        <p:spPr>
+          <a:xfrm>
+            <a:off x="6400800" y="3794760"/>
+            <a:ext cx="5394960" cy="2251752"/>
+          </a:xfrm>
+          <a:prstGeom prst="rect">
+            <a:avLst/>
+          </a:prstGeom>
+        </p:spPr>
+      </p:pic>
+      <p:sp>
+        <p:nvSpPr>
+          <p:cNvPr id="8" name="TextBox 7"/>
           <p:cNvSpPr txBox="1"/>
           <p:nvPr/>
         </p:nvSpPr>
         <p:spPr>
           <a:xfrm>
-            <a:off x="731520" y="6263640"/>
+            <a:off x="731520" y="6309360"/>
             <a:ext cx="10789920" cy="365760"/>
           </a:xfrm>
           <a:prstGeom prst="rect">
@@ -3871,7 +3863,7 @@
                 </a:solidFill>
                 <a:latin typeface="Calibri"/>
               </a:rPr>
-              <a:t>Implication: the backbone must represent the physics — the heads only tell it what to keep</a:t>
+              <a:t>Implication: the backbone does not encode physics by itself — it must be supervised into the representation</a:t>
             </a:r>
           </a:p>
         </p:txBody>
@@ -3957,7 +3949,7 @@
                 </a:solidFill>
                 <a:latin typeface="Calibri"/>
               </a:rPr>
-              <a:t>The Mass Head: Main Result</a:t>
+              <a:t>Part 3 — The Head Zoo</a:t>
             </a:r>
           </a:p>
           <a:p>
@@ -3968,7 +3960,7 @@
                 </a:solidFill>
                 <a:latin typeface="Calibri"/>
               </a:rPr>
-              <a:t>Edge-level regression of log10(m_ππ)</a:t>
+              <a:t>One backbone, many supervised targets — new heads in green</a:t>
             </a:r>
           </a:p>
         </p:txBody>
@@ -4025,7 +4017,7 @@
         <p:spPr>
           <a:xfrm>
             <a:off x="640080" y="1371600"/>
-            <a:ext cx="5486400" cy="4846320"/>
+            <a:ext cx="5486400" cy="4572000"/>
           </a:xfrm>
           <a:prstGeom prst="rect">
             <a:avLst/>
@@ -4050,7 +4042,7 @@
                 </a:solidFill>
                 <a:latin typeface="Calibri"/>
               </a:rPr>
-              <a:t>•  Same-mother track pairs sit near resonance masses → the edge representation must encode sister relations</a:t>
+              <a:t>•  Original heads (blue): the reconstruction machinery — classify, prune, assign</a:t>
             </a:r>
           </a:p>
           <a:p>
@@ -4066,7 +4058,7 @@
                 </a:solidFill>
                 <a:latin typeface="Calibri"/>
               </a:rPr>
-              <a:t>•  Setup: SmoothL1 on log10(m_MeV), sentinel edges masked, weight 1.0</a:t>
+              <a:t>•  New heads (green): supervise physical / structural quantities directly</a:t>
             </a:r>
           </a:p>
           <a:p>
@@ -4076,13 +4068,13 @@
               </a:spcAft>
             </a:pPr>
             <a:r>
-              <a:rPr sz="2200">
-                <a:solidFill>
-                  <a:srgbClr val="333333"/>
-                </a:solidFill>
-                <a:latin typeface="Calibri"/>
-              </a:rPr>
-              <a:t>•  v38 → masshead2 (20 test files):</a:t>
+              <a:rPr sz="2000">
+                <a:solidFill>
+                  <a:srgbClr val="333333"/>
+                </a:solidFill>
+                <a:latin typeface="Calibri"/>
+              </a:rPr>
+              <a:t>    –  source (v36) — chain root · mass — log10 m_ππ · struct — depth + RC · mom — momentum</a:t>
             </a:r>
           </a:p>
           <a:p>
@@ -4092,83 +4084,1110 @@
               </a:spcAft>
             </a:pPr>
             <a:r>
-              <a:rPr sz="2000">
-                <a:solidFill>
-                  <a:srgbClr val="333333"/>
-                </a:solidFill>
-                <a:latin typeface="Calibri"/>
-              </a:rPr>
-              <a:t>    –  PerfectReco 29.3% → 32.7%  (+3.4pp)</a:t>
-            </a:r>
-          </a:p>
-          <a:p>
-            <a:pPr>
-              <a:spcAft>
-                <a:spcPts val="1000"/>
-              </a:spcAft>
-            </a:pPr>
-            <a:r>
-              <a:rPr sz="2000">
-                <a:solidFill>
-                  <a:srgbClr val="333333"/>
-                </a:solidFill>
-                <a:latin typeface="Calibri"/>
-              </a:rPr>
-              <a:t>    –  AllParticles 52.1% → 55.9%  (+3.8pp)</a:t>
-            </a:r>
-          </a:p>
-          <a:p>
-            <a:pPr>
-              <a:spcAft>
-                <a:spcPts val="1000"/>
-              </a:spcAft>
-            </a:pPr>
-            <a:r>
-              <a:rPr sz="2000">
-                <a:solidFill>
-                  <a:srgbClr val="333333"/>
-                </a:solidFill>
-                <a:latin typeface="Calibri"/>
-              </a:rPr>
-              <a:t>    –  LCAG class2 44.7% → 51.1%  (+6.4pp)</a:t>
-            </a:r>
-          </a:p>
-        </p:txBody>
-      </p:sp>
-      <p:pic>
-        <p:nvPicPr>
-          <p:cNvPr id="6" name="Picture 5" descr="NN_edges_2_roc.png"/>
-          <p:cNvPicPr>
-            <a:picLocks noChangeAspect="1"/>
-          </p:cNvPicPr>
-          <p:nvPr/>
-        </p:nvPicPr>
-        <p:blipFill>
-          <a:blip r:embed="rId2"/>
-          <a:stretch>
-            <a:fillRect/>
-          </a:stretch>
-        </p:blipFill>
-        <p:spPr>
-          <a:xfrm>
-            <a:off x="6400800" y="1554480"/>
-            <a:ext cx="5394960" cy="3617075"/>
-          </a:xfrm>
-          <a:prstGeom prst="rect">
-            <a:avLst/>
-          </a:prstGeom>
-        </p:spPr>
-      </p:pic>
-      <p:sp>
-        <p:nvSpPr>
-          <p:cNvPr id="7" name="TextBox 6"/>
+              <a:rPr sz="2200">
+                <a:solidFill>
+                  <a:srgbClr val="333333"/>
+                </a:solidFill>
+                <a:latin typeface="Calibri"/>
+              </a:rPr>
+              <a:t>•  Same backbone, different targets: supervision writes the physics into the representation</a:t>
+            </a:r>
+          </a:p>
+        </p:txBody>
+      </p:sp>
+      <p:sp>
+        <p:nvSpPr>
+          <p:cNvPr id="6" name="Rounded Rectangle 5"/>
+          <p:cNvSpPr/>
+          <p:nvPr/>
+        </p:nvSpPr>
+        <p:spPr>
+          <a:xfrm>
+            <a:off x="6355080" y="1554480"/>
+            <a:ext cx="1234440" cy="4297680"/>
+          </a:xfrm>
+          <a:prstGeom prst="roundRect">
+            <a:avLst/>
+          </a:prstGeom>
+          <a:solidFill>
+            <a:srgbClr val="EAF2F8"/>
+          </a:solidFill>
+          <a:ln w="20320">
+            <a:solidFill>
+              <a:srgbClr val="1F4E79"/>
+            </a:solidFill>
+          </a:ln>
+        </p:spPr>
+        <p:style>
+          <a:lnRef idx="1">
+            <a:schemeClr val="accent1"/>
+          </a:lnRef>
+          <a:fillRef idx="3">
+            <a:schemeClr val="accent1"/>
+          </a:fillRef>
+          <a:effectRef idx="2">
+            <a:schemeClr val="accent1"/>
+          </a:effectRef>
+          <a:fontRef idx="minor">
+            <a:schemeClr val="lt1"/>
+          </a:fontRef>
+        </p:style>
+        <p:txBody>
+          <a:bodyPr rtlCol="0" anchor="ctr" wrap="square" lIns="27432" rIns="27432" tIns="9144" bIns="9144"/>
+          <a:lstStyle/>
+          <a:p>
+            <a:pPr algn="ctr"/>
+            <a:r>
+              <a:rPr sz="900" b="1">
+                <a:solidFill>
+                  <a:srgbClr val="333333"/>
+                </a:solidFill>
+                <a:latin typeface="Calibri"/>
+              </a:rPr>
+              <a:t>shared GNN</a:t>
+            </a:r>
+          </a:p>
+          <a:p>
+            <a:pPr algn="ctr"/>
+            <a:r>
+              <a:rPr sz="900" b="1">
+                <a:solidFill>
+                  <a:srgbClr val="333333"/>
+                </a:solidFill>
+                <a:latin typeface="Calibri"/>
+              </a:rPr>
+              <a:t>backbone</a:t>
+            </a:r>
+          </a:p>
+          <a:p>
+            <a:pPr algn="ctr"/>
+            <a:r>
+              <a:rPr sz="900" b="1">
+                <a:solidFill>
+                  <a:srgbClr val="333333"/>
+                </a:solidFill>
+                <a:latin typeface="Calibri"/>
+              </a:rPr>
+              <a:t/>
+            </a:r>
+          </a:p>
+          <a:p>
+            <a:pPr algn="ctr"/>
+            <a:r>
+              <a:rPr sz="900" b="1">
+                <a:solidFill>
+                  <a:srgbClr val="333333"/>
+                </a:solidFill>
+                <a:latin typeface="Calibri"/>
+              </a:rPr>
+              <a:t>node + edge</a:t>
+            </a:r>
+          </a:p>
+          <a:p>
+            <a:pPr algn="ctr"/>
+            <a:r>
+              <a:rPr sz="900" b="1">
+                <a:solidFill>
+                  <a:srgbClr val="333333"/>
+                </a:solidFill>
+                <a:latin typeface="Calibri"/>
+              </a:rPr>
+              <a:t>representations</a:t>
+            </a:r>
+          </a:p>
+        </p:txBody>
+      </p:sp>
+      <p:sp>
+        <p:nvSpPr>
+          <p:cNvPr id="7" name="Rounded Rectangle 6"/>
+          <p:cNvSpPr/>
+          <p:nvPr/>
+        </p:nvSpPr>
+        <p:spPr>
+          <a:xfrm>
+            <a:off x="7909560" y="4846320"/>
+            <a:ext cx="1417320" cy="1143000"/>
+          </a:xfrm>
+          <a:prstGeom prst="roundRect">
+            <a:avLst/>
+          </a:prstGeom>
+          <a:solidFill>
+            <a:srgbClr val="EAF2F8"/>
+          </a:solidFill>
+          <a:ln w="20320">
+            <a:solidFill>
+              <a:srgbClr val="1F4E79"/>
+            </a:solidFill>
+          </a:ln>
+        </p:spPr>
+        <p:style>
+          <a:lnRef idx="1">
+            <a:schemeClr val="accent1"/>
+          </a:lnRef>
+          <a:fillRef idx="3">
+            <a:schemeClr val="accent1"/>
+          </a:fillRef>
+          <a:effectRef idx="2">
+            <a:schemeClr val="accent1"/>
+          </a:effectRef>
+          <a:fontRef idx="minor">
+            <a:schemeClr val="lt1"/>
+          </a:fontRef>
+        </p:style>
+        <p:txBody>
+          <a:bodyPr rtlCol="0" anchor="ctr" wrap="square" lIns="27432" rIns="27432" tIns="9144" bIns="9144"/>
+          <a:lstStyle/>
+          <a:p>
+            <a:pPr algn="ctr"/>
+            <a:r>
+              <a:rPr sz="800" b="1">
+                <a:solidFill>
+                  <a:srgbClr val="333333"/>
+                </a:solidFill>
+                <a:latin typeface="Calibri"/>
+              </a:rPr>
+              <a:t>LCAG</a:t>
+            </a:r>
+          </a:p>
+          <a:p>
+            <a:pPr algn="ctr"/>
+            <a:r>
+              <a:rPr sz="800" b="1">
+                <a:solidFill>
+                  <a:srgbClr val="333333"/>
+                </a:solidFill>
+                <a:latin typeface="Calibri"/>
+              </a:rPr>
+              <a:t>edge class 0-3</a:t>
+            </a:r>
+          </a:p>
+        </p:txBody>
+      </p:sp>
+      <p:sp>
+        <p:nvSpPr>
+          <p:cNvPr id="8" name="Rounded Rectangle 7"/>
+          <p:cNvSpPr/>
+          <p:nvPr/>
+        </p:nvSpPr>
+        <p:spPr>
+          <a:xfrm>
+            <a:off x="9509760" y="4846320"/>
+            <a:ext cx="1417320" cy="1143000"/>
+          </a:xfrm>
+          <a:prstGeom prst="roundRect">
+            <a:avLst/>
+          </a:prstGeom>
+          <a:solidFill>
+            <a:srgbClr val="EAF2F8"/>
+          </a:solidFill>
+          <a:ln w="20320">
+            <a:solidFill>
+              <a:srgbClr val="1F4E79"/>
+            </a:solidFill>
+          </a:ln>
+        </p:spPr>
+        <p:style>
+          <a:lnRef idx="1">
+            <a:schemeClr val="accent1"/>
+          </a:lnRef>
+          <a:fillRef idx="3">
+            <a:schemeClr val="accent1"/>
+          </a:fillRef>
+          <a:effectRef idx="2">
+            <a:schemeClr val="accent1"/>
+          </a:effectRef>
+          <a:fontRef idx="minor">
+            <a:schemeClr val="lt1"/>
+          </a:fontRef>
+        </p:style>
+        <p:txBody>
+          <a:bodyPr rtlCol="0" anchor="ctr" wrap="square" lIns="27432" rIns="27432" tIns="9144" bIns="9144"/>
+          <a:lstStyle/>
+          <a:p>
+            <a:pPr algn="ctr"/>
+            <a:r>
+              <a:rPr sz="800" b="1">
+                <a:solidFill>
+                  <a:srgbClr val="333333"/>
+                </a:solidFill>
+                <a:latin typeface="Calibri"/>
+              </a:rPr>
+              <a:t>node prune</a:t>
+            </a:r>
+          </a:p>
+          <a:p>
+            <a:pPr algn="ctr"/>
+            <a:r>
+              <a:rPr sz="800" b="1">
+                <a:solidFill>
+                  <a:srgbClr val="333333"/>
+                </a:solidFill>
+                <a:latin typeface="Calibri"/>
+              </a:rPr>
+              <a:t>keep/remove node</a:t>
+            </a:r>
+          </a:p>
+        </p:txBody>
+      </p:sp>
+      <p:sp>
+        <p:nvSpPr>
+          <p:cNvPr id="9" name="Rounded Rectangle 8"/>
+          <p:cNvSpPr/>
+          <p:nvPr/>
+        </p:nvSpPr>
+        <p:spPr>
+          <a:xfrm>
+            <a:off x="11109960" y="4846320"/>
+            <a:ext cx="1417320" cy="1143000"/>
+          </a:xfrm>
+          <a:prstGeom prst="roundRect">
+            <a:avLst/>
+          </a:prstGeom>
+          <a:solidFill>
+            <a:srgbClr val="EAF2F8"/>
+          </a:solidFill>
+          <a:ln w="20320">
+            <a:solidFill>
+              <a:srgbClr val="1F4E79"/>
+            </a:solidFill>
+          </a:ln>
+        </p:spPr>
+        <p:style>
+          <a:lnRef idx="1">
+            <a:schemeClr val="accent1"/>
+          </a:lnRef>
+          <a:fillRef idx="3">
+            <a:schemeClr val="accent1"/>
+          </a:fillRef>
+          <a:effectRef idx="2">
+            <a:schemeClr val="accent1"/>
+          </a:effectRef>
+          <a:fontRef idx="minor">
+            <a:schemeClr val="lt1"/>
+          </a:fontRef>
+        </p:style>
+        <p:txBody>
+          <a:bodyPr rtlCol="0" anchor="ctr" wrap="square" lIns="27432" rIns="27432" tIns="9144" bIns="9144"/>
+          <a:lstStyle/>
+          <a:p>
+            <a:pPr algn="ctr"/>
+            <a:r>
+              <a:rPr sz="800" b="1">
+                <a:solidFill>
+                  <a:srgbClr val="333333"/>
+                </a:solidFill>
+                <a:latin typeface="Calibri"/>
+              </a:rPr>
+              <a:t>edge prune</a:t>
+            </a:r>
+          </a:p>
+          <a:p>
+            <a:pPr algn="ctr"/>
+            <a:r>
+              <a:rPr sz="800" b="1">
+                <a:solidFill>
+                  <a:srgbClr val="333333"/>
+                </a:solidFill>
+                <a:latin typeface="Calibri"/>
+              </a:rPr>
+              <a:t>keep/remove edge</a:t>
+            </a:r>
+          </a:p>
+        </p:txBody>
+      </p:sp>
+      <p:sp>
+        <p:nvSpPr>
+          <p:cNvPr id="10" name="Rounded Rectangle 9"/>
+          <p:cNvSpPr/>
+          <p:nvPr/>
+        </p:nvSpPr>
+        <p:spPr>
+          <a:xfrm>
+            <a:off x="7909560" y="3246120"/>
+            <a:ext cx="1417320" cy="1143000"/>
+          </a:xfrm>
+          <a:prstGeom prst="roundRect">
+            <a:avLst/>
+          </a:prstGeom>
+          <a:solidFill>
+            <a:srgbClr val="EAFAF1"/>
+          </a:solidFill>
+          <a:ln w="20320">
+            <a:solidFill>
+              <a:srgbClr val="2CA02C"/>
+            </a:solidFill>
+          </a:ln>
+        </p:spPr>
+        <p:style>
+          <a:lnRef idx="1">
+            <a:schemeClr val="accent1"/>
+          </a:lnRef>
+          <a:fillRef idx="3">
+            <a:schemeClr val="accent1"/>
+          </a:fillRef>
+          <a:effectRef idx="2">
+            <a:schemeClr val="accent1"/>
+          </a:effectRef>
+          <a:fontRef idx="minor">
+            <a:schemeClr val="lt1"/>
+          </a:fontRef>
+        </p:style>
+        <p:txBody>
+          <a:bodyPr rtlCol="0" anchor="ctr" wrap="square" lIns="27432" rIns="27432" tIns="9144" bIns="9144"/>
+          <a:lstStyle/>
+          <a:p>
+            <a:pPr algn="ctr"/>
+            <a:r>
+              <a:rPr sz="800" b="1">
+                <a:solidFill>
+                  <a:srgbClr val="333333"/>
+                </a:solidFill>
+                <a:latin typeface="Calibri"/>
+              </a:rPr>
+              <a:t>source</a:t>
+            </a:r>
+          </a:p>
+          <a:p>
+            <a:pPr algn="ctr"/>
+            <a:r>
+              <a:rPr sz="800" b="1">
+                <a:solidFill>
+                  <a:srgbClr val="333333"/>
+                </a:solidFill>
+                <a:latin typeface="Calibri"/>
+              </a:rPr>
+              <a:t>chain root (RC)</a:t>
+            </a:r>
+          </a:p>
+        </p:txBody>
+      </p:sp>
+      <p:sp>
+        <p:nvSpPr>
+          <p:cNvPr id="11" name="Rounded Rectangle 10"/>
+          <p:cNvSpPr/>
+          <p:nvPr/>
+        </p:nvSpPr>
+        <p:spPr>
+          <a:xfrm>
+            <a:off x="9509760" y="3246120"/>
+            <a:ext cx="1417320" cy="1143000"/>
+          </a:xfrm>
+          <a:prstGeom prst="roundRect">
+            <a:avLst/>
+          </a:prstGeom>
+          <a:solidFill>
+            <a:srgbClr val="EAFAF1"/>
+          </a:solidFill>
+          <a:ln w="20320">
+            <a:solidFill>
+              <a:srgbClr val="2CA02C"/>
+            </a:solidFill>
+          </a:ln>
+        </p:spPr>
+        <p:style>
+          <a:lnRef idx="1">
+            <a:schemeClr val="accent1"/>
+          </a:lnRef>
+          <a:fillRef idx="3">
+            <a:schemeClr val="accent1"/>
+          </a:fillRef>
+          <a:effectRef idx="2">
+            <a:schemeClr val="accent1"/>
+          </a:effectRef>
+          <a:fontRef idx="minor">
+            <a:schemeClr val="lt1"/>
+          </a:fontRef>
+        </p:style>
+        <p:txBody>
+          <a:bodyPr rtlCol="0" anchor="ctr" wrap="square" lIns="27432" rIns="27432" tIns="9144" bIns="9144"/>
+          <a:lstStyle/>
+          <a:p>
+            <a:pPr algn="ctr"/>
+            <a:r>
+              <a:rPr sz="800" b="1">
+                <a:solidFill>
+                  <a:srgbClr val="333333"/>
+                </a:solidFill>
+                <a:latin typeface="Calibri"/>
+              </a:rPr>
+              <a:t>mass</a:t>
+            </a:r>
+          </a:p>
+          <a:p>
+            <a:pPr algn="ctr"/>
+            <a:r>
+              <a:rPr sz="800" b="1">
+                <a:solidFill>
+                  <a:srgbClr val="333333"/>
+                </a:solidFill>
+                <a:latin typeface="Calibri"/>
+              </a:rPr>
+              <a:t>log10 m_ππ</a:t>
+            </a:r>
+          </a:p>
+        </p:txBody>
+      </p:sp>
+      <p:sp>
+        <p:nvSpPr>
+          <p:cNvPr id="12" name="Rounded Rectangle 11"/>
+          <p:cNvSpPr/>
+          <p:nvPr/>
+        </p:nvSpPr>
+        <p:spPr>
+          <a:xfrm>
+            <a:off x="11109960" y="3246120"/>
+            <a:ext cx="1417320" cy="1143000"/>
+          </a:xfrm>
+          <a:prstGeom prst="roundRect">
+            <a:avLst/>
+          </a:prstGeom>
+          <a:solidFill>
+            <a:srgbClr val="EAFAF1"/>
+          </a:solidFill>
+          <a:ln w="20320">
+            <a:solidFill>
+              <a:srgbClr val="2CA02C"/>
+            </a:solidFill>
+          </a:ln>
+        </p:spPr>
+        <p:style>
+          <a:lnRef idx="1">
+            <a:schemeClr val="accent1"/>
+          </a:lnRef>
+          <a:fillRef idx="3">
+            <a:schemeClr val="accent1"/>
+          </a:fillRef>
+          <a:effectRef idx="2">
+            <a:schemeClr val="accent1"/>
+          </a:effectRef>
+          <a:fontRef idx="minor">
+            <a:schemeClr val="lt1"/>
+          </a:fontRef>
+        </p:style>
+        <p:txBody>
+          <a:bodyPr rtlCol="0" anchor="ctr" wrap="square" lIns="27432" rIns="27432" tIns="9144" bIns="9144"/>
+          <a:lstStyle/>
+          <a:p>
+            <a:pPr algn="ctr"/>
+            <a:r>
+              <a:rPr sz="800" b="1">
+                <a:solidFill>
+                  <a:srgbClr val="333333"/>
+                </a:solidFill>
+                <a:latin typeface="Calibri"/>
+              </a:rPr>
+              <a:t>struct</a:t>
+            </a:r>
+          </a:p>
+          <a:p>
+            <a:pPr algn="ctr"/>
+            <a:r>
+              <a:rPr sz="800" b="1">
+                <a:solidFill>
+                  <a:srgbClr val="333333"/>
+                </a:solidFill>
+                <a:latin typeface="Calibri"/>
+              </a:rPr>
+              <a:t>depth + RC</a:t>
+            </a:r>
+          </a:p>
+        </p:txBody>
+      </p:sp>
+      <p:sp>
+        <p:nvSpPr>
+          <p:cNvPr id="13" name="Rounded Rectangle 12"/>
+          <p:cNvSpPr/>
+          <p:nvPr/>
+        </p:nvSpPr>
+        <p:spPr>
+          <a:xfrm>
+            <a:off x="7909560" y="1645920"/>
+            <a:ext cx="1417320" cy="1143000"/>
+          </a:xfrm>
+          <a:prstGeom prst="roundRect">
+            <a:avLst/>
+          </a:prstGeom>
+          <a:solidFill>
+            <a:srgbClr val="EAFAF1"/>
+          </a:solidFill>
+          <a:ln w="20320">
+            <a:solidFill>
+              <a:srgbClr val="2CA02C"/>
+            </a:solidFill>
+          </a:ln>
+        </p:spPr>
+        <p:style>
+          <a:lnRef idx="1">
+            <a:schemeClr val="accent1"/>
+          </a:lnRef>
+          <a:fillRef idx="3">
+            <a:schemeClr val="accent1"/>
+          </a:fillRef>
+          <a:effectRef idx="2">
+            <a:schemeClr val="accent1"/>
+          </a:effectRef>
+          <a:fontRef idx="minor">
+            <a:schemeClr val="lt1"/>
+          </a:fontRef>
+        </p:style>
+        <p:txBody>
+          <a:bodyPr rtlCol="0" anchor="ctr" wrap="square" lIns="27432" rIns="27432" tIns="9144" bIns="9144"/>
+          <a:lstStyle/>
+          <a:p>
+            <a:pPr algn="ctr"/>
+            <a:r>
+              <a:rPr sz="800" b="1">
+                <a:solidFill>
+                  <a:srgbClr val="333333"/>
+                </a:solidFill>
+                <a:latin typeface="Calibri"/>
+              </a:rPr>
+              <a:t>mom</a:t>
+            </a:r>
+          </a:p>
+          <a:p>
+            <a:pPr algn="ctr"/>
+            <a:r>
+              <a:rPr sz="800" b="1">
+                <a:solidFill>
+                  <a:srgbClr val="333333"/>
+                </a:solidFill>
+                <a:latin typeface="Calibri"/>
+              </a:rPr>
+              <a:t>normalized p</a:t>
+            </a:r>
+          </a:p>
+        </p:txBody>
+      </p:sp>
+      <p:sp>
+        <p:nvSpPr>
+          <p:cNvPr id="14" name="Rounded Rectangle 13"/>
+          <p:cNvSpPr/>
+          <p:nvPr/>
+        </p:nvSpPr>
+        <p:spPr>
+          <a:xfrm>
+            <a:off x="9509760" y="1645920"/>
+            <a:ext cx="1417320" cy="1143000"/>
+          </a:xfrm>
+          <a:prstGeom prst="roundRect">
+            <a:avLst/>
+          </a:prstGeom>
+          <a:solidFill>
+            <a:srgbClr val="EAF2F8"/>
+          </a:solidFill>
+          <a:ln w="20320">
+            <a:solidFill>
+              <a:srgbClr val="1F4E79"/>
+            </a:solidFill>
+          </a:ln>
+        </p:spPr>
+        <p:style>
+          <a:lnRef idx="1">
+            <a:schemeClr val="accent1"/>
+          </a:lnRef>
+          <a:fillRef idx="3">
+            <a:schemeClr val="accent1"/>
+          </a:fillRef>
+          <a:effectRef idx="2">
+            <a:schemeClr val="accent1"/>
+          </a:effectRef>
+          <a:fontRef idx="minor">
+            <a:schemeClr val="lt1"/>
+          </a:fontRef>
+        </p:style>
+        <p:txBody>
+          <a:bodyPr rtlCol="0" anchor="ctr" wrap="square" lIns="27432" rIns="27432" tIns="9144" bIns="9144"/>
+          <a:lstStyle/>
+          <a:p>
+            <a:pPr algn="ctr"/>
+            <a:r>
+              <a:rPr sz="800" b="1">
+                <a:solidFill>
+                  <a:srgbClr val="333333"/>
+                </a:solidFill>
+                <a:latin typeface="Calibri"/>
+              </a:rPr>
+              <a:t>PV asso</a:t>
+            </a:r>
+          </a:p>
+          <a:p>
+            <a:pPr algn="ctr"/>
+            <a:r>
+              <a:rPr sz="800" b="1">
+                <a:solidFill>
+                  <a:srgbClr val="333333"/>
+                </a:solidFill>
+                <a:latin typeface="Calibri"/>
+              </a:rPr>
+              <a:t>PV assignment</a:t>
+            </a:r>
+          </a:p>
+        </p:txBody>
+      </p:sp>
+      <p:sp>
+        <p:nvSpPr>
+          <p:cNvPr id="15" name="Rounded Rectangle 14"/>
+          <p:cNvSpPr/>
+          <p:nvPr/>
+        </p:nvSpPr>
+        <p:spPr>
+          <a:xfrm>
+            <a:off x="11109960" y="1645920"/>
+            <a:ext cx="1417320" cy="1143000"/>
+          </a:xfrm>
+          <a:prstGeom prst="roundRect">
+            <a:avLst/>
+          </a:prstGeom>
+          <a:solidFill>
+            <a:srgbClr val="EAF2F8"/>
+          </a:solidFill>
+          <a:ln w="20320">
+            <a:solidFill>
+              <a:srgbClr val="1F4E79"/>
+            </a:solidFill>
+          </a:ln>
+        </p:spPr>
+        <p:style>
+          <a:lnRef idx="1">
+            <a:schemeClr val="accent1"/>
+          </a:lnRef>
+          <a:fillRef idx="3">
+            <a:schemeClr val="accent1"/>
+          </a:fillRef>
+          <a:effectRef idx="2">
+            <a:schemeClr val="accent1"/>
+          </a:effectRef>
+          <a:fontRef idx="minor">
+            <a:schemeClr val="lt1"/>
+          </a:fontRef>
+        </p:style>
+        <p:txBody>
+          <a:bodyPr rtlCol="0" anchor="ctr" wrap="square" lIns="27432" rIns="27432" tIns="9144" bIns="9144"/>
+          <a:lstStyle/>
+          <a:p>
+            <a:pPr algn="ctr"/>
+            <a:r>
+              <a:rPr sz="800" b="1">
+                <a:solidFill>
+                  <a:srgbClr val="333333"/>
+                </a:solidFill>
+                <a:latin typeface="Calibri"/>
+              </a:rPr>
+              <a:t>chain scorer</a:t>
+            </a:r>
+          </a:p>
+          <a:p>
+            <a:pPr algn="ctr"/>
+            <a:r>
+              <a:rPr sz="800" b="1">
+                <a:solidFill>
+                  <a:srgbClr val="333333"/>
+                </a:solidFill>
+                <a:latin typeface="Calibri"/>
+              </a:rPr>
+              <a:t>chain conf. (planned)</a:t>
+            </a:r>
+          </a:p>
+        </p:txBody>
+      </p:sp>
+      <p:sp>
+        <p:nvSpPr>
+          <p:cNvPr id="16" name="Right Arrow 15"/>
+          <p:cNvSpPr/>
+          <p:nvPr/>
+        </p:nvSpPr>
+        <p:spPr>
+          <a:xfrm>
+            <a:off x="7607808" y="5298948"/>
+            <a:ext cx="237744" cy="237744"/>
+          </a:xfrm>
+          <a:prstGeom prst="rightArrow">
+            <a:avLst/>
+          </a:prstGeom>
+          <a:solidFill>
+            <a:srgbClr val="1F4E79"/>
+          </a:solidFill>
+          <a:ln>
+            <a:noFill/>
+          </a:ln>
+        </p:spPr>
+        <p:style>
+          <a:lnRef idx="1">
+            <a:schemeClr val="accent1"/>
+          </a:lnRef>
+          <a:fillRef idx="3">
+            <a:schemeClr val="accent1"/>
+          </a:fillRef>
+          <a:effectRef idx="2">
+            <a:schemeClr val="accent1"/>
+          </a:effectRef>
+          <a:fontRef idx="minor">
+            <a:schemeClr val="lt1"/>
+          </a:fontRef>
+        </p:style>
+        <p:txBody>
+          <a:bodyPr rtlCol="0" anchor="ctr"/>
+          <a:lstStyle/>
+          <a:p>
+            <a:pPr algn="ctr"/>
+          </a:p>
+        </p:txBody>
+      </p:sp>
+      <p:sp>
+        <p:nvSpPr>
+          <p:cNvPr id="17" name="Right Arrow 16"/>
+          <p:cNvSpPr/>
+          <p:nvPr/>
+        </p:nvSpPr>
+        <p:spPr>
+          <a:xfrm>
+            <a:off x="9345168" y="5298948"/>
+            <a:ext cx="109728" cy="237744"/>
+          </a:xfrm>
+          <a:prstGeom prst="rightArrow">
+            <a:avLst/>
+          </a:prstGeom>
+          <a:solidFill>
+            <a:srgbClr val="1F4E79"/>
+          </a:solidFill>
+          <a:ln>
+            <a:noFill/>
+          </a:ln>
+        </p:spPr>
+        <p:style>
+          <a:lnRef idx="1">
+            <a:schemeClr val="accent1"/>
+          </a:lnRef>
+          <a:fillRef idx="3">
+            <a:schemeClr val="accent1"/>
+          </a:fillRef>
+          <a:effectRef idx="2">
+            <a:schemeClr val="accent1"/>
+          </a:effectRef>
+          <a:fontRef idx="minor">
+            <a:schemeClr val="lt1"/>
+          </a:fontRef>
+        </p:style>
+        <p:txBody>
+          <a:bodyPr rtlCol="0" anchor="ctr"/>
+          <a:lstStyle/>
+          <a:p>
+            <a:pPr algn="ctr"/>
+          </a:p>
+        </p:txBody>
+      </p:sp>
+      <p:sp>
+        <p:nvSpPr>
+          <p:cNvPr id="18" name="Right Arrow 17"/>
+          <p:cNvSpPr/>
+          <p:nvPr/>
+        </p:nvSpPr>
+        <p:spPr>
+          <a:xfrm>
+            <a:off x="10945368" y="5298948"/>
+            <a:ext cx="109728" cy="237744"/>
+          </a:xfrm>
+          <a:prstGeom prst="rightArrow">
+            <a:avLst/>
+          </a:prstGeom>
+          <a:solidFill>
+            <a:srgbClr val="1F4E79"/>
+          </a:solidFill>
+          <a:ln>
+            <a:noFill/>
+          </a:ln>
+        </p:spPr>
+        <p:style>
+          <a:lnRef idx="1">
+            <a:schemeClr val="accent1"/>
+          </a:lnRef>
+          <a:fillRef idx="3">
+            <a:schemeClr val="accent1"/>
+          </a:fillRef>
+          <a:effectRef idx="2">
+            <a:schemeClr val="accent1"/>
+          </a:effectRef>
+          <a:fontRef idx="minor">
+            <a:schemeClr val="lt1"/>
+          </a:fontRef>
+        </p:style>
+        <p:txBody>
+          <a:bodyPr rtlCol="0" anchor="ctr"/>
+          <a:lstStyle/>
+          <a:p>
+            <a:pPr algn="ctr"/>
+          </a:p>
+        </p:txBody>
+      </p:sp>
+      <p:sp>
+        <p:nvSpPr>
+          <p:cNvPr id="19" name="Right Arrow 18"/>
+          <p:cNvSpPr/>
+          <p:nvPr/>
+        </p:nvSpPr>
+        <p:spPr>
+          <a:xfrm>
+            <a:off x="7607808" y="3698748"/>
+            <a:ext cx="237744" cy="237744"/>
+          </a:xfrm>
+          <a:prstGeom prst="rightArrow">
+            <a:avLst/>
+          </a:prstGeom>
+          <a:solidFill>
+            <a:srgbClr val="1F4E79"/>
+          </a:solidFill>
+          <a:ln>
+            <a:noFill/>
+          </a:ln>
+        </p:spPr>
+        <p:style>
+          <a:lnRef idx="1">
+            <a:schemeClr val="accent1"/>
+          </a:lnRef>
+          <a:fillRef idx="3">
+            <a:schemeClr val="accent1"/>
+          </a:fillRef>
+          <a:effectRef idx="2">
+            <a:schemeClr val="accent1"/>
+          </a:effectRef>
+          <a:fontRef idx="minor">
+            <a:schemeClr val="lt1"/>
+          </a:fontRef>
+        </p:style>
+        <p:txBody>
+          <a:bodyPr rtlCol="0" anchor="ctr"/>
+          <a:lstStyle/>
+          <a:p>
+            <a:pPr algn="ctr"/>
+          </a:p>
+        </p:txBody>
+      </p:sp>
+      <p:sp>
+        <p:nvSpPr>
+          <p:cNvPr id="20" name="Right Arrow 19"/>
+          <p:cNvSpPr/>
+          <p:nvPr/>
+        </p:nvSpPr>
+        <p:spPr>
+          <a:xfrm>
+            <a:off x="9345168" y="3698748"/>
+            <a:ext cx="109728" cy="237744"/>
+          </a:xfrm>
+          <a:prstGeom prst="rightArrow">
+            <a:avLst/>
+          </a:prstGeom>
+          <a:solidFill>
+            <a:srgbClr val="1F4E79"/>
+          </a:solidFill>
+          <a:ln>
+            <a:noFill/>
+          </a:ln>
+        </p:spPr>
+        <p:style>
+          <a:lnRef idx="1">
+            <a:schemeClr val="accent1"/>
+          </a:lnRef>
+          <a:fillRef idx="3">
+            <a:schemeClr val="accent1"/>
+          </a:fillRef>
+          <a:effectRef idx="2">
+            <a:schemeClr val="accent1"/>
+          </a:effectRef>
+          <a:fontRef idx="minor">
+            <a:schemeClr val="lt1"/>
+          </a:fontRef>
+        </p:style>
+        <p:txBody>
+          <a:bodyPr rtlCol="0" anchor="ctr"/>
+          <a:lstStyle/>
+          <a:p>
+            <a:pPr algn="ctr"/>
+          </a:p>
+        </p:txBody>
+      </p:sp>
+      <p:sp>
+        <p:nvSpPr>
+          <p:cNvPr id="21" name="Right Arrow 20"/>
+          <p:cNvSpPr/>
+          <p:nvPr/>
+        </p:nvSpPr>
+        <p:spPr>
+          <a:xfrm>
+            <a:off x="10945368" y="3698748"/>
+            <a:ext cx="109728" cy="237744"/>
+          </a:xfrm>
+          <a:prstGeom prst="rightArrow">
+            <a:avLst/>
+          </a:prstGeom>
+          <a:solidFill>
+            <a:srgbClr val="1F4E79"/>
+          </a:solidFill>
+          <a:ln>
+            <a:noFill/>
+          </a:ln>
+        </p:spPr>
+        <p:style>
+          <a:lnRef idx="1">
+            <a:schemeClr val="accent1"/>
+          </a:lnRef>
+          <a:fillRef idx="3">
+            <a:schemeClr val="accent1"/>
+          </a:fillRef>
+          <a:effectRef idx="2">
+            <a:schemeClr val="accent1"/>
+          </a:effectRef>
+          <a:fontRef idx="minor">
+            <a:schemeClr val="lt1"/>
+          </a:fontRef>
+        </p:style>
+        <p:txBody>
+          <a:bodyPr rtlCol="0" anchor="ctr"/>
+          <a:lstStyle/>
+          <a:p>
+            <a:pPr algn="ctr"/>
+          </a:p>
+        </p:txBody>
+      </p:sp>
+      <p:sp>
+        <p:nvSpPr>
+          <p:cNvPr id="22" name="Right Arrow 21"/>
+          <p:cNvSpPr/>
+          <p:nvPr/>
+        </p:nvSpPr>
+        <p:spPr>
+          <a:xfrm>
+            <a:off x="7607808" y="2098548"/>
+            <a:ext cx="237744" cy="237744"/>
+          </a:xfrm>
+          <a:prstGeom prst="rightArrow">
+            <a:avLst/>
+          </a:prstGeom>
+          <a:solidFill>
+            <a:srgbClr val="1F4E79"/>
+          </a:solidFill>
+          <a:ln>
+            <a:noFill/>
+          </a:ln>
+        </p:spPr>
+        <p:style>
+          <a:lnRef idx="1">
+            <a:schemeClr val="accent1"/>
+          </a:lnRef>
+          <a:fillRef idx="3">
+            <a:schemeClr val="accent1"/>
+          </a:fillRef>
+          <a:effectRef idx="2">
+            <a:schemeClr val="accent1"/>
+          </a:effectRef>
+          <a:fontRef idx="minor">
+            <a:schemeClr val="lt1"/>
+          </a:fontRef>
+        </p:style>
+        <p:txBody>
+          <a:bodyPr rtlCol="0" anchor="ctr"/>
+          <a:lstStyle/>
+          <a:p>
+            <a:pPr algn="ctr"/>
+          </a:p>
+        </p:txBody>
+      </p:sp>
+      <p:sp>
+        <p:nvSpPr>
+          <p:cNvPr id="23" name="Right Arrow 22"/>
+          <p:cNvSpPr/>
+          <p:nvPr/>
+        </p:nvSpPr>
+        <p:spPr>
+          <a:xfrm>
+            <a:off x="9345168" y="2098548"/>
+            <a:ext cx="109728" cy="237744"/>
+          </a:xfrm>
+          <a:prstGeom prst="rightArrow">
+            <a:avLst/>
+          </a:prstGeom>
+          <a:solidFill>
+            <a:srgbClr val="1F4E79"/>
+          </a:solidFill>
+          <a:ln>
+            <a:noFill/>
+          </a:ln>
+        </p:spPr>
+        <p:style>
+          <a:lnRef idx="1">
+            <a:schemeClr val="accent1"/>
+          </a:lnRef>
+          <a:fillRef idx="3">
+            <a:schemeClr val="accent1"/>
+          </a:fillRef>
+          <a:effectRef idx="2">
+            <a:schemeClr val="accent1"/>
+          </a:effectRef>
+          <a:fontRef idx="minor">
+            <a:schemeClr val="lt1"/>
+          </a:fontRef>
+        </p:style>
+        <p:txBody>
+          <a:bodyPr rtlCol="0" anchor="ctr"/>
+          <a:lstStyle/>
+          <a:p>
+            <a:pPr algn="ctr"/>
+          </a:p>
+        </p:txBody>
+      </p:sp>
+      <p:sp>
+        <p:nvSpPr>
+          <p:cNvPr id="24" name="Right Arrow 23"/>
+          <p:cNvSpPr/>
+          <p:nvPr/>
+        </p:nvSpPr>
+        <p:spPr>
+          <a:xfrm>
+            <a:off x="10945368" y="2098548"/>
+            <a:ext cx="109728" cy="237744"/>
+          </a:xfrm>
+          <a:prstGeom prst="rightArrow">
+            <a:avLst/>
+          </a:prstGeom>
+          <a:solidFill>
+            <a:srgbClr val="1F4E79"/>
+          </a:solidFill>
+          <a:ln>
+            <a:noFill/>
+          </a:ln>
+        </p:spPr>
+        <p:style>
+          <a:lnRef idx="1">
+            <a:schemeClr val="accent1"/>
+          </a:lnRef>
+          <a:fillRef idx="3">
+            <a:schemeClr val="accent1"/>
+          </a:fillRef>
+          <a:effectRef idx="2">
+            <a:schemeClr val="accent1"/>
+          </a:effectRef>
+          <a:fontRef idx="minor">
+            <a:schemeClr val="lt1"/>
+          </a:fontRef>
+        </p:style>
+        <p:txBody>
+          <a:bodyPr rtlCol="0" anchor="ctr"/>
+          <a:lstStyle/>
+          <a:p>
+            <a:pPr algn="ctr"/>
+          </a:p>
+        </p:txBody>
+      </p:sp>
+      <p:sp>
+        <p:nvSpPr>
+          <p:cNvPr id="25" name="TextBox 24"/>
           <p:cNvSpPr txBox="1"/>
           <p:nvPr/>
         </p:nvSpPr>
         <p:spPr>
           <a:xfrm>
-            <a:off x="6400800" y="5257800"/>
-            <a:ext cx="5394960" cy="822960"/>
+            <a:off x="7863840" y="5989320"/>
+            <a:ext cx="2011680" cy="274320"/>
           </a:xfrm>
           <a:prstGeom prst="rect">
             <a:avLst/>
@@ -4183,27 +5202,27 @@
           <a:p>
             <a:pPr algn="ctr"/>
             <a:r>
-              <a:rPr sz="1200" i="0">
-                <a:solidFill>
-                  <a:srgbClr val="666666"/>
-                </a:solidFill>
-                <a:latin typeface="Calibri"/>
-              </a:rPr>
-              <a:t>ROC — LCAG class-2 (sister) edge detection, v47 masshead2, 20 test files. Mass supervision moves sister information into the edge representation.</a:t>
-            </a:r>
-          </a:p>
-        </p:txBody>
-      </p:sp>
-      <p:sp>
-        <p:nvSpPr>
-          <p:cNvPr id="8" name="TextBox 7"/>
+              <a:rPr sz="900" i="0">
+                <a:solidFill>
+                  <a:srgbClr val="333333"/>
+                </a:solidFill>
+                <a:latin typeface="Calibri"/>
+              </a:rPr>
+              <a:t>green = new physics heads</a:t>
+            </a:r>
+          </a:p>
+        </p:txBody>
+      </p:sp>
+      <p:sp>
+        <p:nvSpPr>
+          <p:cNvPr id="26" name="TextBox 25"/>
           <p:cNvSpPr txBox="1"/>
           <p:nvPr/>
         </p:nvSpPr>
         <p:spPr>
           <a:xfrm>
-            <a:off x="731520" y="6309360"/>
-            <a:ext cx="10789920" cy="365760"/>
+            <a:off x="10058400" y="5989320"/>
+            <a:ext cx="2011680" cy="274320"/>
           </a:xfrm>
           <a:prstGeom prst="rect">
             <a:avLst/>
@@ -4218,13 +5237,13 @@
           <a:p>
             <a:pPr algn="ctr"/>
             <a:r>
-              <a:rPr sz="1200" i="1">
-                <a:solidFill>
-                  <a:srgbClr val="666666"/>
-                </a:solidFill>
-                <a:latin typeface="Calibri"/>
-              </a:rPr>
-              <a:t>Implication: supervising a physical target improved the hardest structural class — and the whole reconstruction</a:t>
+              <a:rPr sz="900" i="0">
+                <a:solidFill>
+                  <a:srgbClr val="333333"/>
+                </a:solidFill>
+                <a:latin typeface="Calibri"/>
+              </a:rPr>
+              <a:t>blue = original heads</a:t>
             </a:r>
           </a:p>
         </p:txBody>
@@ -4310,7 +5329,7 @@
                 </a:solidFill>
                 <a:latin typeface="Calibri"/>
               </a:rPr>
-              <a:t>Structure and Momentum Heads</a:t>
+              <a:t>Part 3 — Structure Head: Depth</a:t>
             </a:r>
           </a:p>
           <a:p>
@@ -4321,7 +5340,7 @@
                 </a:solidFill>
                 <a:latin typeface="Calibri"/>
               </a:rPr>
-              <a:t>Node-level supervision of tree position and momentum</a:t>
+              <a:t>How the "where in the tree" target is computed</a:t>
             </a:r>
           </a:p>
         </p:txBody>
@@ -4369,303 +5388,16 @@
           </a:p>
         </p:txBody>
       </p:sp>
-      <p:graphicFrame>
-        <p:nvGraphicFramePr>
-          <p:cNvPr id="5" name="Table 4"/>
-          <p:cNvGraphicFramePr>
-            <a:graphicFrameLocks noGrp="1"/>
-          </p:cNvGraphicFramePr>
-          <p:nvPr/>
-        </p:nvGraphicFramePr>
-        <p:xfrm>
-          <a:off x="640080" y="1371600"/>
-          <a:ext cx="5486400" cy="1737360"/>
-        </p:xfrm>
-        <a:graphic>
-          <a:graphicData uri="http://schemas.openxmlformats.org/drawingml/2006/table">
-            <a:tbl>
-              <a:tblPr firstRow="1" bandRow="1">
-                <a:tableStyleId>{5C22544A-7EE6-4342-B048-85BDC9FD1C3A}</a:tableStyleId>
-              </a:tblPr>
-              <a:tblGrid>
-                <a:gridCol w="1828800"/>
-                <a:gridCol w="1828800"/>
-                <a:gridCol w="1828800"/>
-              </a:tblGrid>
-              <a:tr h="434340">
-                <a:tc>
-                  <a:txBody>
-                    <a:bodyPr/>
-                    <a:lstStyle/>
-                    <a:p>
-                      <a:pPr algn="ctr"/>
-                      <a:r>
-                        <a:rPr sz="1500">
-                          <a:solidFill>
-                            <a:srgbClr val="FFFFFF"/>
-                          </a:solidFill>
-                          <a:latin typeface="Calibri"/>
-                        </a:rPr>
-                        <a:t>Head</a:t>
-                      </a:r>
-                    </a:p>
-                  </a:txBody>
-                  <a:tcPr marL="54864" marR="54864" marT="18288" marB="18288">
-                    <a:solidFill>
-                      <a:srgbClr val="1F4E79"/>
-                    </a:solidFill>
-                  </a:tcPr>
-                </a:tc>
-                <a:tc>
-                  <a:txBody>
-                    <a:bodyPr/>
-                    <a:lstStyle/>
-                    <a:p>
-                      <a:pPr algn="ctr"/>
-                      <a:r>
-                        <a:rPr sz="1500">
-                          <a:solidFill>
-                            <a:srgbClr val="FFFFFF"/>
-                          </a:solidFill>
-                          <a:latin typeface="Calibri"/>
-                        </a:rPr>
-                        <a:t>Target</a:t>
-                      </a:r>
-                    </a:p>
-                  </a:txBody>
-                  <a:tcPr marL="54864" marR="54864" marT="18288" marB="18288">
-                    <a:solidFill>
-                      <a:srgbClr val="1F4E79"/>
-                    </a:solidFill>
-                  </a:tcPr>
-                </a:tc>
-                <a:tc>
-                  <a:txBody>
-                    <a:bodyPr/>
-                    <a:lstStyle/>
-                    <a:p>
-                      <a:pPr algn="ctr"/>
-                      <a:r>
-                        <a:rPr sz="1500">
-                          <a:solidFill>
-                            <a:srgbClr val="FFFFFF"/>
-                          </a:solidFill>
-                          <a:latin typeface="Calibri"/>
-                        </a:rPr>
-                        <a:t>All / Perfect (5-file eval)</a:t>
-                      </a:r>
-                    </a:p>
-                  </a:txBody>
-                  <a:tcPr marL="54864" marR="54864" marT="18288" marB="18288">
-                    <a:solidFill>
-                      <a:srgbClr val="1F4E79"/>
-                    </a:solidFill>
-                  </a:tcPr>
-                </a:tc>
-              </a:tr>
-              <a:tr h="434340">
-                <a:tc>
-                  <a:txBody>
-                    <a:bodyPr/>
-                    <a:lstStyle/>
-                    <a:p>
-                      <a:pPr algn="l"/>
-                      <a:r>
-                        <a:rPr sz="1500">
-                          <a:solidFill>
-                            <a:srgbClr val="333333"/>
-                          </a:solidFill>
-                          <a:latin typeface="Calibri"/>
-                        </a:rPr>
-                        <a:t>baseline</a:t>
-                      </a:r>
-                    </a:p>
-                  </a:txBody>
-                  <a:tcPr marL="54864" marR="54864" marT="18288" marB="18288"/>
-                </a:tc>
-                <a:tc>
-                  <a:txBody>
-                    <a:bodyPr/>
-                    <a:lstStyle/>
-                    <a:p>
-                      <a:pPr algn="l"/>
-                      <a:r>
-                        <a:rPr sz="1500">
-                          <a:solidFill>
-                            <a:srgbClr val="333333"/>
-                          </a:solidFill>
-                          <a:latin typeface="Calibri"/>
-                        </a:rPr>
-                        <a:t>mass only</a:t>
-                      </a:r>
-                    </a:p>
-                  </a:txBody>
-                  <a:tcPr marL="54864" marR="54864" marT="18288" marB="18288"/>
-                </a:tc>
-                <a:tc>
-                  <a:txBody>
-                    <a:bodyPr/>
-                    <a:lstStyle/>
-                    <a:p>
-                      <a:pPr algn="l"/>
-                      <a:r>
-                        <a:rPr sz="1500">
-                          <a:solidFill>
-                            <a:srgbClr val="333333"/>
-                          </a:solidFill>
-                          <a:latin typeface="Calibri"/>
-                        </a:rPr>
-                        <a:t>51.4 / 29.7</a:t>
-                      </a:r>
-                    </a:p>
-                  </a:txBody>
-                  <a:tcPr marL="54864" marR="54864" marT="18288" marB="18288"/>
-                </a:tc>
-              </a:tr>
-              <a:tr h="434340">
-                <a:tc>
-                  <a:txBody>
-                    <a:bodyPr/>
-                    <a:lstStyle/>
-                    <a:p>
-                      <a:pPr algn="l"/>
-                      <a:r>
-                        <a:rPr sz="1500">
-                          <a:solidFill>
-                            <a:srgbClr val="333333"/>
-                          </a:solidFill>
-                          <a:latin typeface="Calibri"/>
-                        </a:rPr>
-                        <a:t>+ struct</a:t>
-                      </a:r>
-                    </a:p>
-                  </a:txBody>
-                  <a:tcPr marL="54864" marR="54864" marT="18288" marB="18288">
-                    <a:solidFill>
-                      <a:srgbClr val="EAF2F8"/>
-                    </a:solidFill>
-                  </a:tcPr>
-                </a:tc>
-                <a:tc>
-                  <a:txBody>
-                    <a:bodyPr/>
-                    <a:lstStyle/>
-                    <a:p>
-                      <a:pPr algn="l"/>
-                      <a:r>
-                        <a:rPr sz="1500">
-                          <a:solidFill>
-                            <a:srgbClr val="333333"/>
-                          </a:solidFill>
-                          <a:latin typeface="Calibri"/>
-                        </a:rPr>
-                        <a:t>depth + RC</a:t>
-                      </a:r>
-                    </a:p>
-                  </a:txBody>
-                  <a:tcPr marL="54864" marR="54864" marT="18288" marB="18288">
-                    <a:solidFill>
-                      <a:srgbClr val="EAF2F8"/>
-                    </a:solidFill>
-                  </a:tcPr>
-                </a:tc>
-                <a:tc>
-                  <a:txBody>
-                    <a:bodyPr/>
-                    <a:lstStyle/>
-                    <a:p>
-                      <a:pPr algn="l"/>
-                      <a:r>
-                        <a:rPr sz="1500">
-                          <a:solidFill>
-                            <a:srgbClr val="333333"/>
-                          </a:solidFill>
-                          <a:latin typeface="Calibri"/>
-                        </a:rPr>
-                        <a:t>54.5 / 30.5 (+0.8) — best</a:t>
-                      </a:r>
-                    </a:p>
-                  </a:txBody>
-                  <a:tcPr marL="54864" marR="54864" marT="18288" marB="18288">
-                    <a:solidFill>
-                      <a:srgbClr val="EAF2F8"/>
-                    </a:solidFill>
-                  </a:tcPr>
-                </a:tc>
-              </a:tr>
-              <a:tr h="434340">
-                <a:tc>
-                  <a:txBody>
-                    <a:bodyPr/>
-                    <a:lstStyle/>
-                    <a:p>
-                      <a:pPr algn="l"/>
-                      <a:r>
-                        <a:rPr sz="1500">
-                          <a:solidFill>
-                            <a:srgbClr val="333333"/>
-                          </a:solidFill>
-                          <a:latin typeface="Calibri"/>
-                        </a:rPr>
-                        <a:t>+ mom</a:t>
-                      </a:r>
-                    </a:p>
-                  </a:txBody>
-                  <a:tcPr marL="54864" marR="54864" marT="18288" marB="18288"/>
-                </a:tc>
-                <a:tc>
-                  <a:txBody>
-                    <a:bodyPr/>
-                    <a:lstStyle/>
-                    <a:p>
-                      <a:pPr algn="l"/>
-                      <a:r>
-                        <a:rPr sz="1500">
-                          <a:solidFill>
-                            <a:srgbClr val="333333"/>
-                          </a:solidFill>
-                          <a:latin typeface="Calibri"/>
-                        </a:rPr>
-                        <a:t>normalized p</a:t>
-                      </a:r>
-                    </a:p>
-                  </a:txBody>
-                  <a:tcPr marL="54864" marR="54864" marT="18288" marB="18288"/>
-                </a:tc>
-                <a:tc>
-                  <a:txBody>
-                    <a:bodyPr/>
-                    <a:lstStyle/>
-                    <a:p>
-                      <a:pPr algn="l"/>
-                      <a:r>
-                        <a:rPr sz="1500">
-                          <a:solidFill>
-                            <a:srgbClr val="333333"/>
-                          </a:solidFill>
-                          <a:latin typeface="Calibri"/>
-                        </a:rPr>
-                        <a:t>53.8 / 30.5 (+0.8)</a:t>
-                      </a:r>
-                    </a:p>
-                  </a:txBody>
-                  <a:tcPr marL="54864" marR="54864" marT="18288" marB="18288"/>
-                </a:tc>
-              </a:tr>
-            </a:tbl>
-          </a:graphicData>
-        </a:graphic>
-      </p:graphicFrame>
-      <p:sp>
-        <p:nvSpPr>
-          <p:cNvPr id="6" name="TextBox 5"/>
+      <p:sp>
+        <p:nvSpPr>
+          <p:cNvPr id="5" name="TextBox 4"/>
           <p:cNvSpPr txBox="1"/>
           <p:nvPr/>
         </p:nvSpPr>
         <p:spPr>
           <a:xfrm>
-            <a:off x="640080" y="3383280"/>
-            <a:ext cx="5486400" cy="2743200"/>
+            <a:off x="640080" y="1371600"/>
+            <a:ext cx="5486400" cy="4389120"/>
           </a:xfrm>
           <a:prstGeom prst="rect">
             <a:avLst/>
@@ -4690,7 +5422,7 @@
                 </a:solidFill>
                 <a:latin typeface="Calibri"/>
               </a:rPr>
-              <a:t>•  Struct: depth (BFS to chain centroid) + RC value — where the node sits in the tree (see right); class3 60.8→63.2</a:t>
+              <a:t>•  Target: how far a node sits from the chain root (the B candidate)</a:t>
             </a:r>
           </a:p>
           <a:p>
@@ -4706,7 +5438,7 @@
                 </a:solidFill>
                 <a:latin typeface="Calibri"/>
               </a:rPr>
-              <a:t>•  Mom: motivated by a probe — node representations were linearly unreadable for momentum (R² ≈ 0)</a:t>
+              <a:t>•  Computed by BFS on the truth chain: root d=0 → children d=1 → grandchildren d=2 (right)</a:t>
             </a:r>
           </a:p>
           <a:p>
@@ -4722,14 +5454,30 @@
                 </a:solidFill>
                 <a:latin typeface="Calibri"/>
               </a:rPr>
-              <a:t>•  Lesson: probe first, find the missing quantity, then supervise it</a:t>
+              <a:t>•  The struct head regresses this depth from the node representation</a:t>
+            </a:r>
+          </a:p>
+          <a:p>
+            <a:pPr>
+              <a:spcAft>
+                <a:spcPts val="1000"/>
+              </a:spcAft>
+            </a:pPr>
+            <a:r>
+              <a:rPr sz="2200">
+                <a:solidFill>
+                  <a:srgbClr val="333333"/>
+                </a:solidFill>
+                <a:latin typeface="Calibri"/>
+              </a:rPr>
+              <a:t>•  Effect (5-file ablation): +struct → All 51.4 → 54.5, Perfect 29.7 → 30.5; class3 60.8 → 63.2</a:t>
             </a:r>
           </a:p>
         </p:txBody>
       </p:sp>
       <p:pic>
         <p:nvPicPr>
-          <p:cNvPr id="7" name="Picture 6" descr="struct_mom_tree.png"/>
+          <p:cNvPr id="6" name="Picture 5" descr="depth_calc.png"/>
           <p:cNvPicPr>
             <a:picLocks noChangeAspect="1"/>
           </p:cNvPicPr>
@@ -4743,7 +5491,7 @@
         </p:blipFill>
         <p:spPr>
           <a:xfrm>
-            <a:off x="6400800" y="1828800"/>
+            <a:off x="6400800" y="2011680"/>
             <a:ext cx="5394960" cy="2253674"/>
           </a:xfrm>
           <a:prstGeom prst="rect">
@@ -4753,7 +5501,7 @@
       </p:pic>
       <p:sp>
         <p:nvSpPr>
-          <p:cNvPr id="8" name="TextBox 7"/>
+          <p:cNvPr id="7" name="TextBox 6"/>
           <p:cNvSpPr txBox="1"/>
           <p:nvPr/>
         </p:nvSpPr>
@@ -4781,7 +5529,7 @@
                 </a:solidFill>
                 <a:latin typeface="Calibri"/>
               </a:rPr>
-              <a:t>Implication: depth/RC label the node’s role in the tree — the struct head forces the node representation to encode it</a:t>
+              <a:t>Implication: depth labels the node’s role in the chain — supervising it forces the representation to encode tree position</a:t>
             </a:r>
           </a:p>
         </p:txBody>
@@ -4867,7 +5615,7 @@
                 </a:solidFill>
                 <a:latin typeface="Calibri"/>
               </a:rPr>
-              <a:t>Verification: Linear Probes on the Frozen Backbone</a:t>
+              <a:t>Part 3 — Structure Head: Rumor Centrality</a:t>
             </a:r>
           </a:p>
           <a:p>
@@ -4878,7 +5626,7 @@
                 </a:solidFill>
                 <a:latin typeface="Calibri"/>
               </a:rPr>
-              <a:t>Ridge regression; R² of the physical quantity</a:t>
+              <a:t>How the "is this the root?" score is computed</a:t>
             </a:r>
           </a:p>
         </p:txBody>
@@ -4934,7 +5682,7 @@
         </p:nvSpPr>
         <p:spPr>
           <a:xfrm>
-            <a:off x="640080" y="1463040"/>
+            <a:off x="640080" y="1371600"/>
             <a:ext cx="5486400" cy="4389120"/>
           </a:xfrm>
           <a:prstGeom prst="rect">
@@ -4960,7 +5708,7 @@
                 </a:solidFill>
                 <a:latin typeface="Calibri"/>
               </a:rPr>
-              <a:t>•  Probe: fit a linear regressor on the frozen backbone — can the quantity be read off?</a:t>
+              <a:t>•  RC answers: which node is the source of the chain? (Shah &amp; Zaman)</a:t>
             </a:r>
           </a:p>
           <a:p>
@@ -4976,7 +5724,7 @@
                 </a:solidFill>
                 <a:latin typeface="Calibri"/>
               </a:rPr>
-              <a:t>•  Edge repr → log10(m_ππ): R² 0.003 → 0.930 (masshead2)</a:t>
+              <a:t>•  For each candidate root v: root the tree there, measure subtree sizes τ(u)</a:t>
             </a:r>
           </a:p>
           <a:p>
@@ -4992,7 +5740,7 @@
                 </a:solidFill>
                 <a:latin typeface="Calibri"/>
               </a:rPr>
-              <a:t>•  Node repr → p (px/py/pz): R² ≈ 0 both before and after</a:t>
+              <a:t>•  log R(v) = −Σ log τ(u); the root maximizes it (right: B wins)</a:t>
             </a:r>
           </a:p>
           <a:p>
@@ -5008,30 +5756,14 @@
                 </a:solidFill>
                 <a:latin typeface="Calibri"/>
               </a:rPr>
-              <a:t>•  Mass supervision moves mass information into the edge representation — confirmed end-to-end</a:t>
-            </a:r>
-          </a:p>
-          <a:p>
-            <a:pPr>
-              <a:spcAft>
-                <a:spcPts val="1000"/>
-              </a:spcAft>
-            </a:pPr>
-            <a:r>
-              <a:rPr sz="2200">
-                <a:solidFill>
-                  <a:srgbClr val="333333"/>
-                </a:solidFill>
-                <a:latin typeface="Calibri"/>
-              </a:rPr>
-              <a:t>•  Nodes remain unreadable for momentum → addressed by the momentum head (to be re-probed)</a:t>
+              <a:t>•  Struct head: regress the normalized RC value; source head (v36): predict the argmax root</a:t>
             </a:r>
           </a:p>
         </p:txBody>
       </p:sp>
       <p:pic>
         <p:nvPicPr>
-          <p:cNvPr id="6" name="Picture 5" descr="probe_r2.png"/>
+          <p:cNvPr id="6" name="Picture 5" descr="rc_calc.png"/>
           <p:cNvPicPr>
             <a:picLocks noChangeAspect="1"/>
           </p:cNvPicPr>
@@ -5045,8 +5777,8 @@
         </p:blipFill>
         <p:spPr>
           <a:xfrm>
-            <a:off x="6400800" y="2194560"/>
-            <a:ext cx="5394960" cy="2251752"/>
+            <a:off x="6400800" y="2011680"/>
+            <a:ext cx="5394960" cy="2253674"/>
           </a:xfrm>
           <a:prstGeom prst="rect">
             <a:avLst/>
@@ -5083,7 +5815,7 @@
                 </a:solidFill>
                 <a:latin typeface="Calibri"/>
               </a:rPr>
-              <a:t>Implication: the probe is the check that supervision actually wrote the physics into the representation</a:t>
+              <a:t>Implication: RC gives a physics-motivated "root-ness" target — no manual labels needed</a:t>
             </a:r>
           </a:p>
         </p:txBody>
@@ -6375,7 +7107,23 @@
                 </a:solidFill>
                 <a:latin typeface="Calibri"/>
               </a:rPr>
-              <a:t>•  Part 3 — Supervising Representations with Physics (source / mass / struct / mom)</a:t>
+              <a:t>•  Part 3 — Supervising Representations with Physics</a:t>
+            </a:r>
+          </a:p>
+          <a:p>
+            <a:pPr>
+              <a:spcAft>
+                <a:spcPts val="1000"/>
+              </a:spcAft>
+            </a:pPr>
+            <a:r>
+              <a:rPr sz="2200">
+                <a:solidFill>
+                  <a:srgbClr val="333333"/>
+                </a:solidFill>
+                <a:latin typeface="Calibri"/>
+              </a:rPr>
+              <a:t>    –  linear probes first · the head zoo · depth &amp; RC</a:t>
             </a:r>
           </a:p>
           <a:p>

</xml_diff>

<commit_message>
docs: rewrite Part 4 as latent-space argument; drop the PV part
- S15: more heads made things worse (v48: aux 0.877 > main 0.559,
  AllParticles 55.9 -> 50.6) -> the 16-dim space is saturated
- S16: size the latent space from physics — new latent_dof figure
  (track ~12-14 physical DOF + serves 9 heads -> 16-dim at the lower
  bound; v53 widens nodes 32 / tt edges 24)
- S17: slimmed Part 5 (public data, learned DA, chain scorer);
  S18: next steps; PV-subgraph line removed entirely (18 pages)
</commit_message>
<xml_diff>
--- a/meeting_figs/DFEI_progress_20260902_EN.pptx
+++ b/meeting_figs/DFEI_progress_20260902_EN.pptx
@@ -22,6 +22,7 @@
     <p:sldId id="270" r:id="rId21"/>
     <p:sldId id="271" r:id="rId22"/>
     <p:sldId id="272" r:id="rId23"/>
+    <p:sldId id="273" r:id="rId24"/>
   </p:sldIdLst>
   <p:sldSz cx="12191695" cy="6858000" type="screen4x3"/>
   <p:notesSz cx="6858000" cy="9144000"/>
@@ -5901,7 +5902,7 @@
                 </a:solidFill>
                 <a:latin typeface="Calibri"/>
               </a:rPr>
-              <a:t>Part 4 — Controlled Failures and Their Lessons</a:t>
+              <a:t>Part 4 — Why Extend the Latent Space (1/2): More Heads Made Things Worse</a:t>
             </a:r>
           </a:p>
           <a:p>
@@ -5912,7 +5913,7 @@
                 </a:solidFill>
                 <a:latin typeface="Calibri"/>
               </a:rPr>
-              <a:t>Two failed lines, two lessons</a:t>
+              <a:t>Stacking supervisors on a fixed 16-dim space (v48) hurt the reconstruction</a:t>
             </a:r>
           </a:p>
         </p:txBody>
@@ -5969,7 +5970,7 @@
         <p:spPr>
           <a:xfrm>
             <a:off x="640080" y="1371600"/>
-            <a:ext cx="5486400" cy="4937760"/>
+            <a:ext cx="5486400" cy="4572000"/>
           </a:xfrm>
           <a:prstGeom prst="rect">
             <a:avLst/>
@@ -5994,7 +5995,7 @@
                 </a:solidFill>
                 <a:latin typeface="Calibri"/>
               </a:rPr>
-              <a:t>•  PV subgraph training (v39-42): training on per-PV subgraphs while inference runs on the full graph</a:t>
+              <a:t>•  Combined mass + struct + mom at once (v48): aux losses (0.877) exceed the main task (0.559)</a:t>
             </a:r>
           </a:p>
           <a:p>
@@ -6004,13 +6005,13 @@
               </a:spcAft>
             </a:pPr>
             <a:r>
-              <a:rPr sz="2000">
-                <a:solidFill>
-                  <a:srgbClr val="333333"/>
-                </a:solidFill>
-                <a:latin typeface="Calibri"/>
-              </a:rPr>
-              <a:t>    –  full-graph ability degraded: class1 76.8% → 56.4%; line closed</a:t>
+              <a:rPr sz="2200">
+                <a:solidFill>
+                  <a:srgbClr val="333333"/>
+                </a:solidFill>
+                <a:latin typeface="Calibri"/>
+              </a:rPr>
+              <a:t>•  Reconstruction dropped 5pp (AllParticles 55.9 → 50.6) although LCAG accuracy did not</a:t>
             </a:r>
           </a:p>
           <a:p>
@@ -6026,7 +6027,7 @@
                 </a:solidFill>
                 <a:latin typeface="Calibri"/>
               </a:rPr>
-              <a:t>•  Combined mass + struct + mom (v48): aux losses (0.877) exceed the main task (0.559)</a:t>
+              <a:t>•  Interpretation: the 16-dim representation is saturated — extra heads on the same space only compete</a:t>
             </a:r>
           </a:p>
           <a:p>
@@ -6036,45 +6037,13 @@
               </a:spcAft>
             </a:pPr>
             <a:r>
-              <a:rPr sz="2000">
-                <a:solidFill>
-                  <a:srgbClr val="333333"/>
-                </a:solidFill>
-                <a:latin typeface="Calibri"/>
-              </a:rPr>
-              <a:t>    –  reconstruction dropped 5pp although LCAG did not — backbone pulled toward auxiliary tasks</a:t>
-            </a:r>
-          </a:p>
-          <a:p>
-            <a:pPr>
-              <a:spcAft>
-                <a:spcPts val="1000"/>
-              </a:spcAft>
-            </a:pPr>
-            <a:r>
-              <a:rPr sz="2000">
-                <a:solidFill>
-                  <a:srgbClr val="333333"/>
-                </a:solidFill>
-                <a:latin typeface="Calibri"/>
-              </a:rPr>
-              <a:t>    –  resolution: lower aux weights — mom 0.2, struct 0.3</a:t>
-            </a:r>
-          </a:p>
-          <a:p>
-            <a:pPr>
-              <a:spcAft>
-                <a:spcPts val="1000"/>
-              </a:spcAft>
-            </a:pPr>
-            <a:r>
               <a:rPr sz="2200">
                 <a:solidFill>
                   <a:srgbClr val="333333"/>
                 </a:solidFill>
                 <a:latin typeface="Calibri"/>
               </a:rPr>
-              <a:t>•  Lessons: train/infer graph mismatch is fatal; gradient balance must be explicit</a:t>
+              <a:t>•  This motivated giving the representation more room (next slide)</a:t>
             </a:r>
           </a:p>
         </p:txBody>
@@ -6133,7 +6102,7 @@
                 </a:solidFill>
                 <a:latin typeface="Calibri"/>
               </a:rPr>
-              <a:t>Implication: the v48 failure shows why the head zoo needs explicit gradient balance — and why we ablate before stacking</a:t>
+              <a:t>Implication: more heads on a saturated latent space cannot add information — the space itself is the limit</a:t>
             </a:r>
           </a:p>
         </p:txBody>
@@ -6219,7 +6188,18 @@
                 </a:solidFill>
                 <a:latin typeface="Calibri"/>
               </a:rPr>
-              <a:t>Part 5 — Ongoing Attempts</a:t>
+              <a:t>Part 4 — Size the Latent Space from Physics (2/2)</a:t>
+            </a:r>
+          </a:p>
+          <a:p>
+            <a:r>
+              <a:rPr sz="1700">
+                <a:solidFill>
+                  <a:srgbClr val="666666"/>
+                </a:solidFill>
+                <a:latin typeface="Calibri"/>
+              </a:rPr>
+              <a:t>Count the physical variables a node/edge must encode</a:t>
             </a:r>
           </a:p>
         </p:txBody>
@@ -6275,8 +6255,8 @@
         </p:nvSpPr>
         <p:spPr>
           <a:xfrm>
-            <a:off x="731520" y="1280160"/>
-            <a:ext cx="10789920" cy="5120640"/>
+            <a:off x="640080" y="1371600"/>
+            <a:ext cx="5486400" cy="4846320"/>
           </a:xfrm>
           <a:prstGeom prst="rect">
             <a:avLst/>
@@ -6301,7 +6281,7 @@
                 </a:solidFill>
                 <a:latin typeface="Calibri"/>
               </a:rPr>
-              <a:t>•  Wider latent space (v53): tracks nodes 32-dim, tt edges 24-dim — 16-dim sits at the physical-DOF lower bound</a:t>
+              <a:t>•  A d-dim representation holds at most d independent numbers</a:t>
             </a:r>
           </a:p>
           <a:p>
@@ -6311,13 +6291,13 @@
               </a:spcAft>
             </a:pPr>
             <a:r>
-              <a:rPr sz="2000">
-                <a:solidFill>
-                  <a:srgbClr val="333333"/>
-                </a:solidFill>
-                <a:latin typeface="Calibri"/>
-              </a:rPr>
-              <a:t>    –  from-scratch training interrupted at ep74/150, not converged; resume planned</a:t>
+              <a:rPr sz="2200">
+                <a:solidFill>
+                  <a:srgbClr val="333333"/>
+                </a:solidFill>
+                <a:latin typeface="Calibri"/>
+              </a:rPr>
+              <a:t>•  A track carries ~12-14 physical DOF (position, momentum×3, PID, mass-related…) and the node repr must serve 9 heads</a:t>
             </a:r>
           </a:p>
           <a:p>
@@ -6333,7 +6313,7 @@
                 </a:solidFill>
                 <a:latin typeface="Calibri"/>
               </a:rPr>
-              <a:t>•  Public-data verification (v45/v49): no PID, class2/3 counts differ 4-14×; resume best val 33.4 @ep73</a:t>
+              <a:t>•  → 16-dim sits at the lower bound → under-parameterized</a:t>
             </a:r>
           </a:p>
           <a:p>
@@ -6349,7 +6329,7 @@
                 </a:solidFill>
                 <a:latin typeface="Calibri"/>
               </a:rPr>
-              <a:t>•  Learned deterministic annealing: inference-side PV clustering with learned affinity (no subgraph training); core module CPU-verified</a:t>
+              <a:t>•  v53: widen tracks nodes → 32-dim, tt edges → 24-dim (others stay 16); from scratch, v38 stack + mass head</a:t>
             </a:r>
           </a:p>
           <a:p>
@@ -6365,7 +6345,66 @@
                 </a:solidFill>
                 <a:latin typeface="Calibri"/>
               </a:rPr>
-              <a:t>•  Chain scoring for trigger assistance: criteria AUC 0.90 / 0.78 (realistic); training ready, needs GPU</a:t>
+              <a:t>•  Status: interrupted at ep74/150 — inconclusive; resume planned</a:t>
+            </a:r>
+          </a:p>
+        </p:txBody>
+      </p:sp>
+      <p:pic>
+        <p:nvPicPr>
+          <p:cNvPr id="6" name="Picture 5" descr="latent_dof.png"/>
+          <p:cNvPicPr>
+            <a:picLocks noChangeAspect="1"/>
+          </p:cNvPicPr>
+          <p:nvPr/>
+        </p:nvPicPr>
+        <p:blipFill>
+          <a:blip r:embed="rId2"/>
+          <a:stretch>
+            <a:fillRect/>
+          </a:stretch>
+        </p:blipFill>
+        <p:spPr>
+          <a:xfrm>
+            <a:off x="6400800" y="2194560"/>
+            <a:ext cx="5394960" cy="1807994"/>
+          </a:xfrm>
+          <a:prstGeom prst="rect">
+            <a:avLst/>
+          </a:prstGeom>
+        </p:spPr>
+      </p:pic>
+      <p:sp>
+        <p:nvSpPr>
+          <p:cNvPr id="7" name="TextBox 6"/>
+          <p:cNvSpPr txBox="1"/>
+          <p:nvPr/>
+        </p:nvSpPr>
+        <p:spPr>
+          <a:xfrm>
+            <a:off x="731520" y="6263640"/>
+            <a:ext cx="10789920" cy="365760"/>
+          </a:xfrm>
+          <a:prstGeom prst="rect">
+            <a:avLst/>
+          </a:prstGeom>
+          <a:noFill/>
+        </p:spPr>
+        <p:txBody>
+          <a:bodyPr wrap="square">
+            <a:spAutoFit/>
+          </a:bodyPr>
+          <a:lstStyle/>
+          <a:p>
+            <a:pPr algn="ctr"/>
+            <a:r>
+              <a:rPr sz="1200" i="1">
+                <a:solidFill>
+                  <a:srgbClr val="666666"/>
+                </a:solidFill>
+                <a:latin typeface="Calibri"/>
+              </a:rPr>
+              <a:t>Implication: widening is the physics-motivated fix for head competition — to be verified by a full run</a:t>
             </a:r>
           </a:p>
         </p:txBody>
@@ -6418,6 +6457,206 @@
                 <a:latin typeface="Calibri"/>
               </a:rPr>
               <a:t>Qingxiang Guo · UCAS · DFEI group meeting      17</a:t>
+            </a:r>
+          </a:p>
+        </p:txBody>
+      </p:sp>
+      <p:sp>
+        <p:nvSpPr>
+          <p:cNvPr id="3" name="TextBox 2"/>
+          <p:cNvSpPr txBox="1"/>
+          <p:nvPr/>
+        </p:nvSpPr>
+        <p:spPr>
+          <a:xfrm>
+            <a:off x="502920" y="164592"/>
+            <a:ext cx="11155680" cy="914400"/>
+          </a:xfrm>
+          <a:prstGeom prst="rect">
+            <a:avLst/>
+          </a:prstGeom>
+          <a:noFill/>
+        </p:spPr>
+        <p:txBody>
+          <a:bodyPr wrap="square">
+            <a:spAutoFit/>
+          </a:bodyPr>
+          <a:lstStyle/>
+          <a:p>
+            <a:r>
+              <a:rPr sz="3800" b="1">
+                <a:solidFill>
+                  <a:srgbClr val="1F4E79"/>
+                </a:solidFill>
+                <a:latin typeface="Calibri"/>
+              </a:rPr>
+              <a:t>Part 5 — Other Ongoing Lines</a:t>
+            </a:r>
+          </a:p>
+        </p:txBody>
+      </p:sp>
+      <p:sp>
+        <p:nvSpPr>
+          <p:cNvPr id="4" name="Rectangle 3"/>
+          <p:cNvSpPr/>
+          <p:nvPr/>
+        </p:nvSpPr>
+        <p:spPr>
+          <a:xfrm>
+            <a:off x="548640" y="1188720"/>
+            <a:ext cx="11064240" cy="38100"/>
+          </a:xfrm>
+          <a:prstGeom prst="rect">
+            <a:avLst/>
+          </a:prstGeom>
+          <a:solidFill>
+            <a:srgbClr val="1F4E79"/>
+          </a:solidFill>
+          <a:ln>
+            <a:noFill/>
+          </a:ln>
+        </p:spPr>
+        <p:style>
+          <a:lnRef idx="1">
+            <a:schemeClr val="accent1"/>
+          </a:lnRef>
+          <a:fillRef idx="3">
+            <a:schemeClr val="accent1"/>
+          </a:fillRef>
+          <a:effectRef idx="2">
+            <a:schemeClr val="accent1"/>
+          </a:effectRef>
+          <a:fontRef idx="minor">
+            <a:schemeClr val="lt1"/>
+          </a:fontRef>
+        </p:style>
+        <p:txBody>
+          <a:bodyPr rtlCol="0" anchor="ctr"/>
+          <a:lstStyle/>
+          <a:p>
+            <a:pPr algn="ctr"/>
+          </a:p>
+        </p:txBody>
+      </p:sp>
+      <p:sp>
+        <p:nvSpPr>
+          <p:cNvPr id="5" name="TextBox 4"/>
+          <p:cNvSpPr txBox="1"/>
+          <p:nvPr/>
+        </p:nvSpPr>
+        <p:spPr>
+          <a:xfrm>
+            <a:off x="731520" y="1371600"/>
+            <a:ext cx="10789920" cy="4754880"/>
+          </a:xfrm>
+          <a:prstGeom prst="rect">
+            <a:avLst/>
+          </a:prstGeom>
+          <a:noFill/>
+        </p:spPr>
+        <p:txBody>
+          <a:bodyPr wrap="square">
+            <a:spAutoFit/>
+          </a:bodyPr>
+          <a:lstStyle/>
+          <a:p>
+            <a:pPr>
+              <a:spcAft>
+                <a:spcPts val="1000"/>
+              </a:spcAft>
+            </a:pPr>
+            <a:r>
+              <a:rPr sz="2200">
+                <a:solidFill>
+                  <a:srgbClr val="333333"/>
+                </a:solidFill>
+                <a:latin typeface="Calibri"/>
+              </a:rPr>
+              <a:t>•  Public-data verification (v45/v49): no PID, class2/3 counts differ 4-14×; resume best val 33.4 @ep73</a:t>
+            </a:r>
+          </a:p>
+          <a:p>
+            <a:pPr>
+              <a:spcAft>
+                <a:spcPts val="1000"/>
+              </a:spcAft>
+            </a:pPr>
+            <a:r>
+              <a:rPr sz="2200">
+                <a:solidFill>
+                  <a:srgbClr val="333333"/>
+                </a:solidFill>
+                <a:latin typeface="Calibri"/>
+              </a:rPr>
+              <a:t>•  Learned deterministic annealing: inference-side PV clustering with learned affinity (no subgraph training); core module CPU-verified</a:t>
+            </a:r>
+          </a:p>
+          <a:p>
+            <a:pPr>
+              <a:spcAft>
+                <a:spcPts val="1000"/>
+              </a:spcAft>
+            </a:pPr>
+            <a:r>
+              <a:rPr sz="2200">
+                <a:solidFill>
+                  <a:srgbClr val="333333"/>
+                </a:solidFill>
+                <a:latin typeface="Calibri"/>
+              </a:rPr>
+              <a:t>•  Chain scoring for trigger assistance: criteria AUC 0.90 / 0.78 (realistic); training ready, needs GPU</a:t>
+            </a:r>
+          </a:p>
+        </p:txBody>
+      </p:sp>
+    </p:spTree>
+  </p:cSld>
+  <p:clrMapOvr>
+    <a:masterClrMapping/>
+  </p:clrMapOvr>
+</p:sld>
+</file>
+
+<file path=ppt/slides/slide18.xml><?xml version="1.0" encoding="utf-8"?>
+<p:sld xmlns:a="http://schemas.openxmlformats.org/drawingml/2006/main" xmlns:p="http://schemas.openxmlformats.org/presentationml/2006/main" xmlns:r="http://schemas.openxmlformats.org/officeDocument/2006/relationships">
+  <p:cSld>
+    <p:spTree>
+      <p:nvGrpSpPr>
+        <p:cNvPr id="1" name=""/>
+        <p:cNvGrpSpPr/>
+        <p:nvPr/>
+      </p:nvGrpSpPr>
+      <p:grpSpPr/>
+      <p:sp>
+        <p:nvSpPr>
+          <p:cNvPr id="2" name="TextBox 1"/>
+          <p:cNvSpPr txBox="1"/>
+          <p:nvPr/>
+        </p:nvSpPr>
+        <p:spPr>
+          <a:xfrm>
+            <a:off x="502920" y="6510528"/>
+            <a:ext cx="11155680" cy="274320"/>
+          </a:xfrm>
+          <a:prstGeom prst="rect">
+            <a:avLst/>
+          </a:prstGeom>
+          <a:noFill/>
+        </p:spPr>
+        <p:txBody>
+          <a:bodyPr wrap="none">
+            <a:spAutoFit/>
+          </a:bodyPr>
+          <a:lstStyle/>
+          <a:p>
+            <a:r>
+              <a:rPr sz="1000">
+                <a:solidFill>
+                  <a:srgbClr val="666666"/>
+                </a:solidFill>
+                <a:latin typeface="Calibri"/>
+              </a:rPr>
+              <a:t>Qingxiang Guo · UCAS · DFEI group meeting      18</a:t>
             </a:r>
           </a:p>
         </p:txBody>
@@ -7139,7 +7378,7 @@
                 </a:solidFill>
                 <a:latin typeface="Calibri"/>
               </a:rPr>
-              <a:t>•  Part 4 — Controlled Failures and Their Lessons</a:t>
+              <a:t>•  Part 4 — Why Extend the Latent Space</a:t>
             </a:r>
           </a:p>
           <a:p>
@@ -7149,13 +7388,29 @@
               </a:spcAft>
             </a:pPr>
             <a:r>
+              <a:rPr sz="2200">
+                <a:solidFill>
+                  <a:srgbClr val="333333"/>
+                </a:solidFill>
+                <a:latin typeface="Calibri"/>
+              </a:rPr>
+              <a:t>    –  more heads made things worse · size it from the physical DOF</a:t>
+            </a:r>
+          </a:p>
+          <a:p>
+            <a:pPr>
+              <a:spcAft>
+                <a:spcPts val="1000"/>
+              </a:spcAft>
+            </a:pPr>
+            <a:r>
               <a:rPr sz="2400">
                 <a:solidFill>
                   <a:srgbClr val="333333"/>
                 </a:solidFill>
                 <a:latin typeface="Calibri"/>
               </a:rPr>
-              <a:t>•  Part 5 — Ongoing Attempts</a:t>
+              <a:t>•  Part 5 — Other Ongoing Lines</a:t>
             </a:r>
           </a:p>
         </p:txBody>

</xml_diff>